<commit_message>
feat: Optimizar presentacion a 6 slides concisas con ilustraciones 3D incrustadas
</commit_message>
<xml_diff>
--- a/docs/FarmaSenal_Pitch_Presentacion.pptx
+++ b/docs/FarmaSenal_Pitch_Presentacion.pptx
@@ -11,8 +11,6 @@
     <p:sldId id="259" r:id="rId5"/>
     <p:sldId id="260" r:id="rId6"/>
     <p:sldId id="261" r:id="rId7"/>
-    <p:sldId id="262" r:id="rId8"/>
-    <p:sldId id="263" r:id="rId9"/>
   </p:sldIdLst>
   <p:sldSz cx="12192000" cy="6858000"/>
   <p:notesSz cx="6858000" cy="9144000"/>
@@ -136,7 +134,7 @@
           <p:cNvPr id="2" name="Título 1">
             <a:extLst>
               <a:ext uri="{FF2B5EF4-FFF2-40B4-BE49-F238E27FC236}">
-                <a16:creationId xmlns:a16="http://schemas.microsoft.com/office/drawing/2014/main" id="{6450B57C-A357-1F26-4323-A984E294358F}"/>
+                <a16:creationId xmlns:a16="http://schemas.microsoft.com/office/drawing/2014/main" id="{DD9CE589-B549-E190-884D-C9071B33851A}"/>
               </a:ext>
             </a:extLst>
           </p:cNvPr>
@@ -174,7 +172,7 @@
           <p:cNvPr id="3" name="Subtítulo 2">
             <a:extLst>
               <a:ext uri="{FF2B5EF4-FFF2-40B4-BE49-F238E27FC236}">
-                <a16:creationId xmlns:a16="http://schemas.microsoft.com/office/drawing/2014/main" id="{11A81123-34C8-E3C4-1F7F-0726396E7D32}"/>
+                <a16:creationId xmlns:a16="http://schemas.microsoft.com/office/drawing/2014/main" id="{A43B3AA4-61CD-3D65-08BF-DB740A464405}"/>
               </a:ext>
             </a:extLst>
           </p:cNvPr>
@@ -245,7 +243,7 @@
           <p:cNvPr id="4" name="Marcador de fecha 3">
             <a:extLst>
               <a:ext uri="{FF2B5EF4-FFF2-40B4-BE49-F238E27FC236}">
-                <a16:creationId xmlns:a16="http://schemas.microsoft.com/office/drawing/2014/main" id="{0E08C69F-450C-4AA3-7A31-EAF195B53974}"/>
+                <a16:creationId xmlns:a16="http://schemas.microsoft.com/office/drawing/2014/main" id="{CB9112F2-78E8-515D-F24A-B62CD9D45563}"/>
               </a:ext>
             </a:extLst>
           </p:cNvPr>
@@ -261,7 +259,7 @@
           <a:bodyPr/>
           <a:lstStyle/>
           <a:p>
-            <a:fld id="{17539879-592C-4C4D-985F-1D57C6FF2592}" type="datetimeFigureOut">
+            <a:fld id="{2F6522CC-1677-4567-9825-52B108A01684}" type="datetimeFigureOut">
               <a:rPr lang="es-EC" smtClean="0"/>
               <a:t>8/10/2026</a:t>
             </a:fld>
@@ -274,7 +272,7 @@
           <p:cNvPr id="5" name="Marcador de pie de página 4">
             <a:extLst>
               <a:ext uri="{FF2B5EF4-FFF2-40B4-BE49-F238E27FC236}">
-                <a16:creationId xmlns:a16="http://schemas.microsoft.com/office/drawing/2014/main" id="{F891CE02-D463-D0D8-7A30-8A19BC623692}"/>
+                <a16:creationId xmlns:a16="http://schemas.microsoft.com/office/drawing/2014/main" id="{5604E312-EFD8-1929-06EC-5AEAE4AE9782}"/>
               </a:ext>
             </a:extLst>
           </p:cNvPr>
@@ -299,7 +297,7 @@
           <p:cNvPr id="6" name="Marcador de número de diapositiva 5">
             <a:extLst>
               <a:ext uri="{FF2B5EF4-FFF2-40B4-BE49-F238E27FC236}">
-                <a16:creationId xmlns:a16="http://schemas.microsoft.com/office/drawing/2014/main" id="{BBEF42CE-1CBB-949F-67EE-AA17EF1A818F}"/>
+                <a16:creationId xmlns:a16="http://schemas.microsoft.com/office/drawing/2014/main" id="{085DBD51-DDB0-4ACB-1B45-84DC4682C8FC}"/>
               </a:ext>
             </a:extLst>
           </p:cNvPr>
@@ -315,7 +313,7 @@
           <a:bodyPr/>
           <a:lstStyle/>
           <a:p>
-            <a:fld id="{47D8C3AA-9817-4BD1-8355-5466953FF7E7}" type="slidenum">
+            <a:fld id="{F3F25716-C9CD-4922-9EEA-B1CBFD816F36}" type="slidenum">
               <a:rPr lang="es-EC" smtClean="0"/>
               <a:t>‹Nº›</a:t>
             </a:fld>
@@ -326,7 +324,7 @@
     </p:spTree>
     <p:extLst>
       <p:ext uri="{BB962C8B-B14F-4D97-AF65-F5344CB8AC3E}">
-        <p14:creationId xmlns:p14="http://schemas.microsoft.com/office/powerpoint/2010/main" val="978932591"/>
+        <p14:creationId xmlns:p14="http://schemas.microsoft.com/office/powerpoint/2010/main" val="545232084"/>
       </p:ext>
     </p:extLst>
   </p:cSld>
@@ -358,7 +356,7 @@
           <p:cNvPr id="2" name="Título 1">
             <a:extLst>
               <a:ext uri="{FF2B5EF4-FFF2-40B4-BE49-F238E27FC236}">
-                <a16:creationId xmlns:a16="http://schemas.microsoft.com/office/drawing/2014/main" id="{DCA3C919-6AB7-7318-5BC9-B4C48E8A1AB4}"/>
+                <a16:creationId xmlns:a16="http://schemas.microsoft.com/office/drawing/2014/main" id="{D2AF4C18-06DE-8A21-C389-3FDFF7670FBC}"/>
               </a:ext>
             </a:extLst>
           </p:cNvPr>
@@ -387,7 +385,7 @@
           <p:cNvPr id="3" name="Marcador de texto vertical 2">
             <a:extLst>
               <a:ext uri="{FF2B5EF4-FFF2-40B4-BE49-F238E27FC236}">
-                <a16:creationId xmlns:a16="http://schemas.microsoft.com/office/drawing/2014/main" id="{D09ABE5A-6BBE-8AEE-0929-DF52E20E2B0F}"/>
+                <a16:creationId xmlns:a16="http://schemas.microsoft.com/office/drawing/2014/main" id="{E4F0C640-E98C-1F4F-AA06-40D23952AED1}"/>
               </a:ext>
             </a:extLst>
           </p:cNvPr>
@@ -445,7 +443,7 @@
           <p:cNvPr id="4" name="Marcador de fecha 3">
             <a:extLst>
               <a:ext uri="{FF2B5EF4-FFF2-40B4-BE49-F238E27FC236}">
-                <a16:creationId xmlns:a16="http://schemas.microsoft.com/office/drawing/2014/main" id="{CAF4BE8D-92FF-87DC-612E-CA9AB664EE20}"/>
+                <a16:creationId xmlns:a16="http://schemas.microsoft.com/office/drawing/2014/main" id="{ADCD34B4-57AC-2FB8-C8BB-9C985C705A10}"/>
               </a:ext>
             </a:extLst>
           </p:cNvPr>
@@ -461,7 +459,7 @@
           <a:bodyPr/>
           <a:lstStyle/>
           <a:p>
-            <a:fld id="{17539879-592C-4C4D-985F-1D57C6FF2592}" type="datetimeFigureOut">
+            <a:fld id="{2F6522CC-1677-4567-9825-52B108A01684}" type="datetimeFigureOut">
               <a:rPr lang="es-EC" smtClean="0"/>
               <a:t>8/10/2026</a:t>
             </a:fld>
@@ -474,7 +472,7 @@
           <p:cNvPr id="5" name="Marcador de pie de página 4">
             <a:extLst>
               <a:ext uri="{FF2B5EF4-FFF2-40B4-BE49-F238E27FC236}">
-                <a16:creationId xmlns:a16="http://schemas.microsoft.com/office/drawing/2014/main" id="{B42396DF-A7DF-1D5F-7DE2-1812CCF37F1E}"/>
+                <a16:creationId xmlns:a16="http://schemas.microsoft.com/office/drawing/2014/main" id="{2AD1B5C6-486E-0613-5883-E797E5D2D602}"/>
               </a:ext>
             </a:extLst>
           </p:cNvPr>
@@ -499,7 +497,7 @@
           <p:cNvPr id="6" name="Marcador de número de diapositiva 5">
             <a:extLst>
               <a:ext uri="{FF2B5EF4-FFF2-40B4-BE49-F238E27FC236}">
-                <a16:creationId xmlns:a16="http://schemas.microsoft.com/office/drawing/2014/main" id="{7342B9C6-6B9A-FFD6-8CE3-357D43D96D70}"/>
+                <a16:creationId xmlns:a16="http://schemas.microsoft.com/office/drawing/2014/main" id="{656D9B44-DF43-AC0A-3AEB-C5B098DCA558}"/>
               </a:ext>
             </a:extLst>
           </p:cNvPr>
@@ -515,7 +513,7 @@
           <a:bodyPr/>
           <a:lstStyle/>
           <a:p>
-            <a:fld id="{47D8C3AA-9817-4BD1-8355-5466953FF7E7}" type="slidenum">
+            <a:fld id="{F3F25716-C9CD-4922-9EEA-B1CBFD816F36}" type="slidenum">
               <a:rPr lang="es-EC" smtClean="0"/>
               <a:t>‹Nº›</a:t>
             </a:fld>
@@ -526,7 +524,7 @@
     </p:spTree>
     <p:extLst>
       <p:ext uri="{BB962C8B-B14F-4D97-AF65-F5344CB8AC3E}">
-        <p14:creationId xmlns:p14="http://schemas.microsoft.com/office/powerpoint/2010/main" val="3147835590"/>
+        <p14:creationId xmlns:p14="http://schemas.microsoft.com/office/powerpoint/2010/main" val="2168195687"/>
       </p:ext>
     </p:extLst>
   </p:cSld>
@@ -558,7 +556,7 @@
           <p:cNvPr id="2" name="Título vertical 1">
             <a:extLst>
               <a:ext uri="{FF2B5EF4-FFF2-40B4-BE49-F238E27FC236}">
-                <a16:creationId xmlns:a16="http://schemas.microsoft.com/office/drawing/2014/main" id="{36F73BAE-3B54-8C20-09D5-678637F31320}"/>
+                <a16:creationId xmlns:a16="http://schemas.microsoft.com/office/drawing/2014/main" id="{91C72939-C173-ADA6-7F21-71C36BDA3EDD}"/>
               </a:ext>
             </a:extLst>
           </p:cNvPr>
@@ -592,7 +590,7 @@
           <p:cNvPr id="3" name="Marcador de texto vertical 2">
             <a:extLst>
               <a:ext uri="{FF2B5EF4-FFF2-40B4-BE49-F238E27FC236}">
-                <a16:creationId xmlns:a16="http://schemas.microsoft.com/office/drawing/2014/main" id="{B2F9C441-748D-6F32-9046-E1B36C362CA9}"/>
+                <a16:creationId xmlns:a16="http://schemas.microsoft.com/office/drawing/2014/main" id="{551DFBF1-8553-6FD7-EE2F-D4EE4B48262F}"/>
               </a:ext>
             </a:extLst>
           </p:cNvPr>
@@ -655,7 +653,7 @@
           <p:cNvPr id="4" name="Marcador de fecha 3">
             <a:extLst>
               <a:ext uri="{FF2B5EF4-FFF2-40B4-BE49-F238E27FC236}">
-                <a16:creationId xmlns:a16="http://schemas.microsoft.com/office/drawing/2014/main" id="{703A61B7-C45E-846E-0F9D-0FD8F2FD7D84}"/>
+                <a16:creationId xmlns:a16="http://schemas.microsoft.com/office/drawing/2014/main" id="{BFFDC4CA-A60F-A0CF-D1B7-5DD1D956BB65}"/>
               </a:ext>
             </a:extLst>
           </p:cNvPr>
@@ -671,7 +669,7 @@
           <a:bodyPr/>
           <a:lstStyle/>
           <a:p>
-            <a:fld id="{17539879-592C-4C4D-985F-1D57C6FF2592}" type="datetimeFigureOut">
+            <a:fld id="{2F6522CC-1677-4567-9825-52B108A01684}" type="datetimeFigureOut">
               <a:rPr lang="es-EC" smtClean="0"/>
               <a:t>8/10/2026</a:t>
             </a:fld>
@@ -684,7 +682,7 @@
           <p:cNvPr id="5" name="Marcador de pie de página 4">
             <a:extLst>
               <a:ext uri="{FF2B5EF4-FFF2-40B4-BE49-F238E27FC236}">
-                <a16:creationId xmlns:a16="http://schemas.microsoft.com/office/drawing/2014/main" id="{552B63A8-5ED5-26D0-24D2-99B86BDD9FC7}"/>
+                <a16:creationId xmlns:a16="http://schemas.microsoft.com/office/drawing/2014/main" id="{010442A5-606E-03E8-E68C-C025C9231C11}"/>
               </a:ext>
             </a:extLst>
           </p:cNvPr>
@@ -709,7 +707,7 @@
           <p:cNvPr id="6" name="Marcador de número de diapositiva 5">
             <a:extLst>
               <a:ext uri="{FF2B5EF4-FFF2-40B4-BE49-F238E27FC236}">
-                <a16:creationId xmlns:a16="http://schemas.microsoft.com/office/drawing/2014/main" id="{2BCB4AD4-8970-89CF-C8C4-508E44751E14}"/>
+                <a16:creationId xmlns:a16="http://schemas.microsoft.com/office/drawing/2014/main" id="{0548E83E-E931-D781-E2DA-5ECF4074CD6C}"/>
               </a:ext>
             </a:extLst>
           </p:cNvPr>
@@ -725,7 +723,7 @@
           <a:bodyPr/>
           <a:lstStyle/>
           <a:p>
-            <a:fld id="{47D8C3AA-9817-4BD1-8355-5466953FF7E7}" type="slidenum">
+            <a:fld id="{F3F25716-C9CD-4922-9EEA-B1CBFD816F36}" type="slidenum">
               <a:rPr lang="es-EC" smtClean="0"/>
               <a:t>‹Nº›</a:t>
             </a:fld>
@@ -736,7 +734,7 @@
     </p:spTree>
     <p:extLst>
       <p:ext uri="{BB962C8B-B14F-4D97-AF65-F5344CB8AC3E}">
-        <p14:creationId xmlns:p14="http://schemas.microsoft.com/office/powerpoint/2010/main" val="3194524638"/>
+        <p14:creationId xmlns:p14="http://schemas.microsoft.com/office/powerpoint/2010/main" val="2379373298"/>
       </p:ext>
     </p:extLst>
   </p:cSld>
@@ -768,7 +766,7 @@
           <p:cNvPr id="2" name="Título 1">
             <a:extLst>
               <a:ext uri="{FF2B5EF4-FFF2-40B4-BE49-F238E27FC236}">
-                <a16:creationId xmlns:a16="http://schemas.microsoft.com/office/drawing/2014/main" id="{8A0D5F86-11EB-260A-E218-0FBD786BF6BA}"/>
+                <a16:creationId xmlns:a16="http://schemas.microsoft.com/office/drawing/2014/main" id="{2D64FF51-176A-3532-00D7-30B28E6E567F}"/>
               </a:ext>
             </a:extLst>
           </p:cNvPr>
@@ -797,7 +795,7 @@
           <p:cNvPr id="3" name="Marcador de contenido 2">
             <a:extLst>
               <a:ext uri="{FF2B5EF4-FFF2-40B4-BE49-F238E27FC236}">
-                <a16:creationId xmlns:a16="http://schemas.microsoft.com/office/drawing/2014/main" id="{9A0E60FC-B479-6399-E3C8-A7D4AE8AE942}"/>
+                <a16:creationId xmlns:a16="http://schemas.microsoft.com/office/drawing/2014/main" id="{D91EE25C-F422-75CF-BE48-AE053045A933}"/>
               </a:ext>
             </a:extLst>
           </p:cNvPr>
@@ -855,7 +853,7 @@
           <p:cNvPr id="4" name="Marcador de fecha 3">
             <a:extLst>
               <a:ext uri="{FF2B5EF4-FFF2-40B4-BE49-F238E27FC236}">
-                <a16:creationId xmlns:a16="http://schemas.microsoft.com/office/drawing/2014/main" id="{6409B2F1-0E59-6498-37BD-96B35DDFD1B2}"/>
+                <a16:creationId xmlns:a16="http://schemas.microsoft.com/office/drawing/2014/main" id="{29BF65A5-139B-685F-20DC-D24F5FBB8309}"/>
               </a:ext>
             </a:extLst>
           </p:cNvPr>
@@ -871,7 +869,7 @@
           <a:bodyPr/>
           <a:lstStyle/>
           <a:p>
-            <a:fld id="{17539879-592C-4C4D-985F-1D57C6FF2592}" type="datetimeFigureOut">
+            <a:fld id="{2F6522CC-1677-4567-9825-52B108A01684}" type="datetimeFigureOut">
               <a:rPr lang="es-EC" smtClean="0"/>
               <a:t>8/10/2026</a:t>
             </a:fld>
@@ -884,7 +882,7 @@
           <p:cNvPr id="5" name="Marcador de pie de página 4">
             <a:extLst>
               <a:ext uri="{FF2B5EF4-FFF2-40B4-BE49-F238E27FC236}">
-                <a16:creationId xmlns:a16="http://schemas.microsoft.com/office/drawing/2014/main" id="{F501227D-34CC-4ADF-4DFE-63FC22D68B16}"/>
+                <a16:creationId xmlns:a16="http://schemas.microsoft.com/office/drawing/2014/main" id="{C56917C3-9040-8974-245F-123B78F2617B}"/>
               </a:ext>
             </a:extLst>
           </p:cNvPr>
@@ -909,7 +907,7 @@
           <p:cNvPr id="6" name="Marcador de número de diapositiva 5">
             <a:extLst>
               <a:ext uri="{FF2B5EF4-FFF2-40B4-BE49-F238E27FC236}">
-                <a16:creationId xmlns:a16="http://schemas.microsoft.com/office/drawing/2014/main" id="{E6940433-6B5C-A097-9EDF-23D02B4CEBA8}"/>
+                <a16:creationId xmlns:a16="http://schemas.microsoft.com/office/drawing/2014/main" id="{F15A174E-C0AE-D0AE-FF96-3DF9D8174ED1}"/>
               </a:ext>
             </a:extLst>
           </p:cNvPr>
@@ -925,7 +923,7 @@
           <a:bodyPr/>
           <a:lstStyle/>
           <a:p>
-            <a:fld id="{47D8C3AA-9817-4BD1-8355-5466953FF7E7}" type="slidenum">
+            <a:fld id="{F3F25716-C9CD-4922-9EEA-B1CBFD816F36}" type="slidenum">
               <a:rPr lang="es-EC" smtClean="0"/>
               <a:t>‹Nº›</a:t>
             </a:fld>
@@ -936,7 +934,7 @@
     </p:spTree>
     <p:extLst>
       <p:ext uri="{BB962C8B-B14F-4D97-AF65-F5344CB8AC3E}">
-        <p14:creationId xmlns:p14="http://schemas.microsoft.com/office/powerpoint/2010/main" val="2166855632"/>
+        <p14:creationId xmlns:p14="http://schemas.microsoft.com/office/powerpoint/2010/main" val="735381803"/>
       </p:ext>
     </p:extLst>
   </p:cSld>
@@ -968,7 +966,7 @@
           <p:cNvPr id="2" name="Título 1">
             <a:extLst>
               <a:ext uri="{FF2B5EF4-FFF2-40B4-BE49-F238E27FC236}">
-                <a16:creationId xmlns:a16="http://schemas.microsoft.com/office/drawing/2014/main" id="{7914096C-59A5-A8BE-5FB3-70033C02C277}"/>
+                <a16:creationId xmlns:a16="http://schemas.microsoft.com/office/drawing/2014/main" id="{C7A38AA5-326F-08A4-DE84-E6A06D765718}"/>
               </a:ext>
             </a:extLst>
           </p:cNvPr>
@@ -1006,7 +1004,7 @@
           <p:cNvPr id="3" name="Marcador de texto 2">
             <a:extLst>
               <a:ext uri="{FF2B5EF4-FFF2-40B4-BE49-F238E27FC236}">
-                <a16:creationId xmlns:a16="http://schemas.microsoft.com/office/drawing/2014/main" id="{061E4E62-7D97-1C8A-2F85-1CEB4DBF2C97}"/>
+                <a16:creationId xmlns:a16="http://schemas.microsoft.com/office/drawing/2014/main" id="{6A3F41A1-340E-DD35-C93A-898F2CC3E38F}"/>
               </a:ext>
             </a:extLst>
           </p:cNvPr>
@@ -1131,7 +1129,7 @@
           <p:cNvPr id="4" name="Marcador de fecha 3">
             <a:extLst>
               <a:ext uri="{FF2B5EF4-FFF2-40B4-BE49-F238E27FC236}">
-                <a16:creationId xmlns:a16="http://schemas.microsoft.com/office/drawing/2014/main" id="{BF6295BD-D080-D8AE-00B6-96D7F3171031}"/>
+                <a16:creationId xmlns:a16="http://schemas.microsoft.com/office/drawing/2014/main" id="{421F902B-C189-7470-FD20-0111463992CE}"/>
               </a:ext>
             </a:extLst>
           </p:cNvPr>
@@ -1147,7 +1145,7 @@
           <a:bodyPr/>
           <a:lstStyle/>
           <a:p>
-            <a:fld id="{17539879-592C-4C4D-985F-1D57C6FF2592}" type="datetimeFigureOut">
+            <a:fld id="{2F6522CC-1677-4567-9825-52B108A01684}" type="datetimeFigureOut">
               <a:rPr lang="es-EC" smtClean="0"/>
               <a:t>8/10/2026</a:t>
             </a:fld>
@@ -1160,7 +1158,7 @@
           <p:cNvPr id="5" name="Marcador de pie de página 4">
             <a:extLst>
               <a:ext uri="{FF2B5EF4-FFF2-40B4-BE49-F238E27FC236}">
-                <a16:creationId xmlns:a16="http://schemas.microsoft.com/office/drawing/2014/main" id="{04828CBE-3261-DCB6-8160-B6B4F390545F}"/>
+                <a16:creationId xmlns:a16="http://schemas.microsoft.com/office/drawing/2014/main" id="{181FBD0D-C192-C6C8-3C20-34CDA2B4A339}"/>
               </a:ext>
             </a:extLst>
           </p:cNvPr>
@@ -1185,7 +1183,7 @@
           <p:cNvPr id="6" name="Marcador de número de diapositiva 5">
             <a:extLst>
               <a:ext uri="{FF2B5EF4-FFF2-40B4-BE49-F238E27FC236}">
-                <a16:creationId xmlns:a16="http://schemas.microsoft.com/office/drawing/2014/main" id="{5110D651-F863-D38F-C72B-B70512306A98}"/>
+                <a16:creationId xmlns:a16="http://schemas.microsoft.com/office/drawing/2014/main" id="{28525612-8276-225C-F8C4-73D13FF1FD43}"/>
               </a:ext>
             </a:extLst>
           </p:cNvPr>
@@ -1201,7 +1199,7 @@
           <a:bodyPr/>
           <a:lstStyle/>
           <a:p>
-            <a:fld id="{47D8C3AA-9817-4BD1-8355-5466953FF7E7}" type="slidenum">
+            <a:fld id="{F3F25716-C9CD-4922-9EEA-B1CBFD816F36}" type="slidenum">
               <a:rPr lang="es-EC" smtClean="0"/>
               <a:t>‹Nº›</a:t>
             </a:fld>
@@ -1212,7 +1210,7 @@
     </p:spTree>
     <p:extLst>
       <p:ext uri="{BB962C8B-B14F-4D97-AF65-F5344CB8AC3E}">
-        <p14:creationId xmlns:p14="http://schemas.microsoft.com/office/powerpoint/2010/main" val="1689452131"/>
+        <p14:creationId xmlns:p14="http://schemas.microsoft.com/office/powerpoint/2010/main" val="3055172187"/>
       </p:ext>
     </p:extLst>
   </p:cSld>
@@ -1244,7 +1242,7 @@
           <p:cNvPr id="2" name="Título 1">
             <a:extLst>
               <a:ext uri="{FF2B5EF4-FFF2-40B4-BE49-F238E27FC236}">
-                <a16:creationId xmlns:a16="http://schemas.microsoft.com/office/drawing/2014/main" id="{1998C380-64A6-E7E9-6575-5EDF937E6505}"/>
+                <a16:creationId xmlns:a16="http://schemas.microsoft.com/office/drawing/2014/main" id="{00D1F739-2EE5-A26B-A182-D34D52E9B7EA}"/>
               </a:ext>
             </a:extLst>
           </p:cNvPr>
@@ -1273,7 +1271,7 @@
           <p:cNvPr id="3" name="Marcador de contenido 2">
             <a:extLst>
               <a:ext uri="{FF2B5EF4-FFF2-40B4-BE49-F238E27FC236}">
-                <a16:creationId xmlns:a16="http://schemas.microsoft.com/office/drawing/2014/main" id="{36018BC8-0243-B469-4A5F-EF6B516D486A}"/>
+                <a16:creationId xmlns:a16="http://schemas.microsoft.com/office/drawing/2014/main" id="{C864D488-DA36-EC9E-DC01-B96FF93E8A05}"/>
               </a:ext>
             </a:extLst>
           </p:cNvPr>
@@ -1336,7 +1334,7 @@
           <p:cNvPr id="4" name="Marcador de contenido 3">
             <a:extLst>
               <a:ext uri="{FF2B5EF4-FFF2-40B4-BE49-F238E27FC236}">
-                <a16:creationId xmlns:a16="http://schemas.microsoft.com/office/drawing/2014/main" id="{FFB9CDED-E80D-7C37-828D-6D5F0766E641}"/>
+                <a16:creationId xmlns:a16="http://schemas.microsoft.com/office/drawing/2014/main" id="{02275CBE-42DE-F69C-A51A-F1C2479DFE59}"/>
               </a:ext>
             </a:extLst>
           </p:cNvPr>
@@ -1399,7 +1397,7 @@
           <p:cNvPr id="5" name="Marcador de fecha 4">
             <a:extLst>
               <a:ext uri="{FF2B5EF4-FFF2-40B4-BE49-F238E27FC236}">
-                <a16:creationId xmlns:a16="http://schemas.microsoft.com/office/drawing/2014/main" id="{11544272-115A-AD29-D04D-AB51A7C65BE4}"/>
+                <a16:creationId xmlns:a16="http://schemas.microsoft.com/office/drawing/2014/main" id="{3AA755C3-E5AC-91F6-C6B8-C424B8E30CC1}"/>
               </a:ext>
             </a:extLst>
           </p:cNvPr>
@@ -1415,7 +1413,7 @@
           <a:bodyPr/>
           <a:lstStyle/>
           <a:p>
-            <a:fld id="{17539879-592C-4C4D-985F-1D57C6FF2592}" type="datetimeFigureOut">
+            <a:fld id="{2F6522CC-1677-4567-9825-52B108A01684}" type="datetimeFigureOut">
               <a:rPr lang="es-EC" smtClean="0"/>
               <a:t>8/10/2026</a:t>
             </a:fld>
@@ -1428,7 +1426,7 @@
           <p:cNvPr id="6" name="Marcador de pie de página 5">
             <a:extLst>
               <a:ext uri="{FF2B5EF4-FFF2-40B4-BE49-F238E27FC236}">
-                <a16:creationId xmlns:a16="http://schemas.microsoft.com/office/drawing/2014/main" id="{B380AFE7-8F7C-BB1F-184E-97D48DAFB69B}"/>
+                <a16:creationId xmlns:a16="http://schemas.microsoft.com/office/drawing/2014/main" id="{48FDEF29-E022-4465-284D-AFC9E056C23C}"/>
               </a:ext>
             </a:extLst>
           </p:cNvPr>
@@ -1453,7 +1451,7 @@
           <p:cNvPr id="7" name="Marcador de número de diapositiva 6">
             <a:extLst>
               <a:ext uri="{FF2B5EF4-FFF2-40B4-BE49-F238E27FC236}">
-                <a16:creationId xmlns:a16="http://schemas.microsoft.com/office/drawing/2014/main" id="{0E67F594-FCE9-27DD-0EE1-71122EBCFBE9}"/>
+                <a16:creationId xmlns:a16="http://schemas.microsoft.com/office/drawing/2014/main" id="{D45D0A4A-45F1-5207-8711-0CF30BC6B0C1}"/>
               </a:ext>
             </a:extLst>
           </p:cNvPr>
@@ -1469,7 +1467,7 @@
           <a:bodyPr/>
           <a:lstStyle/>
           <a:p>
-            <a:fld id="{47D8C3AA-9817-4BD1-8355-5466953FF7E7}" type="slidenum">
+            <a:fld id="{F3F25716-C9CD-4922-9EEA-B1CBFD816F36}" type="slidenum">
               <a:rPr lang="es-EC" smtClean="0"/>
               <a:t>‹Nº›</a:t>
             </a:fld>
@@ -1480,7 +1478,7 @@
     </p:spTree>
     <p:extLst>
       <p:ext uri="{BB962C8B-B14F-4D97-AF65-F5344CB8AC3E}">
-        <p14:creationId xmlns:p14="http://schemas.microsoft.com/office/powerpoint/2010/main" val="78412814"/>
+        <p14:creationId xmlns:p14="http://schemas.microsoft.com/office/powerpoint/2010/main" val="639178214"/>
       </p:ext>
     </p:extLst>
   </p:cSld>
@@ -1512,7 +1510,7 @@
           <p:cNvPr id="2" name="Título 1">
             <a:extLst>
               <a:ext uri="{FF2B5EF4-FFF2-40B4-BE49-F238E27FC236}">
-                <a16:creationId xmlns:a16="http://schemas.microsoft.com/office/drawing/2014/main" id="{BF55BC5E-9826-0EC2-FAA9-71E914BFA8D7}"/>
+                <a16:creationId xmlns:a16="http://schemas.microsoft.com/office/drawing/2014/main" id="{10B59DB1-EF2E-86DF-FE9D-B44C5195B10E}"/>
               </a:ext>
             </a:extLst>
           </p:cNvPr>
@@ -1546,7 +1544,7 @@
           <p:cNvPr id="3" name="Marcador de texto 2">
             <a:extLst>
               <a:ext uri="{FF2B5EF4-FFF2-40B4-BE49-F238E27FC236}">
-                <a16:creationId xmlns:a16="http://schemas.microsoft.com/office/drawing/2014/main" id="{C64965F0-2CE1-5CDD-2048-978D0AFDC686}"/>
+                <a16:creationId xmlns:a16="http://schemas.microsoft.com/office/drawing/2014/main" id="{E1AE209E-6AC4-4CB7-4FB3-6C25C5A6AAAD}"/>
               </a:ext>
             </a:extLst>
           </p:cNvPr>
@@ -1617,7 +1615,7 @@
           <p:cNvPr id="4" name="Marcador de contenido 3">
             <a:extLst>
               <a:ext uri="{FF2B5EF4-FFF2-40B4-BE49-F238E27FC236}">
-                <a16:creationId xmlns:a16="http://schemas.microsoft.com/office/drawing/2014/main" id="{DE6875E7-C524-61E7-99EA-99F606939F85}"/>
+                <a16:creationId xmlns:a16="http://schemas.microsoft.com/office/drawing/2014/main" id="{2187298C-6808-E160-F8BE-6A270BD88DFD}"/>
               </a:ext>
             </a:extLst>
           </p:cNvPr>
@@ -1680,7 +1678,7 @@
           <p:cNvPr id="5" name="Marcador de texto 4">
             <a:extLst>
               <a:ext uri="{FF2B5EF4-FFF2-40B4-BE49-F238E27FC236}">
-                <a16:creationId xmlns:a16="http://schemas.microsoft.com/office/drawing/2014/main" id="{8E36E7F2-E4A0-E410-3D31-A4BC9531AAA6}"/>
+                <a16:creationId xmlns:a16="http://schemas.microsoft.com/office/drawing/2014/main" id="{A4E5C4E6-B93A-4F68-A947-3811D147495C}"/>
               </a:ext>
             </a:extLst>
           </p:cNvPr>
@@ -1751,7 +1749,7 @@
           <p:cNvPr id="6" name="Marcador de contenido 5">
             <a:extLst>
               <a:ext uri="{FF2B5EF4-FFF2-40B4-BE49-F238E27FC236}">
-                <a16:creationId xmlns:a16="http://schemas.microsoft.com/office/drawing/2014/main" id="{0A01C1BA-3D53-C82F-7701-060F45223002}"/>
+                <a16:creationId xmlns:a16="http://schemas.microsoft.com/office/drawing/2014/main" id="{6C2C6B27-AE99-69CE-7876-AE4511590510}"/>
               </a:ext>
             </a:extLst>
           </p:cNvPr>
@@ -1814,7 +1812,7 @@
           <p:cNvPr id="7" name="Marcador de fecha 6">
             <a:extLst>
               <a:ext uri="{FF2B5EF4-FFF2-40B4-BE49-F238E27FC236}">
-                <a16:creationId xmlns:a16="http://schemas.microsoft.com/office/drawing/2014/main" id="{E620BAE9-013E-F7EF-C062-CE23A30B5663}"/>
+                <a16:creationId xmlns:a16="http://schemas.microsoft.com/office/drawing/2014/main" id="{A02EF343-2F0B-6E60-F248-5A0DBD20C056}"/>
               </a:ext>
             </a:extLst>
           </p:cNvPr>
@@ -1830,7 +1828,7 @@
           <a:bodyPr/>
           <a:lstStyle/>
           <a:p>
-            <a:fld id="{17539879-592C-4C4D-985F-1D57C6FF2592}" type="datetimeFigureOut">
+            <a:fld id="{2F6522CC-1677-4567-9825-52B108A01684}" type="datetimeFigureOut">
               <a:rPr lang="es-EC" smtClean="0"/>
               <a:t>8/10/2026</a:t>
             </a:fld>
@@ -1843,7 +1841,7 @@
           <p:cNvPr id="8" name="Marcador de pie de página 7">
             <a:extLst>
               <a:ext uri="{FF2B5EF4-FFF2-40B4-BE49-F238E27FC236}">
-                <a16:creationId xmlns:a16="http://schemas.microsoft.com/office/drawing/2014/main" id="{202E6B26-2C9D-F946-6FD4-9E7B2CDCA15C}"/>
+                <a16:creationId xmlns:a16="http://schemas.microsoft.com/office/drawing/2014/main" id="{76EDA59D-21CC-E05E-851B-6DA911A98979}"/>
               </a:ext>
             </a:extLst>
           </p:cNvPr>
@@ -1868,7 +1866,7 @@
           <p:cNvPr id="9" name="Marcador de número de diapositiva 8">
             <a:extLst>
               <a:ext uri="{FF2B5EF4-FFF2-40B4-BE49-F238E27FC236}">
-                <a16:creationId xmlns:a16="http://schemas.microsoft.com/office/drawing/2014/main" id="{84715A0B-4CC5-B2B2-4210-7DCCFE62E156}"/>
+                <a16:creationId xmlns:a16="http://schemas.microsoft.com/office/drawing/2014/main" id="{5A7BCBB8-D8F7-9C86-F55D-CCDDC2666012}"/>
               </a:ext>
             </a:extLst>
           </p:cNvPr>
@@ -1884,7 +1882,7 @@
           <a:bodyPr/>
           <a:lstStyle/>
           <a:p>
-            <a:fld id="{47D8C3AA-9817-4BD1-8355-5466953FF7E7}" type="slidenum">
+            <a:fld id="{F3F25716-C9CD-4922-9EEA-B1CBFD816F36}" type="slidenum">
               <a:rPr lang="es-EC" smtClean="0"/>
               <a:t>‹Nº›</a:t>
             </a:fld>
@@ -1895,7 +1893,7 @@
     </p:spTree>
     <p:extLst>
       <p:ext uri="{BB962C8B-B14F-4D97-AF65-F5344CB8AC3E}">
-        <p14:creationId xmlns:p14="http://schemas.microsoft.com/office/powerpoint/2010/main" val="1936641804"/>
+        <p14:creationId xmlns:p14="http://schemas.microsoft.com/office/powerpoint/2010/main" val="3137298480"/>
       </p:ext>
     </p:extLst>
   </p:cSld>
@@ -1927,7 +1925,7 @@
           <p:cNvPr id="2" name="Título 1">
             <a:extLst>
               <a:ext uri="{FF2B5EF4-FFF2-40B4-BE49-F238E27FC236}">
-                <a16:creationId xmlns:a16="http://schemas.microsoft.com/office/drawing/2014/main" id="{28434700-64DB-FBB9-281C-42316A894B5E}"/>
+                <a16:creationId xmlns:a16="http://schemas.microsoft.com/office/drawing/2014/main" id="{98AB86AD-EAFB-5509-760A-8A1F1DF79DEF}"/>
               </a:ext>
             </a:extLst>
           </p:cNvPr>
@@ -1956,7 +1954,7 @@
           <p:cNvPr id="3" name="Marcador de fecha 2">
             <a:extLst>
               <a:ext uri="{FF2B5EF4-FFF2-40B4-BE49-F238E27FC236}">
-                <a16:creationId xmlns:a16="http://schemas.microsoft.com/office/drawing/2014/main" id="{0A1F3E9A-9413-41F5-156A-B81E15582D44}"/>
+                <a16:creationId xmlns:a16="http://schemas.microsoft.com/office/drawing/2014/main" id="{E1C9BAE6-DA0B-A1FB-6CDB-CB3F141A9D18}"/>
               </a:ext>
             </a:extLst>
           </p:cNvPr>
@@ -1972,7 +1970,7 @@
           <a:bodyPr/>
           <a:lstStyle/>
           <a:p>
-            <a:fld id="{17539879-592C-4C4D-985F-1D57C6FF2592}" type="datetimeFigureOut">
+            <a:fld id="{2F6522CC-1677-4567-9825-52B108A01684}" type="datetimeFigureOut">
               <a:rPr lang="es-EC" smtClean="0"/>
               <a:t>8/10/2026</a:t>
             </a:fld>
@@ -1985,7 +1983,7 @@
           <p:cNvPr id="4" name="Marcador de pie de página 3">
             <a:extLst>
               <a:ext uri="{FF2B5EF4-FFF2-40B4-BE49-F238E27FC236}">
-                <a16:creationId xmlns:a16="http://schemas.microsoft.com/office/drawing/2014/main" id="{5C89E10E-B223-B6FC-8DF1-6CFA9FDE3A07}"/>
+                <a16:creationId xmlns:a16="http://schemas.microsoft.com/office/drawing/2014/main" id="{E4264F3C-2C6F-39AA-6D78-AACA79D68419}"/>
               </a:ext>
             </a:extLst>
           </p:cNvPr>
@@ -2010,7 +2008,7 @@
           <p:cNvPr id="5" name="Marcador de número de diapositiva 4">
             <a:extLst>
               <a:ext uri="{FF2B5EF4-FFF2-40B4-BE49-F238E27FC236}">
-                <a16:creationId xmlns:a16="http://schemas.microsoft.com/office/drawing/2014/main" id="{9C3C30A0-3B71-DA9A-1B7B-C68D1DED12D5}"/>
+                <a16:creationId xmlns:a16="http://schemas.microsoft.com/office/drawing/2014/main" id="{51D9D3F7-9CC6-AB4F-5BBD-6268401F062B}"/>
               </a:ext>
             </a:extLst>
           </p:cNvPr>
@@ -2026,7 +2024,7 @@
           <a:bodyPr/>
           <a:lstStyle/>
           <a:p>
-            <a:fld id="{47D8C3AA-9817-4BD1-8355-5466953FF7E7}" type="slidenum">
+            <a:fld id="{F3F25716-C9CD-4922-9EEA-B1CBFD816F36}" type="slidenum">
               <a:rPr lang="es-EC" smtClean="0"/>
               <a:t>‹Nº›</a:t>
             </a:fld>
@@ -2037,7 +2035,7 @@
     </p:spTree>
     <p:extLst>
       <p:ext uri="{BB962C8B-B14F-4D97-AF65-F5344CB8AC3E}">
-        <p14:creationId xmlns:p14="http://schemas.microsoft.com/office/powerpoint/2010/main" val="668687191"/>
+        <p14:creationId xmlns:p14="http://schemas.microsoft.com/office/powerpoint/2010/main" val="1223453750"/>
       </p:ext>
     </p:extLst>
   </p:cSld>
@@ -2069,7 +2067,7 @@
           <p:cNvPr id="2" name="Marcador de fecha 1">
             <a:extLst>
               <a:ext uri="{FF2B5EF4-FFF2-40B4-BE49-F238E27FC236}">
-                <a16:creationId xmlns:a16="http://schemas.microsoft.com/office/drawing/2014/main" id="{30F1EFA6-9CDB-29D7-43D1-5EA937606230}"/>
+                <a16:creationId xmlns:a16="http://schemas.microsoft.com/office/drawing/2014/main" id="{EDE1A686-8D42-5D57-66E5-EF9B3F90EEB4}"/>
               </a:ext>
             </a:extLst>
           </p:cNvPr>
@@ -2085,7 +2083,7 @@
           <a:bodyPr/>
           <a:lstStyle/>
           <a:p>
-            <a:fld id="{17539879-592C-4C4D-985F-1D57C6FF2592}" type="datetimeFigureOut">
+            <a:fld id="{2F6522CC-1677-4567-9825-52B108A01684}" type="datetimeFigureOut">
               <a:rPr lang="es-EC" smtClean="0"/>
               <a:t>8/10/2026</a:t>
             </a:fld>
@@ -2098,7 +2096,7 @@
           <p:cNvPr id="3" name="Marcador de pie de página 2">
             <a:extLst>
               <a:ext uri="{FF2B5EF4-FFF2-40B4-BE49-F238E27FC236}">
-                <a16:creationId xmlns:a16="http://schemas.microsoft.com/office/drawing/2014/main" id="{F605A209-8CF6-DE08-86DB-5DF4B8ECFEAE}"/>
+                <a16:creationId xmlns:a16="http://schemas.microsoft.com/office/drawing/2014/main" id="{2DF6B127-9596-E09C-6F6C-B98929BDD7B7}"/>
               </a:ext>
             </a:extLst>
           </p:cNvPr>
@@ -2123,7 +2121,7 @@
           <p:cNvPr id="4" name="Marcador de número de diapositiva 3">
             <a:extLst>
               <a:ext uri="{FF2B5EF4-FFF2-40B4-BE49-F238E27FC236}">
-                <a16:creationId xmlns:a16="http://schemas.microsoft.com/office/drawing/2014/main" id="{E88D3AA5-CDA7-3ED4-D931-C6788EA3FF77}"/>
+                <a16:creationId xmlns:a16="http://schemas.microsoft.com/office/drawing/2014/main" id="{AD6448E6-0EFB-266E-7A4C-22D47B4B88F9}"/>
               </a:ext>
             </a:extLst>
           </p:cNvPr>
@@ -2139,7 +2137,7 @@
           <a:bodyPr/>
           <a:lstStyle/>
           <a:p>
-            <a:fld id="{47D8C3AA-9817-4BD1-8355-5466953FF7E7}" type="slidenum">
+            <a:fld id="{F3F25716-C9CD-4922-9EEA-B1CBFD816F36}" type="slidenum">
               <a:rPr lang="es-EC" smtClean="0"/>
               <a:t>‹Nº›</a:t>
             </a:fld>
@@ -2150,7 +2148,7 @@
     </p:spTree>
     <p:extLst>
       <p:ext uri="{BB962C8B-B14F-4D97-AF65-F5344CB8AC3E}">
-        <p14:creationId xmlns:p14="http://schemas.microsoft.com/office/powerpoint/2010/main" val="4045163141"/>
+        <p14:creationId xmlns:p14="http://schemas.microsoft.com/office/powerpoint/2010/main" val="2525091768"/>
       </p:ext>
     </p:extLst>
   </p:cSld>
@@ -2182,7 +2180,7 @@
           <p:cNvPr id="2" name="Título 1">
             <a:extLst>
               <a:ext uri="{FF2B5EF4-FFF2-40B4-BE49-F238E27FC236}">
-                <a16:creationId xmlns:a16="http://schemas.microsoft.com/office/drawing/2014/main" id="{3C457AB0-EB2B-E289-FE66-ABFDF4B48803}"/>
+                <a16:creationId xmlns:a16="http://schemas.microsoft.com/office/drawing/2014/main" id="{58B9C435-E6E9-D164-9BFD-BAD5EED06B87}"/>
               </a:ext>
             </a:extLst>
           </p:cNvPr>
@@ -2220,7 +2218,7 @@
           <p:cNvPr id="3" name="Marcador de contenido 2">
             <a:extLst>
               <a:ext uri="{FF2B5EF4-FFF2-40B4-BE49-F238E27FC236}">
-                <a16:creationId xmlns:a16="http://schemas.microsoft.com/office/drawing/2014/main" id="{9B18DE5B-53C7-BDD9-C661-83BD2D9D9F85}"/>
+                <a16:creationId xmlns:a16="http://schemas.microsoft.com/office/drawing/2014/main" id="{EAC2A830-5733-4313-5F61-84B306CE3418}"/>
               </a:ext>
             </a:extLst>
           </p:cNvPr>
@@ -2311,7 +2309,7 @@
           <p:cNvPr id="4" name="Marcador de texto 3">
             <a:extLst>
               <a:ext uri="{FF2B5EF4-FFF2-40B4-BE49-F238E27FC236}">
-                <a16:creationId xmlns:a16="http://schemas.microsoft.com/office/drawing/2014/main" id="{6E769172-DA29-DDC2-A4AB-1B2687AA8F4E}"/>
+                <a16:creationId xmlns:a16="http://schemas.microsoft.com/office/drawing/2014/main" id="{BEA369D3-FF62-03B8-891F-7933406DE21E}"/>
               </a:ext>
             </a:extLst>
           </p:cNvPr>
@@ -2382,7 +2380,7 @@
           <p:cNvPr id="5" name="Marcador de fecha 4">
             <a:extLst>
               <a:ext uri="{FF2B5EF4-FFF2-40B4-BE49-F238E27FC236}">
-                <a16:creationId xmlns:a16="http://schemas.microsoft.com/office/drawing/2014/main" id="{4C0B6284-FF61-DF45-C9A4-3BAFA5634EF4}"/>
+                <a16:creationId xmlns:a16="http://schemas.microsoft.com/office/drawing/2014/main" id="{4D0E02FB-87DA-DE2C-743F-CA5D8D81099C}"/>
               </a:ext>
             </a:extLst>
           </p:cNvPr>
@@ -2398,7 +2396,7 @@
           <a:bodyPr/>
           <a:lstStyle/>
           <a:p>
-            <a:fld id="{17539879-592C-4C4D-985F-1D57C6FF2592}" type="datetimeFigureOut">
+            <a:fld id="{2F6522CC-1677-4567-9825-52B108A01684}" type="datetimeFigureOut">
               <a:rPr lang="es-EC" smtClean="0"/>
               <a:t>8/10/2026</a:t>
             </a:fld>
@@ -2411,7 +2409,7 @@
           <p:cNvPr id="6" name="Marcador de pie de página 5">
             <a:extLst>
               <a:ext uri="{FF2B5EF4-FFF2-40B4-BE49-F238E27FC236}">
-                <a16:creationId xmlns:a16="http://schemas.microsoft.com/office/drawing/2014/main" id="{D4FDA8A7-5674-E2F5-04ED-9CF1B68E8BB8}"/>
+                <a16:creationId xmlns:a16="http://schemas.microsoft.com/office/drawing/2014/main" id="{FC07282D-D580-FDCD-F314-FBD393DA7EA9}"/>
               </a:ext>
             </a:extLst>
           </p:cNvPr>
@@ -2436,7 +2434,7 @@
           <p:cNvPr id="7" name="Marcador de número de diapositiva 6">
             <a:extLst>
               <a:ext uri="{FF2B5EF4-FFF2-40B4-BE49-F238E27FC236}">
-                <a16:creationId xmlns:a16="http://schemas.microsoft.com/office/drawing/2014/main" id="{7E87A5DC-9C98-E135-AF0B-594CED3D5835}"/>
+                <a16:creationId xmlns:a16="http://schemas.microsoft.com/office/drawing/2014/main" id="{CD711A0C-0355-D756-1DED-21F50FC20EB0}"/>
               </a:ext>
             </a:extLst>
           </p:cNvPr>
@@ -2452,7 +2450,7 @@
           <a:bodyPr/>
           <a:lstStyle/>
           <a:p>
-            <a:fld id="{47D8C3AA-9817-4BD1-8355-5466953FF7E7}" type="slidenum">
+            <a:fld id="{F3F25716-C9CD-4922-9EEA-B1CBFD816F36}" type="slidenum">
               <a:rPr lang="es-EC" smtClean="0"/>
               <a:t>‹Nº›</a:t>
             </a:fld>
@@ -2463,7 +2461,7 @@
     </p:spTree>
     <p:extLst>
       <p:ext uri="{BB962C8B-B14F-4D97-AF65-F5344CB8AC3E}">
-        <p14:creationId xmlns:p14="http://schemas.microsoft.com/office/powerpoint/2010/main" val="1514038169"/>
+        <p14:creationId xmlns:p14="http://schemas.microsoft.com/office/powerpoint/2010/main" val="3977824499"/>
       </p:ext>
     </p:extLst>
   </p:cSld>
@@ -2495,7 +2493,7 @@
           <p:cNvPr id="2" name="Título 1">
             <a:extLst>
               <a:ext uri="{FF2B5EF4-FFF2-40B4-BE49-F238E27FC236}">
-                <a16:creationId xmlns:a16="http://schemas.microsoft.com/office/drawing/2014/main" id="{3B6E16ED-6140-343E-50C9-0CAEA908ED5C}"/>
+                <a16:creationId xmlns:a16="http://schemas.microsoft.com/office/drawing/2014/main" id="{DA7E27DF-283F-923B-3DF3-2EA3F1D3C0A4}"/>
               </a:ext>
             </a:extLst>
           </p:cNvPr>
@@ -2533,7 +2531,7 @@
           <p:cNvPr id="3" name="Marcador de posición de imagen 2">
             <a:extLst>
               <a:ext uri="{FF2B5EF4-FFF2-40B4-BE49-F238E27FC236}">
-                <a16:creationId xmlns:a16="http://schemas.microsoft.com/office/drawing/2014/main" id="{BCFC1DAC-8123-B42A-9885-A19F27E4F314}"/>
+                <a16:creationId xmlns:a16="http://schemas.microsoft.com/office/drawing/2014/main" id="{8A7BBB3F-E5AE-883E-A595-62A80156AA68}"/>
               </a:ext>
             </a:extLst>
           </p:cNvPr>
@@ -2600,7 +2598,7 @@
           <p:cNvPr id="4" name="Marcador de texto 3">
             <a:extLst>
               <a:ext uri="{FF2B5EF4-FFF2-40B4-BE49-F238E27FC236}">
-                <a16:creationId xmlns:a16="http://schemas.microsoft.com/office/drawing/2014/main" id="{1CF91BA9-73EF-FE99-E94E-CA5D48990421}"/>
+                <a16:creationId xmlns:a16="http://schemas.microsoft.com/office/drawing/2014/main" id="{AAAD0FDF-AB72-4FF3-5492-30904899C031}"/>
               </a:ext>
             </a:extLst>
           </p:cNvPr>
@@ -2671,7 +2669,7 @@
           <p:cNvPr id="5" name="Marcador de fecha 4">
             <a:extLst>
               <a:ext uri="{FF2B5EF4-FFF2-40B4-BE49-F238E27FC236}">
-                <a16:creationId xmlns:a16="http://schemas.microsoft.com/office/drawing/2014/main" id="{45E29DFE-4F8C-5B0D-1996-5E6A30A0BABF}"/>
+                <a16:creationId xmlns:a16="http://schemas.microsoft.com/office/drawing/2014/main" id="{A3DD8369-BEFD-38EC-1465-5019A56CAF23}"/>
               </a:ext>
             </a:extLst>
           </p:cNvPr>
@@ -2687,7 +2685,7 @@
           <a:bodyPr/>
           <a:lstStyle/>
           <a:p>
-            <a:fld id="{17539879-592C-4C4D-985F-1D57C6FF2592}" type="datetimeFigureOut">
+            <a:fld id="{2F6522CC-1677-4567-9825-52B108A01684}" type="datetimeFigureOut">
               <a:rPr lang="es-EC" smtClean="0"/>
               <a:t>8/10/2026</a:t>
             </a:fld>
@@ -2700,7 +2698,7 @@
           <p:cNvPr id="6" name="Marcador de pie de página 5">
             <a:extLst>
               <a:ext uri="{FF2B5EF4-FFF2-40B4-BE49-F238E27FC236}">
-                <a16:creationId xmlns:a16="http://schemas.microsoft.com/office/drawing/2014/main" id="{B9F14871-8A3B-60DA-DB21-F2BF9C99AAAC}"/>
+                <a16:creationId xmlns:a16="http://schemas.microsoft.com/office/drawing/2014/main" id="{E08DA27D-EA23-72C3-55A7-FA25CB03C7A0}"/>
               </a:ext>
             </a:extLst>
           </p:cNvPr>
@@ -2725,7 +2723,7 @@
           <p:cNvPr id="7" name="Marcador de número de diapositiva 6">
             <a:extLst>
               <a:ext uri="{FF2B5EF4-FFF2-40B4-BE49-F238E27FC236}">
-                <a16:creationId xmlns:a16="http://schemas.microsoft.com/office/drawing/2014/main" id="{AE9EAE86-CE83-B4D8-A720-9F03142AA298}"/>
+                <a16:creationId xmlns:a16="http://schemas.microsoft.com/office/drawing/2014/main" id="{5BA5BC25-10DD-6060-5D72-FEA3EDA86B7D}"/>
               </a:ext>
             </a:extLst>
           </p:cNvPr>
@@ -2741,7 +2739,7 @@
           <a:bodyPr/>
           <a:lstStyle/>
           <a:p>
-            <a:fld id="{47D8C3AA-9817-4BD1-8355-5466953FF7E7}" type="slidenum">
+            <a:fld id="{F3F25716-C9CD-4922-9EEA-B1CBFD816F36}" type="slidenum">
               <a:rPr lang="es-EC" smtClean="0"/>
               <a:t>‹Nº›</a:t>
             </a:fld>
@@ -2752,7 +2750,7 @@
     </p:spTree>
     <p:extLst>
       <p:ext uri="{BB962C8B-B14F-4D97-AF65-F5344CB8AC3E}">
-        <p14:creationId xmlns:p14="http://schemas.microsoft.com/office/powerpoint/2010/main" val="1160159641"/>
+        <p14:creationId xmlns:p14="http://schemas.microsoft.com/office/powerpoint/2010/main" val="622885322"/>
       </p:ext>
     </p:extLst>
   </p:cSld>
@@ -2789,7 +2787,7 @@
           <p:cNvPr id="2" name="Marcador de título 1">
             <a:extLst>
               <a:ext uri="{FF2B5EF4-FFF2-40B4-BE49-F238E27FC236}">
-                <a16:creationId xmlns:a16="http://schemas.microsoft.com/office/drawing/2014/main" id="{F41D44E1-9A19-7819-BF08-6F4A02675176}"/>
+                <a16:creationId xmlns:a16="http://schemas.microsoft.com/office/drawing/2014/main" id="{2FC07939-265E-C67D-4289-48CF2E2EDE91}"/>
               </a:ext>
             </a:extLst>
           </p:cNvPr>
@@ -2828,7 +2826,7 @@
           <p:cNvPr id="3" name="Marcador de texto 2">
             <a:extLst>
               <a:ext uri="{FF2B5EF4-FFF2-40B4-BE49-F238E27FC236}">
-                <a16:creationId xmlns:a16="http://schemas.microsoft.com/office/drawing/2014/main" id="{4BE88AF7-325C-2C7C-EFFF-370CE2A9BEB4}"/>
+                <a16:creationId xmlns:a16="http://schemas.microsoft.com/office/drawing/2014/main" id="{B2E61F7A-7A7C-A8AB-0519-C94ED8DE0636}"/>
               </a:ext>
             </a:extLst>
           </p:cNvPr>
@@ -2896,7 +2894,7 @@
           <p:cNvPr id="4" name="Marcador de fecha 3">
             <a:extLst>
               <a:ext uri="{FF2B5EF4-FFF2-40B4-BE49-F238E27FC236}">
-                <a16:creationId xmlns:a16="http://schemas.microsoft.com/office/drawing/2014/main" id="{F4F9FD51-7A32-2873-C508-68DACA922F41}"/>
+                <a16:creationId xmlns:a16="http://schemas.microsoft.com/office/drawing/2014/main" id="{D5852FE3-0860-FE55-DE3B-A85F03629E85}"/>
               </a:ext>
             </a:extLst>
           </p:cNvPr>
@@ -2930,7 +2928,7 @@
             </a:lvl1pPr>
           </a:lstStyle>
           <a:p>
-            <a:fld id="{17539879-592C-4C4D-985F-1D57C6FF2592}" type="datetimeFigureOut">
+            <a:fld id="{2F6522CC-1677-4567-9825-52B108A01684}" type="datetimeFigureOut">
               <a:rPr lang="es-EC" smtClean="0"/>
               <a:t>8/10/2026</a:t>
             </a:fld>
@@ -2943,7 +2941,7 @@
           <p:cNvPr id="5" name="Marcador de pie de página 4">
             <a:extLst>
               <a:ext uri="{FF2B5EF4-FFF2-40B4-BE49-F238E27FC236}">
-                <a16:creationId xmlns:a16="http://schemas.microsoft.com/office/drawing/2014/main" id="{76198120-B92F-C176-97B4-8FCD51D23D36}"/>
+                <a16:creationId xmlns:a16="http://schemas.microsoft.com/office/drawing/2014/main" id="{1AA1468F-A94A-4D2E-AB9C-13B54AFB2C1E}"/>
               </a:ext>
             </a:extLst>
           </p:cNvPr>
@@ -2986,7 +2984,7 @@
           <p:cNvPr id="6" name="Marcador de número de diapositiva 5">
             <a:extLst>
               <a:ext uri="{FF2B5EF4-FFF2-40B4-BE49-F238E27FC236}">
-                <a16:creationId xmlns:a16="http://schemas.microsoft.com/office/drawing/2014/main" id="{382799AC-6ABB-EFD8-DC63-ADBC52E42A9E}"/>
+                <a16:creationId xmlns:a16="http://schemas.microsoft.com/office/drawing/2014/main" id="{B949342C-0A0B-3535-AB60-41A15DB548E5}"/>
               </a:ext>
             </a:extLst>
           </p:cNvPr>
@@ -3020,7 +3018,7 @@
             </a:lvl1pPr>
           </a:lstStyle>
           <a:p>
-            <a:fld id="{47D8C3AA-9817-4BD1-8355-5466953FF7E7}" type="slidenum">
+            <a:fld id="{F3F25716-C9CD-4922-9EEA-B1CBFD816F36}" type="slidenum">
               <a:rPr lang="es-EC" smtClean="0"/>
               <a:t>‹Nº›</a:t>
             </a:fld>
@@ -3031,7 +3029,7 @@
     </p:spTree>
     <p:extLst>
       <p:ext uri="{BB962C8B-B14F-4D97-AF65-F5344CB8AC3E}">
-        <p14:creationId xmlns:p14="http://schemas.microsoft.com/office/powerpoint/2010/main" val="877624662"/>
+        <p14:creationId xmlns:p14="http://schemas.microsoft.com/office/powerpoint/2010/main" val="4256732197"/>
       </p:ext>
     </p:extLst>
   </p:cSld>
@@ -3354,7 +3352,7 @@
           <p:cNvPr id="2" name="Rectángulo 1">
             <a:extLst>
               <a:ext uri="{FF2B5EF4-FFF2-40B4-BE49-F238E27FC236}">
-                <a16:creationId xmlns:a16="http://schemas.microsoft.com/office/drawing/2014/main" id="{B2B3063F-C5D6-5D74-2BB7-F4BC350E41F3}"/>
+                <a16:creationId xmlns:a16="http://schemas.microsoft.com/office/drawing/2014/main" id="{9A799B5B-D17B-B220-8849-18E9DCCD8D17}"/>
               </a:ext>
             </a:extLst>
           </p:cNvPr>
@@ -3409,7 +3407,7 @@
           <p:cNvPr id="3" name="Rectángulo 2">
             <a:extLst>
               <a:ext uri="{FF2B5EF4-FFF2-40B4-BE49-F238E27FC236}">
-                <a16:creationId xmlns:a16="http://schemas.microsoft.com/office/drawing/2014/main" id="{D7F2682E-04C6-0CB3-CC5C-B00D6B6AB8F7}"/>
+                <a16:creationId xmlns:a16="http://schemas.microsoft.com/office/drawing/2014/main" id="{2D1D39EE-8624-4F20-1954-F1860858DBE0}"/>
               </a:ext>
             </a:extLst>
           </p:cNvPr>
@@ -3418,8 +3416,8 @@
         </p:nvSpPr>
         <p:spPr>
           <a:xfrm>
-            <a:off x="762000" y="1778000"/>
-            <a:ext cx="76200" cy="2286000"/>
+            <a:off x="889000" y="1778000"/>
+            <a:ext cx="76200" cy="2159000"/>
           </a:xfrm>
           <a:prstGeom prst="rect">
             <a:avLst/>
@@ -3464,7 +3462,7 @@
           <p:cNvPr id="4" name="CuadroTexto 3">
             <a:extLst>
               <a:ext uri="{FF2B5EF4-FFF2-40B4-BE49-F238E27FC236}">
-                <a16:creationId xmlns:a16="http://schemas.microsoft.com/office/drawing/2014/main" id="{D83DD823-6F7B-F53E-4471-055E075C77AE}"/>
+                <a16:creationId xmlns:a16="http://schemas.microsoft.com/office/drawing/2014/main" id="{A7A94858-7DBD-E323-E753-E50539D29CBA}"/>
               </a:ext>
             </a:extLst>
           </p:cNvPr>
@@ -3473,7 +3471,7 @@
         </p:nvSpPr>
         <p:spPr>
           <a:xfrm>
-            <a:off x="1016000" y="1651000"/>
+            <a:off x="1143000" y="1651000"/>
             <a:ext cx="10160000" cy="892552"/>
           </a:xfrm>
           <a:prstGeom prst="rect">
@@ -3504,7 +3502,7 @@
           <p:cNvPr id="5" name="CuadroTexto 4">
             <a:extLst>
               <a:ext uri="{FF2B5EF4-FFF2-40B4-BE49-F238E27FC236}">
-                <a16:creationId xmlns:a16="http://schemas.microsoft.com/office/drawing/2014/main" id="{AE2D457F-1704-2B9A-D312-03D6B69143A9}"/>
+                <a16:creationId xmlns:a16="http://schemas.microsoft.com/office/drawing/2014/main" id="{1697DF09-C770-DFC3-D652-630C53536A2D}"/>
               </a:ext>
             </a:extLst>
           </p:cNvPr>
@@ -3513,7 +3511,7 @@
         </p:nvSpPr>
         <p:spPr>
           <a:xfrm>
-            <a:off x="1079500" y="2794000"/>
+            <a:off x="1206500" y="2794000"/>
             <a:ext cx="10160000" cy="400110"/>
           </a:xfrm>
           <a:prstGeom prst="rect">
@@ -3550,7 +3548,7 @@
           <p:cNvPr id="6" name="CuadroTexto 5">
             <a:extLst>
               <a:ext uri="{FF2B5EF4-FFF2-40B4-BE49-F238E27FC236}">
-                <a16:creationId xmlns:a16="http://schemas.microsoft.com/office/drawing/2014/main" id="{E480B91F-2A96-19CF-6D05-190240326C7F}"/>
+                <a16:creationId xmlns:a16="http://schemas.microsoft.com/office/drawing/2014/main" id="{8F5E085C-02A9-11D4-B54D-E38EAA16264A}"/>
               </a:ext>
             </a:extLst>
           </p:cNvPr>
@@ -3559,8 +3557,8 @@
         </p:nvSpPr>
         <p:spPr>
           <a:xfrm>
-            <a:off x="1079500" y="4191000"/>
-            <a:ext cx="10160000" cy="784830"/>
+            <a:off x="1206500" y="4064000"/>
+            <a:ext cx="10160000" cy="523220"/>
           </a:xfrm>
           <a:prstGeom prst="rect">
             <a:avLst/>
@@ -3574,7 +3572,7 @@
           <a:lstStyle/>
           <a:p>
             <a:r>
-              <a:rPr lang="es-MX" sz="1500">
+              <a:rPr lang="es-MX" sz="1400">
                 <a:solidFill>
                   <a:srgbClr val="FFFFFF"/>
                 </a:solidFill>
@@ -3585,26 +3583,15 @@
           </a:p>
           <a:p>
             <a:r>
-              <a:rPr lang="es-MX" sz="1500">
+              <a:rPr lang="es-MX" sz="1400">
                 <a:solidFill>
                   <a:srgbClr val="FFFFFF"/>
                 </a:solidFill>
                 <a:latin typeface="Calibri" panose="020F0502020204030204" pitchFamily="34" charset="0"/>
               </a:rPr>
-              <a:t>Reto: Farmaenlace y BYD</a:t>
-            </a:r>
-          </a:p>
-          <a:p>
-            <a:r>
-              <a:rPr lang="es-MX" sz="1500">
-                <a:solidFill>
-                  <a:srgbClr val="FFFFFF"/>
-                </a:solidFill>
-                <a:latin typeface="Calibri" panose="020F0502020204030204" pitchFamily="34" charset="0"/>
-              </a:rPr>
-              <a:t>Equipo: Los 21 Pilotos</a:t>
-            </a:r>
-            <a:endParaRPr lang="es-EC" sz="1500">
+              <a:t>Reto: Farmaenlace y BYD  |  Equipo: Los 21 Pilotos</a:t>
+            </a:r>
+            <a:endParaRPr lang="es-EC" sz="1400">
               <a:solidFill>
                 <a:srgbClr val="FFFFFF"/>
               </a:solidFill>
@@ -3616,7 +3603,7 @@
     </p:spTree>
     <p:extLst>
       <p:ext uri="{BB962C8B-B14F-4D97-AF65-F5344CB8AC3E}">
-        <p14:creationId xmlns:p14="http://schemas.microsoft.com/office/powerpoint/2010/main" val="3441677816"/>
+        <p14:creationId xmlns:p14="http://schemas.microsoft.com/office/powerpoint/2010/main" val="2817896422"/>
       </p:ext>
     </p:extLst>
   </p:cSld>
@@ -3648,7 +3635,7 @@
           <p:cNvPr id="2" name="Rectángulo 1">
             <a:extLst>
               <a:ext uri="{FF2B5EF4-FFF2-40B4-BE49-F238E27FC236}">
-                <a16:creationId xmlns:a16="http://schemas.microsoft.com/office/drawing/2014/main" id="{E855484C-20A6-FACC-7BF2-7CCE4123020A}"/>
+                <a16:creationId xmlns:a16="http://schemas.microsoft.com/office/drawing/2014/main" id="{4FD99BA4-6DD9-695B-2AE6-2EDF2904FE18}"/>
               </a:ext>
             </a:extLst>
           </p:cNvPr>
@@ -3703,7 +3690,7 @@
           <p:cNvPr id="3" name="Rectángulo 2">
             <a:extLst>
               <a:ext uri="{FF2B5EF4-FFF2-40B4-BE49-F238E27FC236}">
-                <a16:creationId xmlns:a16="http://schemas.microsoft.com/office/drawing/2014/main" id="{6F8CFFC4-77FC-CC17-E3F5-F680AA3F622F}"/>
+                <a16:creationId xmlns:a16="http://schemas.microsoft.com/office/drawing/2014/main" id="{3EB462A2-EC89-3D4E-E632-9ABCF601F939}"/>
               </a:ext>
             </a:extLst>
           </p:cNvPr>
@@ -3758,7 +3745,7 @@
           <p:cNvPr id="4" name="CuadroTexto 3">
             <a:extLst>
               <a:ext uri="{FF2B5EF4-FFF2-40B4-BE49-F238E27FC236}">
-                <a16:creationId xmlns:a16="http://schemas.microsoft.com/office/drawing/2014/main" id="{A30A5C28-17E0-122B-ADC6-C9D6F1D81566}"/>
+                <a16:creationId xmlns:a16="http://schemas.microsoft.com/office/drawing/2014/main" id="{663CBB70-09D0-A5BC-011D-A8A8DD92501A}"/>
               </a:ext>
             </a:extLst>
           </p:cNvPr>
@@ -3767,7 +3754,7 @@
         </p:nvSpPr>
         <p:spPr>
           <a:xfrm>
-            <a:off x="762000" y="444500"/>
+            <a:off x="762000" y="381000"/>
             <a:ext cx="10668000" cy="492443"/>
           </a:xfrm>
           <a:prstGeom prst="rect">
@@ -3798,7 +3785,7 @@
           <p:cNvPr id="5" name="CuadroTexto 4">
             <a:extLst>
               <a:ext uri="{FF2B5EF4-FFF2-40B4-BE49-F238E27FC236}">
-                <a16:creationId xmlns:a16="http://schemas.microsoft.com/office/drawing/2014/main" id="{2F12F4CE-4793-124B-7539-96E5F2D91B49}"/>
+                <a16:creationId xmlns:a16="http://schemas.microsoft.com/office/drawing/2014/main" id="{D16E513A-D8E3-CE0D-4547-C3E1AEB3A2DE}"/>
               </a:ext>
             </a:extLst>
           </p:cNvPr>
@@ -3807,8 +3794,8 @@
         </p:nvSpPr>
         <p:spPr>
           <a:xfrm>
-            <a:off x="762000" y="1016000"/>
-            <a:ext cx="10668000" cy="307777"/>
+            <a:off x="762000" y="952500"/>
+            <a:ext cx="10668000" cy="292388"/>
           </a:xfrm>
           <a:prstGeom prst="rect">
             <a:avLst/>
@@ -3822,15 +3809,15 @@
           <a:lstStyle/>
           <a:p>
             <a:r>
-              <a:rPr lang="es-MX" sz="1400">
+              <a:rPr lang="es-MX" sz="1300">
                 <a:solidFill>
                   <a:srgbClr val="64748B"/>
                 </a:solidFill>
                 <a:latin typeface="Calibri" panose="020F0502020204030204" pitchFamily="34" charset="0"/>
               </a:rPr>
-              <a:t>Una realidad que toca a nuestras familias y a miles de adultos mayores todos los dias</a:t>
-            </a:r>
-            <a:endParaRPr lang="es-EC" sz="1400">
+              <a:t>La realidad humana detras de la percha vacia y el costo de la fuga de clientes</a:t>
+            </a:r>
+            <a:endParaRPr lang="es-EC" sz="1300">
               <a:solidFill>
                 <a:srgbClr val="64748B"/>
               </a:solidFill>
@@ -3844,7 +3831,7 @@
           <p:cNvPr id="6" name="CuadroTexto 5">
             <a:extLst>
               <a:ext uri="{FF2B5EF4-FFF2-40B4-BE49-F238E27FC236}">
-                <a16:creationId xmlns:a16="http://schemas.microsoft.com/office/drawing/2014/main" id="{86AAFCDC-CC6E-E9CB-E387-7AF52C297251}"/>
+                <a16:creationId xmlns:a16="http://schemas.microsoft.com/office/drawing/2014/main" id="{90324ADF-E2D0-79FE-2C3E-B36B1CB44BFA}"/>
               </a:ext>
             </a:extLst>
           </p:cNvPr>
@@ -3853,7 +3840,7 @@
         </p:nvSpPr>
         <p:spPr>
           <a:xfrm>
-            <a:off x="762000" y="6350000"/>
+            <a:off x="762000" y="6413500"/>
             <a:ext cx="10668000" cy="246221"/>
           </a:xfrm>
           <a:prstGeom prst="rect">
@@ -3885,34 +3872,80 @@
           </a:p>
         </p:txBody>
       </p:sp>
-      <p:sp>
-        <p:nvSpPr>
-          <p:cNvPr id="7" name="Rectángulo 6">
-            <a:extLst>
-              <a:ext uri="{FF2B5EF4-FFF2-40B4-BE49-F238E27FC236}">
-                <a16:creationId xmlns:a16="http://schemas.microsoft.com/office/drawing/2014/main" id="{3250CA96-1A62-ED6F-A234-31A5122236C8}"/>
-              </a:ext>
-            </a:extLst>
-          </p:cNvPr>
-          <p:cNvSpPr/>
+      <p:pic>
+        <p:nvPicPr>
+          <p:cNvPr id="8" name="Imagen 7">
+            <a:extLst>
+              <a:ext uri="{FF2B5EF4-FFF2-40B4-BE49-F238E27FC236}">
+                <a16:creationId xmlns:a16="http://schemas.microsoft.com/office/drawing/2014/main" id="{91C44C72-0598-AFF3-9DFB-FA70E741DB7B}"/>
+              </a:ext>
+            </a:extLst>
+          </p:cNvPr>
+          <p:cNvPicPr>
+            <a:picLocks/>
+          </p:cNvPicPr>
           <p:nvPr/>
-        </p:nvSpPr>
-        <p:spPr>
-          <a:xfrm>
-            <a:off x="762000" y="1651000"/>
-            <a:ext cx="5207000" cy="4318000"/>
+        </p:nvPicPr>
+        <p:blipFill>
+          <a:blip r:embed="rId2">
+            <a:extLst>
+              <a:ext uri="{28A0092B-C50C-407E-A947-70E740481C1C}">
+                <a14:useLocalDpi xmlns:a14="http://schemas.microsoft.com/office/drawing/2010/main" val="0"/>
+              </a:ext>
+            </a:extLst>
+          </a:blip>
+          <a:stretch>
+            <a:fillRect/>
+          </a:stretch>
+        </p:blipFill>
+        <p:spPr>
+          <a:xfrm>
+            <a:off x="762000" y="1524000"/>
+            <a:ext cx="4572000" cy="3429000"/>
           </a:xfrm>
           <a:prstGeom prst="rect">
             <a:avLst/>
           </a:prstGeom>
-          <a:solidFill>
-            <a:srgbClr val="FFFFFF"/>
-          </a:solidFill>
-          <a:ln w="19050">
+        </p:spPr>
+      </p:pic>
+      <p:sp>
+        <p:nvSpPr>
+          <p:cNvPr id="9" name="Rectángulo 8">
+            <a:extLst>
+              <a:ext uri="{FF2B5EF4-FFF2-40B4-BE49-F238E27FC236}">
+                <a16:creationId xmlns:a16="http://schemas.microsoft.com/office/drawing/2014/main" id="{8D321282-BB29-5577-4AE0-BCCBFFE86833}"/>
+              </a:ext>
+            </a:extLst>
+          </p:cNvPr>
+          <p:cNvSpPr/>
+          <p:nvPr/>
+        </p:nvSpPr>
+        <p:spPr>
+          <a:xfrm>
+            <a:off x="762000" y="1524000"/>
+            <a:ext cx="4572000" cy="3429000"/>
+          </a:xfrm>
+          <a:prstGeom prst="rect">
+            <a:avLst/>
+          </a:prstGeom>
+          <a:noFill/>
+          <a:ln w="25400" cap="flat" cmpd="sng" algn="ctr">
             <a:solidFill>
-              <a:srgbClr val="E2E8F0"/>
+              <a:srgbClr val="0070BA"/>
             </a:solidFill>
+            <a:prstDash val="solid"/>
+            <a:miter lim="800000"/>
           </a:ln>
+          <a:effectLst/>
+          <a:extLst>
+            <a:ext uri="{909E8E84-426E-40DD-AFC4-6F175D3DCCD1}">
+              <a14:hiddenFill xmlns:a14="http://schemas.microsoft.com/office/drawing/2010/main">
+                <a:solidFill>
+                  <a:schemeClr val="accent1"/>
+                </a:solidFill>
+              </a14:hiddenFill>
+            </a:ext>
+          </a:extLst>
         </p:spPr>
         <p:style>
           <a:lnRef idx="2">
@@ -3941,143 +3974,10 @@
       </p:sp>
       <p:sp>
         <p:nvSpPr>
-          <p:cNvPr id="8" name="CuadroTexto 7">
-            <a:extLst>
-              <a:ext uri="{FF2B5EF4-FFF2-40B4-BE49-F238E27FC236}">
-                <a16:creationId xmlns:a16="http://schemas.microsoft.com/office/drawing/2014/main" id="{5ADCA025-5F42-7DED-A155-14FCF634893F}"/>
-              </a:ext>
-            </a:extLst>
-          </p:cNvPr>
-          <p:cNvSpPr txBox="1"/>
-          <p:nvPr/>
-        </p:nvSpPr>
-        <p:spPr>
-          <a:xfrm>
-            <a:off x="1016000" y="1905000"/>
-            <a:ext cx="4699000" cy="2893100"/>
-          </a:xfrm>
-          <a:prstGeom prst="rect">
-            <a:avLst/>
-          </a:prstGeom>
-          <a:noFill/>
-        </p:spPr>
-        <p:txBody>
-          <a:bodyPr vert="horz" wrap="square" rtlCol="0">
-            <a:spAutoFit/>
-          </a:bodyPr>
-          <a:lstStyle/>
-          <a:p>
-            <a:r>
-              <a:rPr lang="es-MX" sz="1400">
-                <a:solidFill>
-                  <a:srgbClr val="1E293B"/>
-                </a:solidFill>
-                <a:latin typeface="Calibri" panose="020F0502020204030204" pitchFamily="34" charset="0"/>
-              </a:rPr>
-              <a:t>Pensemos en alguien querido:</a:t>
-            </a:r>
-          </a:p>
-          <a:p>
-            <a:endParaRPr lang="es-MX" sz="1400">
-              <a:solidFill>
-                <a:srgbClr val="1E293B"/>
-              </a:solidFill>
-              <a:latin typeface="Calibri" panose="020F0502020204030204" pitchFamily="34" charset="0"/>
-            </a:endParaRPr>
-          </a:p>
-          <a:p>
-            <a:r>
-              <a:rPr lang="es-MX" sz="1400">
-                <a:solidFill>
-                  <a:srgbClr val="1E293B"/>
-                </a:solidFill>
-                <a:latin typeface="Calibri" panose="020F0502020204030204" pitchFamily="34" charset="0"/>
-              </a:rPr>
-              <a:t>- Un padre, una madre o un abuelo que toma medicinas para la presion o dolor cronico (Losartan, Paracetamol).</a:t>
-            </a:r>
-          </a:p>
-          <a:p>
-            <a:endParaRPr lang="es-MX" sz="1400">
-              <a:solidFill>
-                <a:srgbClr val="1E293B"/>
-              </a:solidFill>
-              <a:latin typeface="Calibri" panose="020F0502020204030204" pitchFamily="34" charset="0"/>
-            </a:endParaRPr>
-          </a:p>
-          <a:p>
-            <a:r>
-              <a:rPr lang="es-MX" sz="1400">
-                <a:solidFill>
-                  <a:srgbClr val="1E293B"/>
-                </a:solidFill>
-                <a:latin typeface="Calibri" panose="020F0502020204030204" pitchFamily="34" charset="0"/>
-              </a:rPr>
-              <a:t>- Camina cuatro cuadras con esfuerzo hasta su farmacia de confianza.</a:t>
-            </a:r>
-          </a:p>
-          <a:p>
-            <a:endParaRPr lang="es-MX" sz="1400">
-              <a:solidFill>
-                <a:srgbClr val="1E293B"/>
-              </a:solidFill>
-              <a:latin typeface="Calibri" panose="020F0502020204030204" pitchFamily="34" charset="0"/>
-            </a:endParaRPr>
-          </a:p>
-          <a:p>
-            <a:r>
-              <a:rPr lang="es-MX" sz="1400">
-                <a:solidFill>
-                  <a:srgbClr val="1E293B"/>
-                </a:solidFill>
-                <a:latin typeface="Calibri" panose="020F0502020204030204" pitchFamily="34" charset="0"/>
-              </a:rPr>
-              <a:t>- Al llegar al mostrador escucha:</a:t>
-            </a:r>
-          </a:p>
-          <a:p>
-            <a:r>
-              <a:rPr lang="es-MX" sz="1400">
-                <a:solidFill>
-                  <a:srgbClr val="1E293B"/>
-                </a:solidFill>
-                <a:latin typeface="Calibri" panose="020F0502020204030204" pitchFamily="34" charset="0"/>
-              </a:rPr>
-              <a:t>  'Se nos termino; nos llega la proxima semana'.</a:t>
-            </a:r>
-          </a:p>
-          <a:p>
-            <a:endParaRPr lang="es-MX" sz="1400">
-              <a:solidFill>
-                <a:srgbClr val="1E293B"/>
-              </a:solidFill>
-              <a:latin typeface="Calibri" panose="020F0502020204030204" pitchFamily="34" charset="0"/>
-            </a:endParaRPr>
-          </a:p>
-          <a:p>
-            <a:r>
-              <a:rPr lang="es-MX" sz="1400">
-                <a:solidFill>
-                  <a:srgbClr val="1E293B"/>
-                </a:solidFill>
-                <a:latin typeface="Calibri" panose="020F0502020204030204" pitchFamily="34" charset="0"/>
-              </a:rPr>
-              <a:t>- Frustracion e incertidumbre: un paciente cronico no puede esperar.</a:t>
-            </a:r>
-            <a:endParaRPr lang="es-EC" sz="1400">
-              <a:solidFill>
-                <a:srgbClr val="1E293B"/>
-              </a:solidFill>
-              <a:latin typeface="Calibri" panose="020F0502020204030204" pitchFamily="34" charset="0"/>
-            </a:endParaRPr>
-          </a:p>
-        </p:txBody>
-      </p:sp>
-      <p:sp>
-        <p:nvSpPr>
-          <p:cNvPr id="9" name="Rectángulo 8">
-            <a:extLst>
-              <a:ext uri="{FF2B5EF4-FFF2-40B4-BE49-F238E27FC236}">
-                <a16:creationId xmlns:a16="http://schemas.microsoft.com/office/drawing/2014/main" id="{AECEE587-EC71-1207-938B-D4A919DE6E9C}"/>
+          <p:cNvPr id="10" name="Rectángulo 9">
+            <a:extLst>
+              <a:ext uri="{FF2B5EF4-FFF2-40B4-BE49-F238E27FC236}">
+                <a16:creationId xmlns:a16="http://schemas.microsoft.com/office/drawing/2014/main" id="{296BF80D-3146-A64A-07AC-B6862D9B0342}"/>
               </a:ext>
             </a:extLst>
           </p:cNvPr>
@@ -4086,8 +3986,8 @@
         </p:nvSpPr>
         <p:spPr>
           <a:xfrm>
-            <a:off x="6223000" y="1651000"/>
-            <a:ext cx="5207000" cy="4318000"/>
+            <a:off x="5715000" y="1524000"/>
+            <a:ext cx="5715000" cy="4445000"/>
           </a:xfrm>
           <a:prstGeom prst="rect">
             <a:avLst/>
@@ -4128,10 +4028,10 @@
       </p:sp>
       <p:sp>
         <p:nvSpPr>
-          <p:cNvPr id="10" name="CuadroTexto 9">
-            <a:extLst>
-              <a:ext uri="{FF2B5EF4-FFF2-40B4-BE49-F238E27FC236}">
-                <a16:creationId xmlns:a16="http://schemas.microsoft.com/office/drawing/2014/main" id="{BA3C54BD-C3F0-CD76-3C78-0B691DF805A7}"/>
+          <p:cNvPr id="11" name="CuadroTexto 10">
+            <a:extLst>
+              <a:ext uri="{FF2B5EF4-FFF2-40B4-BE49-F238E27FC236}">
+                <a16:creationId xmlns:a16="http://schemas.microsoft.com/office/drawing/2014/main" id="{3A3883B5-4025-A9FB-4A59-601CF9ED03CD}"/>
               </a:ext>
             </a:extLst>
           </p:cNvPr>
@@ -4140,8 +4040,8 @@
         </p:nvSpPr>
         <p:spPr>
           <a:xfrm>
-            <a:off x="6477000" y="1905000"/>
-            <a:ext cx="4699000" cy="2677656"/>
+            <a:off x="5969000" y="1714500"/>
+            <a:ext cx="5207000" cy="2793072"/>
           </a:xfrm>
           <a:prstGeom prst="rect">
             <a:avLst/>
@@ -4155,17 +4055,17 @@
           <a:lstStyle/>
           <a:p>
             <a:r>
-              <a:rPr lang="es-MX" sz="1400">
+              <a:rPr lang="es-MX" sz="1350">
                 <a:solidFill>
                   <a:srgbClr val="1E293B"/>
                 </a:solidFill>
                 <a:latin typeface="Calibri" panose="020F0502020204030204" pitchFamily="34" charset="0"/>
               </a:rPr>
-              <a:t>La Brecha Digital en Salud:</a:t>
-            </a:r>
-          </a:p>
-          <a:p>
-            <a:endParaRPr lang="es-MX" sz="1400">
+              <a:t>Pensemos en alguien querido:</a:t>
+            </a:r>
+          </a:p>
+          <a:p>
+            <a:endParaRPr lang="es-MX" sz="1350">
               <a:solidFill>
                 <a:srgbClr val="1E293B"/>
               </a:solidFill>
@@ -4174,17 +4074,28 @@
           </a:p>
           <a:p>
             <a:r>
-              <a:rPr lang="es-MX" sz="1400">
+              <a:rPr lang="es-MX" sz="1350">
                 <a:solidFill>
                   <a:srgbClr val="1E293B"/>
                 </a:solidFill>
                 <a:latin typeface="Calibri" panose="020F0502020204030204" pitchFamily="34" charset="0"/>
               </a:rPr>
-              <a:t>- Los adultos mayores NO navegan aplicaciones moviles complejas, carritos de compra ni pasarelas de pago.</a:t>
-            </a:r>
-          </a:p>
-          <a:p>
-            <a:endParaRPr lang="es-MX" sz="1400">
+              <a:t>- Camina a su farmacia de confianza por sus medicinas diarias de la presion o dolor (Losartan, Paracetamol).</a:t>
+            </a:r>
+          </a:p>
+          <a:p>
+            <a:r>
+              <a:rPr lang="es-MX" sz="1350">
+                <a:solidFill>
+                  <a:srgbClr val="1E293B"/>
+                </a:solidFill>
+                <a:latin typeface="Calibri" panose="020F0502020204030204" pitchFamily="34" charset="0"/>
+              </a:rPr>
+              <a:t>- La respuesta en mostrador: 'Se termino, nos llega la proxima semana'.</a:t>
+            </a:r>
+          </a:p>
+          <a:p>
+            <a:endParaRPr lang="es-MX" sz="1350">
               <a:solidFill>
                 <a:srgbClr val="1E293B"/>
               </a:solidFill>
@@ -4193,17 +4104,28 @@
           </a:p>
           <a:p>
             <a:r>
-              <a:rPr lang="es-MX" sz="1400">
+              <a:rPr lang="es-MX" sz="1350">
                 <a:solidFill>
                   <a:srgbClr val="1E293B"/>
                 </a:solidFill>
                 <a:latin typeface="Calibri" panose="020F0502020204030204" pitchFamily="34" charset="0"/>
               </a:rPr>
-              <a:t>- Su unica interfaz con la salud es el MOSTRADOR FISICO.</a:t>
-            </a:r>
-          </a:p>
-          <a:p>
-            <a:endParaRPr lang="es-MX" sz="1400">
+              <a:t>La Brecha Digital Real:</a:t>
+            </a:r>
+          </a:p>
+          <a:p>
+            <a:r>
+              <a:rPr lang="es-MX" sz="1350">
+                <a:solidFill>
+                  <a:srgbClr val="1E293B"/>
+                </a:solidFill>
+                <a:latin typeface="Calibri" panose="020F0502020204030204" pitchFamily="34" charset="0"/>
+              </a:rPr>
+              <a:t>- El adulto mayor no usa apps ni e-commerce; el 98% compra en el canal fisico presencial.</a:t>
+            </a:r>
+          </a:p>
+          <a:p>
+            <a:endParaRPr lang="es-MX" sz="1350">
               <a:solidFill>
                 <a:srgbClr val="1E293B"/>
               </a:solidFill>
@@ -4212,46 +4134,49 @@
           </a:p>
           <a:p>
             <a:r>
-              <a:rPr lang="es-MX" sz="1400">
+              <a:rPr lang="es-MX" sz="1350">
                 <a:solidFill>
                   <a:srgbClr val="1E293B"/>
                 </a:solidFill>
                 <a:latin typeface="Calibri" panose="020F0502020204030204" pitchFamily="34" charset="0"/>
               </a:rPr>
-              <a:t>- Mas del 97% de las compras farmaceuticas ocurren en el canal presencial.</a:t>
-            </a:r>
-          </a:p>
-          <a:p>
-            <a:endParaRPr lang="es-MX" sz="1400">
+              <a:t>El Costo para Farmaenlace:</a:t>
+            </a:r>
+          </a:p>
+          <a:p>
+            <a:r>
+              <a:rPr lang="es-MX" sz="1350">
+                <a:solidFill>
+                  <a:srgbClr val="1E293B"/>
+                </a:solidFill>
+                <a:latin typeface="Calibri" panose="020F0502020204030204" pitchFamily="34" charset="0"/>
+              </a:rPr>
+              <a:t>- &gt; 50% de clientes compra una sola vez (fuga a la competencia).</a:t>
+            </a:r>
+          </a:p>
+          <a:p>
+            <a:r>
+              <a:rPr lang="es-MX" sz="1350">
+                <a:solidFill>
+                  <a:srgbClr val="1E293B"/>
+                </a:solidFill>
+                <a:latin typeface="Calibri" panose="020F0502020204030204" pitchFamily="34" charset="0"/>
+              </a:rPr>
+              <a:t>- Se destruye el Valor de Vida (LTV) del paciente cronico.</a:t>
+            </a:r>
+            <a:endParaRPr lang="es-EC" sz="1350">
               <a:solidFill>
                 <a:srgbClr val="1E293B"/>
               </a:solidFill>
               <a:latin typeface="Calibri" panose="020F0502020204030204" pitchFamily="34" charset="0"/>
             </a:endParaRPr>
           </a:p>
-          <a:p>
-            <a:r>
-              <a:rPr lang="es-MX" sz="1400">
-                <a:solidFill>
-                  <a:srgbClr val="1E293B"/>
-                </a:solidFill>
-                <a:latin typeface="Calibri" panose="020F0502020204030204" pitchFamily="34" charset="0"/>
-              </a:rPr>
-              <a:t>- Si el producto no esta en percha, la salud del paciente queda desprotegida.</a:t>
-            </a:r>
-            <a:endParaRPr lang="es-EC" sz="1400">
-              <a:solidFill>
-                <a:srgbClr val="1E293B"/>
-              </a:solidFill>
-              <a:latin typeface="Calibri" panose="020F0502020204030204" pitchFamily="34" charset="0"/>
-            </a:endParaRPr>
-          </a:p>
         </p:txBody>
       </p:sp>
     </p:spTree>
     <p:extLst>
       <p:ext uri="{BB962C8B-B14F-4D97-AF65-F5344CB8AC3E}">
-        <p14:creationId xmlns:p14="http://schemas.microsoft.com/office/powerpoint/2010/main" val="2097955281"/>
+        <p14:creationId xmlns:p14="http://schemas.microsoft.com/office/powerpoint/2010/main" val="932409807"/>
       </p:ext>
     </p:extLst>
   </p:cSld>
@@ -4283,7 +4208,7 @@
           <p:cNvPr id="2" name="Rectángulo 1">
             <a:extLst>
               <a:ext uri="{FF2B5EF4-FFF2-40B4-BE49-F238E27FC236}">
-                <a16:creationId xmlns:a16="http://schemas.microsoft.com/office/drawing/2014/main" id="{D3DE44D5-3FF2-4E6F-7F9C-D7299C670E93}"/>
+                <a16:creationId xmlns:a16="http://schemas.microsoft.com/office/drawing/2014/main" id="{DB1FA349-6FBB-44B6-768A-F484B2A139B2}"/>
               </a:ext>
             </a:extLst>
           </p:cNvPr>
@@ -4338,7 +4263,7 @@
           <p:cNvPr id="3" name="Rectángulo 2">
             <a:extLst>
               <a:ext uri="{FF2B5EF4-FFF2-40B4-BE49-F238E27FC236}">
-                <a16:creationId xmlns:a16="http://schemas.microsoft.com/office/drawing/2014/main" id="{56DCB83C-E653-6433-8C6E-C3ABBD0A8D94}"/>
+                <a16:creationId xmlns:a16="http://schemas.microsoft.com/office/drawing/2014/main" id="{3E6C3F9B-94CE-1939-8ED8-D5DB8ED9882C}"/>
               </a:ext>
             </a:extLst>
           </p:cNvPr>
@@ -4393,7 +4318,7 @@
           <p:cNvPr id="4" name="CuadroTexto 3">
             <a:extLst>
               <a:ext uri="{FF2B5EF4-FFF2-40B4-BE49-F238E27FC236}">
-                <a16:creationId xmlns:a16="http://schemas.microsoft.com/office/drawing/2014/main" id="{5443CE80-7AE6-2B69-5FAA-F755C723642A}"/>
+                <a16:creationId xmlns:a16="http://schemas.microsoft.com/office/drawing/2014/main" id="{84D259F2-58D6-005F-8857-FAE5B2631991}"/>
               </a:ext>
             </a:extLst>
           </p:cNvPr>
@@ -4402,7 +4327,7 @@
         </p:nvSpPr>
         <p:spPr>
           <a:xfrm>
-            <a:off x="762000" y="444500"/>
+            <a:off x="762000" y="381000"/>
             <a:ext cx="10668000" cy="492443"/>
           </a:xfrm>
           <a:prstGeom prst="rect">
@@ -4423,7 +4348,7 @@
                 </a:solidFill>
                 <a:latin typeface="Calibri" panose="020F0502020204030204" pitchFamily="34" charset="0"/>
               </a:rPr>
-              <a:t>El Quiebre de Stock Destruye la Fidelizacion</a:t>
+              <a:t>Por que ocurre? Fallas del Abastecimiento Tradicional</a:t>
             </a:r>
             <a:endParaRPr lang="es-EC" sz="2600" b="1">
               <a:solidFill>
@@ -4439,7 +4364,7 @@
           <p:cNvPr id="5" name="CuadroTexto 4">
             <a:extLst>
               <a:ext uri="{FF2B5EF4-FFF2-40B4-BE49-F238E27FC236}">
-                <a16:creationId xmlns:a16="http://schemas.microsoft.com/office/drawing/2014/main" id="{ED3907D8-F24E-3258-6AAE-D2F777E43A67}"/>
+                <a16:creationId xmlns:a16="http://schemas.microsoft.com/office/drawing/2014/main" id="{B11FD4C5-9607-8F32-AEF5-36448435719D}"/>
               </a:ext>
             </a:extLst>
           </p:cNvPr>
@@ -4448,8 +4373,8 @@
         </p:nvSpPr>
         <p:spPr>
           <a:xfrm>
-            <a:off x="762000" y="1016000"/>
-            <a:ext cx="10668000" cy="307777"/>
+            <a:off x="762000" y="952500"/>
+            <a:ext cx="10668000" cy="292388"/>
           </a:xfrm>
           <a:prstGeom prst="rect">
             <a:avLst/>
@@ -4463,15 +4388,15 @@
           <a:lstStyle/>
           <a:p>
             <a:r>
-              <a:rPr lang="es-MX" sz="1400">
+              <a:rPr lang="es-MX" sz="1300">
                 <a:solidFill>
                   <a:srgbClr val="64748B"/>
                 </a:solidFill>
                 <a:latin typeface="Calibri" panose="020F0502020204030204" pitchFamily="34" charset="0"/>
               </a:rPr>
-              <a:t>El impacto financiero y la fuga de clientes en la red de farmacias</a:t>
-            </a:r>
-            <a:endParaRPr lang="es-EC" sz="1400">
+              <a:t>El bache logistico de 24-48h y el aislamiento territorial entre farmacias</a:t>
+            </a:r>
+            <a:endParaRPr lang="es-EC" sz="1300">
               <a:solidFill>
                 <a:srgbClr val="64748B"/>
               </a:solidFill>
@@ -4485,7 +4410,7 @@
           <p:cNvPr id="6" name="CuadroTexto 5">
             <a:extLst>
               <a:ext uri="{FF2B5EF4-FFF2-40B4-BE49-F238E27FC236}">
-                <a16:creationId xmlns:a16="http://schemas.microsoft.com/office/drawing/2014/main" id="{1803BEFA-7928-4786-D254-F4F6CA255D11}"/>
+                <a16:creationId xmlns:a16="http://schemas.microsoft.com/office/drawing/2014/main" id="{91B0757B-4AC8-C66C-7C62-61756AE3AD05}"/>
               </a:ext>
             </a:extLst>
           </p:cNvPr>
@@ -4494,7 +4419,7 @@
         </p:nvSpPr>
         <p:spPr>
           <a:xfrm>
-            <a:off x="762000" y="6350000"/>
+            <a:off x="762000" y="6413500"/>
             <a:ext cx="10668000" cy="246221"/>
           </a:xfrm>
           <a:prstGeom prst="rect">
@@ -4531,7 +4456,7 @@
           <p:cNvPr id="7" name="Rectángulo 6">
             <a:extLst>
               <a:ext uri="{FF2B5EF4-FFF2-40B4-BE49-F238E27FC236}">
-                <a16:creationId xmlns:a16="http://schemas.microsoft.com/office/drawing/2014/main" id="{D032018A-B91C-1418-0E87-853967040C56}"/>
+                <a16:creationId xmlns:a16="http://schemas.microsoft.com/office/drawing/2014/main" id="{60CF1D8E-BA28-58D8-8B8C-65CB92DAD893}"/>
               </a:ext>
             </a:extLst>
           </p:cNvPr>
@@ -4541,7 +4466,7 @@
         <p:spPr>
           <a:xfrm>
             <a:off x="762000" y="1651000"/>
-            <a:ext cx="3302000" cy="4318000"/>
+            <a:ext cx="3302000" cy="4191000"/>
           </a:xfrm>
           <a:prstGeom prst="rect">
             <a:avLst/>
@@ -4549,9 +4474,9 @@
           <a:solidFill>
             <a:srgbClr val="FFFFFF"/>
           </a:solidFill>
-          <a:ln w="25400">
+          <a:ln w="19050">
             <a:solidFill>
-              <a:srgbClr val="E11D48"/>
+              <a:srgbClr val="E2E8F0"/>
             </a:solidFill>
           </a:ln>
         </p:spPr>
@@ -4585,7 +4510,7 @@
           <p:cNvPr id="8" name="CuadroTexto 7">
             <a:extLst>
               <a:ext uri="{FF2B5EF4-FFF2-40B4-BE49-F238E27FC236}">
-                <a16:creationId xmlns:a16="http://schemas.microsoft.com/office/drawing/2014/main" id="{DCAC9D0C-DE43-645F-E3B0-1D319E91A23D}"/>
+                <a16:creationId xmlns:a16="http://schemas.microsoft.com/office/drawing/2014/main" id="{D30D3A2C-A113-BED5-B5E9-ECE8C9D9B044}"/>
               </a:ext>
             </a:extLst>
           </p:cNvPr>
@@ -4595,7 +4520,7 @@
         <p:spPr>
           <a:xfrm>
             <a:off x="952500" y="1841500"/>
-            <a:ext cx="2921000" cy="2092881"/>
+            <a:ext cx="2921000" cy="1661993"/>
           </a:xfrm>
           <a:prstGeom prst="rect">
             <a:avLst/>
@@ -4609,24 +4534,13 @@
           <a:lstStyle/>
           <a:p>
             <a:r>
-              <a:rPr lang="es-MX" sz="3200" b="1">
-                <a:solidFill>
-                  <a:srgbClr val="E11D48"/>
+              <a:rPr lang="es-MX" b="1">
+                <a:solidFill>
+                  <a:srgbClr val="0F2042"/>
                 </a:solidFill>
                 <a:latin typeface="Calibri" panose="020F0502020204030204" pitchFamily="34" charset="0"/>
               </a:rPr>
-              <a:t>&gt; 50%</a:t>
-            </a:r>
-          </a:p>
-          <a:p>
-            <a:r>
-              <a:rPr lang="es-MX" sz="1400">
-                <a:solidFill>
-                  <a:srgbClr val="1E293B"/>
-                </a:solidFill>
-                <a:latin typeface="Calibri" panose="020F0502020204030204" pitchFamily="34" charset="0"/>
-              </a:rPr>
-              <a:t>Clientes Unicos</a:t>
+              <a:t>1. Modelo Reactivo</a:t>
             </a:r>
           </a:p>
           <a:p>
@@ -4645,7 +4559,26 @@
                 </a:solidFill>
                 <a:latin typeface="Calibri" panose="020F0502020204030204" pitchFamily="34" charset="0"/>
               </a:rPr>
-              <a:t>En 4 de cada 5 marcas de Farmaenlace, mas de la mitad de los clientes compra una sola vez y no regresa (Dato oficial presentacion reto).</a:t>
+              <a:t>La reposicion se ordena tarde: solo cuando el estante ya esta vacio o cruzo minimos criticos.</a:t>
+            </a:r>
+          </a:p>
+          <a:p>
+            <a:endParaRPr lang="es-MX" sz="1400">
+              <a:solidFill>
+                <a:srgbClr val="1E293B"/>
+              </a:solidFill>
+              <a:latin typeface="Calibri" panose="020F0502020204030204" pitchFamily="34" charset="0"/>
+            </a:endParaRPr>
+          </a:p>
+          <a:p>
+            <a:r>
+              <a:rPr lang="es-MX" sz="1400">
+                <a:solidFill>
+                  <a:srgbClr val="1E293B"/>
+                </a:solidFill>
+                <a:latin typeface="Calibri" panose="020F0502020204030204" pitchFamily="34" charset="0"/>
+              </a:rPr>
+              <a:t>No anticipa picos de consumo local.</a:t>
             </a:r>
             <a:endParaRPr lang="es-EC" sz="1400">
               <a:solidFill>
@@ -4661,7 +4594,7 @@
           <p:cNvPr id="9" name="Rectángulo 8">
             <a:extLst>
               <a:ext uri="{FF2B5EF4-FFF2-40B4-BE49-F238E27FC236}">
-                <a16:creationId xmlns:a16="http://schemas.microsoft.com/office/drawing/2014/main" id="{A8435A2E-5674-9596-B489-90308E568E47}"/>
+                <a16:creationId xmlns:a16="http://schemas.microsoft.com/office/drawing/2014/main" id="{18B90502-D698-C3C6-5241-5E8D63974D62}"/>
               </a:ext>
             </a:extLst>
           </p:cNvPr>
@@ -4671,7 +4604,7 @@
         <p:spPr>
           <a:xfrm>
             <a:off x="4445000" y="1651000"/>
-            <a:ext cx="3302000" cy="4318000"/>
+            <a:ext cx="3302000" cy="4191000"/>
           </a:xfrm>
           <a:prstGeom prst="rect">
             <a:avLst/>
@@ -4715,7 +4648,7 @@
           <p:cNvPr id="10" name="CuadroTexto 9">
             <a:extLst>
               <a:ext uri="{FF2B5EF4-FFF2-40B4-BE49-F238E27FC236}">
-                <a16:creationId xmlns:a16="http://schemas.microsoft.com/office/drawing/2014/main" id="{3A2F029E-9119-C9E8-6BF7-F4B5ABE7DF2D}"/>
+                <a16:creationId xmlns:a16="http://schemas.microsoft.com/office/drawing/2014/main" id="{22CCCB85-B7BE-7139-8F84-49C5B2CC3DAF}"/>
               </a:ext>
             </a:extLst>
           </p:cNvPr>
@@ -4725,7 +4658,7 @@
         <p:spPr>
           <a:xfrm>
             <a:off x="4635500" y="1841500"/>
-            <a:ext cx="2921000" cy="2154436"/>
+            <a:ext cx="2921000" cy="1877437"/>
           </a:xfrm>
           <a:prstGeom prst="rect">
             <a:avLst/>
@@ -4739,24 +4672,13 @@
           <a:lstStyle/>
           <a:p>
             <a:r>
-              <a:rPr lang="es-MX" sz="2200" b="1">
-                <a:solidFill>
-                  <a:srgbClr val="0F2042"/>
+              <a:rPr lang="es-MX" b="1">
+                <a:solidFill>
+                  <a:srgbClr val="E11D48"/>
                 </a:solidFill>
                 <a:latin typeface="Calibri" panose="020F0502020204030204" pitchFamily="34" charset="0"/>
               </a:rPr>
-              <a:t>Destruccion de LTV</a:t>
-            </a:r>
-          </a:p>
-          <a:p>
-            <a:r>
-              <a:rPr lang="es-MX" sz="1400">
-                <a:solidFill>
-                  <a:srgbClr val="1E293B"/>
-                </a:solidFill>
-                <a:latin typeface="Calibri" panose="020F0502020204030204" pitchFamily="34" charset="0"/>
-              </a:rPr>
-              <a:t>Valor de Vida Perdido</a:t>
+              <a:t>2. Bache Logistico</a:t>
             </a:r>
           </a:p>
           <a:p>
@@ -4775,7 +4697,7 @@
                 </a:solidFill>
                 <a:latin typeface="Calibri" panose="020F0502020204030204" pitchFamily="34" charset="0"/>
               </a:rPr>
-              <a:t>No se pierde una venta puntual de 8 o 10 dolares.</a:t>
+              <a:t>Entre emitir la orden a bodega central, alistar el despacho y transportar el producto transcurren 24 a 48 horas.</a:t>
             </a:r>
           </a:p>
           <a:p>
@@ -4794,7 +4716,7 @@
                 </a:solidFill>
                 <a:latin typeface="Calibri" panose="020F0502020204030204" pitchFamily="34" charset="0"/>
               </a:rPr>
-              <a:t>Se pierde la recurrencia anual del paciente cronico que cruza la calle y se va a la competencia.</a:t>
+              <a:t>Ventana ciega con percha vacia.</a:t>
             </a:r>
             <a:endParaRPr lang="es-EC" sz="1400">
               <a:solidFill>
@@ -4810,7 +4732,7 @@
           <p:cNvPr id="11" name="Rectángulo 10">
             <a:extLst>
               <a:ext uri="{FF2B5EF4-FFF2-40B4-BE49-F238E27FC236}">
-                <a16:creationId xmlns:a16="http://schemas.microsoft.com/office/drawing/2014/main" id="{714FFD4B-80D1-3E55-BBD4-A770879DFECF}"/>
+                <a16:creationId xmlns:a16="http://schemas.microsoft.com/office/drawing/2014/main" id="{6CB960CF-0150-BB67-6D3F-21D14852B4FB}"/>
               </a:ext>
             </a:extLst>
           </p:cNvPr>
@@ -4820,7 +4742,7 @@
         <p:spPr>
           <a:xfrm>
             <a:off x="8128000" y="1651000"/>
-            <a:ext cx="3302000" cy="4318000"/>
+            <a:ext cx="3302000" cy="4191000"/>
           </a:xfrm>
           <a:prstGeom prst="rect">
             <a:avLst/>
@@ -4864,7 +4786,7 @@
           <p:cNvPr id="12" name="CuadroTexto 11">
             <a:extLst>
               <a:ext uri="{FF2B5EF4-FFF2-40B4-BE49-F238E27FC236}">
-                <a16:creationId xmlns:a16="http://schemas.microsoft.com/office/drawing/2014/main" id="{47316FAC-2368-9142-7AB1-E5E12A0EA4A4}"/>
+                <a16:creationId xmlns:a16="http://schemas.microsoft.com/office/drawing/2014/main" id="{2E754962-081A-1DD4-DB02-619FDB96D09C}"/>
               </a:ext>
             </a:extLst>
           </p:cNvPr>
@@ -4874,7 +4796,7 @@
         <p:spPr>
           <a:xfrm>
             <a:off x="8318500" y="1841500"/>
-            <a:ext cx="2921000" cy="2092881"/>
+            <a:ext cx="2921000" cy="1877437"/>
           </a:xfrm>
           <a:prstGeom prst="rect">
             <a:avLst/>
@@ -4888,24 +4810,13 @@
           <a:lstStyle/>
           <a:p>
             <a:r>
-              <a:rPr lang="es-MX" sz="3200" b="1">
+              <a:rPr lang="es-MX" b="1">
                 <a:solidFill>
                   <a:srgbClr val="0070BA"/>
                 </a:solidFill>
                 <a:latin typeface="Calibri" panose="020F0502020204030204" pitchFamily="34" charset="0"/>
               </a:rPr>
-              <a:t>172.000</a:t>
-            </a:r>
-          </a:p>
-          <a:p>
-            <a:r>
-              <a:rPr lang="es-MX" sz="1400">
-                <a:solidFill>
-                  <a:srgbClr val="1E293B"/>
-                </a:solidFill>
-                <a:latin typeface="Calibri" panose="020F0502020204030204" pitchFamily="34" charset="0"/>
-              </a:rPr>
-              <a:t>Transacciones Diarias</a:t>
+              <a:t>3. Aislamiento Local</a:t>
             </a:r>
           </a:p>
           <a:p>
@@ -4924,7 +4835,26 @@
                 </a:solidFill>
                 <a:latin typeface="Calibri" panose="020F0502020204030204" pitchFamily="34" charset="0"/>
               </a:rPr>
-              <a:t>Con mas de 1.400 puntos de venta a nivel nacional, un desfase en disponibilidad representa perdidas millonarias por demanda insatisfecha.</a:t>
+              <a:t>Dos farmacias en el mismo sector (a 10 minutos de distancia) no se comunican operativamente.</a:t>
+            </a:r>
+          </a:p>
+          <a:p>
+            <a:endParaRPr lang="es-MX" sz="1400">
+              <a:solidFill>
+                <a:srgbClr val="1E293B"/>
+              </a:solidFill>
+              <a:latin typeface="Calibri" panose="020F0502020204030204" pitchFamily="34" charset="0"/>
+            </a:endParaRPr>
+          </a:p>
+          <a:p>
+            <a:r>
+              <a:rPr lang="es-MX" sz="1400">
+                <a:solidFill>
+                  <a:srgbClr val="1E293B"/>
+                </a:solidFill>
+                <a:latin typeface="Calibri" panose="020F0502020204030204" pitchFamily="34" charset="0"/>
+              </a:rPr>
+              <a:t>Una sufre quiebre mientras la otra tiene excedentes en riesgo de vencer.</a:t>
             </a:r>
             <a:endParaRPr lang="es-EC" sz="1400">
               <a:solidFill>
@@ -4938,7 +4868,7 @@
     </p:spTree>
     <p:extLst>
       <p:ext uri="{BB962C8B-B14F-4D97-AF65-F5344CB8AC3E}">
-        <p14:creationId xmlns:p14="http://schemas.microsoft.com/office/powerpoint/2010/main" val="4061223178"/>
+        <p14:creationId xmlns:p14="http://schemas.microsoft.com/office/powerpoint/2010/main" val="2520685199"/>
       </p:ext>
     </p:extLst>
   </p:cSld>
@@ -4970,7 +4900,7 @@
           <p:cNvPr id="2" name="Rectángulo 1">
             <a:extLst>
               <a:ext uri="{FF2B5EF4-FFF2-40B4-BE49-F238E27FC236}">
-                <a16:creationId xmlns:a16="http://schemas.microsoft.com/office/drawing/2014/main" id="{45CCDA7A-FF37-4BE8-2E4D-CDB3C16C2D42}"/>
+                <a16:creationId xmlns:a16="http://schemas.microsoft.com/office/drawing/2014/main" id="{97D669B3-C5A6-8570-84B2-48388244C523}"/>
               </a:ext>
             </a:extLst>
           </p:cNvPr>
@@ -5025,7 +4955,7 @@
           <p:cNvPr id="3" name="Rectángulo 2">
             <a:extLst>
               <a:ext uri="{FF2B5EF4-FFF2-40B4-BE49-F238E27FC236}">
-                <a16:creationId xmlns:a16="http://schemas.microsoft.com/office/drawing/2014/main" id="{2F6BCFD2-5D7B-ED5B-2B62-1E8B16EAA7BC}"/>
+                <a16:creationId xmlns:a16="http://schemas.microsoft.com/office/drawing/2014/main" id="{E9BD9B29-5B33-7356-6CCE-77D3C4EA6F19}"/>
               </a:ext>
             </a:extLst>
           </p:cNvPr>
@@ -5080,7 +5010,7 @@
           <p:cNvPr id="4" name="CuadroTexto 3">
             <a:extLst>
               <a:ext uri="{FF2B5EF4-FFF2-40B4-BE49-F238E27FC236}">
-                <a16:creationId xmlns:a16="http://schemas.microsoft.com/office/drawing/2014/main" id="{C706CAB7-852A-6049-5532-F7B20DBF415D}"/>
+                <a16:creationId xmlns:a16="http://schemas.microsoft.com/office/drawing/2014/main" id="{2C97B78B-16D2-C49D-CD9E-9E6844316063}"/>
               </a:ext>
             </a:extLst>
           </p:cNvPr>
@@ -5089,7 +5019,7 @@
         </p:nvSpPr>
         <p:spPr>
           <a:xfrm>
-            <a:off x="762000" y="444500"/>
+            <a:off x="762000" y="381000"/>
             <a:ext cx="10668000" cy="492443"/>
           </a:xfrm>
           <a:prstGeom prst="rect">
@@ -5110,7 +5040,7 @@
                 </a:solidFill>
                 <a:latin typeface="Calibri" panose="020F0502020204030204" pitchFamily="34" charset="0"/>
               </a:rPr>
-              <a:t>Por que ocurre? Fallas del Abastecimiento Tradicional</a:t>
+              <a:t>FarmaSenal: Inteligencia Geoespacial en Vivo</a:t>
             </a:r>
             <a:endParaRPr lang="es-EC" sz="2600" b="1">
               <a:solidFill>
@@ -5126,7 +5056,7 @@
           <p:cNvPr id="5" name="CuadroTexto 4">
             <a:extLst>
               <a:ext uri="{FF2B5EF4-FFF2-40B4-BE49-F238E27FC236}">
-                <a16:creationId xmlns:a16="http://schemas.microsoft.com/office/drawing/2014/main" id="{1D59FDFF-C1C3-47F6-FD16-8BCAC352F6DF}"/>
+                <a16:creationId xmlns:a16="http://schemas.microsoft.com/office/drawing/2014/main" id="{5E38F017-102D-F69A-1598-1C761FA699AB}"/>
               </a:ext>
             </a:extLst>
           </p:cNvPr>
@@ -5135,8 +5065,8 @@
         </p:nvSpPr>
         <p:spPr>
           <a:xfrm>
-            <a:off x="762000" y="1016000"/>
-            <a:ext cx="10668000" cy="307777"/>
+            <a:off x="762000" y="952500"/>
+            <a:ext cx="10668000" cy="292388"/>
           </a:xfrm>
           <a:prstGeom prst="rect">
             <a:avLst/>
@@ -5150,15 +5080,15 @@
           <a:lstStyle/>
           <a:p>
             <a:r>
-              <a:rPr lang="es-MX" sz="1400">
+              <a:rPr lang="es-MX" sz="1300">
                 <a:solidFill>
                   <a:srgbClr val="64748B"/>
                 </a:solidFill>
                 <a:latin typeface="Calibri" panose="020F0502020204030204" pitchFamily="34" charset="0"/>
               </a:rPr>
-              <a:t>El bache de 24 a 48 horas y el aislamiento entre sucursales de proximidad</a:t>
-            </a:r>
-            <a:endParaRPr lang="es-EC" sz="1400">
+              <a:t>Deteccion preventiva y semaforo de demanda para balancear inventario en tiempo real</a:t>
+            </a:r>
+            <a:endParaRPr lang="es-EC" sz="1300">
               <a:solidFill>
                 <a:srgbClr val="64748B"/>
               </a:solidFill>
@@ -5172,7 +5102,7 @@
           <p:cNvPr id="6" name="CuadroTexto 5">
             <a:extLst>
               <a:ext uri="{FF2B5EF4-FFF2-40B4-BE49-F238E27FC236}">
-                <a16:creationId xmlns:a16="http://schemas.microsoft.com/office/drawing/2014/main" id="{A2F03FDF-FE7A-5307-36CE-CAA42597A6AC}"/>
+                <a16:creationId xmlns:a16="http://schemas.microsoft.com/office/drawing/2014/main" id="{3C155545-7C2B-84DE-46B0-17A0A745E9C4}"/>
               </a:ext>
             </a:extLst>
           </p:cNvPr>
@@ -5181,7 +5111,7 @@
         </p:nvSpPr>
         <p:spPr>
           <a:xfrm>
-            <a:off x="762000" y="6350000"/>
+            <a:off x="762000" y="6413500"/>
             <a:ext cx="10668000" cy="246221"/>
           </a:xfrm>
           <a:prstGeom prst="rect">
@@ -5218,7 +5148,7 @@
           <p:cNvPr id="7" name="Rectángulo 6">
             <a:extLst>
               <a:ext uri="{FF2B5EF4-FFF2-40B4-BE49-F238E27FC236}">
-                <a16:creationId xmlns:a16="http://schemas.microsoft.com/office/drawing/2014/main" id="{B5687C4B-271F-CDFC-F766-485EFDBA0A0A}"/>
+                <a16:creationId xmlns:a16="http://schemas.microsoft.com/office/drawing/2014/main" id="{A243AD66-8806-0C6C-13D0-E077C7B0DEC4}"/>
               </a:ext>
             </a:extLst>
           </p:cNvPr>
@@ -5227,8 +5157,8 @@
         </p:nvSpPr>
         <p:spPr>
           <a:xfrm>
-            <a:off x="762000" y="1714500"/>
-            <a:ext cx="5207000" cy="1905000"/>
+            <a:off x="762000" y="1524000"/>
+            <a:ext cx="6096000" cy="4318000"/>
           </a:xfrm>
           <a:prstGeom prst="rect">
             <a:avLst/>
@@ -5236,9 +5166,9 @@
           <a:solidFill>
             <a:srgbClr val="FFFFFF"/>
           </a:solidFill>
-          <a:ln>
+          <a:ln w="25400">
             <a:solidFill>
-              <a:srgbClr val="E2E8F0"/>
+              <a:srgbClr val="0070BA"/>
             </a:solidFill>
           </a:ln>
         </p:spPr>
@@ -5272,7 +5202,7 @@
           <p:cNvPr id="8" name="CuadroTexto 7">
             <a:extLst>
               <a:ext uri="{FF2B5EF4-FFF2-40B4-BE49-F238E27FC236}">
-                <a16:creationId xmlns:a16="http://schemas.microsoft.com/office/drawing/2014/main" id="{2CA642CE-B2EB-D5A4-1321-440FB985AFF8}"/>
+                <a16:creationId xmlns:a16="http://schemas.microsoft.com/office/drawing/2014/main" id="{F999C6D1-A57D-67A2-D590-6758F6B68CAD}"/>
               </a:ext>
             </a:extLst>
           </p:cNvPr>
@@ -5281,8 +5211,8 @@
         </p:nvSpPr>
         <p:spPr>
           <a:xfrm>
-            <a:off x="952500" y="1841500"/>
-            <a:ext cx="4826000" cy="784830"/>
+            <a:off x="1016000" y="1714500"/>
+            <a:ext cx="5588000" cy="3108543"/>
           </a:xfrm>
           <a:prstGeom prst="rect">
             <a:avLst/>
@@ -5296,32 +5226,113 @@
           <a:lstStyle/>
           <a:p>
             <a:r>
-              <a:rPr lang="es-MX" sz="1500">
+              <a:rPr lang="es-EC" sz="1400">
                 <a:solidFill>
                   <a:srgbClr val="1E293B"/>
                 </a:solidFill>
                 <a:latin typeface="Calibri" panose="020F0502020204030204" pitchFamily="34" charset="0"/>
               </a:rPr>
-              <a:t>1. Modelo Reactivo (Tarde)</a:t>
-            </a:r>
-          </a:p>
-          <a:p>
-            <a:r>
-              <a:rPr lang="es-MX" sz="1500">
-                <a:solidFill>
-                  <a:srgbClr val="1E293B"/>
-                </a:solidFill>
-                <a:latin typeface="Calibri" panose="020F0502020204030204" pitchFamily="34" charset="0"/>
-              </a:rPr>
-              <a:t>La orden de reposicion se genera unicamente cuando el stock en percha ya se agoto o cruzo minimos criticos.</a:t>
-            </a:r>
-            <a:endParaRPr lang="es-EC" sz="1500">
+              <a:t>Como funciona el motor:</a:t>
+            </a:r>
+          </a:p>
+          <a:p>
+            <a:endParaRPr lang="es-EC" sz="1400">
               <a:solidFill>
                 <a:srgbClr val="1E293B"/>
               </a:solidFill>
               <a:latin typeface="Calibri" panose="020F0502020204030204" pitchFamily="34" charset="0"/>
             </a:endParaRPr>
           </a:p>
+          <a:p>
+            <a:r>
+              <a:rPr lang="es-EC" sz="1400">
+                <a:solidFill>
+                  <a:srgbClr val="1E293B"/>
+                </a:solidFill>
+                <a:latin typeface="Calibri" panose="020F0502020204030204" pitchFamily="34" charset="0"/>
+              </a:rPr>
+              <a:t>- Ventana Movil Predictiva: Compara los ultimos 30 dias vs la linea base historica de 90 dias.</a:t>
+            </a:r>
+          </a:p>
+          <a:p>
+            <a:endParaRPr lang="es-EC" sz="1400">
+              <a:solidFill>
+                <a:srgbClr val="1E293B"/>
+              </a:solidFill>
+              <a:latin typeface="Calibri" panose="020F0502020204030204" pitchFamily="34" charset="0"/>
+            </a:endParaRPr>
+          </a:p>
+          <a:p>
+            <a:r>
+              <a:rPr lang="es-EC" sz="1400">
+                <a:solidFill>
+                  <a:srgbClr val="1E293B"/>
+                </a:solidFill>
+                <a:latin typeface="Calibri" panose="020F0502020204030204" pitchFamily="34" charset="0"/>
+              </a:rPr>
+              <a:t>- Semaforo Explicable por Sector:</a:t>
+            </a:r>
+          </a:p>
+          <a:p>
+            <a:r>
+              <a:rPr lang="es-EC" sz="1400">
+                <a:solidFill>
+                  <a:srgbClr val="1E293B"/>
+                </a:solidFill>
+                <a:latin typeface="Calibri" panose="020F0502020204030204" pitchFamily="34" charset="0"/>
+              </a:rPr>
+              <a:t>  * Amarillo: Alza observada (+50% demanda diaria).</a:t>
+            </a:r>
+          </a:p>
+          <a:p>
+            <a:r>
+              <a:rPr lang="es-EC" sz="1400">
+                <a:solidFill>
+                  <a:srgbClr val="1E293B"/>
+                </a:solidFill>
+                <a:latin typeface="Calibri" panose="020F0502020204030204" pitchFamily="34" charset="0"/>
+              </a:rPr>
+              <a:t>  * Rojo: Alza critica (+100% demanda diaria).</a:t>
+            </a:r>
+          </a:p>
+          <a:p>
+            <a:endParaRPr lang="es-EC" sz="1400">
+              <a:solidFill>
+                <a:srgbClr val="1E293B"/>
+              </a:solidFill>
+              <a:latin typeface="Calibri" panose="020F0502020204030204" pitchFamily="34" charset="0"/>
+            </a:endParaRPr>
+          </a:p>
+          <a:p>
+            <a:r>
+              <a:rPr lang="es-EC" sz="1400">
+                <a:solidFill>
+                  <a:srgbClr val="1E293B"/>
+                </a:solidFill>
+                <a:latin typeface="Calibri" panose="020F0502020204030204" pitchFamily="34" charset="0"/>
+              </a:rPr>
+              <a:t>- Filtro por Categorias Criticas: Analgesicos, Cardiovasculares y Respiratorios.</a:t>
+            </a:r>
+          </a:p>
+          <a:p>
+            <a:endParaRPr lang="es-EC" sz="1400">
+              <a:solidFill>
+                <a:srgbClr val="1E293B"/>
+              </a:solidFill>
+              <a:latin typeface="Calibri" panose="020F0502020204030204" pitchFamily="34" charset="0"/>
+            </a:endParaRPr>
+          </a:p>
+          <a:p>
+            <a:r>
+              <a:rPr lang="es-EC" sz="1400">
+                <a:solidFill>
+                  <a:srgbClr val="1E293B"/>
+                </a:solidFill>
+                <a:latin typeface="Calibri" panose="020F0502020204030204" pitchFamily="34" charset="0"/>
+              </a:rPr>
+              <a:t>- Recomendacion de Traslado: Identifica farmacias cercanas con excedente para reabastecer antes de agotar stock.</a:t>
+            </a:r>
+          </a:p>
         </p:txBody>
       </p:sp>
       <p:sp>
@@ -5329,7 +5340,7 @@
           <p:cNvPr id="9" name="Rectángulo 8">
             <a:extLst>
               <a:ext uri="{FF2B5EF4-FFF2-40B4-BE49-F238E27FC236}">
-                <a16:creationId xmlns:a16="http://schemas.microsoft.com/office/drawing/2014/main" id="{3C91F6DC-A4E5-98FB-F6D6-F711928F302C}"/>
+                <a16:creationId xmlns:a16="http://schemas.microsoft.com/office/drawing/2014/main" id="{5ADA2DAA-E8DE-28E5-A3F2-7545EEC3D64A}"/>
               </a:ext>
             </a:extLst>
           </p:cNvPr>
@@ -5338,20 +5349,34 @@
         </p:nvSpPr>
         <p:spPr>
           <a:xfrm>
-            <a:off x="6223000" y="1714500"/>
-            <a:ext cx="5207000" cy="1905000"/>
+            <a:off x="7239000" y="1524000"/>
+            <a:ext cx="4191000" cy="4318000"/>
           </a:xfrm>
           <a:prstGeom prst="rect">
             <a:avLst/>
           </a:prstGeom>
           <a:solidFill>
-            <a:srgbClr val="FFFFFF"/>
+            <a:srgbClr val="0F2042"/>
           </a:solidFill>
-          <a:ln>
-            <a:solidFill>
-              <a:srgbClr val="E2E8F0"/>
-            </a:solidFill>
+          <a:ln w="19050" cap="flat" cmpd="sng" algn="ctr">
+            <a:noFill/>
+            <a:prstDash val="solid"/>
+            <a:miter lim="800000"/>
           </a:ln>
+          <a:effectLst/>
+          <a:extLst>
+            <a:ext uri="{91240B29-F687-4F45-9708-019B960494DF}">
+              <a14:hiddenLine xmlns:a14="http://schemas.microsoft.com/office/drawing/2010/main" w="19050" cap="flat" cmpd="sng" algn="ctr">
+                <a:solidFill>
+                  <a:schemeClr val="accent1">
+                    <a:shade val="15000"/>
+                  </a:schemeClr>
+                </a:solidFill>
+                <a:prstDash val="solid"/>
+                <a:miter lim="800000"/>
+              </a14:hiddenLine>
+            </a:ext>
+          </a:extLst>
         </p:spPr>
         <p:style>
           <a:lnRef idx="2">
@@ -5383,7 +5408,7 @@
           <p:cNvPr id="10" name="CuadroTexto 9">
             <a:extLst>
               <a:ext uri="{FF2B5EF4-FFF2-40B4-BE49-F238E27FC236}">
-                <a16:creationId xmlns:a16="http://schemas.microsoft.com/office/drawing/2014/main" id="{74F75099-8334-DF87-194E-1CA1C1E65018}"/>
+                <a16:creationId xmlns:a16="http://schemas.microsoft.com/office/drawing/2014/main" id="{B0192600-D743-687C-D134-5995C2246549}"/>
               </a:ext>
             </a:extLst>
           </p:cNvPr>
@@ -5392,8 +5417,8 @@
         </p:nvSpPr>
         <p:spPr>
           <a:xfrm>
-            <a:off x="6413500" y="1841500"/>
-            <a:ext cx="4826000" cy="1015663"/>
+            <a:off x="7493000" y="1905000"/>
+            <a:ext cx="3683000" cy="2277547"/>
           </a:xfrm>
           <a:prstGeom prst="rect">
             <a:avLst/>
@@ -5407,130 +5432,38 @@
           <a:lstStyle/>
           <a:p>
             <a:r>
-              <a:rPr lang="es-MX" sz="1500">
-                <a:solidFill>
-                  <a:srgbClr val="1E293B"/>
+              <a:rPr lang="es-MX" sz="2200" b="1">
+                <a:solidFill>
+                  <a:srgbClr val="0070BA"/>
                 </a:solidFill>
                 <a:latin typeface="Calibri" panose="020F0502020204030204" pitchFamily="34" charset="0"/>
               </a:rPr>
-              <a:t>2. Bache Logistico Inevitable</a:t>
-            </a:r>
-          </a:p>
-          <a:p>
-            <a:r>
-              <a:rPr lang="es-MX" sz="1500">
-                <a:solidFill>
-                  <a:srgbClr val="1E293B"/>
-                </a:solidFill>
-                <a:latin typeface="Calibri" panose="020F0502020204030204" pitchFamily="34" charset="0"/>
-              </a:rPr>
-              <a:t>Entre emitir la orden a bodega central, alistar el despacho y transportar el producto transcurren 24 a 48 horas con percha vacia.</a:t>
-            </a:r>
-            <a:endParaRPr lang="es-EC" sz="1500">
+              <a:t>DEMO EN VIVO</a:t>
+            </a:r>
+          </a:p>
+          <a:p>
+            <a:endParaRPr lang="es-MX" sz="1500">
               <a:solidFill>
-                <a:srgbClr val="1E293B"/>
+                <a:srgbClr val="FFFFFF"/>
               </a:solidFill>
               <a:latin typeface="Calibri" panose="020F0502020204030204" pitchFamily="34" charset="0"/>
             </a:endParaRPr>
           </a:p>
-        </p:txBody>
-      </p:sp>
-      <p:sp>
-        <p:nvSpPr>
-          <p:cNvPr id="11" name="Rectángulo 10">
-            <a:extLst>
-              <a:ext uri="{FF2B5EF4-FFF2-40B4-BE49-F238E27FC236}">
-                <a16:creationId xmlns:a16="http://schemas.microsoft.com/office/drawing/2014/main" id="{8754AB19-A075-B3AA-DB20-E6B9F9BBBC4D}"/>
-              </a:ext>
-            </a:extLst>
-          </p:cNvPr>
-          <p:cNvSpPr/>
-          <p:nvPr/>
-        </p:nvSpPr>
-        <p:spPr>
-          <a:xfrm>
-            <a:off x="762000" y="3873500"/>
-            <a:ext cx="10668000" cy="2095500"/>
-          </a:xfrm>
-          <a:prstGeom prst="rect">
-            <a:avLst/>
-          </a:prstGeom>
-          <a:solidFill>
-            <a:srgbClr val="FFFFFF"/>
-          </a:solidFill>
-          <a:ln>
-            <a:solidFill>
-              <a:srgbClr val="E2E8F0"/>
-            </a:solidFill>
-          </a:ln>
-        </p:spPr>
-        <p:style>
-          <a:lnRef idx="2">
-            <a:schemeClr val="accent1">
-              <a:shade val="15000"/>
-            </a:schemeClr>
-          </a:lnRef>
-          <a:fillRef idx="1">
-            <a:schemeClr val="accent1"/>
-          </a:fillRef>
-          <a:effectRef idx="0">
-            <a:schemeClr val="accent1"/>
-          </a:effectRef>
-          <a:fontRef idx="minor">
-            <a:schemeClr val="lt1"/>
-          </a:fontRef>
-        </p:style>
-        <p:txBody>
-          <a:bodyPr rtlCol="0" anchor="ctr"/>
-          <a:lstStyle/>
-          <a:p>
-            <a:pPr algn="ctr"/>
-            <a:endParaRPr lang="es-EC"/>
-          </a:p>
-        </p:txBody>
-      </p:sp>
-      <p:sp>
-        <p:nvSpPr>
-          <p:cNvPr id="12" name="CuadroTexto 11">
-            <a:extLst>
-              <a:ext uri="{FF2B5EF4-FFF2-40B4-BE49-F238E27FC236}">
-                <a16:creationId xmlns:a16="http://schemas.microsoft.com/office/drawing/2014/main" id="{D7BEC7F1-3F16-26F1-A118-18C76515BB8E}"/>
-              </a:ext>
-            </a:extLst>
-          </p:cNvPr>
-          <p:cNvSpPr txBox="1"/>
-          <p:nvPr/>
-        </p:nvSpPr>
-        <p:spPr>
-          <a:xfrm>
-            <a:off x="1016000" y="4064000"/>
-            <a:ext cx="10160000" cy="1246495"/>
-          </a:xfrm>
-          <a:prstGeom prst="rect">
-            <a:avLst/>
-          </a:prstGeom>
-          <a:noFill/>
-        </p:spPr>
-        <p:txBody>
-          <a:bodyPr vert="horz" wrap="square" rtlCol="0">
-            <a:spAutoFit/>
-          </a:bodyPr>
-          <a:lstStyle/>
           <a:p>
             <a:r>
               <a:rPr lang="es-MX" sz="1500">
                 <a:solidFill>
-                  <a:srgbClr val="1E293B"/>
+                  <a:srgbClr val="FFFFFF"/>
                 </a:solidFill>
                 <a:latin typeface="Calibri" panose="020F0502020204030204" pitchFamily="34" charset="0"/>
               </a:rPr>
-              <a:t>3. Aislamiento Territorial entre Farmacias Cercanas</a:t>
+              <a:t>[Paso al Dashboard]</a:t>
             </a:r>
           </a:p>
           <a:p>
             <a:endParaRPr lang="es-MX" sz="1500">
               <a:solidFill>
-                <a:srgbClr val="1E293B"/>
+                <a:srgbClr val="FFFFFF"/>
               </a:solidFill>
               <a:latin typeface="Calibri" panose="020F0502020204030204" pitchFamily="34" charset="0"/>
             </a:endParaRPr>
@@ -5539,26 +5472,59 @@
             <a:r>
               <a:rPr lang="es-MX" sz="1500">
                 <a:solidFill>
-                  <a:srgbClr val="1E293B"/>
+                  <a:srgbClr val="FFFFFF"/>
                 </a:solidFill>
                 <a:latin typeface="Calibri" panose="020F0502020204030204" pitchFamily="34" charset="0"/>
               </a:rPr>
-              <a:t>Mientras la farmacia de Don Jose esta en quiebre de stock, otra farmacia a 10 minutos en el mismo sector tiene excedentes de inventario con riesgo de caducidad.</a:t>
+              <a:t>- Mapa interactivo Leaflet</a:t>
             </a:r>
           </a:p>
           <a:p>
             <a:r>
               <a:rPr lang="es-MX" sz="1500">
                 <a:solidFill>
-                  <a:srgbClr val="1E293B"/>
+                  <a:srgbClr val="FFFFFF"/>
                 </a:solidFill>
                 <a:latin typeface="Calibri" panose="020F0502020204030204" pitchFamily="34" charset="0"/>
               </a:rPr>
-              <a:t>Hoy esas dos sucursales no dialogan operativamente en tiempo real.</a:t>
+              <a:t>- 100 farmacias geolocalizadas</a:t>
+            </a:r>
+          </a:p>
+          <a:p>
+            <a:r>
+              <a:rPr lang="es-MX" sz="1500">
+                <a:solidFill>
+                  <a:srgbClr val="FFFFFF"/>
+                </a:solidFill>
+                <a:latin typeface="Calibri" panose="020F0502020204030204" pitchFamily="34" charset="0"/>
+              </a:rPr>
+              <a:t>- Alertas dinamicas en tiempo real</a:t>
+            </a:r>
+          </a:p>
+          <a:p>
+            <a:r>
+              <a:rPr lang="es-MX" sz="1500">
+                <a:solidFill>
+                  <a:srgbClr val="FFFFFF"/>
+                </a:solidFill>
+                <a:latin typeface="Calibri" panose="020F0502020204030204" pitchFamily="34" charset="0"/>
+              </a:rPr>
+              <a:t>- API Python + React Vite</a:t>
+            </a:r>
+          </a:p>
+          <a:p>
+            <a:r>
+              <a:rPr lang="es-MX" sz="1500">
+                <a:solidFill>
+                  <a:srgbClr val="FFFFFF"/>
+                </a:solidFill>
+                <a:latin typeface="Calibri" panose="020F0502020204030204" pitchFamily="34" charset="0"/>
+              </a:rPr>
+              <a:t>- Listo para AWS Lambda y Vendix POS</a:t>
             </a:r>
             <a:endParaRPr lang="es-EC" sz="1500">
               <a:solidFill>
-                <a:srgbClr val="1E293B"/>
+                <a:srgbClr val="FFFFFF"/>
               </a:solidFill>
               <a:latin typeface="Calibri" panose="020F0502020204030204" pitchFamily="34" charset="0"/>
             </a:endParaRPr>
@@ -5568,7 +5534,7 @@
     </p:spTree>
     <p:extLst>
       <p:ext uri="{BB962C8B-B14F-4D97-AF65-F5344CB8AC3E}">
-        <p14:creationId xmlns:p14="http://schemas.microsoft.com/office/powerpoint/2010/main" val="926228553"/>
+        <p14:creationId xmlns:p14="http://schemas.microsoft.com/office/powerpoint/2010/main" val="4241332731"/>
       </p:ext>
     </p:extLst>
   </p:cSld>
@@ -5600,7 +5566,7 @@
           <p:cNvPr id="2" name="Rectángulo 1">
             <a:extLst>
               <a:ext uri="{FF2B5EF4-FFF2-40B4-BE49-F238E27FC236}">
-                <a16:creationId xmlns:a16="http://schemas.microsoft.com/office/drawing/2014/main" id="{E3049C67-7BD7-1792-FB9D-7286D6E9A98F}"/>
+                <a16:creationId xmlns:a16="http://schemas.microsoft.com/office/drawing/2014/main" id="{CF47162D-CC82-4A40-81AA-CC2D478C05DE}"/>
               </a:ext>
             </a:extLst>
           </p:cNvPr>
@@ -5655,7 +5621,7 @@
           <p:cNvPr id="3" name="Rectángulo 2">
             <a:extLst>
               <a:ext uri="{FF2B5EF4-FFF2-40B4-BE49-F238E27FC236}">
-                <a16:creationId xmlns:a16="http://schemas.microsoft.com/office/drawing/2014/main" id="{32AF24AF-9C54-D273-FA90-A46B9A768BAC}"/>
+                <a16:creationId xmlns:a16="http://schemas.microsoft.com/office/drawing/2014/main" id="{D30D972A-3986-8EF7-64C7-9FFA2AF60EEA}"/>
               </a:ext>
             </a:extLst>
           </p:cNvPr>
@@ -5710,7 +5676,7 @@
           <p:cNvPr id="4" name="CuadroTexto 3">
             <a:extLst>
               <a:ext uri="{FF2B5EF4-FFF2-40B4-BE49-F238E27FC236}">
-                <a16:creationId xmlns:a16="http://schemas.microsoft.com/office/drawing/2014/main" id="{B6CC5FA0-D243-7086-8598-CCDD7193C6D9}"/>
+                <a16:creationId xmlns:a16="http://schemas.microsoft.com/office/drawing/2014/main" id="{203CE488-EF21-042B-8714-770717C1D97A}"/>
               </a:ext>
             </a:extLst>
           </p:cNvPr>
@@ -5719,7 +5685,7 @@
         </p:nvSpPr>
         <p:spPr>
           <a:xfrm>
-            <a:off x="762000" y="444500"/>
+            <a:off x="762000" y="381000"/>
             <a:ext cx="10668000" cy="492443"/>
           </a:xfrm>
           <a:prstGeom prst="rect">
@@ -5734,14 +5700,20 @@
           <a:lstStyle/>
           <a:p>
             <a:r>
-              <a:rPr lang="es-EC" sz="2600" b="1">
+              <a:rPr lang="es-MX" sz="2600" b="1">
                 <a:solidFill>
                   <a:srgbClr val="0F2042"/>
                 </a:solidFill>
                 <a:latin typeface="Calibri" panose="020F0502020204030204" pitchFamily="34" charset="0"/>
               </a:rPr>
-              <a:t>Nuestra Solucion: FarmaSenal</a:t>
-            </a:r>
+              <a:t>Diferenciacion, Sinergia BYD e Impacto</a:t>
+            </a:r>
+            <a:endParaRPr lang="es-EC" sz="2600" b="1">
+              <a:solidFill>
+                <a:srgbClr val="0F2042"/>
+              </a:solidFill>
+              <a:latin typeface="Calibri" panose="020F0502020204030204" pitchFamily="34" charset="0"/>
+            </a:endParaRPr>
           </a:p>
         </p:txBody>
       </p:sp>
@@ -5750,7 +5722,7 @@
           <p:cNvPr id="5" name="CuadroTexto 4">
             <a:extLst>
               <a:ext uri="{FF2B5EF4-FFF2-40B4-BE49-F238E27FC236}">
-                <a16:creationId xmlns:a16="http://schemas.microsoft.com/office/drawing/2014/main" id="{8DD2FF05-EFB8-F564-38DF-C58D75FD459F}"/>
+                <a16:creationId xmlns:a16="http://schemas.microsoft.com/office/drawing/2014/main" id="{20FEE8EA-B7F9-348C-42FF-15552B249609}"/>
               </a:ext>
             </a:extLst>
           </p:cNvPr>
@@ -5759,8 +5731,8 @@
         </p:nvSpPr>
         <p:spPr>
           <a:xfrm>
-            <a:off x="762000" y="1016000"/>
-            <a:ext cx="10668000" cy="307777"/>
+            <a:off x="762000" y="952500"/>
+            <a:ext cx="10668000" cy="292388"/>
           </a:xfrm>
           <a:prstGeom prst="rect">
             <a:avLst/>
@@ -5774,15 +5746,15 @@
           <a:lstStyle/>
           <a:p>
             <a:r>
-              <a:rPr lang="es-MX" sz="1400">
+              <a:rPr lang="es-MX" sz="1300">
                 <a:solidFill>
                   <a:srgbClr val="64748B"/>
                 </a:solidFill>
                 <a:latin typeface="Calibri" panose="020F0502020204030204" pitchFamily="34" charset="0"/>
               </a:rPr>
-              <a:t>Motor de inteligencia geoespacial para anticipar quiebres y habilitar traslados agiles</a:t>
-            </a:r>
-            <a:endParaRPr lang="es-EC" sz="1400">
+              <a:t>Logistica electrica de proximidad y retorno de inversion medible</a:t>
+            </a:r>
+            <a:endParaRPr lang="es-EC" sz="1300">
               <a:solidFill>
                 <a:srgbClr val="64748B"/>
               </a:solidFill>
@@ -5796,7 +5768,7 @@
           <p:cNvPr id="6" name="CuadroTexto 5">
             <a:extLst>
               <a:ext uri="{FF2B5EF4-FFF2-40B4-BE49-F238E27FC236}">
-                <a16:creationId xmlns:a16="http://schemas.microsoft.com/office/drawing/2014/main" id="{B6F94C46-D465-59B8-0BD0-575F7FC5FEAC}"/>
+                <a16:creationId xmlns:a16="http://schemas.microsoft.com/office/drawing/2014/main" id="{4D9E9B34-5A3B-A49C-9FAB-2492E06B09F7}"/>
               </a:ext>
             </a:extLst>
           </p:cNvPr>
@@ -5805,7 +5777,7 @@
         </p:nvSpPr>
         <p:spPr>
           <a:xfrm>
-            <a:off x="762000" y="6350000"/>
+            <a:off x="762000" y="6413500"/>
             <a:ext cx="10668000" cy="246221"/>
           </a:xfrm>
           <a:prstGeom prst="rect">
@@ -5842,7 +5814,7 @@
           <p:cNvPr id="7" name="Rectángulo 6">
             <a:extLst>
               <a:ext uri="{FF2B5EF4-FFF2-40B4-BE49-F238E27FC236}">
-                <a16:creationId xmlns:a16="http://schemas.microsoft.com/office/drawing/2014/main" id="{BF4FB7A0-1D63-32C1-B789-1018F937A560}"/>
+                <a16:creationId xmlns:a16="http://schemas.microsoft.com/office/drawing/2014/main" id="{511FF2C4-B64B-F3D3-41CB-E6B7D2FE54BE}"/>
               </a:ext>
             </a:extLst>
           </p:cNvPr>
@@ -5851,8 +5823,8 @@
         </p:nvSpPr>
         <p:spPr>
           <a:xfrm>
-            <a:off x="762000" y="1651000"/>
-            <a:ext cx="5334000" cy="4318000"/>
+            <a:off x="762000" y="1524000"/>
+            <a:ext cx="5715000" cy="4445000"/>
           </a:xfrm>
           <a:prstGeom prst="rect">
             <a:avLst/>
@@ -5862,7 +5834,7 @@
           </a:solidFill>
           <a:ln w="25400">
             <a:solidFill>
-              <a:srgbClr val="0070BA"/>
+              <a:srgbClr val="10B981"/>
             </a:solidFill>
           </a:ln>
         </p:spPr>
@@ -5896,7 +5868,7 @@
           <p:cNvPr id="8" name="CuadroTexto 7">
             <a:extLst>
               <a:ext uri="{FF2B5EF4-FFF2-40B4-BE49-F238E27FC236}">
-                <a16:creationId xmlns:a16="http://schemas.microsoft.com/office/drawing/2014/main" id="{C18CCE2D-14C5-BA21-2D09-3FCED0EA0F13}"/>
+                <a16:creationId xmlns:a16="http://schemas.microsoft.com/office/drawing/2014/main" id="{70977A77-5F4A-6548-6FE4-B4D911CEFE45}"/>
               </a:ext>
             </a:extLst>
           </p:cNvPr>
@@ -5905,8 +5877,8 @@
         </p:nvSpPr>
         <p:spPr>
           <a:xfrm>
-            <a:off x="952500" y="1841500"/>
-            <a:ext cx="4953000" cy="3108543"/>
+            <a:off x="1016000" y="1714500"/>
+            <a:ext cx="5207000" cy="2585323"/>
           </a:xfrm>
           <a:prstGeom prst="rect">
             <a:avLst/>
@@ -5920,17 +5892,39 @@
           <a:lstStyle/>
           <a:p>
             <a:r>
-              <a:rPr lang="es-EC" sz="1400">
+              <a:rPr lang="es-MX" sz="1350">
                 <a:solidFill>
                   <a:srgbClr val="1E293B"/>
                 </a:solidFill>
                 <a:latin typeface="Calibri" panose="020F0502020204030204" pitchFamily="34" charset="0"/>
               </a:rPr>
-              <a:t>Capacidades Clave de FarmaSenal:</a:t>
-            </a:r>
-          </a:p>
-          <a:p>
-            <a:endParaRPr lang="es-EC" sz="1400">
+              <a:t>Novedad frente a Power BI/Qlik:</a:t>
+            </a:r>
+          </a:p>
+          <a:p>
+            <a:r>
+              <a:rPr lang="es-MX" sz="1350">
+                <a:solidFill>
+                  <a:srgbClr val="1E293B"/>
+                </a:solidFill>
+                <a:latin typeface="Calibri" panose="020F0502020204030204" pitchFamily="34" charset="0"/>
+              </a:rPr>
+              <a:t>- No es un reporte forense mensual del pasado.</a:t>
+            </a:r>
+          </a:p>
+          <a:p>
+            <a:r>
+              <a:rPr lang="es-MX" sz="1350">
+                <a:solidFill>
+                  <a:srgbClr val="1E293B"/>
+                </a:solidFill>
+                <a:latin typeface="Calibri" panose="020F0502020204030204" pitchFamily="34" charset="0"/>
+              </a:rPr>
+              <a:t>- Es un motor OPERATIVO en tiempo real que previene quiebres hoy.</a:t>
+            </a:r>
+          </a:p>
+          <a:p>
+            <a:endParaRPr lang="es-MX" sz="1350">
               <a:solidFill>
                 <a:srgbClr val="1E293B"/>
               </a:solidFill>
@@ -5939,28 +5933,50 @@
           </a:p>
           <a:p>
             <a:r>
-              <a:rPr lang="es-EC" sz="1400">
+              <a:rPr lang="es-MX" sz="1350">
                 <a:solidFill>
                   <a:srgbClr val="1E293B"/>
                 </a:solidFill>
                 <a:latin typeface="Calibri" panose="020F0502020204030204" pitchFamily="34" charset="0"/>
               </a:rPr>
-              <a:t>- Mapa Interactivo en Vivo:</a:t>
-            </a:r>
-          </a:p>
-          <a:p>
-            <a:r>
-              <a:rPr lang="es-EC" sz="1400">
+              <a:t>Sinergia Verde con BYD:</a:t>
+            </a:r>
+          </a:p>
+          <a:p>
+            <a:r>
+              <a:rPr lang="es-MX" sz="1350">
                 <a:solidFill>
                   <a:srgbClr val="1E293B"/>
                 </a:solidFill>
                 <a:latin typeface="Calibri" panose="020F0502020204030204" pitchFamily="34" charset="0"/>
               </a:rPr>
-              <a:t>  Farmacias georreferenciadas con semaforo territorial.</a:t>
-            </a:r>
-          </a:p>
-          <a:p>
-            <a:endParaRPr lang="es-EC" sz="1400">
+              <a:t>- Traslados de proximidad entre farmacias con vehiculos electricos BYD.</a:t>
+            </a:r>
+          </a:p>
+          <a:p>
+            <a:r>
+              <a:rPr lang="es-MX" sz="1350">
+                <a:solidFill>
+                  <a:srgbClr val="1E293B"/>
+                </a:solidFill>
+                <a:latin typeface="Calibri" panose="020F0502020204030204" pitchFamily="34" charset="0"/>
+              </a:rPr>
+              <a:t>- Integracion con la red de +150 puntos de carga.</a:t>
+            </a:r>
+          </a:p>
+          <a:p>
+            <a:r>
+              <a:rPr lang="es-MX" sz="1350">
+                <a:solidFill>
+                  <a:srgbClr val="1E293B"/>
+                </a:solidFill>
+                <a:latin typeface="Calibri" panose="020F0502020204030204" pitchFamily="34" charset="0"/>
+              </a:rPr>
+              <a:t>- Menor costo por kilometro y cero emisiones.</a:t>
+            </a:r>
+          </a:p>
+          <a:p>
+            <a:endParaRPr lang="es-MX" sz="1350">
               <a:solidFill>
                 <a:srgbClr val="1E293B"/>
               </a:solidFill>
@@ -5969,139 +5985,106 @@
           </a:p>
           <a:p>
             <a:r>
-              <a:rPr lang="es-EC" sz="1400">
+              <a:rPr lang="es-MX" sz="1350">
                 <a:solidFill>
                   <a:srgbClr val="1E293B"/>
                 </a:solidFill>
                 <a:latin typeface="Calibri" panose="020F0502020204030204" pitchFamily="34" charset="0"/>
               </a:rPr>
-              <a:t>- Ventana Movil Predictiva (30 vs 90 dias):</a:t>
-            </a:r>
-          </a:p>
-          <a:p>
-            <a:r>
-              <a:rPr lang="es-EC" sz="1400">
+              <a:t>Impacto Medible:</a:t>
+            </a:r>
+          </a:p>
+          <a:p>
+            <a:r>
+              <a:rPr lang="es-MX" sz="1350">
                 <a:solidFill>
                   <a:srgbClr val="1E293B"/>
                 </a:solidFill>
                 <a:latin typeface="Calibri" panose="020F0502020204030204" pitchFamily="34" charset="0"/>
               </a:rPr>
-              <a:t>  Deteccion estadistica temprana de aceleracion de ventas.</a:t>
-            </a:r>
-          </a:p>
-          <a:p>
-            <a:endParaRPr lang="es-EC" sz="1400">
+              <a:t>- Ecuacion de ahorro: Reduccion de ventas perdidas + Ahorro en mermas por vencimiento + Eficiencia en fletes.</a:t>
+            </a:r>
+            <a:endParaRPr lang="es-EC" sz="1350">
               <a:solidFill>
                 <a:srgbClr val="1E293B"/>
               </a:solidFill>
               <a:latin typeface="Calibri" panose="020F0502020204030204" pitchFamily="34" charset="0"/>
             </a:endParaRPr>
           </a:p>
-          <a:p>
-            <a:r>
-              <a:rPr lang="es-EC" sz="1400">
-                <a:solidFill>
-                  <a:srgbClr val="1E293B"/>
-                </a:solidFill>
-                <a:latin typeface="Calibri" panose="020F0502020204030204" pitchFamily="34" charset="0"/>
-              </a:rPr>
-              <a:t>- Alertas Claras y Explicables:</a:t>
-            </a:r>
-          </a:p>
-          <a:p>
-            <a:r>
-              <a:rPr lang="es-EC" sz="1400">
-                <a:solidFill>
-                  <a:srgbClr val="1E293B"/>
-                </a:solidFill>
-                <a:latin typeface="Calibri" panose="020F0502020204030204" pitchFamily="34" charset="0"/>
-              </a:rPr>
-              <a:t>  Amarillo: Alza observada (+50% demanda)</a:t>
-            </a:r>
-          </a:p>
-          <a:p>
-            <a:r>
-              <a:rPr lang="es-EC" sz="1400">
-                <a:solidFill>
-                  <a:srgbClr val="1E293B"/>
-                </a:solidFill>
-                <a:latin typeface="Calibri" panose="020F0502020204030204" pitchFamily="34" charset="0"/>
-              </a:rPr>
-              <a:t>  Rojo: Alza critica (+100% demanda)</a:t>
-            </a:r>
-          </a:p>
-          <a:p>
-            <a:endParaRPr lang="es-EC" sz="1400">
-              <a:solidFill>
-                <a:srgbClr val="1E293B"/>
-              </a:solidFill>
-              <a:latin typeface="Calibri" panose="020F0502020204030204" pitchFamily="34" charset="0"/>
-            </a:endParaRPr>
-          </a:p>
-          <a:p>
-            <a:r>
-              <a:rPr lang="es-EC" sz="1400">
-                <a:solidFill>
-                  <a:srgbClr val="1E293B"/>
-                </a:solidFill>
-                <a:latin typeface="Calibri" panose="020F0502020204030204" pitchFamily="34" charset="0"/>
-              </a:rPr>
-              <a:t>- Filtro por Categorias Sensibles:</a:t>
-            </a:r>
-          </a:p>
-          <a:p>
-            <a:r>
-              <a:rPr lang="es-EC" sz="1400">
-                <a:solidFill>
-                  <a:srgbClr val="1E293B"/>
-                </a:solidFill>
-                <a:latin typeface="Calibri" panose="020F0502020204030204" pitchFamily="34" charset="0"/>
-              </a:rPr>
-              <a:t>  Cardiovasculares, Analgesicos y Respiratorios.</a:t>
-            </a:r>
-          </a:p>
-        </p:txBody>
-      </p:sp>
-      <p:sp>
-        <p:nvSpPr>
-          <p:cNvPr id="9" name="Rectángulo 8">
-            <a:extLst>
-              <a:ext uri="{FF2B5EF4-FFF2-40B4-BE49-F238E27FC236}">
-                <a16:creationId xmlns:a16="http://schemas.microsoft.com/office/drawing/2014/main" id="{43599D69-BD2E-45EA-B1C9-B02E98EAE940}"/>
-              </a:ext>
-            </a:extLst>
-          </p:cNvPr>
-          <p:cNvSpPr/>
+        </p:txBody>
+      </p:sp>
+      <p:pic>
+        <p:nvPicPr>
+          <p:cNvPr id="10" name="Imagen 9">
+            <a:extLst>
+              <a:ext uri="{FF2B5EF4-FFF2-40B4-BE49-F238E27FC236}">
+                <a16:creationId xmlns:a16="http://schemas.microsoft.com/office/drawing/2014/main" id="{58B61973-43EC-C0BE-0D8C-9750A1DF34C9}"/>
+              </a:ext>
+            </a:extLst>
+          </p:cNvPr>
+          <p:cNvPicPr>
+            <a:picLocks/>
+          </p:cNvPicPr>
           <p:nvPr/>
-        </p:nvSpPr>
-        <p:spPr>
-          <a:xfrm>
-            <a:off x="6350000" y="1651000"/>
-            <a:ext cx="5080000" cy="4318000"/>
+        </p:nvPicPr>
+        <p:blipFill>
+          <a:blip r:embed="rId2">
+            <a:extLst>
+              <a:ext uri="{28A0092B-C50C-407E-A947-70E740481C1C}">
+                <a14:useLocalDpi xmlns:a14="http://schemas.microsoft.com/office/drawing/2010/main" val="0"/>
+              </a:ext>
+            </a:extLst>
+          </a:blip>
+          <a:stretch>
+            <a:fillRect/>
+          </a:stretch>
+        </p:blipFill>
+        <p:spPr>
+          <a:xfrm>
+            <a:off x="6858000" y="1524000"/>
+            <a:ext cx="4572000" cy="3429000"/>
           </a:xfrm>
           <a:prstGeom prst="rect">
             <a:avLst/>
           </a:prstGeom>
-          <a:solidFill>
-            <a:srgbClr val="0F2042"/>
-          </a:solidFill>
-          <a:ln w="19050" cap="flat" cmpd="sng" algn="ctr">
-            <a:noFill/>
+        </p:spPr>
+      </p:pic>
+      <p:sp>
+        <p:nvSpPr>
+          <p:cNvPr id="11" name="Rectángulo 10">
+            <a:extLst>
+              <a:ext uri="{FF2B5EF4-FFF2-40B4-BE49-F238E27FC236}">
+                <a16:creationId xmlns:a16="http://schemas.microsoft.com/office/drawing/2014/main" id="{AF95DF19-E9B1-99D2-C3C1-A275FB03A6C4}"/>
+              </a:ext>
+            </a:extLst>
+          </p:cNvPr>
+          <p:cNvSpPr/>
+          <p:nvPr/>
+        </p:nvSpPr>
+        <p:spPr>
+          <a:xfrm>
+            <a:off x="6858000" y="1524000"/>
+            <a:ext cx="4572000" cy="3429000"/>
+          </a:xfrm>
+          <a:prstGeom prst="rect">
+            <a:avLst/>
+          </a:prstGeom>
+          <a:noFill/>
+          <a:ln w="25400" cap="flat" cmpd="sng" algn="ctr">
+            <a:solidFill>
+              <a:srgbClr val="10B981"/>
+            </a:solidFill>
             <a:prstDash val="solid"/>
             <a:miter lim="800000"/>
           </a:ln>
           <a:effectLst/>
           <a:extLst>
-            <a:ext uri="{91240B29-F687-4F45-9708-019B960494DF}">
-              <a14:hiddenLine xmlns:a14="http://schemas.microsoft.com/office/drawing/2010/main" w="19050" cap="flat" cmpd="sng" algn="ctr">
-                <a:solidFill>
-                  <a:schemeClr val="accent1">
-                    <a:shade val="15000"/>
-                  </a:schemeClr>
-                </a:solidFill>
-                <a:prstDash val="solid"/>
-                <a:miter lim="800000"/>
-              </a14:hiddenLine>
+            <a:ext uri="{909E8E84-426E-40DD-AFC4-6F175D3DCCD1}">
+              <a14:hiddenFill xmlns:a14="http://schemas.microsoft.com/office/drawing/2010/main">
+                <a:solidFill>
+                  <a:schemeClr val="accent1"/>
+                </a:solidFill>
+              </a14:hiddenFill>
             </a:ext>
           </a:extLst>
         </p:spPr>
@@ -6132,10 +6115,78 @@
       </p:sp>
       <p:sp>
         <p:nvSpPr>
-          <p:cNvPr id="10" name="CuadroTexto 9">
-            <a:extLst>
-              <a:ext uri="{FF2B5EF4-FFF2-40B4-BE49-F238E27FC236}">
-                <a16:creationId xmlns:a16="http://schemas.microsoft.com/office/drawing/2014/main" id="{9ADB69FF-733B-77C7-C0F6-60661CD89D82}"/>
+          <p:cNvPr id="12" name="Rectángulo 11">
+            <a:extLst>
+              <a:ext uri="{FF2B5EF4-FFF2-40B4-BE49-F238E27FC236}">
+                <a16:creationId xmlns:a16="http://schemas.microsoft.com/office/drawing/2014/main" id="{FE441F6D-CB23-0029-7895-6148601EAD6D}"/>
+              </a:ext>
+            </a:extLst>
+          </p:cNvPr>
+          <p:cNvSpPr/>
+          <p:nvPr/>
+        </p:nvSpPr>
+        <p:spPr>
+          <a:xfrm>
+            <a:off x="6858000" y="5143500"/>
+            <a:ext cx="4572000" cy="825500"/>
+          </a:xfrm>
+          <a:prstGeom prst="rect">
+            <a:avLst/>
+          </a:prstGeom>
+          <a:solidFill>
+            <a:srgbClr val="0F2042"/>
+          </a:solidFill>
+          <a:ln w="19050" cap="flat" cmpd="sng" algn="ctr">
+            <a:noFill/>
+            <a:prstDash val="solid"/>
+            <a:miter lim="800000"/>
+          </a:ln>
+          <a:effectLst/>
+          <a:extLst>
+            <a:ext uri="{91240B29-F687-4F45-9708-019B960494DF}">
+              <a14:hiddenLine xmlns:a14="http://schemas.microsoft.com/office/drawing/2010/main" w="19050" cap="flat" cmpd="sng" algn="ctr">
+                <a:solidFill>
+                  <a:schemeClr val="accent1">
+                    <a:shade val="15000"/>
+                  </a:schemeClr>
+                </a:solidFill>
+                <a:prstDash val="solid"/>
+                <a:miter lim="800000"/>
+              </a14:hiddenLine>
+            </a:ext>
+          </a:extLst>
+        </p:spPr>
+        <p:style>
+          <a:lnRef idx="2">
+            <a:schemeClr val="accent1">
+              <a:shade val="15000"/>
+            </a:schemeClr>
+          </a:lnRef>
+          <a:fillRef idx="1">
+            <a:schemeClr val="accent1"/>
+          </a:fillRef>
+          <a:effectRef idx="0">
+            <a:schemeClr val="accent1"/>
+          </a:effectRef>
+          <a:fontRef idx="minor">
+            <a:schemeClr val="lt1"/>
+          </a:fontRef>
+        </p:style>
+        <p:txBody>
+          <a:bodyPr rtlCol="0" anchor="ctr"/>
+          <a:lstStyle/>
+          <a:p>
+            <a:pPr algn="ctr"/>
+            <a:endParaRPr lang="es-EC"/>
+          </a:p>
+        </p:txBody>
+      </p:sp>
+      <p:sp>
+        <p:nvSpPr>
+          <p:cNvPr id="13" name="CuadroTexto 12">
+            <a:extLst>
+              <a:ext uri="{FF2B5EF4-FFF2-40B4-BE49-F238E27FC236}">
+                <a16:creationId xmlns:a16="http://schemas.microsoft.com/office/drawing/2014/main" id="{2CFE2CEE-2147-BA8A-7A7E-723B0A0B7C47}"/>
               </a:ext>
             </a:extLst>
           </p:cNvPr>
@@ -6144,8 +6195,8 @@
         </p:nvSpPr>
         <p:spPr>
           <a:xfrm>
-            <a:off x="6540500" y="1841500"/>
-            <a:ext cx="4699000" cy="2893100"/>
+            <a:off x="6985000" y="5232400"/>
+            <a:ext cx="4318000" cy="461665"/>
           </a:xfrm>
           <a:prstGeom prst="rect">
             <a:avLst/>
@@ -6159,141 +6210,38 @@
           <a:lstStyle/>
           <a:p>
             <a:r>
-              <a:rPr lang="es-EC" sz="1400">
+              <a:rPr lang="es-MX" sz="1200">
                 <a:solidFill>
                   <a:srgbClr val="FFFFFF"/>
                 </a:solidFill>
                 <a:latin typeface="Calibri" panose="020F0502020204030204" pitchFamily="34" charset="0"/>
               </a:rPr>
-              <a:t>Arquitectura del Prototipo:</a:t>
-            </a:r>
-          </a:p>
-          <a:p>
-            <a:endParaRPr lang="es-EC" sz="1400">
+              <a:t>Movilidad Limpia para la Red de Salud</a:t>
+            </a:r>
+          </a:p>
+          <a:p>
+            <a:r>
+              <a:rPr lang="es-MX" sz="1200">
+                <a:solidFill>
+                  <a:srgbClr val="FFFFFF"/>
+                </a:solidFill>
+                <a:latin typeface="Calibri" panose="020F0502020204030204" pitchFamily="34" charset="0"/>
+              </a:rPr>
+              <a:t>Conexion operativa entre Farmacias y Flota BYD</a:t>
+            </a:r>
+            <a:endParaRPr lang="es-EC" sz="1200">
               <a:solidFill>
                 <a:srgbClr val="FFFFFF"/>
               </a:solidFill>
               <a:latin typeface="Calibri" panose="020F0502020204030204" pitchFamily="34" charset="0"/>
             </a:endParaRPr>
           </a:p>
-          <a:p>
-            <a:r>
-              <a:rPr lang="es-EC" sz="1400">
-                <a:solidFill>
-                  <a:srgbClr val="FFFFFF"/>
-                </a:solidFill>
-                <a:latin typeface="Calibri" panose="020F0502020204030204" pitchFamily="34" charset="0"/>
-              </a:rPr>
-              <a:t>- Frontend Visual:</a:t>
-            </a:r>
-          </a:p>
-          <a:p>
-            <a:r>
-              <a:rPr lang="es-EC" sz="1400">
-                <a:solidFill>
-                  <a:srgbClr val="FFFFFF"/>
-                </a:solidFill>
-                <a:latin typeface="Calibri" panose="020F0502020204030204" pitchFamily="34" charset="0"/>
-              </a:rPr>
-              <a:t>  React 18 + Vite + Leaflet + CARTO Basemaps + Lucide Icons.</a:t>
-            </a:r>
-          </a:p>
-          <a:p>
-            <a:endParaRPr lang="es-EC" sz="1400">
-              <a:solidFill>
-                <a:srgbClr val="FFFFFF"/>
-              </a:solidFill>
-              <a:latin typeface="Calibri" panose="020F0502020204030204" pitchFamily="34" charset="0"/>
-            </a:endParaRPr>
-          </a:p>
-          <a:p>
-            <a:r>
-              <a:rPr lang="es-EC" sz="1400">
-                <a:solidFill>
-                  <a:srgbClr val="FFFFFF"/>
-                </a:solidFill>
-                <a:latin typeface="Calibri" panose="020F0502020204030204" pitchFamily="34" charset="0"/>
-              </a:rPr>
-              <a:t>- Backend Serverless:</a:t>
-            </a:r>
-          </a:p>
-          <a:p>
-            <a:r>
-              <a:rPr lang="es-EC" sz="1400">
-                <a:solidFill>
-                  <a:srgbClr val="FFFFFF"/>
-                </a:solidFill>
-                <a:latin typeface="Calibri" panose="020F0502020204030204" pitchFamily="34" charset="0"/>
-              </a:rPr>
-              <a:t>  API REST en Python (estandar, ultraligera).</a:t>
-            </a:r>
-          </a:p>
-          <a:p>
-            <a:endParaRPr lang="es-EC" sz="1400">
-              <a:solidFill>
-                <a:srgbClr val="FFFFFF"/>
-              </a:solidFill>
-              <a:latin typeface="Calibri" panose="020F0502020204030204" pitchFamily="34" charset="0"/>
-            </a:endParaRPr>
-          </a:p>
-          <a:p>
-            <a:r>
-              <a:rPr lang="es-EC" sz="1400">
-                <a:solidFill>
-                  <a:srgbClr val="FFFFFF"/>
-                </a:solidFill>
-                <a:latin typeface="Calibri" panose="020F0502020204030204" pitchFamily="34" charset="0"/>
-              </a:rPr>
-              <a:t>- Preparado para la Nube:</a:t>
-            </a:r>
-          </a:p>
-          <a:p>
-            <a:r>
-              <a:rPr lang="es-EC" sz="1400">
-                <a:solidFill>
-                  <a:srgbClr val="FFFFFF"/>
-                </a:solidFill>
-                <a:latin typeface="Calibri" panose="020F0502020204030204" pitchFamily="34" charset="0"/>
-              </a:rPr>
-              <a:t>  AWS Lambda + API Gateway HTTP v2.</a:t>
-            </a:r>
-          </a:p>
-          <a:p>
-            <a:endParaRPr lang="es-EC" sz="1400">
-              <a:solidFill>
-                <a:srgbClr val="FFFFFF"/>
-              </a:solidFill>
-              <a:latin typeface="Calibri" panose="020F0502020204030204" pitchFamily="34" charset="0"/>
-            </a:endParaRPr>
-          </a:p>
-          <a:p>
-            <a:r>
-              <a:rPr lang="es-EC" sz="1400">
-                <a:solidFill>
-                  <a:srgbClr val="FFFFFF"/>
-                </a:solidFill>
-                <a:latin typeface="Calibri" panose="020F0502020204030204" pitchFamily="34" charset="0"/>
-              </a:rPr>
-              <a:t>- Integracion Transaccional:</a:t>
-            </a:r>
-          </a:p>
-          <a:p>
-            <a:r>
-              <a:rPr lang="es-EC" sz="1400">
-                <a:solidFill>
-                  <a:srgbClr val="FFFFFF"/>
-                </a:solidFill>
-                <a:latin typeface="Calibri" panose="020F0502020204030204" pitchFamily="34" charset="0"/>
-              </a:rPr>
-              <a:t>  Listo para conectar via API con SAP S/4HANA y Vendix POS.</a:t>
-            </a:r>
-          </a:p>
         </p:txBody>
       </p:sp>
     </p:spTree>
     <p:extLst>
       <p:ext uri="{BB962C8B-B14F-4D97-AF65-F5344CB8AC3E}">
-        <p14:creationId xmlns:p14="http://schemas.microsoft.com/office/powerpoint/2010/main" val="3639941571"/>
+        <p14:creationId xmlns:p14="http://schemas.microsoft.com/office/powerpoint/2010/main" val="458353967"/>
       </p:ext>
     </p:extLst>
   </p:cSld>
@@ -6325,7 +6273,7 @@
           <p:cNvPr id="2" name="Rectángulo 1">
             <a:extLst>
               <a:ext uri="{FF2B5EF4-FFF2-40B4-BE49-F238E27FC236}">
-                <a16:creationId xmlns:a16="http://schemas.microsoft.com/office/drawing/2014/main" id="{0B4DABCE-F25B-53AD-0B3B-DB914F4C40E7}"/>
+                <a16:creationId xmlns:a16="http://schemas.microsoft.com/office/drawing/2014/main" id="{639DB0EB-7061-436D-2112-B7E78B47DA9F}"/>
               </a:ext>
             </a:extLst>
           </p:cNvPr>
@@ -6341,7 +6289,7 @@
             <a:avLst/>
           </a:prstGeom>
           <a:solidFill>
-            <a:srgbClr val="F8FAFC"/>
+            <a:srgbClr val="0F2042"/>
           </a:solidFill>
           <a:ln w="19050" cap="flat" cmpd="sng" algn="ctr">
             <a:noFill/>
@@ -6377,1321 +6325,10 @@
       </p:sp>
       <p:sp>
         <p:nvSpPr>
-          <p:cNvPr id="3" name="Rectángulo 2">
-            <a:extLst>
-              <a:ext uri="{FF2B5EF4-FFF2-40B4-BE49-F238E27FC236}">
-                <a16:creationId xmlns:a16="http://schemas.microsoft.com/office/drawing/2014/main" id="{CB9BA75C-DF6F-4D00-0813-06CF679BA1B2}"/>
-              </a:ext>
-            </a:extLst>
-          </p:cNvPr>
-          <p:cNvSpPr/>
-          <p:nvPr/>
-        </p:nvSpPr>
-        <p:spPr>
-          <a:xfrm>
-            <a:off x="0" y="0"/>
-            <a:ext cx="12192000" cy="101600"/>
-          </a:xfrm>
-          <a:prstGeom prst="rect">
-            <a:avLst/>
-          </a:prstGeom>
-          <a:solidFill>
-            <a:srgbClr val="0070BA"/>
-          </a:solidFill>
-          <a:ln w="19050" cap="flat" cmpd="sng" algn="ctr">
-            <a:noFill/>
-            <a:prstDash val="solid"/>
-            <a:miter lim="800000"/>
-          </a:ln>
-          <a:effectLst/>
-        </p:spPr>
-        <p:style>
-          <a:lnRef idx="2">
-            <a:schemeClr val="accent1">
-              <a:shade val="15000"/>
-            </a:schemeClr>
-          </a:lnRef>
-          <a:fillRef idx="1">
-            <a:schemeClr val="accent1"/>
-          </a:fillRef>
-          <a:effectRef idx="0">
-            <a:schemeClr val="accent1"/>
-          </a:effectRef>
-          <a:fontRef idx="minor">
-            <a:schemeClr val="lt1"/>
-          </a:fontRef>
-        </p:style>
-        <p:txBody>
-          <a:bodyPr rtlCol="0" anchor="ctr"/>
-          <a:lstStyle/>
-          <a:p>
-            <a:pPr algn="ctr"/>
-            <a:endParaRPr lang="es-EC"/>
-          </a:p>
-        </p:txBody>
-      </p:sp>
-      <p:sp>
-        <p:nvSpPr>
-          <p:cNvPr id="4" name="CuadroTexto 3">
-            <a:extLst>
-              <a:ext uri="{FF2B5EF4-FFF2-40B4-BE49-F238E27FC236}">
-                <a16:creationId xmlns:a16="http://schemas.microsoft.com/office/drawing/2014/main" id="{C7391E44-13AC-F356-F40D-C51FFD98A846}"/>
-              </a:ext>
-            </a:extLst>
-          </p:cNvPr>
-          <p:cNvSpPr txBox="1"/>
-          <p:nvPr/>
-        </p:nvSpPr>
-        <p:spPr>
-          <a:xfrm>
-            <a:off x="762000" y="444500"/>
-            <a:ext cx="10668000" cy="492443"/>
-          </a:xfrm>
-          <a:prstGeom prst="rect">
-            <a:avLst/>
-          </a:prstGeom>
-          <a:noFill/>
-        </p:spPr>
-        <p:txBody>
-          <a:bodyPr vert="horz" wrap="square" rtlCol="0">
-            <a:spAutoFit/>
-          </a:bodyPr>
-          <a:lstStyle/>
-          <a:p>
-            <a:r>
-              <a:rPr lang="es-MX" sz="2600" b="1">
-                <a:solidFill>
-                  <a:srgbClr val="0F2042"/>
-                </a:solidFill>
-                <a:latin typeface="Calibri" panose="020F0502020204030204" pitchFamily="34" charset="0"/>
-              </a:rPr>
-              <a:t>Novedad y Diferenciacion: Por que es Unico?</a:t>
-            </a:r>
-            <a:endParaRPr lang="es-EC" sz="2600" b="1">
-              <a:solidFill>
-                <a:srgbClr val="0F2042"/>
-              </a:solidFill>
-              <a:latin typeface="Calibri" panose="020F0502020204030204" pitchFamily="34" charset="0"/>
-            </a:endParaRPr>
-          </a:p>
-        </p:txBody>
-      </p:sp>
-      <p:sp>
-        <p:nvSpPr>
-          <p:cNvPr id="5" name="CuadroTexto 4">
-            <a:extLst>
-              <a:ext uri="{FF2B5EF4-FFF2-40B4-BE49-F238E27FC236}">
-                <a16:creationId xmlns:a16="http://schemas.microsoft.com/office/drawing/2014/main" id="{5188692D-A6B0-7B64-189F-844A58CB6038}"/>
-              </a:ext>
-            </a:extLst>
-          </p:cNvPr>
-          <p:cNvSpPr txBox="1"/>
-          <p:nvPr/>
-        </p:nvSpPr>
-        <p:spPr>
-          <a:xfrm>
-            <a:off x="762000" y="1016000"/>
-            <a:ext cx="10668000" cy="307777"/>
-          </a:xfrm>
-          <a:prstGeom prst="rect">
-            <a:avLst/>
-          </a:prstGeom>
-          <a:noFill/>
-        </p:spPr>
-        <p:txBody>
-          <a:bodyPr vert="horz" rtlCol="0">
-            <a:spAutoFit/>
-          </a:bodyPr>
-          <a:lstStyle/>
-          <a:p>
-            <a:r>
-              <a:rPr lang="es-MX" sz="1400">
-                <a:solidFill>
-                  <a:srgbClr val="64748B"/>
-                </a:solidFill>
-                <a:latin typeface="Calibri" panose="020F0502020204030204" pitchFamily="34" charset="0"/>
-              </a:rPr>
-              <a:t>Mas alla de un reporte estatico: accion operativa en primera linea y movilidad sostenible</a:t>
-            </a:r>
-            <a:endParaRPr lang="es-EC" sz="1400">
-              <a:solidFill>
-                <a:srgbClr val="64748B"/>
-              </a:solidFill>
-              <a:latin typeface="Calibri" panose="020F0502020204030204" pitchFamily="34" charset="0"/>
-            </a:endParaRPr>
-          </a:p>
-        </p:txBody>
-      </p:sp>
-      <p:sp>
-        <p:nvSpPr>
-          <p:cNvPr id="6" name="CuadroTexto 5">
-            <a:extLst>
-              <a:ext uri="{FF2B5EF4-FFF2-40B4-BE49-F238E27FC236}">
-                <a16:creationId xmlns:a16="http://schemas.microsoft.com/office/drawing/2014/main" id="{0D261A16-E6FD-CA75-B006-51F89FF3187D}"/>
-              </a:ext>
-            </a:extLst>
-          </p:cNvPr>
-          <p:cNvSpPr txBox="1"/>
-          <p:nvPr/>
-        </p:nvSpPr>
-        <p:spPr>
-          <a:xfrm>
-            <a:off x="762000" y="6350000"/>
-            <a:ext cx="10668000" cy="246221"/>
-          </a:xfrm>
-          <a:prstGeom prst="rect">
-            <a:avLst/>
-          </a:prstGeom>
-          <a:noFill/>
-        </p:spPr>
-        <p:txBody>
-          <a:bodyPr vert="horz" rtlCol="0">
-            <a:spAutoFit/>
-          </a:bodyPr>
-          <a:lstStyle/>
-          <a:p>
-            <a:r>
-              <a:rPr lang="es-MX" sz="1000">
-                <a:solidFill>
-                  <a:srgbClr val="64748B"/>
-                </a:solidFill>
-                <a:latin typeface="Calibri" panose="020F0502020204030204" pitchFamily="34" charset="0"/>
-              </a:rPr>
-              <a:t>FarmaSenal | Reto Farmaenlace y BYD - Equipo Los 21 Pilotos</a:t>
-            </a:r>
-            <a:endParaRPr lang="es-EC" sz="1000">
-              <a:solidFill>
-                <a:srgbClr val="64748B"/>
-              </a:solidFill>
-              <a:latin typeface="Calibri" panose="020F0502020204030204" pitchFamily="34" charset="0"/>
-            </a:endParaRPr>
-          </a:p>
-        </p:txBody>
-      </p:sp>
-      <p:sp>
-        <p:nvSpPr>
-          <p:cNvPr id="7" name="Rectángulo 6">
-            <a:extLst>
-              <a:ext uri="{FF2B5EF4-FFF2-40B4-BE49-F238E27FC236}">
-                <a16:creationId xmlns:a16="http://schemas.microsoft.com/office/drawing/2014/main" id="{1D079B48-8D8A-222E-9A51-D7C9FFC44FFA}"/>
-              </a:ext>
-            </a:extLst>
-          </p:cNvPr>
-          <p:cNvSpPr/>
-          <p:nvPr/>
-        </p:nvSpPr>
-        <p:spPr>
-          <a:xfrm>
-            <a:off x="762000" y="1651000"/>
-            <a:ext cx="5207000" cy="4318000"/>
-          </a:xfrm>
-          <a:prstGeom prst="rect">
-            <a:avLst/>
-          </a:prstGeom>
-          <a:solidFill>
-            <a:srgbClr val="FFFFFF"/>
-          </a:solidFill>
-          <a:ln>
-            <a:solidFill>
-              <a:srgbClr val="E2E8F0"/>
-            </a:solidFill>
-          </a:ln>
-        </p:spPr>
-        <p:style>
-          <a:lnRef idx="2">
-            <a:schemeClr val="accent1">
-              <a:shade val="15000"/>
-            </a:schemeClr>
-          </a:lnRef>
-          <a:fillRef idx="1">
-            <a:schemeClr val="accent1"/>
-          </a:fillRef>
-          <a:effectRef idx="0">
-            <a:schemeClr val="accent1"/>
-          </a:effectRef>
-          <a:fontRef idx="minor">
-            <a:schemeClr val="lt1"/>
-          </a:fontRef>
-        </p:style>
-        <p:txBody>
-          <a:bodyPr rtlCol="0" anchor="ctr"/>
-          <a:lstStyle/>
-          <a:p>
-            <a:pPr algn="ctr"/>
-            <a:endParaRPr lang="es-EC"/>
-          </a:p>
-        </p:txBody>
-      </p:sp>
-      <p:sp>
-        <p:nvSpPr>
-          <p:cNvPr id="8" name="CuadroTexto 7">
-            <a:extLst>
-              <a:ext uri="{FF2B5EF4-FFF2-40B4-BE49-F238E27FC236}">
-                <a16:creationId xmlns:a16="http://schemas.microsoft.com/office/drawing/2014/main" id="{9AC1ED94-6A3B-9DA8-E7C5-0AD1D665B145}"/>
-              </a:ext>
-            </a:extLst>
-          </p:cNvPr>
-          <p:cNvSpPr txBox="1"/>
-          <p:nvPr/>
-        </p:nvSpPr>
-        <p:spPr>
-          <a:xfrm>
-            <a:off x="952500" y="1841500"/>
-            <a:ext cx="4826000" cy="2031325"/>
-          </a:xfrm>
-          <a:prstGeom prst="rect">
-            <a:avLst/>
-          </a:prstGeom>
-          <a:noFill/>
-        </p:spPr>
-        <p:txBody>
-          <a:bodyPr vert="horz" wrap="square" rtlCol="0">
-            <a:spAutoFit/>
-          </a:bodyPr>
-          <a:lstStyle/>
-          <a:p>
-            <a:r>
-              <a:rPr lang="es-MX" sz="1400">
-                <a:solidFill>
-                  <a:srgbClr val="1E293B"/>
-                </a:solidFill>
-                <a:latin typeface="Calibri" panose="020F0502020204030204" pitchFamily="34" charset="0"/>
-              </a:rPr>
-              <a:t>Frente a Power BI / Qlik tradicional:</a:t>
-            </a:r>
-          </a:p>
-          <a:p>
-            <a:endParaRPr lang="es-MX" sz="1400">
-              <a:solidFill>
-                <a:srgbClr val="1E293B"/>
-              </a:solidFill>
-              <a:latin typeface="Calibri" panose="020F0502020204030204" pitchFamily="34" charset="0"/>
-            </a:endParaRPr>
-          </a:p>
-          <a:p>
-            <a:r>
-              <a:rPr lang="es-MX" sz="1400">
-                <a:solidFill>
-                  <a:srgbClr val="1E293B"/>
-                </a:solidFill>
-                <a:latin typeface="Calibri" panose="020F0502020204030204" pitchFamily="34" charset="0"/>
-              </a:rPr>
-              <a:t>x Reporte forense mensual o semanal (pasado).</a:t>
-            </a:r>
-          </a:p>
-          <a:p>
-            <a:r>
-              <a:rPr lang="es-MX" sz="1400">
-                <a:solidFill>
-                  <a:srgbClr val="1E293B"/>
-                </a:solidFill>
-                <a:latin typeface="Calibri" panose="020F0502020204030204" pitchFamily="34" charset="0"/>
-              </a:rPr>
-              <a:t>x Requiere analistas para interpretar graficos abstractos.</a:t>
-            </a:r>
-          </a:p>
-          <a:p>
-            <a:r>
-              <a:rPr lang="es-MX" sz="1400">
-                <a:solidFill>
-                  <a:srgbClr val="1E293B"/>
-                </a:solidFill>
-                <a:latin typeface="Calibri" panose="020F0502020204030204" pitchFamily="34" charset="0"/>
-              </a:rPr>
-              <a:t>x No calcula distancias ni tiempos de ruta.</a:t>
-            </a:r>
-          </a:p>
-          <a:p>
-            <a:endParaRPr lang="es-MX" sz="1400">
-              <a:solidFill>
-                <a:srgbClr val="1E293B"/>
-              </a:solidFill>
-              <a:latin typeface="Calibri" panose="020F0502020204030204" pitchFamily="34" charset="0"/>
-            </a:endParaRPr>
-          </a:p>
-          <a:p>
-            <a:r>
-              <a:rPr lang="es-MX" sz="1400">
-                <a:solidFill>
-                  <a:srgbClr val="1E293B"/>
-                </a:solidFill>
-                <a:latin typeface="Calibri" panose="020F0502020204030204" pitchFamily="34" charset="0"/>
-              </a:rPr>
-              <a:t>v FarmaSenal es OPERATIVO en tiempo real:</a:t>
-            </a:r>
-          </a:p>
-          <a:p>
-            <a:r>
-              <a:rPr lang="es-MX" sz="1400">
-                <a:solidFill>
-                  <a:srgbClr val="1E293B"/>
-                </a:solidFill>
-                <a:latin typeface="Calibri" panose="020F0502020204030204" pitchFamily="34" charset="0"/>
-              </a:rPr>
-              <a:t>  Genera recomendaciones directas de traslado entre farmacias del mismo barrio antes de que ocurra el quiebre.</a:t>
-            </a:r>
-            <a:endParaRPr lang="es-EC" sz="1400">
-              <a:solidFill>
-                <a:srgbClr val="1E293B"/>
-              </a:solidFill>
-              <a:latin typeface="Calibri" panose="020F0502020204030204" pitchFamily="34" charset="0"/>
-            </a:endParaRPr>
-          </a:p>
-        </p:txBody>
-      </p:sp>
-      <p:sp>
-        <p:nvSpPr>
-          <p:cNvPr id="9" name="Rectángulo 8">
-            <a:extLst>
-              <a:ext uri="{FF2B5EF4-FFF2-40B4-BE49-F238E27FC236}">
-                <a16:creationId xmlns:a16="http://schemas.microsoft.com/office/drawing/2014/main" id="{ABC7F0DA-1D46-285F-2432-C110087C2900}"/>
-              </a:ext>
-            </a:extLst>
-          </p:cNvPr>
-          <p:cNvSpPr/>
-          <p:nvPr/>
-        </p:nvSpPr>
-        <p:spPr>
-          <a:xfrm>
-            <a:off x="6223000" y="1651000"/>
-            <a:ext cx="5207000" cy="4318000"/>
-          </a:xfrm>
-          <a:prstGeom prst="rect">
-            <a:avLst/>
-          </a:prstGeom>
-          <a:solidFill>
-            <a:srgbClr val="FFFFFF"/>
-          </a:solidFill>
-          <a:ln w="25400">
-            <a:solidFill>
-              <a:srgbClr val="10B981"/>
-            </a:solidFill>
-          </a:ln>
-        </p:spPr>
-        <p:style>
-          <a:lnRef idx="2">
-            <a:schemeClr val="accent1">
-              <a:shade val="15000"/>
-            </a:schemeClr>
-          </a:lnRef>
-          <a:fillRef idx="1">
-            <a:schemeClr val="accent1"/>
-          </a:fillRef>
-          <a:effectRef idx="0">
-            <a:schemeClr val="accent1"/>
-          </a:effectRef>
-          <a:fontRef idx="minor">
-            <a:schemeClr val="lt1"/>
-          </a:fontRef>
-        </p:style>
-        <p:txBody>
-          <a:bodyPr rtlCol="0" anchor="ctr"/>
-          <a:lstStyle/>
-          <a:p>
-            <a:pPr algn="ctr"/>
-            <a:endParaRPr lang="es-EC"/>
-          </a:p>
-        </p:txBody>
-      </p:sp>
-      <p:sp>
-        <p:nvSpPr>
-          <p:cNvPr id="10" name="CuadroTexto 9">
-            <a:extLst>
-              <a:ext uri="{FF2B5EF4-FFF2-40B4-BE49-F238E27FC236}">
-                <a16:creationId xmlns:a16="http://schemas.microsoft.com/office/drawing/2014/main" id="{955E1F69-B8D6-0725-D709-EF8F662D25CB}"/>
-              </a:ext>
-            </a:extLst>
-          </p:cNvPr>
-          <p:cNvSpPr txBox="1"/>
-          <p:nvPr/>
-        </p:nvSpPr>
-        <p:spPr>
-          <a:xfrm>
-            <a:off x="6413500" y="1841500"/>
-            <a:ext cx="4826000" cy="2677656"/>
-          </a:xfrm>
-          <a:prstGeom prst="rect">
-            <a:avLst/>
-          </a:prstGeom>
-          <a:noFill/>
-        </p:spPr>
-        <p:txBody>
-          <a:bodyPr vert="horz" wrap="square" rtlCol="0">
-            <a:spAutoFit/>
-          </a:bodyPr>
-          <a:lstStyle/>
-          <a:p>
-            <a:r>
-              <a:rPr lang="es-MX" sz="1400">
-                <a:solidFill>
-                  <a:srgbClr val="1E293B"/>
-                </a:solidFill>
-                <a:latin typeface="Calibri" panose="020F0502020204030204" pitchFamily="34" charset="0"/>
-              </a:rPr>
-              <a:t>Sinergia Verde con BYD:</a:t>
-            </a:r>
-          </a:p>
-          <a:p>
-            <a:endParaRPr lang="es-MX" sz="1400">
-              <a:solidFill>
-                <a:srgbClr val="1E293B"/>
-              </a:solidFill>
-              <a:latin typeface="Calibri" panose="020F0502020204030204" pitchFamily="34" charset="0"/>
-            </a:endParaRPr>
-          </a:p>
-          <a:p>
-            <a:r>
-              <a:rPr lang="es-MX" sz="1400">
-                <a:solidFill>
-                  <a:srgbClr val="1E293B"/>
-                </a:solidFill>
-                <a:latin typeface="Calibri" panose="020F0502020204030204" pitchFamily="34" charset="0"/>
-              </a:rPr>
-              <a:t>- Logistica Electrica de Proximidad:</a:t>
-            </a:r>
-          </a:p>
-          <a:p>
-            <a:r>
-              <a:rPr lang="es-MX" sz="1400">
-                <a:solidFill>
-                  <a:srgbClr val="1E293B"/>
-                </a:solidFill>
-                <a:latin typeface="Calibri" panose="020F0502020204030204" pitchFamily="34" charset="0"/>
-              </a:rPr>
-              <a:t>  Los traslados intercomunitarios de medicamentos se ejecutan con vehiculos electricos BYD.</a:t>
-            </a:r>
-          </a:p>
-          <a:p>
-            <a:endParaRPr lang="es-MX" sz="1400">
-              <a:solidFill>
-                <a:srgbClr val="1E293B"/>
-              </a:solidFill>
-              <a:latin typeface="Calibri" panose="020F0502020204030204" pitchFamily="34" charset="0"/>
-            </a:endParaRPr>
-          </a:p>
-          <a:p>
-            <a:r>
-              <a:rPr lang="es-MX" sz="1400">
-                <a:solidFill>
-                  <a:srgbClr val="1E293B"/>
-                </a:solidFill>
-                <a:latin typeface="Calibri" panose="020F0502020204030204" pitchFamily="34" charset="0"/>
-              </a:rPr>
-              <a:t>- Red Nacional de Recarga:</a:t>
-            </a:r>
-          </a:p>
-          <a:p>
-            <a:r>
-              <a:rPr lang="es-MX" sz="1400">
-                <a:solidFill>
-                  <a:srgbClr val="1E293B"/>
-                </a:solidFill>
-                <a:latin typeface="Calibri" panose="020F0502020204030204" pitchFamily="34" charset="0"/>
-              </a:rPr>
-              <a:t>  Integracion con los mas de 150 puntos de carga BYD.</a:t>
-            </a:r>
-          </a:p>
-          <a:p>
-            <a:endParaRPr lang="es-MX" sz="1400">
-              <a:solidFill>
-                <a:srgbClr val="1E293B"/>
-              </a:solidFill>
-              <a:latin typeface="Calibri" panose="020F0502020204030204" pitchFamily="34" charset="0"/>
-            </a:endParaRPr>
-          </a:p>
-          <a:p>
-            <a:r>
-              <a:rPr lang="es-MX" sz="1400">
-                <a:solidFill>
-                  <a:srgbClr val="1E293B"/>
-                </a:solidFill>
-                <a:latin typeface="Calibri" panose="020F0502020204030204" pitchFamily="34" charset="0"/>
-              </a:rPr>
-              <a:t>- Cero Emisiones y Menor Costo por Km:</a:t>
-            </a:r>
-          </a:p>
-          <a:p>
-            <a:r>
-              <a:rPr lang="es-MX" sz="1400">
-                <a:solidFill>
-                  <a:srgbClr val="1E293B"/>
-                </a:solidFill>
-                <a:latin typeface="Calibri" panose="020F0502020204030204" pitchFamily="34" charset="0"/>
-              </a:rPr>
-              <a:t>  Reduccion drastica del costo de transporte en reabastecimiento de emergencia.</a:t>
-            </a:r>
-            <a:endParaRPr lang="es-EC" sz="1400">
-              <a:solidFill>
-                <a:srgbClr val="1E293B"/>
-              </a:solidFill>
-              <a:latin typeface="Calibri" panose="020F0502020204030204" pitchFamily="34" charset="0"/>
-            </a:endParaRPr>
-          </a:p>
-        </p:txBody>
-      </p:sp>
-    </p:spTree>
-    <p:extLst>
-      <p:ext uri="{BB962C8B-B14F-4D97-AF65-F5344CB8AC3E}">
-        <p14:creationId xmlns:p14="http://schemas.microsoft.com/office/powerpoint/2010/main" val="2767000344"/>
-      </p:ext>
-    </p:extLst>
-  </p:cSld>
-  <p:clrMapOvr>
-    <a:masterClrMapping/>
-  </p:clrMapOvr>
-</p:sld>
-</file>
-
-<file path=ppt/slides/slide7.xml><?xml version="1.0" encoding="utf-8"?>
-<p:sld xmlns:a="http://schemas.openxmlformats.org/drawingml/2006/main" xmlns:r="http://schemas.openxmlformats.org/officeDocument/2006/relationships" xmlns:p="http://schemas.openxmlformats.org/presentationml/2006/main">
-  <p:cSld>
-    <p:spTree>
-      <p:nvGrpSpPr>
-        <p:cNvPr id="1" name=""/>
-        <p:cNvGrpSpPr/>
-        <p:nvPr/>
-      </p:nvGrpSpPr>
-      <p:grpSpPr>
-        <a:xfrm>
-          <a:off x="0" y="0"/>
-          <a:ext cx="0" cy="0"/>
-          <a:chOff x="0" y="0"/>
-          <a:chExt cx="0" cy="0"/>
-        </a:xfrm>
-      </p:grpSpPr>
-      <p:sp>
-        <p:nvSpPr>
-          <p:cNvPr id="2" name="Rectángulo 1">
-            <a:extLst>
-              <a:ext uri="{FF2B5EF4-FFF2-40B4-BE49-F238E27FC236}">
-                <a16:creationId xmlns:a16="http://schemas.microsoft.com/office/drawing/2014/main" id="{8911B2F0-0785-C112-C062-2397C4580B4C}"/>
-              </a:ext>
-            </a:extLst>
-          </p:cNvPr>
-          <p:cNvSpPr/>
-          <p:nvPr/>
-        </p:nvSpPr>
-        <p:spPr>
-          <a:xfrm>
-            <a:off x="0" y="0"/>
-            <a:ext cx="12192000" cy="6858000"/>
-          </a:xfrm>
-          <a:prstGeom prst="rect">
-            <a:avLst/>
-          </a:prstGeom>
-          <a:solidFill>
-            <a:srgbClr val="F8FAFC"/>
-          </a:solidFill>
-          <a:ln w="19050" cap="flat" cmpd="sng" algn="ctr">
-            <a:noFill/>
-            <a:prstDash val="solid"/>
-            <a:miter lim="800000"/>
-          </a:ln>
-          <a:effectLst/>
-        </p:spPr>
-        <p:style>
-          <a:lnRef idx="2">
-            <a:schemeClr val="accent1">
-              <a:shade val="15000"/>
-            </a:schemeClr>
-          </a:lnRef>
-          <a:fillRef idx="1">
-            <a:schemeClr val="accent1"/>
-          </a:fillRef>
-          <a:effectRef idx="0">
-            <a:schemeClr val="accent1"/>
-          </a:effectRef>
-          <a:fontRef idx="minor">
-            <a:schemeClr val="lt1"/>
-          </a:fontRef>
-        </p:style>
-        <p:txBody>
-          <a:bodyPr rtlCol="0" anchor="ctr"/>
-          <a:lstStyle/>
-          <a:p>
-            <a:pPr algn="ctr"/>
-            <a:endParaRPr lang="es-EC"/>
-          </a:p>
-        </p:txBody>
-      </p:sp>
-      <p:sp>
-        <p:nvSpPr>
-          <p:cNvPr id="3" name="Rectángulo 2">
-            <a:extLst>
-              <a:ext uri="{FF2B5EF4-FFF2-40B4-BE49-F238E27FC236}">
-                <a16:creationId xmlns:a16="http://schemas.microsoft.com/office/drawing/2014/main" id="{9EADCED2-1830-86BD-1250-82C114CBDBAA}"/>
-              </a:ext>
-            </a:extLst>
-          </p:cNvPr>
-          <p:cNvSpPr/>
-          <p:nvPr/>
-        </p:nvSpPr>
-        <p:spPr>
-          <a:xfrm>
-            <a:off x="0" y="0"/>
-            <a:ext cx="12192000" cy="101600"/>
-          </a:xfrm>
-          <a:prstGeom prst="rect">
-            <a:avLst/>
-          </a:prstGeom>
-          <a:solidFill>
-            <a:srgbClr val="0070BA"/>
-          </a:solidFill>
-          <a:ln w="19050" cap="flat" cmpd="sng" algn="ctr">
-            <a:noFill/>
-            <a:prstDash val="solid"/>
-            <a:miter lim="800000"/>
-          </a:ln>
-          <a:effectLst/>
-        </p:spPr>
-        <p:style>
-          <a:lnRef idx="2">
-            <a:schemeClr val="accent1">
-              <a:shade val="15000"/>
-            </a:schemeClr>
-          </a:lnRef>
-          <a:fillRef idx="1">
-            <a:schemeClr val="accent1"/>
-          </a:fillRef>
-          <a:effectRef idx="0">
-            <a:schemeClr val="accent1"/>
-          </a:effectRef>
-          <a:fontRef idx="minor">
-            <a:schemeClr val="lt1"/>
-          </a:fontRef>
-        </p:style>
-        <p:txBody>
-          <a:bodyPr rtlCol="0" anchor="ctr"/>
-          <a:lstStyle/>
-          <a:p>
-            <a:pPr algn="ctr"/>
-            <a:endParaRPr lang="es-EC"/>
-          </a:p>
-        </p:txBody>
-      </p:sp>
-      <p:sp>
-        <p:nvSpPr>
-          <p:cNvPr id="4" name="CuadroTexto 3">
-            <a:extLst>
-              <a:ext uri="{FF2B5EF4-FFF2-40B4-BE49-F238E27FC236}">
-                <a16:creationId xmlns:a16="http://schemas.microsoft.com/office/drawing/2014/main" id="{C1DFAA1E-2EB9-3FC7-8A2F-3924B77C9D07}"/>
-              </a:ext>
-            </a:extLst>
-          </p:cNvPr>
-          <p:cNvSpPr txBox="1"/>
-          <p:nvPr/>
-        </p:nvSpPr>
-        <p:spPr>
-          <a:xfrm>
-            <a:off x="762000" y="444500"/>
-            <a:ext cx="10668000" cy="492443"/>
-          </a:xfrm>
-          <a:prstGeom prst="rect">
-            <a:avLst/>
-          </a:prstGeom>
-          <a:noFill/>
-        </p:spPr>
-        <p:txBody>
-          <a:bodyPr vert="horz" wrap="square" rtlCol="0">
-            <a:spAutoFit/>
-          </a:bodyPr>
-          <a:lstStyle/>
-          <a:p>
-            <a:r>
-              <a:rPr lang="es-MX" sz="2600" b="1">
-                <a:solidFill>
-                  <a:srgbClr val="0F2042"/>
-                </a:solidFill>
-                <a:latin typeface="Calibri" panose="020F0502020204030204" pitchFamily="34" charset="0"/>
-              </a:rPr>
-              <a:t>Impacto en Negocio y Ruta a Produccion</a:t>
-            </a:r>
-            <a:endParaRPr lang="es-EC" sz="2600" b="1">
-              <a:solidFill>
-                <a:srgbClr val="0F2042"/>
-              </a:solidFill>
-              <a:latin typeface="Calibri" panose="020F0502020204030204" pitchFamily="34" charset="0"/>
-            </a:endParaRPr>
-          </a:p>
-        </p:txBody>
-      </p:sp>
-      <p:sp>
-        <p:nvSpPr>
-          <p:cNvPr id="5" name="CuadroTexto 4">
-            <a:extLst>
-              <a:ext uri="{FF2B5EF4-FFF2-40B4-BE49-F238E27FC236}">
-                <a16:creationId xmlns:a16="http://schemas.microsoft.com/office/drawing/2014/main" id="{66363C5F-873E-5B16-CCAD-082F6730E75D}"/>
-              </a:ext>
-            </a:extLst>
-          </p:cNvPr>
-          <p:cNvSpPr txBox="1"/>
-          <p:nvPr/>
-        </p:nvSpPr>
-        <p:spPr>
-          <a:xfrm>
-            <a:off x="762000" y="1016000"/>
-            <a:ext cx="10668000" cy="307777"/>
-          </a:xfrm>
-          <a:prstGeom prst="rect">
-            <a:avLst/>
-          </a:prstGeom>
-          <a:noFill/>
-        </p:spPr>
-        <p:txBody>
-          <a:bodyPr vert="horz" rtlCol="0">
-            <a:spAutoFit/>
-          </a:bodyPr>
-          <a:lstStyle/>
-          <a:p>
-            <a:r>
-              <a:rPr lang="es-MX" sz="1400">
-                <a:solidFill>
-                  <a:srgbClr val="64748B"/>
-                </a:solidFill>
-                <a:latin typeface="Calibri" panose="020F0502020204030204" pitchFamily="34" charset="0"/>
-              </a:rPr>
-              <a:t>Retorno de inversion medible y compatibilidad con la operacion actual</a:t>
-            </a:r>
-            <a:endParaRPr lang="es-EC" sz="1400">
-              <a:solidFill>
-                <a:srgbClr val="64748B"/>
-              </a:solidFill>
-              <a:latin typeface="Calibri" panose="020F0502020204030204" pitchFamily="34" charset="0"/>
-            </a:endParaRPr>
-          </a:p>
-        </p:txBody>
-      </p:sp>
-      <p:sp>
-        <p:nvSpPr>
-          <p:cNvPr id="6" name="CuadroTexto 5">
-            <a:extLst>
-              <a:ext uri="{FF2B5EF4-FFF2-40B4-BE49-F238E27FC236}">
-                <a16:creationId xmlns:a16="http://schemas.microsoft.com/office/drawing/2014/main" id="{53AE4FCF-C3D0-9D06-515D-391CCDA3A7CA}"/>
-              </a:ext>
-            </a:extLst>
-          </p:cNvPr>
-          <p:cNvSpPr txBox="1"/>
-          <p:nvPr/>
-        </p:nvSpPr>
-        <p:spPr>
-          <a:xfrm>
-            <a:off x="762000" y="6350000"/>
-            <a:ext cx="10668000" cy="246221"/>
-          </a:xfrm>
-          <a:prstGeom prst="rect">
-            <a:avLst/>
-          </a:prstGeom>
-          <a:noFill/>
-        </p:spPr>
-        <p:txBody>
-          <a:bodyPr vert="horz" rtlCol="0">
-            <a:spAutoFit/>
-          </a:bodyPr>
-          <a:lstStyle/>
-          <a:p>
-            <a:r>
-              <a:rPr lang="es-MX" sz="1000">
-                <a:solidFill>
-                  <a:srgbClr val="64748B"/>
-                </a:solidFill>
-                <a:latin typeface="Calibri" panose="020F0502020204030204" pitchFamily="34" charset="0"/>
-              </a:rPr>
-              <a:t>FarmaSenal | Reto Farmaenlace y BYD - Equipo Los 21 Pilotos</a:t>
-            </a:r>
-            <a:endParaRPr lang="es-EC" sz="1000">
-              <a:solidFill>
-                <a:srgbClr val="64748B"/>
-              </a:solidFill>
-              <a:latin typeface="Calibri" panose="020F0502020204030204" pitchFamily="34" charset="0"/>
-            </a:endParaRPr>
-          </a:p>
-        </p:txBody>
-      </p:sp>
-      <p:sp>
-        <p:nvSpPr>
-          <p:cNvPr id="7" name="Rectángulo 6">
-            <a:extLst>
-              <a:ext uri="{FF2B5EF4-FFF2-40B4-BE49-F238E27FC236}">
-                <a16:creationId xmlns:a16="http://schemas.microsoft.com/office/drawing/2014/main" id="{D0448FC5-CCDD-A035-A711-7808BB2F3DB0}"/>
-              </a:ext>
-            </a:extLst>
-          </p:cNvPr>
-          <p:cNvSpPr/>
-          <p:nvPr/>
-        </p:nvSpPr>
-        <p:spPr>
-          <a:xfrm>
-            <a:off x="762000" y="1651000"/>
-            <a:ext cx="5207000" cy="4318000"/>
-          </a:xfrm>
-          <a:prstGeom prst="rect">
-            <a:avLst/>
-          </a:prstGeom>
-          <a:solidFill>
-            <a:srgbClr val="FFFFFF"/>
-          </a:solidFill>
-          <a:ln>
-            <a:solidFill>
-              <a:srgbClr val="E2E8F0"/>
-            </a:solidFill>
-          </a:ln>
-        </p:spPr>
-        <p:style>
-          <a:lnRef idx="2">
-            <a:schemeClr val="accent1">
-              <a:shade val="15000"/>
-            </a:schemeClr>
-          </a:lnRef>
-          <a:fillRef idx="1">
-            <a:schemeClr val="accent1"/>
-          </a:fillRef>
-          <a:effectRef idx="0">
-            <a:schemeClr val="accent1"/>
-          </a:effectRef>
-          <a:fontRef idx="minor">
-            <a:schemeClr val="lt1"/>
-          </a:fontRef>
-        </p:style>
-        <p:txBody>
-          <a:bodyPr rtlCol="0" anchor="ctr"/>
-          <a:lstStyle/>
-          <a:p>
-            <a:pPr algn="ctr"/>
-            <a:endParaRPr lang="es-EC"/>
-          </a:p>
-        </p:txBody>
-      </p:sp>
-      <p:sp>
-        <p:nvSpPr>
-          <p:cNvPr id="8" name="CuadroTexto 7">
-            <a:extLst>
-              <a:ext uri="{FF2B5EF4-FFF2-40B4-BE49-F238E27FC236}">
-                <a16:creationId xmlns:a16="http://schemas.microsoft.com/office/drawing/2014/main" id="{5571A1E0-E103-BEAE-C2B5-29B0C1CB1FD5}"/>
-              </a:ext>
-            </a:extLst>
-          </p:cNvPr>
-          <p:cNvSpPr txBox="1"/>
-          <p:nvPr/>
-        </p:nvSpPr>
-        <p:spPr>
-          <a:xfrm>
-            <a:off x="1016000" y="1841500"/>
-            <a:ext cx="4699000" cy="2462213"/>
-          </a:xfrm>
-          <a:prstGeom prst="rect">
-            <a:avLst/>
-          </a:prstGeom>
-          <a:noFill/>
-        </p:spPr>
-        <p:txBody>
-          <a:bodyPr vert="horz" wrap="square" rtlCol="0">
-            <a:spAutoFit/>
-          </a:bodyPr>
-          <a:lstStyle/>
-          <a:p>
-            <a:r>
-              <a:rPr lang="es-MX" sz="1400">
-                <a:solidFill>
-                  <a:srgbClr val="1E293B"/>
-                </a:solidFill>
-                <a:latin typeface="Calibri" panose="020F0502020204030204" pitchFamily="34" charset="0"/>
-              </a:rPr>
-              <a:t>Metrica de Reduccion de Costos:</a:t>
-            </a:r>
-          </a:p>
-          <a:p>
-            <a:endParaRPr lang="es-MX" sz="1400">
-              <a:solidFill>
-                <a:srgbClr val="1E293B"/>
-              </a:solidFill>
-              <a:latin typeface="Calibri" panose="020F0502020204030204" pitchFamily="34" charset="0"/>
-            </a:endParaRPr>
-          </a:p>
-          <a:p>
-            <a:r>
-              <a:rPr lang="es-MX" sz="1400">
-                <a:solidFill>
-                  <a:srgbClr val="1E293B"/>
-                </a:solidFill>
-                <a:latin typeface="Calibri" panose="020F0502020204030204" pitchFamily="34" charset="0"/>
-              </a:rPr>
-              <a:t>Costo Operativo = </a:t>
-            </a:r>
-          </a:p>
-          <a:p>
-            <a:r>
-              <a:rPr lang="es-MX" sz="1400">
-                <a:solidFill>
-                  <a:srgbClr val="1E293B"/>
-                </a:solidFill>
-                <a:latin typeface="Calibri" panose="020F0502020204030204" pitchFamily="34" charset="0"/>
-              </a:rPr>
-              <a:t>  (Ventas Perdidas x Margen)</a:t>
-            </a:r>
-          </a:p>
-          <a:p>
-            <a:r>
-              <a:rPr lang="es-MX" sz="1400">
-                <a:solidFill>
-                  <a:srgbClr val="1E293B"/>
-                </a:solidFill>
-                <a:latin typeface="Calibri" panose="020F0502020204030204" pitchFamily="34" charset="0"/>
-              </a:rPr>
-              <a:t>  + (Mermas por Caducidad x Costo)</a:t>
-            </a:r>
-          </a:p>
-          <a:p>
-            <a:r>
-              <a:rPr lang="es-MX" sz="1400">
-                <a:solidFill>
-                  <a:srgbClr val="1E293B"/>
-                </a:solidFill>
-                <a:latin typeface="Calibri" panose="020F0502020204030204" pitchFamily="34" charset="0"/>
-              </a:rPr>
-              <a:t>  + Costos de Fletes Urgentes</a:t>
-            </a:r>
-          </a:p>
-          <a:p>
-            <a:endParaRPr lang="es-MX" sz="1400">
-              <a:solidFill>
-                <a:srgbClr val="1E293B"/>
-              </a:solidFill>
-              <a:latin typeface="Calibri" panose="020F0502020204030204" pitchFamily="34" charset="0"/>
-            </a:endParaRPr>
-          </a:p>
-          <a:p>
-            <a:r>
-              <a:rPr lang="es-MX" sz="1400">
-                <a:solidFill>
-                  <a:srgbClr val="1E293B"/>
-                </a:solidFill>
-                <a:latin typeface="Calibri" panose="020F0502020204030204" pitchFamily="34" charset="0"/>
-              </a:rPr>
-              <a:t>Resultados Esperados:</a:t>
-            </a:r>
-          </a:p>
-          <a:p>
-            <a:r>
-              <a:rPr lang="es-MX" sz="1400">
-                <a:solidFill>
-                  <a:srgbClr val="1E293B"/>
-                </a:solidFill>
-                <a:latin typeface="Calibri" panose="020F0502020204030204" pitchFamily="34" charset="0"/>
-              </a:rPr>
-              <a:t>- Retencion del paciente cronico en mostrador.</a:t>
-            </a:r>
-          </a:p>
-          <a:p>
-            <a:r>
-              <a:rPr lang="es-MX" sz="1400">
-                <a:solidFill>
-                  <a:srgbClr val="1E293B"/>
-                </a:solidFill>
-                <a:latin typeface="Calibri" panose="020F0502020204030204" pitchFamily="34" charset="0"/>
-              </a:rPr>
-              <a:t>- Disminucion del stock inmovilizado con riesgo de vencer.</a:t>
-            </a:r>
-          </a:p>
-          <a:p>
-            <a:r>
-              <a:rPr lang="es-MX" sz="1400">
-                <a:solidFill>
-                  <a:srgbClr val="1E293B"/>
-                </a:solidFill>
-                <a:latin typeface="Calibri" panose="020F0502020204030204" pitchFamily="34" charset="0"/>
-              </a:rPr>
-              <a:t>- Eficiencia de fletes y abastecimiento programado.</a:t>
-            </a:r>
-            <a:endParaRPr lang="es-EC" sz="1400">
-              <a:solidFill>
-                <a:srgbClr val="1E293B"/>
-              </a:solidFill>
-              <a:latin typeface="Calibri" panose="020F0502020204030204" pitchFamily="34" charset="0"/>
-            </a:endParaRPr>
-          </a:p>
-        </p:txBody>
-      </p:sp>
-      <p:sp>
-        <p:nvSpPr>
-          <p:cNvPr id="9" name="Rectángulo 8">
-            <a:extLst>
-              <a:ext uri="{FF2B5EF4-FFF2-40B4-BE49-F238E27FC236}">
-                <a16:creationId xmlns:a16="http://schemas.microsoft.com/office/drawing/2014/main" id="{CB2289D2-51A7-F85C-0E62-6AE1D221500C}"/>
-              </a:ext>
-            </a:extLst>
-          </p:cNvPr>
-          <p:cNvSpPr/>
-          <p:nvPr/>
-        </p:nvSpPr>
-        <p:spPr>
-          <a:xfrm>
-            <a:off x="6223000" y="1651000"/>
-            <a:ext cx="5207000" cy="4318000"/>
-          </a:xfrm>
-          <a:prstGeom prst="rect">
-            <a:avLst/>
-          </a:prstGeom>
-          <a:solidFill>
-            <a:srgbClr val="FFFFFF"/>
-          </a:solidFill>
-          <a:ln>
-            <a:solidFill>
-              <a:srgbClr val="E2E8F0"/>
-            </a:solidFill>
-          </a:ln>
-        </p:spPr>
-        <p:style>
-          <a:lnRef idx="2">
-            <a:schemeClr val="accent1">
-              <a:shade val="15000"/>
-            </a:schemeClr>
-          </a:lnRef>
-          <a:fillRef idx="1">
-            <a:schemeClr val="accent1"/>
-          </a:fillRef>
-          <a:effectRef idx="0">
-            <a:schemeClr val="accent1"/>
-          </a:effectRef>
-          <a:fontRef idx="minor">
-            <a:schemeClr val="lt1"/>
-          </a:fontRef>
-        </p:style>
-        <p:txBody>
-          <a:bodyPr rtlCol="0" anchor="ctr"/>
-          <a:lstStyle/>
-          <a:p>
-            <a:pPr algn="ctr"/>
-            <a:endParaRPr lang="es-EC"/>
-          </a:p>
-        </p:txBody>
-      </p:sp>
-      <p:sp>
-        <p:nvSpPr>
-          <p:cNvPr id="10" name="CuadroTexto 9">
-            <a:extLst>
-              <a:ext uri="{FF2B5EF4-FFF2-40B4-BE49-F238E27FC236}">
-                <a16:creationId xmlns:a16="http://schemas.microsoft.com/office/drawing/2014/main" id="{A9BC4B16-7557-F420-BBD8-678A529A8B63}"/>
-              </a:ext>
-            </a:extLst>
-          </p:cNvPr>
-          <p:cNvSpPr txBox="1"/>
-          <p:nvPr/>
-        </p:nvSpPr>
-        <p:spPr>
-          <a:xfrm>
-            <a:off x="6413500" y="1841500"/>
-            <a:ext cx="4826000" cy="2677656"/>
-          </a:xfrm>
-          <a:prstGeom prst="rect">
-            <a:avLst/>
-          </a:prstGeom>
-          <a:noFill/>
-        </p:spPr>
-        <p:txBody>
-          <a:bodyPr vert="horz" wrap="square" rtlCol="0">
-            <a:spAutoFit/>
-          </a:bodyPr>
-          <a:lstStyle/>
-          <a:p>
-            <a:r>
-              <a:rPr lang="es-MX" sz="1400">
-                <a:solidFill>
-                  <a:srgbClr val="1E293B"/>
-                </a:solidFill>
-                <a:latin typeface="Calibri" panose="020F0502020204030204" pitchFamily="34" charset="0"/>
-              </a:rPr>
-              <a:t>Ruta hacia el Piloto Real:</a:t>
-            </a:r>
-          </a:p>
-          <a:p>
-            <a:endParaRPr lang="es-MX" sz="1400">
-              <a:solidFill>
-                <a:srgbClr val="1E293B"/>
-              </a:solidFill>
-              <a:latin typeface="Calibri" panose="020F0502020204030204" pitchFamily="34" charset="0"/>
-            </a:endParaRPr>
-          </a:p>
-          <a:p>
-            <a:r>
-              <a:rPr lang="es-MX" sz="1400">
-                <a:solidFill>
-                  <a:srgbClr val="1E293B"/>
-                </a:solidFill>
-                <a:latin typeface="Calibri" panose="020F0502020204030204" pitchFamily="34" charset="0"/>
-              </a:rPr>
-              <a:t>1. Fase 1 (Completada hoy):</a:t>
-            </a:r>
-          </a:p>
-          <a:p>
-            <a:r>
-              <a:rPr lang="es-MX" sz="1400">
-                <a:solidFill>
-                  <a:srgbClr val="1E293B"/>
-                </a:solidFill>
-                <a:latin typeface="Calibri" panose="020F0502020204030204" pitchFamily="34" charset="0"/>
-              </a:rPr>
-              <a:t>   Prototipo funcional extremo a extremo con datasets sinteticos validados (farmacias, productos, ventas e inventario).</a:t>
-            </a:r>
-          </a:p>
-          <a:p>
-            <a:endParaRPr lang="es-MX" sz="1400">
-              <a:solidFill>
-                <a:srgbClr val="1E293B"/>
-              </a:solidFill>
-              <a:latin typeface="Calibri" panose="020F0502020204030204" pitchFamily="34" charset="0"/>
-            </a:endParaRPr>
-          </a:p>
-          <a:p>
-            <a:r>
-              <a:rPr lang="es-MX" sz="1400">
-                <a:solidFill>
-                  <a:srgbClr val="1E293B"/>
-                </a:solidFill>
-                <a:latin typeface="Calibri" panose="020F0502020204030204" pitchFamily="34" charset="0"/>
-              </a:rPr>
-              <a:t>2. Fase 2 (Piloto Territorial):</a:t>
-            </a:r>
-          </a:p>
-          <a:p>
-            <a:r>
-              <a:rPr lang="es-MX" sz="1400">
-                <a:solidFill>
-                  <a:srgbClr val="1E293B"/>
-                </a:solidFill>
-                <a:latin typeface="Calibri" panose="020F0502020204030204" pitchFamily="34" charset="0"/>
-              </a:rPr>
-              <a:t>   Conexion con capa de APIs de Vendix / SAP en cluster piloto (ej. 15 locales en Quito).</a:t>
-            </a:r>
-          </a:p>
-          <a:p>
-            <a:endParaRPr lang="es-MX" sz="1400">
-              <a:solidFill>
-                <a:srgbClr val="1E293B"/>
-              </a:solidFill>
-              <a:latin typeface="Calibri" panose="020F0502020204030204" pitchFamily="34" charset="0"/>
-            </a:endParaRPr>
-          </a:p>
-          <a:p>
-            <a:r>
-              <a:rPr lang="es-MX" sz="1400">
-                <a:solidFill>
-                  <a:srgbClr val="1E293B"/>
-                </a:solidFill>
-                <a:latin typeface="Calibri" panose="020F0502020204030204" pitchFamily="34" charset="0"/>
-              </a:rPr>
-              <a:t>3. Fase 3 (Escalamiento Nacional):</a:t>
-            </a:r>
-          </a:p>
-          <a:p>
-            <a:r>
-              <a:rPr lang="es-MX" sz="1400">
-                <a:solidFill>
-                  <a:srgbClr val="1E293B"/>
-                </a:solidFill>
-                <a:latin typeface="Calibri" panose="020F0502020204030204" pitchFamily="34" charset="0"/>
-              </a:rPr>
-              <a:t>   Despliegue serverless en AWS y balanceo automatico.</a:t>
-            </a:r>
-            <a:endParaRPr lang="es-EC" sz="1400">
-              <a:solidFill>
-                <a:srgbClr val="1E293B"/>
-              </a:solidFill>
-              <a:latin typeface="Calibri" panose="020F0502020204030204" pitchFamily="34" charset="0"/>
-            </a:endParaRPr>
-          </a:p>
-        </p:txBody>
-      </p:sp>
-    </p:spTree>
-    <p:extLst>
-      <p:ext uri="{BB962C8B-B14F-4D97-AF65-F5344CB8AC3E}">
-        <p14:creationId xmlns:p14="http://schemas.microsoft.com/office/powerpoint/2010/main" val="3005774153"/>
-      </p:ext>
-    </p:extLst>
-  </p:cSld>
-  <p:clrMapOvr>
-    <a:masterClrMapping/>
-  </p:clrMapOvr>
-</p:sld>
-</file>
-
-<file path=ppt/slides/slide8.xml><?xml version="1.0" encoding="utf-8"?>
-<p:sld xmlns:a="http://schemas.openxmlformats.org/drawingml/2006/main" xmlns:r="http://schemas.openxmlformats.org/officeDocument/2006/relationships" xmlns:p="http://schemas.openxmlformats.org/presentationml/2006/main">
-  <p:cSld>
-    <p:spTree>
-      <p:nvGrpSpPr>
-        <p:cNvPr id="1" name=""/>
-        <p:cNvGrpSpPr/>
-        <p:nvPr/>
-      </p:nvGrpSpPr>
-      <p:grpSpPr>
-        <a:xfrm>
-          <a:off x="0" y="0"/>
-          <a:ext cx="0" cy="0"/>
-          <a:chOff x="0" y="0"/>
-          <a:chExt cx="0" cy="0"/>
-        </a:xfrm>
-      </p:grpSpPr>
-      <p:sp>
-        <p:nvSpPr>
-          <p:cNvPr id="2" name="Rectángulo 1">
-            <a:extLst>
-              <a:ext uri="{FF2B5EF4-FFF2-40B4-BE49-F238E27FC236}">
-                <a16:creationId xmlns:a16="http://schemas.microsoft.com/office/drawing/2014/main" id="{685AF30F-0F58-E4FA-6DAD-9E617579F3EA}"/>
-              </a:ext>
-            </a:extLst>
-          </p:cNvPr>
-          <p:cNvSpPr/>
-          <p:nvPr/>
-        </p:nvSpPr>
-        <p:spPr>
-          <a:xfrm>
-            <a:off x="0" y="0"/>
-            <a:ext cx="12192000" cy="6858000"/>
-          </a:xfrm>
-          <a:prstGeom prst="rect">
-            <a:avLst/>
-          </a:prstGeom>
-          <a:solidFill>
-            <a:srgbClr val="0F2042"/>
-          </a:solidFill>
-          <a:ln w="19050" cap="flat" cmpd="sng" algn="ctr">
-            <a:noFill/>
-            <a:prstDash val="solid"/>
-            <a:miter lim="800000"/>
-          </a:ln>
-          <a:effectLst/>
-        </p:spPr>
-        <p:style>
-          <a:lnRef idx="2">
-            <a:schemeClr val="accent1">
-              <a:shade val="15000"/>
-            </a:schemeClr>
-          </a:lnRef>
-          <a:fillRef idx="1">
-            <a:schemeClr val="accent1"/>
-          </a:fillRef>
-          <a:effectRef idx="0">
-            <a:schemeClr val="accent1"/>
-          </a:effectRef>
-          <a:fontRef idx="minor">
-            <a:schemeClr val="lt1"/>
-          </a:fontRef>
-        </p:style>
-        <p:txBody>
-          <a:bodyPr rtlCol="0" anchor="ctr"/>
-          <a:lstStyle/>
-          <a:p>
-            <a:pPr algn="ctr"/>
-            <a:endParaRPr lang="es-EC"/>
-          </a:p>
-        </p:txBody>
-      </p:sp>
-      <p:sp>
-        <p:nvSpPr>
           <p:cNvPr id="3" name="CuadroTexto 2">
             <a:extLst>
               <a:ext uri="{FF2B5EF4-FFF2-40B4-BE49-F238E27FC236}">
-                <a16:creationId xmlns:a16="http://schemas.microsoft.com/office/drawing/2014/main" id="{F099C9EB-1AD6-3676-201B-53CC02F1EA5C}"/>
+                <a16:creationId xmlns:a16="http://schemas.microsoft.com/office/drawing/2014/main" id="{07682D6A-122A-38D6-9B31-6B861F18046C}"/>
               </a:ext>
             </a:extLst>
           </p:cNvPr>
@@ -7737,7 +6374,7 @@
           <p:cNvPr id="4" name="CuadroTexto 3">
             <a:extLst>
               <a:ext uri="{FF2B5EF4-FFF2-40B4-BE49-F238E27FC236}">
-                <a16:creationId xmlns:a16="http://schemas.microsoft.com/office/drawing/2014/main" id="{594BD290-A8BE-D4B0-791F-E137DC346B00}"/>
+                <a16:creationId xmlns:a16="http://schemas.microsoft.com/office/drawing/2014/main" id="{EE63CDAC-55DE-21C1-92B8-C2666AA80A98}"/>
               </a:ext>
             </a:extLst>
           </p:cNvPr>
@@ -7786,7 +6423,7 @@
                 </a:solidFill>
                 <a:latin typeface="Calibri" panose="020F0502020204030204" pitchFamily="34" charset="0"/>
               </a:rPr>
-              <a:t>Muchas gracias. Quedamos atentos a sus preguntas.</a:t>
+              <a:t>Muchas gracias. Pasamos a la sesion de preguntas.</a:t>
             </a:r>
             <a:endParaRPr lang="es-EC" sz="2000">
               <a:solidFill>
@@ -7800,7 +6437,7 @@
     </p:spTree>
     <p:extLst>
       <p:ext uri="{BB962C8B-B14F-4D97-AF65-F5344CB8AC3E}">
-        <p14:creationId xmlns:p14="http://schemas.microsoft.com/office/powerpoint/2010/main" val="3543137976"/>
+        <p14:creationId xmlns:p14="http://schemas.microsoft.com/office/powerpoint/2010/main" val="558561524"/>
       </p:ext>
     </p:extLst>
   </p:cSld>

</xml_diff>

<commit_message>
feat: Enfocar presentacion 100% en Linea 3 Mejora Operativa, remover BYD y agregar arte 3D de red logistica
</commit_message>
<xml_diff>
--- a/docs/FarmaSenal_Pitch_Presentacion.pptx
+++ b/docs/FarmaSenal_Pitch_Presentacion.pptx
@@ -134,7 +134,7 @@
           <p:cNvPr id="2" name="Título 1">
             <a:extLst>
               <a:ext uri="{FF2B5EF4-FFF2-40B4-BE49-F238E27FC236}">
-                <a16:creationId xmlns:a16="http://schemas.microsoft.com/office/drawing/2014/main" id="{DD9CE589-B549-E190-884D-C9071B33851A}"/>
+                <a16:creationId xmlns:a16="http://schemas.microsoft.com/office/drawing/2014/main" id="{87EB26E1-4FCD-D50E-2364-3CE55626A371}"/>
               </a:ext>
             </a:extLst>
           </p:cNvPr>
@@ -172,7 +172,7 @@
           <p:cNvPr id="3" name="Subtítulo 2">
             <a:extLst>
               <a:ext uri="{FF2B5EF4-FFF2-40B4-BE49-F238E27FC236}">
-                <a16:creationId xmlns:a16="http://schemas.microsoft.com/office/drawing/2014/main" id="{A43B3AA4-61CD-3D65-08BF-DB740A464405}"/>
+                <a16:creationId xmlns:a16="http://schemas.microsoft.com/office/drawing/2014/main" id="{14542D52-208E-5D17-00B1-F648466603AF}"/>
               </a:ext>
             </a:extLst>
           </p:cNvPr>
@@ -243,7 +243,7 @@
           <p:cNvPr id="4" name="Marcador de fecha 3">
             <a:extLst>
               <a:ext uri="{FF2B5EF4-FFF2-40B4-BE49-F238E27FC236}">
-                <a16:creationId xmlns:a16="http://schemas.microsoft.com/office/drawing/2014/main" id="{CB9112F2-78E8-515D-F24A-B62CD9D45563}"/>
+                <a16:creationId xmlns:a16="http://schemas.microsoft.com/office/drawing/2014/main" id="{C1F37DE1-2580-ECE9-FFD1-AE3806223859}"/>
               </a:ext>
             </a:extLst>
           </p:cNvPr>
@@ -259,7 +259,7 @@
           <a:bodyPr/>
           <a:lstStyle/>
           <a:p>
-            <a:fld id="{2F6522CC-1677-4567-9825-52B108A01684}" type="datetimeFigureOut">
+            <a:fld id="{C2ABA621-767C-4C50-B589-2B8966EB5CF9}" type="datetimeFigureOut">
               <a:rPr lang="es-EC" smtClean="0"/>
               <a:t>8/10/2026</a:t>
             </a:fld>
@@ -272,7 +272,7 @@
           <p:cNvPr id="5" name="Marcador de pie de página 4">
             <a:extLst>
               <a:ext uri="{FF2B5EF4-FFF2-40B4-BE49-F238E27FC236}">
-                <a16:creationId xmlns:a16="http://schemas.microsoft.com/office/drawing/2014/main" id="{5604E312-EFD8-1929-06EC-5AEAE4AE9782}"/>
+                <a16:creationId xmlns:a16="http://schemas.microsoft.com/office/drawing/2014/main" id="{993A39AB-938C-8A25-0A31-D05904E0D885}"/>
               </a:ext>
             </a:extLst>
           </p:cNvPr>
@@ -297,7 +297,7 @@
           <p:cNvPr id="6" name="Marcador de número de diapositiva 5">
             <a:extLst>
               <a:ext uri="{FF2B5EF4-FFF2-40B4-BE49-F238E27FC236}">
-                <a16:creationId xmlns:a16="http://schemas.microsoft.com/office/drawing/2014/main" id="{085DBD51-DDB0-4ACB-1B45-84DC4682C8FC}"/>
+                <a16:creationId xmlns:a16="http://schemas.microsoft.com/office/drawing/2014/main" id="{BA8C223F-5BF7-08C5-2221-CD158E057E88}"/>
               </a:ext>
             </a:extLst>
           </p:cNvPr>
@@ -313,7 +313,7 @@
           <a:bodyPr/>
           <a:lstStyle/>
           <a:p>
-            <a:fld id="{F3F25716-C9CD-4922-9EEA-B1CBFD816F36}" type="slidenum">
+            <a:fld id="{C537BDE0-565E-4BE3-A05B-A9A5BD51F203}" type="slidenum">
               <a:rPr lang="es-EC" smtClean="0"/>
               <a:t>‹Nº›</a:t>
             </a:fld>
@@ -324,7 +324,7 @@
     </p:spTree>
     <p:extLst>
       <p:ext uri="{BB962C8B-B14F-4D97-AF65-F5344CB8AC3E}">
-        <p14:creationId xmlns:p14="http://schemas.microsoft.com/office/powerpoint/2010/main" val="545232084"/>
+        <p14:creationId xmlns:p14="http://schemas.microsoft.com/office/powerpoint/2010/main" val="1466204465"/>
       </p:ext>
     </p:extLst>
   </p:cSld>
@@ -356,7 +356,7 @@
           <p:cNvPr id="2" name="Título 1">
             <a:extLst>
               <a:ext uri="{FF2B5EF4-FFF2-40B4-BE49-F238E27FC236}">
-                <a16:creationId xmlns:a16="http://schemas.microsoft.com/office/drawing/2014/main" id="{D2AF4C18-06DE-8A21-C389-3FDFF7670FBC}"/>
+                <a16:creationId xmlns:a16="http://schemas.microsoft.com/office/drawing/2014/main" id="{03BA6076-FEC3-023B-8E1E-3FFD40AB87A0}"/>
               </a:ext>
             </a:extLst>
           </p:cNvPr>
@@ -385,7 +385,7 @@
           <p:cNvPr id="3" name="Marcador de texto vertical 2">
             <a:extLst>
               <a:ext uri="{FF2B5EF4-FFF2-40B4-BE49-F238E27FC236}">
-                <a16:creationId xmlns:a16="http://schemas.microsoft.com/office/drawing/2014/main" id="{E4F0C640-E98C-1F4F-AA06-40D23952AED1}"/>
+                <a16:creationId xmlns:a16="http://schemas.microsoft.com/office/drawing/2014/main" id="{7E6C4503-1562-3546-6B86-06A95C3EC015}"/>
               </a:ext>
             </a:extLst>
           </p:cNvPr>
@@ -443,7 +443,7 @@
           <p:cNvPr id="4" name="Marcador de fecha 3">
             <a:extLst>
               <a:ext uri="{FF2B5EF4-FFF2-40B4-BE49-F238E27FC236}">
-                <a16:creationId xmlns:a16="http://schemas.microsoft.com/office/drawing/2014/main" id="{ADCD34B4-57AC-2FB8-C8BB-9C985C705A10}"/>
+                <a16:creationId xmlns:a16="http://schemas.microsoft.com/office/drawing/2014/main" id="{D79D9811-F9B0-9B01-FA03-D3FBD181E2A3}"/>
               </a:ext>
             </a:extLst>
           </p:cNvPr>
@@ -459,7 +459,7 @@
           <a:bodyPr/>
           <a:lstStyle/>
           <a:p>
-            <a:fld id="{2F6522CC-1677-4567-9825-52B108A01684}" type="datetimeFigureOut">
+            <a:fld id="{C2ABA621-767C-4C50-B589-2B8966EB5CF9}" type="datetimeFigureOut">
               <a:rPr lang="es-EC" smtClean="0"/>
               <a:t>8/10/2026</a:t>
             </a:fld>
@@ -472,7 +472,7 @@
           <p:cNvPr id="5" name="Marcador de pie de página 4">
             <a:extLst>
               <a:ext uri="{FF2B5EF4-FFF2-40B4-BE49-F238E27FC236}">
-                <a16:creationId xmlns:a16="http://schemas.microsoft.com/office/drawing/2014/main" id="{2AD1B5C6-486E-0613-5883-E797E5D2D602}"/>
+                <a16:creationId xmlns:a16="http://schemas.microsoft.com/office/drawing/2014/main" id="{0896ADE0-5776-BD6D-490C-84308ABCC0C0}"/>
               </a:ext>
             </a:extLst>
           </p:cNvPr>
@@ -497,7 +497,7 @@
           <p:cNvPr id="6" name="Marcador de número de diapositiva 5">
             <a:extLst>
               <a:ext uri="{FF2B5EF4-FFF2-40B4-BE49-F238E27FC236}">
-                <a16:creationId xmlns:a16="http://schemas.microsoft.com/office/drawing/2014/main" id="{656D9B44-DF43-AC0A-3AEB-C5B098DCA558}"/>
+                <a16:creationId xmlns:a16="http://schemas.microsoft.com/office/drawing/2014/main" id="{F01F3166-67D0-8396-08DE-55E74DC33CFE}"/>
               </a:ext>
             </a:extLst>
           </p:cNvPr>
@@ -513,7 +513,7 @@
           <a:bodyPr/>
           <a:lstStyle/>
           <a:p>
-            <a:fld id="{F3F25716-C9CD-4922-9EEA-B1CBFD816F36}" type="slidenum">
+            <a:fld id="{C537BDE0-565E-4BE3-A05B-A9A5BD51F203}" type="slidenum">
               <a:rPr lang="es-EC" smtClean="0"/>
               <a:t>‹Nº›</a:t>
             </a:fld>
@@ -524,7 +524,7 @@
     </p:spTree>
     <p:extLst>
       <p:ext uri="{BB962C8B-B14F-4D97-AF65-F5344CB8AC3E}">
-        <p14:creationId xmlns:p14="http://schemas.microsoft.com/office/powerpoint/2010/main" val="2168195687"/>
+        <p14:creationId xmlns:p14="http://schemas.microsoft.com/office/powerpoint/2010/main" val="2385386882"/>
       </p:ext>
     </p:extLst>
   </p:cSld>
@@ -556,7 +556,7 @@
           <p:cNvPr id="2" name="Título vertical 1">
             <a:extLst>
               <a:ext uri="{FF2B5EF4-FFF2-40B4-BE49-F238E27FC236}">
-                <a16:creationId xmlns:a16="http://schemas.microsoft.com/office/drawing/2014/main" id="{91C72939-C173-ADA6-7F21-71C36BDA3EDD}"/>
+                <a16:creationId xmlns:a16="http://schemas.microsoft.com/office/drawing/2014/main" id="{FA72CE71-8C3A-F192-93BD-ABB0B0445B4B}"/>
               </a:ext>
             </a:extLst>
           </p:cNvPr>
@@ -590,7 +590,7 @@
           <p:cNvPr id="3" name="Marcador de texto vertical 2">
             <a:extLst>
               <a:ext uri="{FF2B5EF4-FFF2-40B4-BE49-F238E27FC236}">
-                <a16:creationId xmlns:a16="http://schemas.microsoft.com/office/drawing/2014/main" id="{551DFBF1-8553-6FD7-EE2F-D4EE4B48262F}"/>
+                <a16:creationId xmlns:a16="http://schemas.microsoft.com/office/drawing/2014/main" id="{5E577475-A37F-0FBA-2B8A-0E20B80E1083}"/>
               </a:ext>
             </a:extLst>
           </p:cNvPr>
@@ -653,7 +653,7 @@
           <p:cNvPr id="4" name="Marcador de fecha 3">
             <a:extLst>
               <a:ext uri="{FF2B5EF4-FFF2-40B4-BE49-F238E27FC236}">
-                <a16:creationId xmlns:a16="http://schemas.microsoft.com/office/drawing/2014/main" id="{BFFDC4CA-A60F-A0CF-D1B7-5DD1D956BB65}"/>
+                <a16:creationId xmlns:a16="http://schemas.microsoft.com/office/drawing/2014/main" id="{5054FF8C-A8F2-19EE-3DDA-C9A867B5E69D}"/>
               </a:ext>
             </a:extLst>
           </p:cNvPr>
@@ -669,7 +669,7 @@
           <a:bodyPr/>
           <a:lstStyle/>
           <a:p>
-            <a:fld id="{2F6522CC-1677-4567-9825-52B108A01684}" type="datetimeFigureOut">
+            <a:fld id="{C2ABA621-767C-4C50-B589-2B8966EB5CF9}" type="datetimeFigureOut">
               <a:rPr lang="es-EC" smtClean="0"/>
               <a:t>8/10/2026</a:t>
             </a:fld>
@@ -682,7 +682,7 @@
           <p:cNvPr id="5" name="Marcador de pie de página 4">
             <a:extLst>
               <a:ext uri="{FF2B5EF4-FFF2-40B4-BE49-F238E27FC236}">
-                <a16:creationId xmlns:a16="http://schemas.microsoft.com/office/drawing/2014/main" id="{010442A5-606E-03E8-E68C-C025C9231C11}"/>
+                <a16:creationId xmlns:a16="http://schemas.microsoft.com/office/drawing/2014/main" id="{54505AA1-F5D2-086D-264F-CA6A3C3E3C7A}"/>
               </a:ext>
             </a:extLst>
           </p:cNvPr>
@@ -707,7 +707,7 @@
           <p:cNvPr id="6" name="Marcador de número de diapositiva 5">
             <a:extLst>
               <a:ext uri="{FF2B5EF4-FFF2-40B4-BE49-F238E27FC236}">
-                <a16:creationId xmlns:a16="http://schemas.microsoft.com/office/drawing/2014/main" id="{0548E83E-E931-D781-E2DA-5ECF4074CD6C}"/>
+                <a16:creationId xmlns:a16="http://schemas.microsoft.com/office/drawing/2014/main" id="{4A10469D-ECE4-BA82-E3C1-35512068CE6C}"/>
               </a:ext>
             </a:extLst>
           </p:cNvPr>
@@ -723,7 +723,7 @@
           <a:bodyPr/>
           <a:lstStyle/>
           <a:p>
-            <a:fld id="{F3F25716-C9CD-4922-9EEA-B1CBFD816F36}" type="slidenum">
+            <a:fld id="{C537BDE0-565E-4BE3-A05B-A9A5BD51F203}" type="slidenum">
               <a:rPr lang="es-EC" smtClean="0"/>
               <a:t>‹Nº›</a:t>
             </a:fld>
@@ -734,7 +734,7 @@
     </p:spTree>
     <p:extLst>
       <p:ext uri="{BB962C8B-B14F-4D97-AF65-F5344CB8AC3E}">
-        <p14:creationId xmlns:p14="http://schemas.microsoft.com/office/powerpoint/2010/main" val="2379373298"/>
+        <p14:creationId xmlns:p14="http://schemas.microsoft.com/office/powerpoint/2010/main" val="1446416619"/>
       </p:ext>
     </p:extLst>
   </p:cSld>
@@ -766,7 +766,7 @@
           <p:cNvPr id="2" name="Título 1">
             <a:extLst>
               <a:ext uri="{FF2B5EF4-FFF2-40B4-BE49-F238E27FC236}">
-                <a16:creationId xmlns:a16="http://schemas.microsoft.com/office/drawing/2014/main" id="{2D64FF51-176A-3532-00D7-30B28E6E567F}"/>
+                <a16:creationId xmlns:a16="http://schemas.microsoft.com/office/drawing/2014/main" id="{C56D1A81-AAE9-EFAB-4B43-8D6AB6C0411C}"/>
               </a:ext>
             </a:extLst>
           </p:cNvPr>
@@ -795,7 +795,7 @@
           <p:cNvPr id="3" name="Marcador de contenido 2">
             <a:extLst>
               <a:ext uri="{FF2B5EF4-FFF2-40B4-BE49-F238E27FC236}">
-                <a16:creationId xmlns:a16="http://schemas.microsoft.com/office/drawing/2014/main" id="{D91EE25C-F422-75CF-BE48-AE053045A933}"/>
+                <a16:creationId xmlns:a16="http://schemas.microsoft.com/office/drawing/2014/main" id="{2853D34B-EE99-CF07-44BA-F605A0B19B76}"/>
               </a:ext>
             </a:extLst>
           </p:cNvPr>
@@ -853,7 +853,7 @@
           <p:cNvPr id="4" name="Marcador de fecha 3">
             <a:extLst>
               <a:ext uri="{FF2B5EF4-FFF2-40B4-BE49-F238E27FC236}">
-                <a16:creationId xmlns:a16="http://schemas.microsoft.com/office/drawing/2014/main" id="{29BF65A5-139B-685F-20DC-D24F5FBB8309}"/>
+                <a16:creationId xmlns:a16="http://schemas.microsoft.com/office/drawing/2014/main" id="{3068B884-91B2-8C82-309F-AA5D14E5F458}"/>
               </a:ext>
             </a:extLst>
           </p:cNvPr>
@@ -869,7 +869,7 @@
           <a:bodyPr/>
           <a:lstStyle/>
           <a:p>
-            <a:fld id="{2F6522CC-1677-4567-9825-52B108A01684}" type="datetimeFigureOut">
+            <a:fld id="{C2ABA621-767C-4C50-B589-2B8966EB5CF9}" type="datetimeFigureOut">
               <a:rPr lang="es-EC" smtClean="0"/>
               <a:t>8/10/2026</a:t>
             </a:fld>
@@ -882,7 +882,7 @@
           <p:cNvPr id="5" name="Marcador de pie de página 4">
             <a:extLst>
               <a:ext uri="{FF2B5EF4-FFF2-40B4-BE49-F238E27FC236}">
-                <a16:creationId xmlns:a16="http://schemas.microsoft.com/office/drawing/2014/main" id="{C56917C3-9040-8974-245F-123B78F2617B}"/>
+                <a16:creationId xmlns:a16="http://schemas.microsoft.com/office/drawing/2014/main" id="{39980468-83AF-87A2-82E2-14487260C027}"/>
               </a:ext>
             </a:extLst>
           </p:cNvPr>
@@ -907,7 +907,7 @@
           <p:cNvPr id="6" name="Marcador de número de diapositiva 5">
             <a:extLst>
               <a:ext uri="{FF2B5EF4-FFF2-40B4-BE49-F238E27FC236}">
-                <a16:creationId xmlns:a16="http://schemas.microsoft.com/office/drawing/2014/main" id="{F15A174E-C0AE-D0AE-FF96-3DF9D8174ED1}"/>
+                <a16:creationId xmlns:a16="http://schemas.microsoft.com/office/drawing/2014/main" id="{A08462D4-2AD1-A283-94A0-C49FECB6D939}"/>
               </a:ext>
             </a:extLst>
           </p:cNvPr>
@@ -923,7 +923,7 @@
           <a:bodyPr/>
           <a:lstStyle/>
           <a:p>
-            <a:fld id="{F3F25716-C9CD-4922-9EEA-B1CBFD816F36}" type="slidenum">
+            <a:fld id="{C537BDE0-565E-4BE3-A05B-A9A5BD51F203}" type="slidenum">
               <a:rPr lang="es-EC" smtClean="0"/>
               <a:t>‹Nº›</a:t>
             </a:fld>
@@ -934,7 +934,7 @@
     </p:spTree>
     <p:extLst>
       <p:ext uri="{BB962C8B-B14F-4D97-AF65-F5344CB8AC3E}">
-        <p14:creationId xmlns:p14="http://schemas.microsoft.com/office/powerpoint/2010/main" val="735381803"/>
+        <p14:creationId xmlns:p14="http://schemas.microsoft.com/office/powerpoint/2010/main" val="1632297787"/>
       </p:ext>
     </p:extLst>
   </p:cSld>
@@ -966,7 +966,7 @@
           <p:cNvPr id="2" name="Título 1">
             <a:extLst>
               <a:ext uri="{FF2B5EF4-FFF2-40B4-BE49-F238E27FC236}">
-                <a16:creationId xmlns:a16="http://schemas.microsoft.com/office/drawing/2014/main" id="{C7A38AA5-326F-08A4-DE84-E6A06D765718}"/>
+                <a16:creationId xmlns:a16="http://schemas.microsoft.com/office/drawing/2014/main" id="{91DADD15-ACB4-56FB-43AD-684DB7C0C63F}"/>
               </a:ext>
             </a:extLst>
           </p:cNvPr>
@@ -1004,7 +1004,7 @@
           <p:cNvPr id="3" name="Marcador de texto 2">
             <a:extLst>
               <a:ext uri="{FF2B5EF4-FFF2-40B4-BE49-F238E27FC236}">
-                <a16:creationId xmlns:a16="http://schemas.microsoft.com/office/drawing/2014/main" id="{6A3F41A1-340E-DD35-C93A-898F2CC3E38F}"/>
+                <a16:creationId xmlns:a16="http://schemas.microsoft.com/office/drawing/2014/main" id="{48E8129E-A833-2B41-AA55-43F0D47D2A4F}"/>
               </a:ext>
             </a:extLst>
           </p:cNvPr>
@@ -1129,7 +1129,7 @@
           <p:cNvPr id="4" name="Marcador de fecha 3">
             <a:extLst>
               <a:ext uri="{FF2B5EF4-FFF2-40B4-BE49-F238E27FC236}">
-                <a16:creationId xmlns:a16="http://schemas.microsoft.com/office/drawing/2014/main" id="{421F902B-C189-7470-FD20-0111463992CE}"/>
+                <a16:creationId xmlns:a16="http://schemas.microsoft.com/office/drawing/2014/main" id="{8B7FAF8B-353B-6A25-0389-3F9AD2E87541}"/>
               </a:ext>
             </a:extLst>
           </p:cNvPr>
@@ -1145,7 +1145,7 @@
           <a:bodyPr/>
           <a:lstStyle/>
           <a:p>
-            <a:fld id="{2F6522CC-1677-4567-9825-52B108A01684}" type="datetimeFigureOut">
+            <a:fld id="{C2ABA621-767C-4C50-B589-2B8966EB5CF9}" type="datetimeFigureOut">
               <a:rPr lang="es-EC" smtClean="0"/>
               <a:t>8/10/2026</a:t>
             </a:fld>
@@ -1158,7 +1158,7 @@
           <p:cNvPr id="5" name="Marcador de pie de página 4">
             <a:extLst>
               <a:ext uri="{FF2B5EF4-FFF2-40B4-BE49-F238E27FC236}">
-                <a16:creationId xmlns:a16="http://schemas.microsoft.com/office/drawing/2014/main" id="{181FBD0D-C192-C6C8-3C20-34CDA2B4A339}"/>
+                <a16:creationId xmlns:a16="http://schemas.microsoft.com/office/drawing/2014/main" id="{2FC7CFEC-7D82-9683-85EC-C6D15A5383CF}"/>
               </a:ext>
             </a:extLst>
           </p:cNvPr>
@@ -1183,7 +1183,7 @@
           <p:cNvPr id="6" name="Marcador de número de diapositiva 5">
             <a:extLst>
               <a:ext uri="{FF2B5EF4-FFF2-40B4-BE49-F238E27FC236}">
-                <a16:creationId xmlns:a16="http://schemas.microsoft.com/office/drawing/2014/main" id="{28525612-8276-225C-F8C4-73D13FF1FD43}"/>
+                <a16:creationId xmlns:a16="http://schemas.microsoft.com/office/drawing/2014/main" id="{06035E52-1D95-0C00-D714-56DD7CDE1EE2}"/>
               </a:ext>
             </a:extLst>
           </p:cNvPr>
@@ -1199,7 +1199,7 @@
           <a:bodyPr/>
           <a:lstStyle/>
           <a:p>
-            <a:fld id="{F3F25716-C9CD-4922-9EEA-B1CBFD816F36}" type="slidenum">
+            <a:fld id="{C537BDE0-565E-4BE3-A05B-A9A5BD51F203}" type="slidenum">
               <a:rPr lang="es-EC" smtClean="0"/>
               <a:t>‹Nº›</a:t>
             </a:fld>
@@ -1210,7 +1210,7 @@
     </p:spTree>
     <p:extLst>
       <p:ext uri="{BB962C8B-B14F-4D97-AF65-F5344CB8AC3E}">
-        <p14:creationId xmlns:p14="http://schemas.microsoft.com/office/powerpoint/2010/main" val="3055172187"/>
+        <p14:creationId xmlns:p14="http://schemas.microsoft.com/office/powerpoint/2010/main" val="3795489511"/>
       </p:ext>
     </p:extLst>
   </p:cSld>
@@ -1242,7 +1242,7 @@
           <p:cNvPr id="2" name="Título 1">
             <a:extLst>
               <a:ext uri="{FF2B5EF4-FFF2-40B4-BE49-F238E27FC236}">
-                <a16:creationId xmlns:a16="http://schemas.microsoft.com/office/drawing/2014/main" id="{00D1F739-2EE5-A26B-A182-D34D52E9B7EA}"/>
+                <a16:creationId xmlns:a16="http://schemas.microsoft.com/office/drawing/2014/main" id="{82DDA68C-99C7-1F05-C506-88922A687756}"/>
               </a:ext>
             </a:extLst>
           </p:cNvPr>
@@ -1271,7 +1271,7 @@
           <p:cNvPr id="3" name="Marcador de contenido 2">
             <a:extLst>
               <a:ext uri="{FF2B5EF4-FFF2-40B4-BE49-F238E27FC236}">
-                <a16:creationId xmlns:a16="http://schemas.microsoft.com/office/drawing/2014/main" id="{C864D488-DA36-EC9E-DC01-B96FF93E8A05}"/>
+                <a16:creationId xmlns:a16="http://schemas.microsoft.com/office/drawing/2014/main" id="{2B410204-ED14-99B0-B150-65C9F7F3AEDA}"/>
               </a:ext>
             </a:extLst>
           </p:cNvPr>
@@ -1334,7 +1334,7 @@
           <p:cNvPr id="4" name="Marcador de contenido 3">
             <a:extLst>
               <a:ext uri="{FF2B5EF4-FFF2-40B4-BE49-F238E27FC236}">
-                <a16:creationId xmlns:a16="http://schemas.microsoft.com/office/drawing/2014/main" id="{02275CBE-42DE-F69C-A51A-F1C2479DFE59}"/>
+                <a16:creationId xmlns:a16="http://schemas.microsoft.com/office/drawing/2014/main" id="{7F43DCDF-C30B-E533-0446-6AFC280EDC81}"/>
               </a:ext>
             </a:extLst>
           </p:cNvPr>
@@ -1397,7 +1397,7 @@
           <p:cNvPr id="5" name="Marcador de fecha 4">
             <a:extLst>
               <a:ext uri="{FF2B5EF4-FFF2-40B4-BE49-F238E27FC236}">
-                <a16:creationId xmlns:a16="http://schemas.microsoft.com/office/drawing/2014/main" id="{3AA755C3-E5AC-91F6-C6B8-C424B8E30CC1}"/>
+                <a16:creationId xmlns:a16="http://schemas.microsoft.com/office/drawing/2014/main" id="{CFAF0EEA-7642-4B66-FA93-F4AD51131B3C}"/>
               </a:ext>
             </a:extLst>
           </p:cNvPr>
@@ -1413,7 +1413,7 @@
           <a:bodyPr/>
           <a:lstStyle/>
           <a:p>
-            <a:fld id="{2F6522CC-1677-4567-9825-52B108A01684}" type="datetimeFigureOut">
+            <a:fld id="{C2ABA621-767C-4C50-B589-2B8966EB5CF9}" type="datetimeFigureOut">
               <a:rPr lang="es-EC" smtClean="0"/>
               <a:t>8/10/2026</a:t>
             </a:fld>
@@ -1426,7 +1426,7 @@
           <p:cNvPr id="6" name="Marcador de pie de página 5">
             <a:extLst>
               <a:ext uri="{FF2B5EF4-FFF2-40B4-BE49-F238E27FC236}">
-                <a16:creationId xmlns:a16="http://schemas.microsoft.com/office/drawing/2014/main" id="{48FDEF29-E022-4465-284D-AFC9E056C23C}"/>
+                <a16:creationId xmlns:a16="http://schemas.microsoft.com/office/drawing/2014/main" id="{B3740E35-9BD7-514F-9DA9-0A7335954C6F}"/>
               </a:ext>
             </a:extLst>
           </p:cNvPr>
@@ -1451,7 +1451,7 @@
           <p:cNvPr id="7" name="Marcador de número de diapositiva 6">
             <a:extLst>
               <a:ext uri="{FF2B5EF4-FFF2-40B4-BE49-F238E27FC236}">
-                <a16:creationId xmlns:a16="http://schemas.microsoft.com/office/drawing/2014/main" id="{D45D0A4A-45F1-5207-8711-0CF30BC6B0C1}"/>
+                <a16:creationId xmlns:a16="http://schemas.microsoft.com/office/drawing/2014/main" id="{21567E3B-42A2-42E2-1A52-4746CA4A4A38}"/>
               </a:ext>
             </a:extLst>
           </p:cNvPr>
@@ -1467,7 +1467,7 @@
           <a:bodyPr/>
           <a:lstStyle/>
           <a:p>
-            <a:fld id="{F3F25716-C9CD-4922-9EEA-B1CBFD816F36}" type="slidenum">
+            <a:fld id="{C537BDE0-565E-4BE3-A05B-A9A5BD51F203}" type="slidenum">
               <a:rPr lang="es-EC" smtClean="0"/>
               <a:t>‹Nº›</a:t>
             </a:fld>
@@ -1478,7 +1478,7 @@
     </p:spTree>
     <p:extLst>
       <p:ext uri="{BB962C8B-B14F-4D97-AF65-F5344CB8AC3E}">
-        <p14:creationId xmlns:p14="http://schemas.microsoft.com/office/powerpoint/2010/main" val="639178214"/>
+        <p14:creationId xmlns:p14="http://schemas.microsoft.com/office/powerpoint/2010/main" val="3886902062"/>
       </p:ext>
     </p:extLst>
   </p:cSld>
@@ -1510,7 +1510,7 @@
           <p:cNvPr id="2" name="Título 1">
             <a:extLst>
               <a:ext uri="{FF2B5EF4-FFF2-40B4-BE49-F238E27FC236}">
-                <a16:creationId xmlns:a16="http://schemas.microsoft.com/office/drawing/2014/main" id="{10B59DB1-EF2E-86DF-FE9D-B44C5195B10E}"/>
+                <a16:creationId xmlns:a16="http://schemas.microsoft.com/office/drawing/2014/main" id="{76BD3C5D-81F7-E6D2-E267-B967F30E8293}"/>
               </a:ext>
             </a:extLst>
           </p:cNvPr>
@@ -1544,7 +1544,7 @@
           <p:cNvPr id="3" name="Marcador de texto 2">
             <a:extLst>
               <a:ext uri="{FF2B5EF4-FFF2-40B4-BE49-F238E27FC236}">
-                <a16:creationId xmlns:a16="http://schemas.microsoft.com/office/drawing/2014/main" id="{E1AE209E-6AC4-4CB7-4FB3-6C25C5A6AAAD}"/>
+                <a16:creationId xmlns:a16="http://schemas.microsoft.com/office/drawing/2014/main" id="{757A7303-289F-B463-B225-C0F09FFC9A5E}"/>
               </a:ext>
             </a:extLst>
           </p:cNvPr>
@@ -1615,7 +1615,7 @@
           <p:cNvPr id="4" name="Marcador de contenido 3">
             <a:extLst>
               <a:ext uri="{FF2B5EF4-FFF2-40B4-BE49-F238E27FC236}">
-                <a16:creationId xmlns:a16="http://schemas.microsoft.com/office/drawing/2014/main" id="{2187298C-6808-E160-F8BE-6A270BD88DFD}"/>
+                <a16:creationId xmlns:a16="http://schemas.microsoft.com/office/drawing/2014/main" id="{7E3A882D-CED9-E056-AB57-7C40AE458F78}"/>
               </a:ext>
             </a:extLst>
           </p:cNvPr>
@@ -1678,7 +1678,7 @@
           <p:cNvPr id="5" name="Marcador de texto 4">
             <a:extLst>
               <a:ext uri="{FF2B5EF4-FFF2-40B4-BE49-F238E27FC236}">
-                <a16:creationId xmlns:a16="http://schemas.microsoft.com/office/drawing/2014/main" id="{A4E5C4E6-B93A-4F68-A947-3811D147495C}"/>
+                <a16:creationId xmlns:a16="http://schemas.microsoft.com/office/drawing/2014/main" id="{2B2EF67B-E0A8-0445-AD2F-784D8C6A1BF0}"/>
               </a:ext>
             </a:extLst>
           </p:cNvPr>
@@ -1749,7 +1749,7 @@
           <p:cNvPr id="6" name="Marcador de contenido 5">
             <a:extLst>
               <a:ext uri="{FF2B5EF4-FFF2-40B4-BE49-F238E27FC236}">
-                <a16:creationId xmlns:a16="http://schemas.microsoft.com/office/drawing/2014/main" id="{6C2C6B27-AE99-69CE-7876-AE4511590510}"/>
+                <a16:creationId xmlns:a16="http://schemas.microsoft.com/office/drawing/2014/main" id="{02881BB8-A576-EBE7-C6D0-EB3C06656C00}"/>
               </a:ext>
             </a:extLst>
           </p:cNvPr>
@@ -1812,7 +1812,7 @@
           <p:cNvPr id="7" name="Marcador de fecha 6">
             <a:extLst>
               <a:ext uri="{FF2B5EF4-FFF2-40B4-BE49-F238E27FC236}">
-                <a16:creationId xmlns:a16="http://schemas.microsoft.com/office/drawing/2014/main" id="{A02EF343-2F0B-6E60-F248-5A0DBD20C056}"/>
+                <a16:creationId xmlns:a16="http://schemas.microsoft.com/office/drawing/2014/main" id="{13067829-C198-C7C4-41FF-9D6D9E2556ED}"/>
               </a:ext>
             </a:extLst>
           </p:cNvPr>
@@ -1828,7 +1828,7 @@
           <a:bodyPr/>
           <a:lstStyle/>
           <a:p>
-            <a:fld id="{2F6522CC-1677-4567-9825-52B108A01684}" type="datetimeFigureOut">
+            <a:fld id="{C2ABA621-767C-4C50-B589-2B8966EB5CF9}" type="datetimeFigureOut">
               <a:rPr lang="es-EC" smtClean="0"/>
               <a:t>8/10/2026</a:t>
             </a:fld>
@@ -1841,7 +1841,7 @@
           <p:cNvPr id="8" name="Marcador de pie de página 7">
             <a:extLst>
               <a:ext uri="{FF2B5EF4-FFF2-40B4-BE49-F238E27FC236}">
-                <a16:creationId xmlns:a16="http://schemas.microsoft.com/office/drawing/2014/main" id="{76EDA59D-21CC-E05E-851B-6DA911A98979}"/>
+                <a16:creationId xmlns:a16="http://schemas.microsoft.com/office/drawing/2014/main" id="{CCDE9F5F-9865-7800-1152-CB87570ADE78}"/>
               </a:ext>
             </a:extLst>
           </p:cNvPr>
@@ -1866,7 +1866,7 @@
           <p:cNvPr id="9" name="Marcador de número de diapositiva 8">
             <a:extLst>
               <a:ext uri="{FF2B5EF4-FFF2-40B4-BE49-F238E27FC236}">
-                <a16:creationId xmlns:a16="http://schemas.microsoft.com/office/drawing/2014/main" id="{5A7BCBB8-D8F7-9C86-F55D-CCDDC2666012}"/>
+                <a16:creationId xmlns:a16="http://schemas.microsoft.com/office/drawing/2014/main" id="{105328D4-6B7C-1C4C-A51D-528441B43F1D}"/>
               </a:ext>
             </a:extLst>
           </p:cNvPr>
@@ -1882,7 +1882,7 @@
           <a:bodyPr/>
           <a:lstStyle/>
           <a:p>
-            <a:fld id="{F3F25716-C9CD-4922-9EEA-B1CBFD816F36}" type="slidenum">
+            <a:fld id="{C537BDE0-565E-4BE3-A05B-A9A5BD51F203}" type="slidenum">
               <a:rPr lang="es-EC" smtClean="0"/>
               <a:t>‹Nº›</a:t>
             </a:fld>
@@ -1893,7 +1893,7 @@
     </p:spTree>
     <p:extLst>
       <p:ext uri="{BB962C8B-B14F-4D97-AF65-F5344CB8AC3E}">
-        <p14:creationId xmlns:p14="http://schemas.microsoft.com/office/powerpoint/2010/main" val="3137298480"/>
+        <p14:creationId xmlns:p14="http://schemas.microsoft.com/office/powerpoint/2010/main" val="3908622628"/>
       </p:ext>
     </p:extLst>
   </p:cSld>
@@ -1925,7 +1925,7 @@
           <p:cNvPr id="2" name="Título 1">
             <a:extLst>
               <a:ext uri="{FF2B5EF4-FFF2-40B4-BE49-F238E27FC236}">
-                <a16:creationId xmlns:a16="http://schemas.microsoft.com/office/drawing/2014/main" id="{98AB86AD-EAFB-5509-760A-8A1F1DF79DEF}"/>
+                <a16:creationId xmlns:a16="http://schemas.microsoft.com/office/drawing/2014/main" id="{786BC19C-12CA-AD43-1CF4-142D8F581DF4}"/>
               </a:ext>
             </a:extLst>
           </p:cNvPr>
@@ -1954,7 +1954,7 @@
           <p:cNvPr id="3" name="Marcador de fecha 2">
             <a:extLst>
               <a:ext uri="{FF2B5EF4-FFF2-40B4-BE49-F238E27FC236}">
-                <a16:creationId xmlns:a16="http://schemas.microsoft.com/office/drawing/2014/main" id="{E1C9BAE6-DA0B-A1FB-6CDB-CB3F141A9D18}"/>
+                <a16:creationId xmlns:a16="http://schemas.microsoft.com/office/drawing/2014/main" id="{88E60EAE-6A75-32F7-80C0-2D9FCFCFE6F0}"/>
               </a:ext>
             </a:extLst>
           </p:cNvPr>
@@ -1970,7 +1970,7 @@
           <a:bodyPr/>
           <a:lstStyle/>
           <a:p>
-            <a:fld id="{2F6522CC-1677-4567-9825-52B108A01684}" type="datetimeFigureOut">
+            <a:fld id="{C2ABA621-767C-4C50-B589-2B8966EB5CF9}" type="datetimeFigureOut">
               <a:rPr lang="es-EC" smtClean="0"/>
               <a:t>8/10/2026</a:t>
             </a:fld>
@@ -1983,7 +1983,7 @@
           <p:cNvPr id="4" name="Marcador de pie de página 3">
             <a:extLst>
               <a:ext uri="{FF2B5EF4-FFF2-40B4-BE49-F238E27FC236}">
-                <a16:creationId xmlns:a16="http://schemas.microsoft.com/office/drawing/2014/main" id="{E4264F3C-2C6F-39AA-6D78-AACA79D68419}"/>
+                <a16:creationId xmlns:a16="http://schemas.microsoft.com/office/drawing/2014/main" id="{DDE9B66F-2B3F-DB4A-2AC0-80E0CC1CD9FE}"/>
               </a:ext>
             </a:extLst>
           </p:cNvPr>
@@ -2008,7 +2008,7 @@
           <p:cNvPr id="5" name="Marcador de número de diapositiva 4">
             <a:extLst>
               <a:ext uri="{FF2B5EF4-FFF2-40B4-BE49-F238E27FC236}">
-                <a16:creationId xmlns:a16="http://schemas.microsoft.com/office/drawing/2014/main" id="{51D9D3F7-9CC6-AB4F-5BBD-6268401F062B}"/>
+                <a16:creationId xmlns:a16="http://schemas.microsoft.com/office/drawing/2014/main" id="{B5211C76-1605-4C82-F0BB-3AB47B8EC21B}"/>
               </a:ext>
             </a:extLst>
           </p:cNvPr>
@@ -2024,7 +2024,7 @@
           <a:bodyPr/>
           <a:lstStyle/>
           <a:p>
-            <a:fld id="{F3F25716-C9CD-4922-9EEA-B1CBFD816F36}" type="slidenum">
+            <a:fld id="{C537BDE0-565E-4BE3-A05B-A9A5BD51F203}" type="slidenum">
               <a:rPr lang="es-EC" smtClean="0"/>
               <a:t>‹Nº›</a:t>
             </a:fld>
@@ -2035,7 +2035,7 @@
     </p:spTree>
     <p:extLst>
       <p:ext uri="{BB962C8B-B14F-4D97-AF65-F5344CB8AC3E}">
-        <p14:creationId xmlns:p14="http://schemas.microsoft.com/office/powerpoint/2010/main" val="1223453750"/>
+        <p14:creationId xmlns:p14="http://schemas.microsoft.com/office/powerpoint/2010/main" val="2851176187"/>
       </p:ext>
     </p:extLst>
   </p:cSld>
@@ -2067,7 +2067,7 @@
           <p:cNvPr id="2" name="Marcador de fecha 1">
             <a:extLst>
               <a:ext uri="{FF2B5EF4-FFF2-40B4-BE49-F238E27FC236}">
-                <a16:creationId xmlns:a16="http://schemas.microsoft.com/office/drawing/2014/main" id="{EDE1A686-8D42-5D57-66E5-EF9B3F90EEB4}"/>
+                <a16:creationId xmlns:a16="http://schemas.microsoft.com/office/drawing/2014/main" id="{3E684C4B-D146-24E4-7FBB-976C5D798308}"/>
               </a:ext>
             </a:extLst>
           </p:cNvPr>
@@ -2083,7 +2083,7 @@
           <a:bodyPr/>
           <a:lstStyle/>
           <a:p>
-            <a:fld id="{2F6522CC-1677-4567-9825-52B108A01684}" type="datetimeFigureOut">
+            <a:fld id="{C2ABA621-767C-4C50-B589-2B8966EB5CF9}" type="datetimeFigureOut">
               <a:rPr lang="es-EC" smtClean="0"/>
               <a:t>8/10/2026</a:t>
             </a:fld>
@@ -2096,7 +2096,7 @@
           <p:cNvPr id="3" name="Marcador de pie de página 2">
             <a:extLst>
               <a:ext uri="{FF2B5EF4-FFF2-40B4-BE49-F238E27FC236}">
-                <a16:creationId xmlns:a16="http://schemas.microsoft.com/office/drawing/2014/main" id="{2DF6B127-9596-E09C-6F6C-B98929BDD7B7}"/>
+                <a16:creationId xmlns:a16="http://schemas.microsoft.com/office/drawing/2014/main" id="{148AC3BC-3B3F-30CB-189A-812B527DE2C4}"/>
               </a:ext>
             </a:extLst>
           </p:cNvPr>
@@ -2121,7 +2121,7 @@
           <p:cNvPr id="4" name="Marcador de número de diapositiva 3">
             <a:extLst>
               <a:ext uri="{FF2B5EF4-FFF2-40B4-BE49-F238E27FC236}">
-                <a16:creationId xmlns:a16="http://schemas.microsoft.com/office/drawing/2014/main" id="{AD6448E6-0EFB-266E-7A4C-22D47B4B88F9}"/>
+                <a16:creationId xmlns:a16="http://schemas.microsoft.com/office/drawing/2014/main" id="{AA4EED23-EC1A-D098-5BF8-80071CB48B67}"/>
               </a:ext>
             </a:extLst>
           </p:cNvPr>
@@ -2137,7 +2137,7 @@
           <a:bodyPr/>
           <a:lstStyle/>
           <a:p>
-            <a:fld id="{F3F25716-C9CD-4922-9EEA-B1CBFD816F36}" type="slidenum">
+            <a:fld id="{C537BDE0-565E-4BE3-A05B-A9A5BD51F203}" type="slidenum">
               <a:rPr lang="es-EC" smtClean="0"/>
               <a:t>‹Nº›</a:t>
             </a:fld>
@@ -2148,7 +2148,7 @@
     </p:spTree>
     <p:extLst>
       <p:ext uri="{BB962C8B-B14F-4D97-AF65-F5344CB8AC3E}">
-        <p14:creationId xmlns:p14="http://schemas.microsoft.com/office/powerpoint/2010/main" val="2525091768"/>
+        <p14:creationId xmlns:p14="http://schemas.microsoft.com/office/powerpoint/2010/main" val="676322599"/>
       </p:ext>
     </p:extLst>
   </p:cSld>
@@ -2180,7 +2180,7 @@
           <p:cNvPr id="2" name="Título 1">
             <a:extLst>
               <a:ext uri="{FF2B5EF4-FFF2-40B4-BE49-F238E27FC236}">
-                <a16:creationId xmlns:a16="http://schemas.microsoft.com/office/drawing/2014/main" id="{58B9C435-E6E9-D164-9BFD-BAD5EED06B87}"/>
+                <a16:creationId xmlns:a16="http://schemas.microsoft.com/office/drawing/2014/main" id="{698A5727-95C1-69CE-16A3-1300D5E3B5B9}"/>
               </a:ext>
             </a:extLst>
           </p:cNvPr>
@@ -2218,7 +2218,7 @@
           <p:cNvPr id="3" name="Marcador de contenido 2">
             <a:extLst>
               <a:ext uri="{FF2B5EF4-FFF2-40B4-BE49-F238E27FC236}">
-                <a16:creationId xmlns:a16="http://schemas.microsoft.com/office/drawing/2014/main" id="{EAC2A830-5733-4313-5F61-84B306CE3418}"/>
+                <a16:creationId xmlns:a16="http://schemas.microsoft.com/office/drawing/2014/main" id="{DD5513BC-5AA7-B580-97D2-1CA9890DAABE}"/>
               </a:ext>
             </a:extLst>
           </p:cNvPr>
@@ -2309,7 +2309,7 @@
           <p:cNvPr id="4" name="Marcador de texto 3">
             <a:extLst>
               <a:ext uri="{FF2B5EF4-FFF2-40B4-BE49-F238E27FC236}">
-                <a16:creationId xmlns:a16="http://schemas.microsoft.com/office/drawing/2014/main" id="{BEA369D3-FF62-03B8-891F-7933406DE21E}"/>
+                <a16:creationId xmlns:a16="http://schemas.microsoft.com/office/drawing/2014/main" id="{EB8DAA90-4448-67A7-D040-0593DB6B0FBE}"/>
               </a:ext>
             </a:extLst>
           </p:cNvPr>
@@ -2380,7 +2380,7 @@
           <p:cNvPr id="5" name="Marcador de fecha 4">
             <a:extLst>
               <a:ext uri="{FF2B5EF4-FFF2-40B4-BE49-F238E27FC236}">
-                <a16:creationId xmlns:a16="http://schemas.microsoft.com/office/drawing/2014/main" id="{4D0E02FB-87DA-DE2C-743F-CA5D8D81099C}"/>
+                <a16:creationId xmlns:a16="http://schemas.microsoft.com/office/drawing/2014/main" id="{64EF6B5D-A827-47C0-7CB1-A6DE695D2D74}"/>
               </a:ext>
             </a:extLst>
           </p:cNvPr>
@@ -2396,7 +2396,7 @@
           <a:bodyPr/>
           <a:lstStyle/>
           <a:p>
-            <a:fld id="{2F6522CC-1677-4567-9825-52B108A01684}" type="datetimeFigureOut">
+            <a:fld id="{C2ABA621-767C-4C50-B589-2B8966EB5CF9}" type="datetimeFigureOut">
               <a:rPr lang="es-EC" smtClean="0"/>
               <a:t>8/10/2026</a:t>
             </a:fld>
@@ -2409,7 +2409,7 @@
           <p:cNvPr id="6" name="Marcador de pie de página 5">
             <a:extLst>
               <a:ext uri="{FF2B5EF4-FFF2-40B4-BE49-F238E27FC236}">
-                <a16:creationId xmlns:a16="http://schemas.microsoft.com/office/drawing/2014/main" id="{FC07282D-D580-FDCD-F314-FBD393DA7EA9}"/>
+                <a16:creationId xmlns:a16="http://schemas.microsoft.com/office/drawing/2014/main" id="{916E466A-25A3-DEFB-EF50-4E258DBECA38}"/>
               </a:ext>
             </a:extLst>
           </p:cNvPr>
@@ -2434,7 +2434,7 @@
           <p:cNvPr id="7" name="Marcador de número de diapositiva 6">
             <a:extLst>
               <a:ext uri="{FF2B5EF4-FFF2-40B4-BE49-F238E27FC236}">
-                <a16:creationId xmlns:a16="http://schemas.microsoft.com/office/drawing/2014/main" id="{CD711A0C-0355-D756-1DED-21F50FC20EB0}"/>
+                <a16:creationId xmlns:a16="http://schemas.microsoft.com/office/drawing/2014/main" id="{266B5041-6DF0-2C5A-FFC0-85B626331886}"/>
               </a:ext>
             </a:extLst>
           </p:cNvPr>
@@ -2450,7 +2450,7 @@
           <a:bodyPr/>
           <a:lstStyle/>
           <a:p>
-            <a:fld id="{F3F25716-C9CD-4922-9EEA-B1CBFD816F36}" type="slidenum">
+            <a:fld id="{C537BDE0-565E-4BE3-A05B-A9A5BD51F203}" type="slidenum">
               <a:rPr lang="es-EC" smtClean="0"/>
               <a:t>‹Nº›</a:t>
             </a:fld>
@@ -2461,7 +2461,7 @@
     </p:spTree>
     <p:extLst>
       <p:ext uri="{BB962C8B-B14F-4D97-AF65-F5344CB8AC3E}">
-        <p14:creationId xmlns:p14="http://schemas.microsoft.com/office/powerpoint/2010/main" val="3977824499"/>
+        <p14:creationId xmlns:p14="http://schemas.microsoft.com/office/powerpoint/2010/main" val="4032522997"/>
       </p:ext>
     </p:extLst>
   </p:cSld>
@@ -2493,7 +2493,7 @@
           <p:cNvPr id="2" name="Título 1">
             <a:extLst>
               <a:ext uri="{FF2B5EF4-FFF2-40B4-BE49-F238E27FC236}">
-                <a16:creationId xmlns:a16="http://schemas.microsoft.com/office/drawing/2014/main" id="{DA7E27DF-283F-923B-3DF3-2EA3F1D3C0A4}"/>
+                <a16:creationId xmlns:a16="http://schemas.microsoft.com/office/drawing/2014/main" id="{82E4BC4A-B2DA-F6DA-0DED-864A951DF560}"/>
               </a:ext>
             </a:extLst>
           </p:cNvPr>
@@ -2531,7 +2531,7 @@
           <p:cNvPr id="3" name="Marcador de posición de imagen 2">
             <a:extLst>
               <a:ext uri="{FF2B5EF4-FFF2-40B4-BE49-F238E27FC236}">
-                <a16:creationId xmlns:a16="http://schemas.microsoft.com/office/drawing/2014/main" id="{8A7BBB3F-E5AE-883E-A595-62A80156AA68}"/>
+                <a16:creationId xmlns:a16="http://schemas.microsoft.com/office/drawing/2014/main" id="{12B09912-6FCA-DEB0-2ECD-AA0A267F74D0}"/>
               </a:ext>
             </a:extLst>
           </p:cNvPr>
@@ -2598,7 +2598,7 @@
           <p:cNvPr id="4" name="Marcador de texto 3">
             <a:extLst>
               <a:ext uri="{FF2B5EF4-FFF2-40B4-BE49-F238E27FC236}">
-                <a16:creationId xmlns:a16="http://schemas.microsoft.com/office/drawing/2014/main" id="{AAAD0FDF-AB72-4FF3-5492-30904899C031}"/>
+                <a16:creationId xmlns:a16="http://schemas.microsoft.com/office/drawing/2014/main" id="{03B15B51-B850-54DF-FFE2-E672D27A0796}"/>
               </a:ext>
             </a:extLst>
           </p:cNvPr>
@@ -2669,7 +2669,7 @@
           <p:cNvPr id="5" name="Marcador de fecha 4">
             <a:extLst>
               <a:ext uri="{FF2B5EF4-FFF2-40B4-BE49-F238E27FC236}">
-                <a16:creationId xmlns:a16="http://schemas.microsoft.com/office/drawing/2014/main" id="{A3DD8369-BEFD-38EC-1465-5019A56CAF23}"/>
+                <a16:creationId xmlns:a16="http://schemas.microsoft.com/office/drawing/2014/main" id="{BEF05B45-8DE0-C098-315C-32450FFC2383}"/>
               </a:ext>
             </a:extLst>
           </p:cNvPr>
@@ -2685,7 +2685,7 @@
           <a:bodyPr/>
           <a:lstStyle/>
           <a:p>
-            <a:fld id="{2F6522CC-1677-4567-9825-52B108A01684}" type="datetimeFigureOut">
+            <a:fld id="{C2ABA621-767C-4C50-B589-2B8966EB5CF9}" type="datetimeFigureOut">
               <a:rPr lang="es-EC" smtClean="0"/>
               <a:t>8/10/2026</a:t>
             </a:fld>
@@ -2698,7 +2698,7 @@
           <p:cNvPr id="6" name="Marcador de pie de página 5">
             <a:extLst>
               <a:ext uri="{FF2B5EF4-FFF2-40B4-BE49-F238E27FC236}">
-                <a16:creationId xmlns:a16="http://schemas.microsoft.com/office/drawing/2014/main" id="{E08DA27D-EA23-72C3-55A7-FA25CB03C7A0}"/>
+                <a16:creationId xmlns:a16="http://schemas.microsoft.com/office/drawing/2014/main" id="{965D7FE3-2D0E-CCC6-ED6F-52D723E20B1F}"/>
               </a:ext>
             </a:extLst>
           </p:cNvPr>
@@ -2723,7 +2723,7 @@
           <p:cNvPr id="7" name="Marcador de número de diapositiva 6">
             <a:extLst>
               <a:ext uri="{FF2B5EF4-FFF2-40B4-BE49-F238E27FC236}">
-                <a16:creationId xmlns:a16="http://schemas.microsoft.com/office/drawing/2014/main" id="{5BA5BC25-10DD-6060-5D72-FEA3EDA86B7D}"/>
+                <a16:creationId xmlns:a16="http://schemas.microsoft.com/office/drawing/2014/main" id="{74342B4C-2B9B-EBCC-81A5-2D4D9AEE8991}"/>
               </a:ext>
             </a:extLst>
           </p:cNvPr>
@@ -2739,7 +2739,7 @@
           <a:bodyPr/>
           <a:lstStyle/>
           <a:p>
-            <a:fld id="{F3F25716-C9CD-4922-9EEA-B1CBFD816F36}" type="slidenum">
+            <a:fld id="{C537BDE0-565E-4BE3-A05B-A9A5BD51F203}" type="slidenum">
               <a:rPr lang="es-EC" smtClean="0"/>
               <a:t>‹Nº›</a:t>
             </a:fld>
@@ -2750,7 +2750,7 @@
     </p:spTree>
     <p:extLst>
       <p:ext uri="{BB962C8B-B14F-4D97-AF65-F5344CB8AC3E}">
-        <p14:creationId xmlns:p14="http://schemas.microsoft.com/office/powerpoint/2010/main" val="622885322"/>
+        <p14:creationId xmlns:p14="http://schemas.microsoft.com/office/powerpoint/2010/main" val="2797420559"/>
       </p:ext>
     </p:extLst>
   </p:cSld>
@@ -2787,7 +2787,7 @@
           <p:cNvPr id="2" name="Marcador de título 1">
             <a:extLst>
               <a:ext uri="{FF2B5EF4-FFF2-40B4-BE49-F238E27FC236}">
-                <a16:creationId xmlns:a16="http://schemas.microsoft.com/office/drawing/2014/main" id="{2FC07939-265E-C67D-4289-48CF2E2EDE91}"/>
+                <a16:creationId xmlns:a16="http://schemas.microsoft.com/office/drawing/2014/main" id="{ED159DE5-3460-F922-E178-BD989A4B9EF6}"/>
               </a:ext>
             </a:extLst>
           </p:cNvPr>
@@ -2826,7 +2826,7 @@
           <p:cNvPr id="3" name="Marcador de texto 2">
             <a:extLst>
               <a:ext uri="{FF2B5EF4-FFF2-40B4-BE49-F238E27FC236}">
-                <a16:creationId xmlns:a16="http://schemas.microsoft.com/office/drawing/2014/main" id="{B2E61F7A-7A7C-A8AB-0519-C94ED8DE0636}"/>
+                <a16:creationId xmlns:a16="http://schemas.microsoft.com/office/drawing/2014/main" id="{E773EF3D-611C-1267-44DD-F90830F452E4}"/>
               </a:ext>
             </a:extLst>
           </p:cNvPr>
@@ -2894,7 +2894,7 @@
           <p:cNvPr id="4" name="Marcador de fecha 3">
             <a:extLst>
               <a:ext uri="{FF2B5EF4-FFF2-40B4-BE49-F238E27FC236}">
-                <a16:creationId xmlns:a16="http://schemas.microsoft.com/office/drawing/2014/main" id="{D5852FE3-0860-FE55-DE3B-A85F03629E85}"/>
+                <a16:creationId xmlns:a16="http://schemas.microsoft.com/office/drawing/2014/main" id="{EC5DB3DE-3489-3C99-FDC2-3D542EEB7D99}"/>
               </a:ext>
             </a:extLst>
           </p:cNvPr>
@@ -2928,7 +2928,7 @@
             </a:lvl1pPr>
           </a:lstStyle>
           <a:p>
-            <a:fld id="{2F6522CC-1677-4567-9825-52B108A01684}" type="datetimeFigureOut">
+            <a:fld id="{C2ABA621-767C-4C50-B589-2B8966EB5CF9}" type="datetimeFigureOut">
               <a:rPr lang="es-EC" smtClean="0"/>
               <a:t>8/10/2026</a:t>
             </a:fld>
@@ -2941,7 +2941,7 @@
           <p:cNvPr id="5" name="Marcador de pie de página 4">
             <a:extLst>
               <a:ext uri="{FF2B5EF4-FFF2-40B4-BE49-F238E27FC236}">
-                <a16:creationId xmlns:a16="http://schemas.microsoft.com/office/drawing/2014/main" id="{1AA1468F-A94A-4D2E-AB9C-13B54AFB2C1E}"/>
+                <a16:creationId xmlns:a16="http://schemas.microsoft.com/office/drawing/2014/main" id="{25654862-65C9-2732-6D0B-58B000DA64C1}"/>
               </a:ext>
             </a:extLst>
           </p:cNvPr>
@@ -2984,7 +2984,7 @@
           <p:cNvPr id="6" name="Marcador de número de diapositiva 5">
             <a:extLst>
               <a:ext uri="{FF2B5EF4-FFF2-40B4-BE49-F238E27FC236}">
-                <a16:creationId xmlns:a16="http://schemas.microsoft.com/office/drawing/2014/main" id="{B949342C-0A0B-3535-AB60-41A15DB548E5}"/>
+                <a16:creationId xmlns:a16="http://schemas.microsoft.com/office/drawing/2014/main" id="{7F664373-B83A-7C85-4640-FBD89830432C}"/>
               </a:ext>
             </a:extLst>
           </p:cNvPr>
@@ -3018,7 +3018,7 @@
             </a:lvl1pPr>
           </a:lstStyle>
           <a:p>
-            <a:fld id="{F3F25716-C9CD-4922-9EEA-B1CBFD816F36}" type="slidenum">
+            <a:fld id="{C537BDE0-565E-4BE3-A05B-A9A5BD51F203}" type="slidenum">
               <a:rPr lang="es-EC" smtClean="0"/>
               <a:t>‹Nº›</a:t>
             </a:fld>
@@ -3029,7 +3029,7 @@
     </p:spTree>
     <p:extLst>
       <p:ext uri="{BB962C8B-B14F-4D97-AF65-F5344CB8AC3E}">
-        <p14:creationId xmlns:p14="http://schemas.microsoft.com/office/powerpoint/2010/main" val="4256732197"/>
+        <p14:creationId xmlns:p14="http://schemas.microsoft.com/office/powerpoint/2010/main" val="657343699"/>
       </p:ext>
     </p:extLst>
   </p:cSld>
@@ -3352,7 +3352,7 @@
           <p:cNvPr id="2" name="Rectángulo 1">
             <a:extLst>
               <a:ext uri="{FF2B5EF4-FFF2-40B4-BE49-F238E27FC236}">
-                <a16:creationId xmlns:a16="http://schemas.microsoft.com/office/drawing/2014/main" id="{9A799B5B-D17B-B220-8849-18E9DCCD8D17}"/>
+                <a16:creationId xmlns:a16="http://schemas.microsoft.com/office/drawing/2014/main" id="{7526D181-044A-E827-11B2-F57F517DEFA1}"/>
               </a:ext>
             </a:extLst>
           </p:cNvPr>
@@ -3407,7 +3407,7 @@
           <p:cNvPr id="3" name="Rectángulo 2">
             <a:extLst>
               <a:ext uri="{FF2B5EF4-FFF2-40B4-BE49-F238E27FC236}">
-                <a16:creationId xmlns:a16="http://schemas.microsoft.com/office/drawing/2014/main" id="{2D1D39EE-8624-4F20-1954-F1860858DBE0}"/>
+                <a16:creationId xmlns:a16="http://schemas.microsoft.com/office/drawing/2014/main" id="{28A94069-985B-7E40-C080-6267D007012C}"/>
               </a:ext>
             </a:extLst>
           </p:cNvPr>
@@ -3462,7 +3462,7 @@
           <p:cNvPr id="4" name="CuadroTexto 3">
             <a:extLst>
               <a:ext uri="{FF2B5EF4-FFF2-40B4-BE49-F238E27FC236}">
-                <a16:creationId xmlns:a16="http://schemas.microsoft.com/office/drawing/2014/main" id="{A7A94858-7DBD-E323-E753-E50539D29CBA}"/>
+                <a16:creationId xmlns:a16="http://schemas.microsoft.com/office/drawing/2014/main" id="{31F771DA-7567-8488-BC04-8E8A7F3FB59E}"/>
               </a:ext>
             </a:extLst>
           </p:cNvPr>
@@ -3502,7 +3502,7 @@
           <p:cNvPr id="5" name="CuadroTexto 4">
             <a:extLst>
               <a:ext uri="{FF2B5EF4-FFF2-40B4-BE49-F238E27FC236}">
-                <a16:creationId xmlns:a16="http://schemas.microsoft.com/office/drawing/2014/main" id="{1697DF09-C770-DFC3-D652-630C53536A2D}"/>
+                <a16:creationId xmlns:a16="http://schemas.microsoft.com/office/drawing/2014/main" id="{E0B21D2D-51CB-AA41-B949-61DA83EC6A39}"/>
               </a:ext>
             </a:extLst>
           </p:cNvPr>
@@ -3548,7 +3548,7 @@
           <p:cNvPr id="6" name="CuadroTexto 5">
             <a:extLst>
               <a:ext uri="{FF2B5EF4-FFF2-40B4-BE49-F238E27FC236}">
-                <a16:creationId xmlns:a16="http://schemas.microsoft.com/office/drawing/2014/main" id="{8F5E085C-02A9-11D4-B54D-E38EAA16264A}"/>
+                <a16:creationId xmlns:a16="http://schemas.microsoft.com/office/drawing/2014/main" id="{708B3534-C43D-4E3E-9AC4-620633D0E3CF}"/>
               </a:ext>
             </a:extLst>
           </p:cNvPr>
@@ -3589,7 +3589,7 @@
                 </a:solidFill>
                 <a:latin typeface="Calibri" panose="020F0502020204030204" pitchFamily="34" charset="0"/>
               </a:rPr>
-              <a:t>Reto: Farmaenlace y BYD  |  Equipo: Los 21 Pilotos</a:t>
+              <a:t>Reto: Farmaenlace - Linea: Mejora Operativa  |  Equipo: Los 21 Pilotos</a:t>
             </a:r>
             <a:endParaRPr lang="es-EC" sz="1400">
               <a:solidFill>
@@ -3603,7 +3603,7 @@
     </p:spTree>
     <p:extLst>
       <p:ext uri="{BB962C8B-B14F-4D97-AF65-F5344CB8AC3E}">
-        <p14:creationId xmlns:p14="http://schemas.microsoft.com/office/powerpoint/2010/main" val="2817896422"/>
+        <p14:creationId xmlns:p14="http://schemas.microsoft.com/office/powerpoint/2010/main" val="438993333"/>
       </p:ext>
     </p:extLst>
   </p:cSld>
@@ -3635,7 +3635,7 @@
           <p:cNvPr id="2" name="Rectángulo 1">
             <a:extLst>
               <a:ext uri="{FF2B5EF4-FFF2-40B4-BE49-F238E27FC236}">
-                <a16:creationId xmlns:a16="http://schemas.microsoft.com/office/drawing/2014/main" id="{4FD99BA4-6DD9-695B-2AE6-2EDF2904FE18}"/>
+                <a16:creationId xmlns:a16="http://schemas.microsoft.com/office/drawing/2014/main" id="{23EBCB0A-4263-4D7C-3618-EDF03FD389A8}"/>
               </a:ext>
             </a:extLst>
           </p:cNvPr>
@@ -3690,7 +3690,7 @@
           <p:cNvPr id="3" name="Rectángulo 2">
             <a:extLst>
               <a:ext uri="{FF2B5EF4-FFF2-40B4-BE49-F238E27FC236}">
-                <a16:creationId xmlns:a16="http://schemas.microsoft.com/office/drawing/2014/main" id="{3EB462A2-EC89-3D4E-E632-9ABCF601F939}"/>
+                <a16:creationId xmlns:a16="http://schemas.microsoft.com/office/drawing/2014/main" id="{B1674EDB-AAFC-2E93-1C7B-DF8BF99DAEE4}"/>
               </a:ext>
             </a:extLst>
           </p:cNvPr>
@@ -3745,7 +3745,7 @@
           <p:cNvPr id="4" name="CuadroTexto 3">
             <a:extLst>
               <a:ext uri="{FF2B5EF4-FFF2-40B4-BE49-F238E27FC236}">
-                <a16:creationId xmlns:a16="http://schemas.microsoft.com/office/drawing/2014/main" id="{663CBB70-09D0-A5BC-011D-A8A8DD92501A}"/>
+                <a16:creationId xmlns:a16="http://schemas.microsoft.com/office/drawing/2014/main" id="{268DF4EA-3B42-FECE-366E-130B97CDA67D}"/>
               </a:ext>
             </a:extLst>
           </p:cNvPr>
@@ -3785,7 +3785,7 @@
           <p:cNvPr id="5" name="CuadroTexto 4">
             <a:extLst>
               <a:ext uri="{FF2B5EF4-FFF2-40B4-BE49-F238E27FC236}">
-                <a16:creationId xmlns:a16="http://schemas.microsoft.com/office/drawing/2014/main" id="{D16E513A-D8E3-CE0D-4547-C3E1AEB3A2DE}"/>
+                <a16:creationId xmlns:a16="http://schemas.microsoft.com/office/drawing/2014/main" id="{453F91AB-8B84-3188-056D-8B09C0FAC0B7}"/>
               </a:ext>
             </a:extLst>
           </p:cNvPr>
@@ -3831,7 +3831,7 @@
           <p:cNvPr id="6" name="CuadroTexto 5">
             <a:extLst>
               <a:ext uri="{FF2B5EF4-FFF2-40B4-BE49-F238E27FC236}">
-                <a16:creationId xmlns:a16="http://schemas.microsoft.com/office/drawing/2014/main" id="{90324ADF-E2D0-79FE-2C3E-B36B1CB44BFA}"/>
+                <a16:creationId xmlns:a16="http://schemas.microsoft.com/office/drawing/2014/main" id="{79BA7106-EC60-8F7E-1B97-AF034796A9C5}"/>
               </a:ext>
             </a:extLst>
           </p:cNvPr>
@@ -3861,7 +3861,7 @@
                 </a:solidFill>
                 <a:latin typeface="Calibri" panose="020F0502020204030204" pitchFamily="34" charset="0"/>
               </a:rPr>
-              <a:t>FarmaSenal | Reto Farmaenlace y BYD - Equipo Los 21 Pilotos</a:t>
+              <a:t>FarmaSenal | Reto Farmaenlace: Linea Mejora Operativa - Equipo Los 21 Pilotos</a:t>
             </a:r>
             <a:endParaRPr lang="es-EC" sz="1000">
               <a:solidFill>
@@ -3877,7 +3877,7 @@
           <p:cNvPr id="8" name="Imagen 7">
             <a:extLst>
               <a:ext uri="{FF2B5EF4-FFF2-40B4-BE49-F238E27FC236}">
-                <a16:creationId xmlns:a16="http://schemas.microsoft.com/office/drawing/2014/main" id="{91C44C72-0598-AFF3-9DFB-FA70E741DB7B}"/>
+                <a16:creationId xmlns:a16="http://schemas.microsoft.com/office/drawing/2014/main" id="{070E6857-3344-9A04-9AAA-128DBD6B1767}"/>
               </a:ext>
             </a:extLst>
           </p:cNvPr>
@@ -3913,7 +3913,7 @@
           <p:cNvPr id="9" name="Rectángulo 8">
             <a:extLst>
               <a:ext uri="{FF2B5EF4-FFF2-40B4-BE49-F238E27FC236}">
-                <a16:creationId xmlns:a16="http://schemas.microsoft.com/office/drawing/2014/main" id="{8D321282-BB29-5577-4AE0-BCCBFFE86833}"/>
+                <a16:creationId xmlns:a16="http://schemas.microsoft.com/office/drawing/2014/main" id="{A46AF4BF-5F76-3664-3E4A-EC65CE7E68F6}"/>
               </a:ext>
             </a:extLst>
           </p:cNvPr>
@@ -3977,7 +3977,7 @@
           <p:cNvPr id="10" name="Rectángulo 9">
             <a:extLst>
               <a:ext uri="{FF2B5EF4-FFF2-40B4-BE49-F238E27FC236}">
-                <a16:creationId xmlns:a16="http://schemas.microsoft.com/office/drawing/2014/main" id="{296BF80D-3146-A64A-07AC-B6862D9B0342}"/>
+                <a16:creationId xmlns:a16="http://schemas.microsoft.com/office/drawing/2014/main" id="{0949E502-80B3-DE4E-A4EA-E80555DB87EA}"/>
               </a:ext>
             </a:extLst>
           </p:cNvPr>
@@ -4031,7 +4031,7 @@
           <p:cNvPr id="11" name="CuadroTexto 10">
             <a:extLst>
               <a:ext uri="{FF2B5EF4-FFF2-40B4-BE49-F238E27FC236}">
-                <a16:creationId xmlns:a16="http://schemas.microsoft.com/office/drawing/2014/main" id="{3A3883B5-4025-A9FB-4A59-601CF9ED03CD}"/>
+                <a16:creationId xmlns:a16="http://schemas.microsoft.com/office/drawing/2014/main" id="{32AFA6B6-7475-D463-4ABC-9349C0ACE130}"/>
               </a:ext>
             </a:extLst>
           </p:cNvPr>
@@ -4176,7 +4176,7 @@
     </p:spTree>
     <p:extLst>
       <p:ext uri="{BB962C8B-B14F-4D97-AF65-F5344CB8AC3E}">
-        <p14:creationId xmlns:p14="http://schemas.microsoft.com/office/powerpoint/2010/main" val="932409807"/>
+        <p14:creationId xmlns:p14="http://schemas.microsoft.com/office/powerpoint/2010/main" val="211041013"/>
       </p:ext>
     </p:extLst>
   </p:cSld>
@@ -4208,7 +4208,7 @@
           <p:cNvPr id="2" name="Rectángulo 1">
             <a:extLst>
               <a:ext uri="{FF2B5EF4-FFF2-40B4-BE49-F238E27FC236}">
-                <a16:creationId xmlns:a16="http://schemas.microsoft.com/office/drawing/2014/main" id="{DB1FA349-6FBB-44B6-768A-F484B2A139B2}"/>
+                <a16:creationId xmlns:a16="http://schemas.microsoft.com/office/drawing/2014/main" id="{4510E932-2E97-1453-51E4-6A864A06F6B8}"/>
               </a:ext>
             </a:extLst>
           </p:cNvPr>
@@ -4263,7 +4263,7 @@
           <p:cNvPr id="3" name="Rectángulo 2">
             <a:extLst>
               <a:ext uri="{FF2B5EF4-FFF2-40B4-BE49-F238E27FC236}">
-                <a16:creationId xmlns:a16="http://schemas.microsoft.com/office/drawing/2014/main" id="{3E6C3F9B-94CE-1939-8ED8-D5DB8ED9882C}"/>
+                <a16:creationId xmlns:a16="http://schemas.microsoft.com/office/drawing/2014/main" id="{1FB11653-46D0-EE56-EC61-4C5639BFDA2A}"/>
               </a:ext>
             </a:extLst>
           </p:cNvPr>
@@ -4318,7 +4318,7 @@
           <p:cNvPr id="4" name="CuadroTexto 3">
             <a:extLst>
               <a:ext uri="{FF2B5EF4-FFF2-40B4-BE49-F238E27FC236}">
-                <a16:creationId xmlns:a16="http://schemas.microsoft.com/office/drawing/2014/main" id="{84D259F2-58D6-005F-8857-FAE5B2631991}"/>
+                <a16:creationId xmlns:a16="http://schemas.microsoft.com/office/drawing/2014/main" id="{9C473B7A-0FC4-6D00-8A94-99CAC7934967}"/>
               </a:ext>
             </a:extLst>
           </p:cNvPr>
@@ -4364,7 +4364,7 @@
           <p:cNvPr id="5" name="CuadroTexto 4">
             <a:extLst>
               <a:ext uri="{FF2B5EF4-FFF2-40B4-BE49-F238E27FC236}">
-                <a16:creationId xmlns:a16="http://schemas.microsoft.com/office/drawing/2014/main" id="{B11FD4C5-9607-8F32-AEF5-36448435719D}"/>
+                <a16:creationId xmlns:a16="http://schemas.microsoft.com/office/drawing/2014/main" id="{484C3731-AC3E-A0FE-B3A4-543C9F605DBF}"/>
               </a:ext>
             </a:extLst>
           </p:cNvPr>
@@ -4410,7 +4410,7 @@
           <p:cNvPr id="6" name="CuadroTexto 5">
             <a:extLst>
               <a:ext uri="{FF2B5EF4-FFF2-40B4-BE49-F238E27FC236}">
-                <a16:creationId xmlns:a16="http://schemas.microsoft.com/office/drawing/2014/main" id="{91B0757B-4AC8-C66C-7C62-61756AE3AD05}"/>
+                <a16:creationId xmlns:a16="http://schemas.microsoft.com/office/drawing/2014/main" id="{97CCF74D-C09C-36C7-BA41-449A90E447F5}"/>
               </a:ext>
             </a:extLst>
           </p:cNvPr>
@@ -4440,7 +4440,7 @@
                 </a:solidFill>
                 <a:latin typeface="Calibri" panose="020F0502020204030204" pitchFamily="34" charset="0"/>
               </a:rPr>
-              <a:t>FarmaSenal | Reto Farmaenlace y BYD - Equipo Los 21 Pilotos</a:t>
+              <a:t>FarmaSenal | Reto Farmaenlace: Linea Mejora Operativa - Equipo Los 21 Pilotos</a:t>
             </a:r>
             <a:endParaRPr lang="es-EC" sz="1000">
               <a:solidFill>
@@ -4456,7 +4456,7 @@
           <p:cNvPr id="7" name="Rectángulo 6">
             <a:extLst>
               <a:ext uri="{FF2B5EF4-FFF2-40B4-BE49-F238E27FC236}">
-                <a16:creationId xmlns:a16="http://schemas.microsoft.com/office/drawing/2014/main" id="{60CF1D8E-BA28-58D8-8B8C-65CB92DAD893}"/>
+                <a16:creationId xmlns:a16="http://schemas.microsoft.com/office/drawing/2014/main" id="{10D95DBD-C508-3253-240D-2FEEA8C15B35}"/>
               </a:ext>
             </a:extLst>
           </p:cNvPr>
@@ -4510,7 +4510,7 @@
           <p:cNvPr id="8" name="CuadroTexto 7">
             <a:extLst>
               <a:ext uri="{FF2B5EF4-FFF2-40B4-BE49-F238E27FC236}">
-                <a16:creationId xmlns:a16="http://schemas.microsoft.com/office/drawing/2014/main" id="{D30D3A2C-A113-BED5-B5E9-ECE8C9D9B044}"/>
+                <a16:creationId xmlns:a16="http://schemas.microsoft.com/office/drawing/2014/main" id="{B8AB4500-BA18-7C7D-1874-E0830851250A}"/>
               </a:ext>
             </a:extLst>
           </p:cNvPr>
@@ -4594,7 +4594,7 @@
           <p:cNvPr id="9" name="Rectángulo 8">
             <a:extLst>
               <a:ext uri="{FF2B5EF4-FFF2-40B4-BE49-F238E27FC236}">
-                <a16:creationId xmlns:a16="http://schemas.microsoft.com/office/drawing/2014/main" id="{18B90502-D698-C3C6-5241-5E8D63974D62}"/>
+                <a16:creationId xmlns:a16="http://schemas.microsoft.com/office/drawing/2014/main" id="{4EB8D637-2B52-4007-6CC4-C2A769F1CDA5}"/>
               </a:ext>
             </a:extLst>
           </p:cNvPr>
@@ -4648,7 +4648,7 @@
           <p:cNvPr id="10" name="CuadroTexto 9">
             <a:extLst>
               <a:ext uri="{FF2B5EF4-FFF2-40B4-BE49-F238E27FC236}">
-                <a16:creationId xmlns:a16="http://schemas.microsoft.com/office/drawing/2014/main" id="{22CCCB85-B7BE-7139-8F84-49C5B2CC3DAF}"/>
+                <a16:creationId xmlns:a16="http://schemas.microsoft.com/office/drawing/2014/main" id="{4CED8547-CE70-A41D-4C15-3465B7EF336F}"/>
               </a:ext>
             </a:extLst>
           </p:cNvPr>
@@ -4732,7 +4732,7 @@
           <p:cNvPr id="11" name="Rectángulo 10">
             <a:extLst>
               <a:ext uri="{FF2B5EF4-FFF2-40B4-BE49-F238E27FC236}">
-                <a16:creationId xmlns:a16="http://schemas.microsoft.com/office/drawing/2014/main" id="{6CB960CF-0150-BB67-6D3F-21D14852B4FB}"/>
+                <a16:creationId xmlns:a16="http://schemas.microsoft.com/office/drawing/2014/main" id="{D904A4F2-7818-9074-3A4D-D782769B5FD8}"/>
               </a:ext>
             </a:extLst>
           </p:cNvPr>
@@ -4786,7 +4786,7 @@
           <p:cNvPr id="12" name="CuadroTexto 11">
             <a:extLst>
               <a:ext uri="{FF2B5EF4-FFF2-40B4-BE49-F238E27FC236}">
-                <a16:creationId xmlns:a16="http://schemas.microsoft.com/office/drawing/2014/main" id="{2E754962-081A-1DD4-DB02-619FDB96D09C}"/>
+                <a16:creationId xmlns:a16="http://schemas.microsoft.com/office/drawing/2014/main" id="{74BEAEDC-B775-D96A-7D6D-409EA5A3F1FF}"/>
               </a:ext>
             </a:extLst>
           </p:cNvPr>
@@ -4868,7 +4868,7 @@
     </p:spTree>
     <p:extLst>
       <p:ext uri="{BB962C8B-B14F-4D97-AF65-F5344CB8AC3E}">
-        <p14:creationId xmlns:p14="http://schemas.microsoft.com/office/powerpoint/2010/main" val="2520685199"/>
+        <p14:creationId xmlns:p14="http://schemas.microsoft.com/office/powerpoint/2010/main" val="1174165592"/>
       </p:ext>
     </p:extLst>
   </p:cSld>
@@ -4900,7 +4900,7 @@
           <p:cNvPr id="2" name="Rectángulo 1">
             <a:extLst>
               <a:ext uri="{FF2B5EF4-FFF2-40B4-BE49-F238E27FC236}">
-                <a16:creationId xmlns:a16="http://schemas.microsoft.com/office/drawing/2014/main" id="{97D669B3-C5A6-8570-84B2-48388244C523}"/>
+                <a16:creationId xmlns:a16="http://schemas.microsoft.com/office/drawing/2014/main" id="{9A3F5E25-6C06-50C6-2974-55A0B6CE68BC}"/>
               </a:ext>
             </a:extLst>
           </p:cNvPr>
@@ -4955,7 +4955,7 @@
           <p:cNvPr id="3" name="Rectángulo 2">
             <a:extLst>
               <a:ext uri="{FF2B5EF4-FFF2-40B4-BE49-F238E27FC236}">
-                <a16:creationId xmlns:a16="http://schemas.microsoft.com/office/drawing/2014/main" id="{E9BD9B29-5B33-7356-6CCE-77D3C4EA6F19}"/>
+                <a16:creationId xmlns:a16="http://schemas.microsoft.com/office/drawing/2014/main" id="{F61CA618-70FB-616D-5F64-B60BD2013FE3}"/>
               </a:ext>
             </a:extLst>
           </p:cNvPr>
@@ -5010,7 +5010,7 @@
           <p:cNvPr id="4" name="CuadroTexto 3">
             <a:extLst>
               <a:ext uri="{FF2B5EF4-FFF2-40B4-BE49-F238E27FC236}">
-                <a16:creationId xmlns:a16="http://schemas.microsoft.com/office/drawing/2014/main" id="{2C97B78B-16D2-C49D-CD9E-9E6844316063}"/>
+                <a16:creationId xmlns:a16="http://schemas.microsoft.com/office/drawing/2014/main" id="{98C15D28-E1AD-6F31-73A2-E94DEEB327F0}"/>
               </a:ext>
             </a:extLst>
           </p:cNvPr>
@@ -5056,7 +5056,7 @@
           <p:cNvPr id="5" name="CuadroTexto 4">
             <a:extLst>
               <a:ext uri="{FF2B5EF4-FFF2-40B4-BE49-F238E27FC236}">
-                <a16:creationId xmlns:a16="http://schemas.microsoft.com/office/drawing/2014/main" id="{5E38F017-102D-F69A-1598-1C761FA699AB}"/>
+                <a16:creationId xmlns:a16="http://schemas.microsoft.com/office/drawing/2014/main" id="{6FC23486-F7D7-20B5-78F6-898D68987E1A}"/>
               </a:ext>
             </a:extLst>
           </p:cNvPr>
@@ -5080,20 +5080,14 @@
           <a:lstStyle/>
           <a:p>
             <a:r>
-              <a:rPr lang="es-MX" sz="1300">
+              <a:rPr lang="es-EC" sz="1300">
                 <a:solidFill>
                   <a:srgbClr val="64748B"/>
                 </a:solidFill>
                 <a:latin typeface="Calibri" panose="020F0502020204030204" pitchFamily="34" charset="0"/>
               </a:rPr>
-              <a:t>Deteccion preventiva y semaforo de demanda para balancear inventario en tiempo real</a:t>
-            </a:r>
-            <a:endParaRPr lang="es-EC" sz="1300">
-              <a:solidFill>
-                <a:srgbClr val="64748B"/>
-              </a:solidFill>
-              <a:latin typeface="Calibri" panose="020F0502020204030204" pitchFamily="34" charset="0"/>
-            </a:endParaRPr>
+              <a:t>Foco Estrategico: Linea 3 - Mejora Operativa de la Cadena de Suministro</a:t>
+            </a:r>
           </a:p>
         </p:txBody>
       </p:sp>
@@ -5102,7 +5096,7 @@
           <p:cNvPr id="6" name="CuadroTexto 5">
             <a:extLst>
               <a:ext uri="{FF2B5EF4-FFF2-40B4-BE49-F238E27FC236}">
-                <a16:creationId xmlns:a16="http://schemas.microsoft.com/office/drawing/2014/main" id="{3C155545-7C2B-84DE-46B0-17A0A745E9C4}"/>
+                <a16:creationId xmlns:a16="http://schemas.microsoft.com/office/drawing/2014/main" id="{9F38A81E-EB83-618B-DC59-ED25762F53EC}"/>
               </a:ext>
             </a:extLst>
           </p:cNvPr>
@@ -5132,7 +5126,7 @@
                 </a:solidFill>
                 <a:latin typeface="Calibri" panose="020F0502020204030204" pitchFamily="34" charset="0"/>
               </a:rPr>
-              <a:t>FarmaSenal | Reto Farmaenlace y BYD - Equipo Los 21 Pilotos</a:t>
+              <a:t>FarmaSenal | Reto Farmaenlace: Linea Mejora Operativa - Equipo Los 21 Pilotos</a:t>
             </a:r>
             <a:endParaRPr lang="es-EC" sz="1000">
               <a:solidFill>
@@ -5148,7 +5142,7 @@
           <p:cNvPr id="7" name="Rectángulo 6">
             <a:extLst>
               <a:ext uri="{FF2B5EF4-FFF2-40B4-BE49-F238E27FC236}">
-                <a16:creationId xmlns:a16="http://schemas.microsoft.com/office/drawing/2014/main" id="{A243AD66-8806-0C6C-13D0-E077C7B0DEC4}"/>
+                <a16:creationId xmlns:a16="http://schemas.microsoft.com/office/drawing/2014/main" id="{2ED97D7D-E75E-A991-6C9E-BC14ECBA685C}"/>
               </a:ext>
             </a:extLst>
           </p:cNvPr>
@@ -5158,7 +5152,7 @@
         <p:spPr>
           <a:xfrm>
             <a:off x="762000" y="1524000"/>
-            <a:ext cx="6096000" cy="4318000"/>
+            <a:ext cx="6350000" cy="4445000"/>
           </a:xfrm>
           <a:prstGeom prst="rect">
             <a:avLst/>
@@ -5199,148 +5193,10 @@
       </p:sp>
       <p:sp>
         <p:nvSpPr>
-          <p:cNvPr id="8" name="CuadroTexto 7">
-            <a:extLst>
-              <a:ext uri="{FF2B5EF4-FFF2-40B4-BE49-F238E27FC236}">
-                <a16:creationId xmlns:a16="http://schemas.microsoft.com/office/drawing/2014/main" id="{F999C6D1-A57D-67A2-D590-6758F6B68CAD}"/>
-              </a:ext>
-            </a:extLst>
-          </p:cNvPr>
-          <p:cNvSpPr txBox="1"/>
-          <p:nvPr/>
-        </p:nvSpPr>
-        <p:spPr>
-          <a:xfrm>
-            <a:off x="1016000" y="1714500"/>
-            <a:ext cx="5588000" cy="3108543"/>
-          </a:xfrm>
-          <a:prstGeom prst="rect">
-            <a:avLst/>
-          </a:prstGeom>
-          <a:noFill/>
-        </p:spPr>
-        <p:txBody>
-          <a:bodyPr vert="horz" wrap="square" rtlCol="0">
-            <a:spAutoFit/>
-          </a:bodyPr>
-          <a:lstStyle/>
-          <a:p>
-            <a:r>
-              <a:rPr lang="es-EC" sz="1400">
-                <a:solidFill>
-                  <a:srgbClr val="1E293B"/>
-                </a:solidFill>
-                <a:latin typeface="Calibri" panose="020F0502020204030204" pitchFamily="34" charset="0"/>
-              </a:rPr>
-              <a:t>Como funciona el motor:</a:t>
-            </a:r>
-          </a:p>
-          <a:p>
-            <a:endParaRPr lang="es-EC" sz="1400">
-              <a:solidFill>
-                <a:srgbClr val="1E293B"/>
-              </a:solidFill>
-              <a:latin typeface="Calibri" panose="020F0502020204030204" pitchFamily="34" charset="0"/>
-            </a:endParaRPr>
-          </a:p>
-          <a:p>
-            <a:r>
-              <a:rPr lang="es-EC" sz="1400">
-                <a:solidFill>
-                  <a:srgbClr val="1E293B"/>
-                </a:solidFill>
-                <a:latin typeface="Calibri" panose="020F0502020204030204" pitchFamily="34" charset="0"/>
-              </a:rPr>
-              <a:t>- Ventana Movil Predictiva: Compara los ultimos 30 dias vs la linea base historica de 90 dias.</a:t>
-            </a:r>
-          </a:p>
-          <a:p>
-            <a:endParaRPr lang="es-EC" sz="1400">
-              <a:solidFill>
-                <a:srgbClr val="1E293B"/>
-              </a:solidFill>
-              <a:latin typeface="Calibri" panose="020F0502020204030204" pitchFamily="34" charset="0"/>
-            </a:endParaRPr>
-          </a:p>
-          <a:p>
-            <a:r>
-              <a:rPr lang="es-EC" sz="1400">
-                <a:solidFill>
-                  <a:srgbClr val="1E293B"/>
-                </a:solidFill>
-                <a:latin typeface="Calibri" panose="020F0502020204030204" pitchFamily="34" charset="0"/>
-              </a:rPr>
-              <a:t>- Semaforo Explicable por Sector:</a:t>
-            </a:r>
-          </a:p>
-          <a:p>
-            <a:r>
-              <a:rPr lang="es-EC" sz="1400">
-                <a:solidFill>
-                  <a:srgbClr val="1E293B"/>
-                </a:solidFill>
-                <a:latin typeface="Calibri" panose="020F0502020204030204" pitchFamily="34" charset="0"/>
-              </a:rPr>
-              <a:t>  * Amarillo: Alza observada (+50% demanda diaria).</a:t>
-            </a:r>
-          </a:p>
-          <a:p>
-            <a:r>
-              <a:rPr lang="es-EC" sz="1400">
-                <a:solidFill>
-                  <a:srgbClr val="1E293B"/>
-                </a:solidFill>
-                <a:latin typeface="Calibri" panose="020F0502020204030204" pitchFamily="34" charset="0"/>
-              </a:rPr>
-              <a:t>  * Rojo: Alza critica (+100% demanda diaria).</a:t>
-            </a:r>
-          </a:p>
-          <a:p>
-            <a:endParaRPr lang="es-EC" sz="1400">
-              <a:solidFill>
-                <a:srgbClr val="1E293B"/>
-              </a:solidFill>
-              <a:latin typeface="Calibri" panose="020F0502020204030204" pitchFamily="34" charset="0"/>
-            </a:endParaRPr>
-          </a:p>
-          <a:p>
-            <a:r>
-              <a:rPr lang="es-EC" sz="1400">
-                <a:solidFill>
-                  <a:srgbClr val="1E293B"/>
-                </a:solidFill>
-                <a:latin typeface="Calibri" panose="020F0502020204030204" pitchFamily="34" charset="0"/>
-              </a:rPr>
-              <a:t>- Filtro por Categorias Criticas: Analgesicos, Cardiovasculares y Respiratorios.</a:t>
-            </a:r>
-          </a:p>
-          <a:p>
-            <a:endParaRPr lang="es-EC" sz="1400">
-              <a:solidFill>
-                <a:srgbClr val="1E293B"/>
-              </a:solidFill>
-              <a:latin typeface="Calibri" panose="020F0502020204030204" pitchFamily="34" charset="0"/>
-            </a:endParaRPr>
-          </a:p>
-          <a:p>
-            <a:r>
-              <a:rPr lang="es-EC" sz="1400">
-                <a:solidFill>
-                  <a:srgbClr val="1E293B"/>
-                </a:solidFill>
-                <a:latin typeface="Calibri" panose="020F0502020204030204" pitchFamily="34" charset="0"/>
-              </a:rPr>
-              <a:t>- Recomendacion de Traslado: Identifica farmacias cercanas con excedente para reabastecer antes de agotar stock.</a:t>
-            </a:r>
-          </a:p>
-        </p:txBody>
-      </p:sp>
-      <p:sp>
-        <p:nvSpPr>
-          <p:cNvPr id="9" name="Rectángulo 8">
-            <a:extLst>
-              <a:ext uri="{FF2B5EF4-FFF2-40B4-BE49-F238E27FC236}">
-                <a16:creationId xmlns:a16="http://schemas.microsoft.com/office/drawing/2014/main" id="{5ADA2DAA-E8DE-28E5-A3F2-7545EEC3D64A}"/>
+          <p:cNvPr id="8" name="Rectángulo 7">
+            <a:extLst>
+              <a:ext uri="{FF2B5EF4-FFF2-40B4-BE49-F238E27FC236}">
+                <a16:creationId xmlns:a16="http://schemas.microsoft.com/office/drawing/2014/main" id="{FF1248A7-1B87-9987-F210-D7D3505CDE87}"/>
               </a:ext>
             </a:extLst>
           </p:cNvPr>
@@ -5349,8 +5205,8 @@
         </p:nvSpPr>
         <p:spPr>
           <a:xfrm>
-            <a:off x="7239000" y="1524000"/>
-            <a:ext cx="4191000" cy="4318000"/>
+            <a:off x="1016000" y="1714500"/>
+            <a:ext cx="5842000" cy="444500"/>
           </a:xfrm>
           <a:prstGeom prst="rect">
             <a:avLst/>
@@ -5405,10 +5261,10 @@
       </p:sp>
       <p:sp>
         <p:nvSpPr>
-          <p:cNvPr id="10" name="CuadroTexto 9">
-            <a:extLst>
-              <a:ext uri="{FF2B5EF4-FFF2-40B4-BE49-F238E27FC236}">
-                <a16:creationId xmlns:a16="http://schemas.microsoft.com/office/drawing/2014/main" id="{B0192600-D743-687C-D134-5995C2246549}"/>
+          <p:cNvPr id="9" name="CuadroTexto 8">
+            <a:extLst>
+              <a:ext uri="{FF2B5EF4-FFF2-40B4-BE49-F238E27FC236}">
+                <a16:creationId xmlns:a16="http://schemas.microsoft.com/office/drawing/2014/main" id="{7D230E78-2346-ED1C-5ABF-011FD49CE84F}"/>
               </a:ext>
             </a:extLst>
           </p:cNvPr>
@@ -5417,8 +5273,8 @@
         </p:nvSpPr>
         <p:spPr>
           <a:xfrm>
-            <a:off x="7493000" y="1905000"/>
-            <a:ext cx="3683000" cy="2277547"/>
+            <a:off x="1079500" y="1778000"/>
+            <a:ext cx="5715000" cy="276999"/>
           </a:xfrm>
           <a:prstGeom prst="rect">
             <a:avLst/>
@@ -5426,12 +5282,261 @@
           <a:noFill/>
         </p:spPr>
         <p:txBody>
+          <a:bodyPr vert="horz" rtlCol="0">
+            <a:spAutoFit/>
+          </a:bodyPr>
+          <a:lstStyle/>
+          <a:p>
+            <a:r>
+              <a:rPr lang="es-EC" sz="1200" b="1">
+                <a:solidFill>
+                  <a:srgbClr val="FFFFFF"/>
+                </a:solidFill>
+                <a:latin typeface="Calibri" panose="020F0502020204030204" pitchFamily="34" charset="0"/>
+              </a:rPr>
+              <a:t>ENFOQUE DEL RETO: LINEA 3 - MEJORA OPERATIVA</a:t>
+            </a:r>
+          </a:p>
+        </p:txBody>
+      </p:sp>
+      <p:sp>
+        <p:nvSpPr>
+          <p:cNvPr id="10" name="CuadroTexto 9">
+            <a:extLst>
+              <a:ext uri="{FF2B5EF4-FFF2-40B4-BE49-F238E27FC236}">
+                <a16:creationId xmlns:a16="http://schemas.microsoft.com/office/drawing/2014/main" id="{D769474B-23E3-643F-0BD8-43C16CA6ACF8}"/>
+              </a:ext>
+            </a:extLst>
+          </p:cNvPr>
+          <p:cNvSpPr txBox="1"/>
+          <p:nvPr/>
+        </p:nvSpPr>
+        <p:spPr>
+          <a:xfrm>
+            <a:off x="1016000" y="2286000"/>
+            <a:ext cx="5842000" cy="2793072"/>
+          </a:xfrm>
+          <a:prstGeom prst="rect">
+            <a:avLst/>
+          </a:prstGeom>
+          <a:noFill/>
+        </p:spPr>
+        <p:txBody>
           <a:bodyPr vert="horz" wrap="square" rtlCol="0">
             <a:spAutoFit/>
           </a:bodyPr>
           <a:lstStyle/>
           <a:p>
             <a:r>
+              <a:rPr lang="es-EC" sz="1350">
+                <a:solidFill>
+                  <a:srgbClr val="1E293B"/>
+                </a:solidFill>
+                <a:latin typeface="Calibri" panose="020F0502020204030204" pitchFamily="34" charset="0"/>
+              </a:rPr>
+              <a:t>Transformamos la reposicion de REACTIVA a PREDICTIVA:</a:t>
+            </a:r>
+          </a:p>
+          <a:p>
+            <a:endParaRPr lang="es-EC" sz="1350">
+              <a:solidFill>
+                <a:srgbClr val="1E293B"/>
+              </a:solidFill>
+              <a:latin typeface="Calibri" panose="020F0502020204030204" pitchFamily="34" charset="0"/>
+            </a:endParaRPr>
+          </a:p>
+          <a:p>
+            <a:r>
+              <a:rPr lang="es-EC" sz="1350">
+                <a:solidFill>
+                  <a:srgbClr val="1E293B"/>
+                </a:solidFill>
+                <a:latin typeface="Calibri" panose="020F0502020204030204" pitchFamily="34" charset="0"/>
+              </a:rPr>
+              <a:t>- Ventana Movil Predictiva:</a:t>
+            </a:r>
+          </a:p>
+          <a:p>
+            <a:r>
+              <a:rPr lang="es-EC" sz="1350">
+                <a:solidFill>
+                  <a:srgbClr val="1E293B"/>
+                </a:solidFill>
+                <a:latin typeface="Calibri" panose="020F0502020204030204" pitchFamily="34" charset="0"/>
+              </a:rPr>
+              <a:t>  Compara 30 dias recientes vs 90 dias base para detectar anomalias tempranas de consumo.</a:t>
+            </a:r>
+          </a:p>
+          <a:p>
+            <a:endParaRPr lang="es-EC" sz="1350">
+              <a:solidFill>
+                <a:srgbClr val="1E293B"/>
+              </a:solidFill>
+              <a:latin typeface="Calibri" panose="020F0502020204030204" pitchFamily="34" charset="0"/>
+            </a:endParaRPr>
+          </a:p>
+          <a:p>
+            <a:r>
+              <a:rPr lang="es-EC" sz="1350">
+                <a:solidFill>
+                  <a:srgbClr val="1E293B"/>
+                </a:solidFill>
+                <a:latin typeface="Calibri" panose="020F0502020204030204" pitchFamily="34" charset="0"/>
+              </a:rPr>
+              <a:t>- Semaforo Explicable por Sector:</a:t>
+            </a:r>
+          </a:p>
+          <a:p>
+            <a:r>
+              <a:rPr lang="es-EC" sz="1350">
+                <a:solidFill>
+                  <a:srgbClr val="1E293B"/>
+                </a:solidFill>
+                <a:latin typeface="Calibri" panose="020F0502020204030204" pitchFamily="34" charset="0"/>
+              </a:rPr>
+              <a:t>  * Amarillo: Alza observada (+50% demanda diaria).</a:t>
+            </a:r>
+          </a:p>
+          <a:p>
+            <a:r>
+              <a:rPr lang="es-EC" sz="1350">
+                <a:solidFill>
+                  <a:srgbClr val="1E293B"/>
+                </a:solidFill>
+                <a:latin typeface="Calibri" panose="020F0502020204030204" pitchFamily="34" charset="0"/>
+              </a:rPr>
+              <a:t>  * Rojo: Alza critica (+100% demanda diaria).</a:t>
+            </a:r>
+          </a:p>
+          <a:p>
+            <a:endParaRPr lang="es-EC" sz="1350">
+              <a:solidFill>
+                <a:srgbClr val="1E293B"/>
+              </a:solidFill>
+              <a:latin typeface="Calibri" panose="020F0502020204030204" pitchFamily="34" charset="0"/>
+            </a:endParaRPr>
+          </a:p>
+          <a:p>
+            <a:r>
+              <a:rPr lang="es-EC" sz="1350">
+                <a:solidFill>
+                  <a:srgbClr val="1E293B"/>
+                </a:solidFill>
+                <a:latin typeface="Calibri" panose="020F0502020204030204" pitchFamily="34" charset="0"/>
+              </a:rPr>
+              <a:t>- Balanceo Preventivo entre Sucursales:</a:t>
+            </a:r>
+          </a:p>
+          <a:p>
+            <a:r>
+              <a:rPr lang="es-EC" sz="1350">
+                <a:solidFill>
+                  <a:srgbClr val="1E293B"/>
+                </a:solidFill>
+                <a:latin typeface="Calibri" panose="020F0502020204030204" pitchFamily="34" charset="0"/>
+              </a:rPr>
+              <a:t>  Identifica excedentes en locales cercanos para sugerir traslados antes de que ocurra el quiebre.</a:t>
+            </a:r>
+          </a:p>
+        </p:txBody>
+      </p:sp>
+      <p:sp>
+        <p:nvSpPr>
+          <p:cNvPr id="11" name="Rectángulo 10">
+            <a:extLst>
+              <a:ext uri="{FF2B5EF4-FFF2-40B4-BE49-F238E27FC236}">
+                <a16:creationId xmlns:a16="http://schemas.microsoft.com/office/drawing/2014/main" id="{1F4E1B2A-3CA7-0F23-C967-BB681658D8E8}"/>
+              </a:ext>
+            </a:extLst>
+          </p:cNvPr>
+          <p:cNvSpPr/>
+          <p:nvPr/>
+        </p:nvSpPr>
+        <p:spPr>
+          <a:xfrm>
+            <a:off x="7366000" y="1524000"/>
+            <a:ext cx="4064000" cy="4445000"/>
+          </a:xfrm>
+          <a:prstGeom prst="rect">
+            <a:avLst/>
+          </a:prstGeom>
+          <a:solidFill>
+            <a:srgbClr val="0F2042"/>
+          </a:solidFill>
+          <a:ln w="19050" cap="flat" cmpd="sng" algn="ctr">
+            <a:noFill/>
+            <a:prstDash val="solid"/>
+            <a:miter lim="800000"/>
+          </a:ln>
+          <a:effectLst/>
+          <a:extLst>
+            <a:ext uri="{91240B29-F687-4F45-9708-019B960494DF}">
+              <a14:hiddenLine xmlns:a14="http://schemas.microsoft.com/office/drawing/2010/main" w="19050" cap="flat" cmpd="sng" algn="ctr">
+                <a:solidFill>
+                  <a:schemeClr val="accent1">
+                    <a:shade val="15000"/>
+                  </a:schemeClr>
+                </a:solidFill>
+                <a:prstDash val="solid"/>
+                <a:miter lim="800000"/>
+              </a14:hiddenLine>
+            </a:ext>
+          </a:extLst>
+        </p:spPr>
+        <p:style>
+          <a:lnRef idx="2">
+            <a:schemeClr val="accent1">
+              <a:shade val="15000"/>
+            </a:schemeClr>
+          </a:lnRef>
+          <a:fillRef idx="1">
+            <a:schemeClr val="accent1"/>
+          </a:fillRef>
+          <a:effectRef idx="0">
+            <a:schemeClr val="accent1"/>
+          </a:effectRef>
+          <a:fontRef idx="minor">
+            <a:schemeClr val="lt1"/>
+          </a:fontRef>
+        </p:style>
+        <p:txBody>
+          <a:bodyPr rtlCol="0" anchor="ctr"/>
+          <a:lstStyle/>
+          <a:p>
+            <a:pPr algn="ctr"/>
+            <a:endParaRPr lang="es-EC"/>
+          </a:p>
+        </p:txBody>
+      </p:sp>
+      <p:sp>
+        <p:nvSpPr>
+          <p:cNvPr id="12" name="CuadroTexto 11">
+            <a:extLst>
+              <a:ext uri="{FF2B5EF4-FFF2-40B4-BE49-F238E27FC236}">
+                <a16:creationId xmlns:a16="http://schemas.microsoft.com/office/drawing/2014/main" id="{452BD576-0CBB-A218-AB3C-02068DF4A583}"/>
+              </a:ext>
+            </a:extLst>
+          </p:cNvPr>
+          <p:cNvSpPr txBox="1"/>
+          <p:nvPr/>
+        </p:nvSpPr>
+        <p:spPr>
+          <a:xfrm>
+            <a:off x="7620000" y="1905000"/>
+            <a:ext cx="3556000" cy="2585323"/>
+          </a:xfrm>
+          <a:prstGeom prst="rect">
+            <a:avLst/>
+          </a:prstGeom>
+          <a:noFill/>
+        </p:spPr>
+        <p:txBody>
+          <a:bodyPr vert="horz" wrap="square" rtlCol="0">
+            <a:spAutoFit/>
+          </a:bodyPr>
+          <a:lstStyle/>
+          <a:p>
+            <a:r>
               <a:rPr lang="es-MX" sz="2200" b="1">
                 <a:solidFill>
                   <a:srgbClr val="0070BA"/>
@@ -5442,7 +5547,7 @@
             </a:r>
           </a:p>
           <a:p>
-            <a:endParaRPr lang="es-MX" sz="1500">
+            <a:endParaRPr lang="es-MX" sz="1400">
               <a:solidFill>
                 <a:srgbClr val="FFFFFF"/>
               </a:solidFill>
@@ -5451,7 +5556,7 @@
           </a:p>
           <a:p>
             <a:r>
-              <a:rPr lang="es-MX" sz="1500">
+              <a:rPr lang="es-MX" sz="1400">
                 <a:solidFill>
                   <a:srgbClr val="FFFFFF"/>
                 </a:solidFill>
@@ -5461,7 +5566,7 @@
             </a:r>
           </a:p>
           <a:p>
-            <a:endParaRPr lang="es-MX" sz="1500">
+            <a:endParaRPr lang="es-MX" sz="1400">
               <a:solidFill>
                 <a:srgbClr val="FFFFFF"/>
               </a:solidFill>
@@ -5470,18 +5575,18 @@
           </a:p>
           <a:p>
             <a:r>
-              <a:rPr lang="es-MX" sz="1500">
+              <a:rPr lang="es-MX" sz="1400">
                 <a:solidFill>
                   <a:srgbClr val="FFFFFF"/>
                 </a:solidFill>
                 <a:latin typeface="Calibri" panose="020F0502020204030204" pitchFamily="34" charset="0"/>
               </a:rPr>
-              <a:t>- Mapa interactivo Leaflet</a:t>
-            </a:r>
-          </a:p>
-          <a:p>
-            <a:r>
-              <a:rPr lang="es-MX" sz="1500">
+              <a:t>- Mapa interactivo Leaflet + CARTO</a:t>
+            </a:r>
+          </a:p>
+          <a:p>
+            <a:r>
+              <a:rPr lang="es-MX" sz="1400">
                 <a:solidFill>
                   <a:srgbClr val="FFFFFF"/>
                 </a:solidFill>
@@ -5492,7 +5597,18 @@
           </a:p>
           <a:p>
             <a:r>
-              <a:rPr lang="es-MX" sz="1500">
+              <a:rPr lang="es-MX" sz="1400">
+                <a:solidFill>
+                  <a:srgbClr val="FFFFFF"/>
+                </a:solidFill>
+                <a:latin typeface="Calibri" panose="020F0502020204030204" pitchFamily="34" charset="0"/>
+              </a:rPr>
+              <a:t>- Filtro en categorias sensibles (Cardio, Analgesicos, Respiratorios)</a:t>
+            </a:r>
+          </a:p>
+          <a:p>
+            <a:r>
+              <a:rPr lang="es-MX" sz="1400">
                 <a:solidFill>
                   <a:srgbClr val="FFFFFF"/>
                 </a:solidFill>
@@ -5503,26 +5619,15 @@
           </a:p>
           <a:p>
             <a:r>
-              <a:rPr lang="es-MX" sz="1500">
+              <a:rPr lang="es-MX" sz="1400">
                 <a:solidFill>
                   <a:srgbClr val="FFFFFF"/>
                 </a:solidFill>
                 <a:latin typeface="Calibri" panose="020F0502020204030204" pitchFamily="34" charset="0"/>
               </a:rPr>
-              <a:t>- API Python + React Vite</a:t>
-            </a:r>
-          </a:p>
-          <a:p>
-            <a:r>
-              <a:rPr lang="es-MX" sz="1500">
-                <a:solidFill>
-                  <a:srgbClr val="FFFFFF"/>
-                </a:solidFill>
-                <a:latin typeface="Calibri" panose="020F0502020204030204" pitchFamily="34" charset="0"/>
-              </a:rPr>
-              <a:t>- Listo para AWS Lambda y Vendix POS</a:t>
-            </a:r>
-            <a:endParaRPr lang="es-EC" sz="1500">
+              <a:t>- API Python lista para AWS Lambda y Vendix POS</a:t>
+            </a:r>
+            <a:endParaRPr lang="es-EC" sz="1400">
               <a:solidFill>
                 <a:srgbClr val="FFFFFF"/>
               </a:solidFill>
@@ -5534,7 +5639,7 @@
     </p:spTree>
     <p:extLst>
       <p:ext uri="{BB962C8B-B14F-4D97-AF65-F5344CB8AC3E}">
-        <p14:creationId xmlns:p14="http://schemas.microsoft.com/office/powerpoint/2010/main" val="4241332731"/>
+        <p14:creationId xmlns:p14="http://schemas.microsoft.com/office/powerpoint/2010/main" val="3758465133"/>
       </p:ext>
     </p:extLst>
   </p:cSld>
@@ -5566,7 +5671,7 @@
           <p:cNvPr id="2" name="Rectángulo 1">
             <a:extLst>
               <a:ext uri="{FF2B5EF4-FFF2-40B4-BE49-F238E27FC236}">
-                <a16:creationId xmlns:a16="http://schemas.microsoft.com/office/drawing/2014/main" id="{CF47162D-CC82-4A40-81AA-CC2D478C05DE}"/>
+                <a16:creationId xmlns:a16="http://schemas.microsoft.com/office/drawing/2014/main" id="{1B33BB2B-1A67-A177-280E-A103838C1F73}"/>
               </a:ext>
             </a:extLst>
           </p:cNvPr>
@@ -5621,7 +5726,7 @@
           <p:cNvPr id="3" name="Rectángulo 2">
             <a:extLst>
               <a:ext uri="{FF2B5EF4-FFF2-40B4-BE49-F238E27FC236}">
-                <a16:creationId xmlns:a16="http://schemas.microsoft.com/office/drawing/2014/main" id="{D30D972A-3986-8EF7-64C7-9FFA2AF60EEA}"/>
+                <a16:creationId xmlns:a16="http://schemas.microsoft.com/office/drawing/2014/main" id="{EDA2B893-760B-BB27-9D7C-0F8E8C47A1A6}"/>
               </a:ext>
             </a:extLst>
           </p:cNvPr>
@@ -5676,7 +5781,7 @@
           <p:cNvPr id="4" name="CuadroTexto 3">
             <a:extLst>
               <a:ext uri="{FF2B5EF4-FFF2-40B4-BE49-F238E27FC236}">
-                <a16:creationId xmlns:a16="http://schemas.microsoft.com/office/drawing/2014/main" id="{203CE488-EF21-042B-8714-770717C1D97A}"/>
+                <a16:creationId xmlns:a16="http://schemas.microsoft.com/office/drawing/2014/main" id="{5B344BF5-B61E-9C12-BC6A-FD37738750A1}"/>
               </a:ext>
             </a:extLst>
           </p:cNvPr>
@@ -5706,7 +5811,7 @@
                 </a:solidFill>
                 <a:latin typeface="Calibri" panose="020F0502020204030204" pitchFamily="34" charset="0"/>
               </a:rPr>
-              <a:t>Diferenciacion, Sinergia BYD e Impacto</a:t>
+              <a:t>Novedad, Diferenciacion e Impacto Operativo</a:t>
             </a:r>
             <a:endParaRPr lang="es-EC" sz="2600" b="1">
               <a:solidFill>
@@ -5722,7 +5827,7 @@
           <p:cNvPr id="5" name="CuadroTexto 4">
             <a:extLst>
               <a:ext uri="{FF2B5EF4-FFF2-40B4-BE49-F238E27FC236}">
-                <a16:creationId xmlns:a16="http://schemas.microsoft.com/office/drawing/2014/main" id="{20FEE8EA-B7F9-348C-42FF-15552B249609}"/>
+                <a16:creationId xmlns:a16="http://schemas.microsoft.com/office/drawing/2014/main" id="{19CAB6C8-69BB-172E-35E3-A30415AF06B8}"/>
               </a:ext>
             </a:extLst>
           </p:cNvPr>
@@ -5752,7 +5857,7 @@
                 </a:solidFill>
                 <a:latin typeface="Calibri" panose="020F0502020204030204" pitchFamily="34" charset="0"/>
               </a:rPr>
-              <a:t>Logistica electrica de proximidad y retorno de inversion medible</a:t>
+              <a:t>Eficiencia logistica de proximidad y retorno de inversion medible</a:t>
             </a:r>
             <a:endParaRPr lang="es-EC" sz="1300">
               <a:solidFill>
@@ -5768,7 +5873,7 @@
           <p:cNvPr id="6" name="CuadroTexto 5">
             <a:extLst>
               <a:ext uri="{FF2B5EF4-FFF2-40B4-BE49-F238E27FC236}">
-                <a16:creationId xmlns:a16="http://schemas.microsoft.com/office/drawing/2014/main" id="{4D9E9B34-5A3B-A49C-9FAB-2492E06B09F7}"/>
+                <a16:creationId xmlns:a16="http://schemas.microsoft.com/office/drawing/2014/main" id="{9862A837-A02E-D356-D0F9-A10829828E66}"/>
               </a:ext>
             </a:extLst>
           </p:cNvPr>
@@ -5798,7 +5903,7 @@
                 </a:solidFill>
                 <a:latin typeface="Calibri" panose="020F0502020204030204" pitchFamily="34" charset="0"/>
               </a:rPr>
-              <a:t>FarmaSenal | Reto Farmaenlace y BYD - Equipo Los 21 Pilotos</a:t>
+              <a:t>FarmaSenal | Reto Farmaenlace: Linea Mejora Operativa - Equipo Los 21 Pilotos</a:t>
             </a:r>
             <a:endParaRPr lang="es-EC" sz="1000">
               <a:solidFill>
@@ -5814,7 +5919,7 @@
           <p:cNvPr id="7" name="Rectángulo 6">
             <a:extLst>
               <a:ext uri="{FF2B5EF4-FFF2-40B4-BE49-F238E27FC236}">
-                <a16:creationId xmlns:a16="http://schemas.microsoft.com/office/drawing/2014/main" id="{511FF2C4-B64B-F3D3-41CB-E6B7D2FE54BE}"/>
+                <a16:creationId xmlns:a16="http://schemas.microsoft.com/office/drawing/2014/main" id="{2332235A-3F5A-1040-035E-DBD5137DA1C0}"/>
               </a:ext>
             </a:extLst>
           </p:cNvPr>
@@ -5868,7 +5973,7 @@
           <p:cNvPr id="8" name="CuadroTexto 7">
             <a:extLst>
               <a:ext uri="{FF2B5EF4-FFF2-40B4-BE49-F238E27FC236}">
-                <a16:creationId xmlns:a16="http://schemas.microsoft.com/office/drawing/2014/main" id="{70977A77-5F4A-6548-6FE4-B4D911CEFE45}"/>
+                <a16:creationId xmlns:a16="http://schemas.microsoft.com/office/drawing/2014/main" id="{1687A8E0-BEBB-6E7C-C57B-00FA8E7C737C}"/>
               </a:ext>
             </a:extLst>
           </p:cNvPr>
@@ -5878,7 +5983,7 @@
         <p:spPr>
           <a:xfrm>
             <a:off x="1016000" y="1714500"/>
-            <a:ext cx="5207000" cy="2585323"/>
+            <a:ext cx="5207000" cy="3000821"/>
           </a:xfrm>
           <a:prstGeom prst="rect">
             <a:avLst/>
@@ -5898,7 +6003,7 @@
                 </a:solidFill>
                 <a:latin typeface="Calibri" panose="020F0502020204030204" pitchFamily="34" charset="0"/>
               </a:rPr>
-              <a:t>Novedad frente a Power BI/Qlik:</a:t>
+              <a:t>Diferenciacion vs BI Tradicional (Power BI / Qlik):</a:t>
             </a:r>
           </a:p>
           <a:p>
@@ -5909,7 +6014,7 @@
                 </a:solidFill>
                 <a:latin typeface="Calibri" panose="020F0502020204030204" pitchFamily="34" charset="0"/>
               </a:rPr>
-              <a:t>- No es un reporte forense mensual del pasado.</a:t>
+              <a:t>- No es un reporte forense mensual o semanal del pasado.</a:t>
             </a:r>
           </a:p>
           <a:p>
@@ -5920,7 +6025,7 @@
                 </a:solidFill>
                 <a:latin typeface="Calibri" panose="020F0502020204030204" pitchFamily="34" charset="0"/>
               </a:rPr>
-              <a:t>- Es un motor OPERATIVO en tiempo real que previene quiebres hoy.</a:t>
+              <a:t>- Es un motor OPERATIVO en tiempo real que previene quiebres hoy y activa decisiones en primera linea.</a:t>
             </a:r>
           </a:p>
           <a:p>
@@ -5939,7 +6044,7 @@
                 </a:solidFill>
                 <a:latin typeface="Calibri" panose="020F0502020204030204" pitchFamily="34" charset="0"/>
               </a:rPr>
-              <a:t>Sinergia Verde con BYD:</a:t>
+              <a:t>Interconexion de Sucursales en Red:</a:t>
             </a:r>
           </a:p>
           <a:p>
@@ -5950,29 +6055,7 @@
                 </a:solidFill>
                 <a:latin typeface="Calibri" panose="020F0502020204030204" pitchFamily="34" charset="0"/>
               </a:rPr>
-              <a:t>- Traslados de proximidad entre farmacias con vehiculos electricos BYD.</a:t>
-            </a:r>
-          </a:p>
-          <a:p>
-            <a:r>
-              <a:rPr lang="es-MX" sz="1350">
-                <a:solidFill>
-                  <a:srgbClr val="1E293B"/>
-                </a:solidFill>
-                <a:latin typeface="Calibri" panose="020F0502020204030204" pitchFamily="34" charset="0"/>
-              </a:rPr>
-              <a:t>- Integracion con la red de +150 puntos de carga.</a:t>
-            </a:r>
-          </a:p>
-          <a:p>
-            <a:r>
-              <a:rPr lang="es-MX" sz="1350">
-                <a:solidFill>
-                  <a:srgbClr val="1E293B"/>
-                </a:solidFill>
-                <a:latin typeface="Calibri" panose="020F0502020204030204" pitchFamily="34" charset="0"/>
-              </a:rPr>
-              <a:t>- Menor costo por kilometro y cero emisiones.</a:t>
+              <a:t>- Convierte locales aislados en una red colaborativa que equilibra stock por proximidad.</a:t>
             </a:r>
           </a:p>
           <a:p>
@@ -5991,7 +6074,7 @@
                 </a:solidFill>
                 <a:latin typeface="Calibri" panose="020F0502020204030204" pitchFamily="34" charset="0"/>
               </a:rPr>
-              <a:t>Impacto Medible:</a:t>
+              <a:t>Impacto Operativo Cuantificable:</a:t>
             </a:r>
           </a:p>
           <a:p>
@@ -6002,7 +6085,29 @@
                 </a:solidFill>
                 <a:latin typeface="Calibri" panose="020F0502020204030204" pitchFamily="34" charset="0"/>
               </a:rPr>
-              <a:t>- Ecuacion de ahorro: Reduccion de ventas perdidas + Ahorro en mermas por vencimiento + Eficiencia en fletes.</a:t>
+              <a:t>- Ecuacion de Ahorro: </a:t>
+            </a:r>
+          </a:p>
+          <a:p>
+            <a:r>
+              <a:rPr lang="es-MX" sz="1350">
+                <a:solidFill>
+                  <a:srgbClr val="1E293B"/>
+                </a:solidFill>
+                <a:latin typeface="Calibri" panose="020F0502020204030204" pitchFamily="34" charset="0"/>
+              </a:rPr>
+              <a:t>  (Ventas Perdidas x Margen) + (Mermas por Caducidad x Costo) + Fletes Urgentes</a:t>
+            </a:r>
+          </a:p>
+          <a:p>
+            <a:r>
+              <a:rPr lang="es-MX" sz="1350">
+                <a:solidFill>
+                  <a:srgbClr val="1E293B"/>
+                </a:solidFill>
+                <a:latin typeface="Calibri" panose="020F0502020204030204" pitchFamily="34" charset="0"/>
+              </a:rPr>
+              <a:t>- Proteccion directa del LTV del paciente cronico.</a:t>
             </a:r>
             <a:endParaRPr lang="es-EC" sz="1350">
               <a:solidFill>
@@ -6018,7 +6123,7 @@
           <p:cNvPr id="10" name="Imagen 9">
             <a:extLst>
               <a:ext uri="{FF2B5EF4-FFF2-40B4-BE49-F238E27FC236}">
-                <a16:creationId xmlns:a16="http://schemas.microsoft.com/office/drawing/2014/main" id="{58B61973-43EC-C0BE-0D8C-9750A1DF34C9}"/>
+                <a16:creationId xmlns:a16="http://schemas.microsoft.com/office/drawing/2014/main" id="{0FAAE524-DFE0-A1EB-E17A-C684E24B3DC7}"/>
               </a:ext>
             </a:extLst>
           </p:cNvPr>
@@ -6054,7 +6159,7 @@
           <p:cNvPr id="11" name="Rectángulo 10">
             <a:extLst>
               <a:ext uri="{FF2B5EF4-FFF2-40B4-BE49-F238E27FC236}">
-                <a16:creationId xmlns:a16="http://schemas.microsoft.com/office/drawing/2014/main" id="{AF95DF19-E9B1-99D2-C3C1-A275FB03A6C4}"/>
+                <a16:creationId xmlns:a16="http://schemas.microsoft.com/office/drawing/2014/main" id="{ED8F95D2-6D98-4D8F-C5A0-252BF7274D4F}"/>
               </a:ext>
             </a:extLst>
           </p:cNvPr>
@@ -6118,7 +6223,7 @@
           <p:cNvPr id="12" name="Rectángulo 11">
             <a:extLst>
               <a:ext uri="{FF2B5EF4-FFF2-40B4-BE49-F238E27FC236}">
-                <a16:creationId xmlns:a16="http://schemas.microsoft.com/office/drawing/2014/main" id="{FE441F6D-CB23-0029-7895-6148601EAD6D}"/>
+                <a16:creationId xmlns:a16="http://schemas.microsoft.com/office/drawing/2014/main" id="{70A79FA5-01E8-14CF-BE93-53552AD3775A}"/>
               </a:ext>
             </a:extLst>
           </p:cNvPr>
@@ -6186,7 +6291,7 @@
           <p:cNvPr id="13" name="CuadroTexto 12">
             <a:extLst>
               <a:ext uri="{FF2B5EF4-FFF2-40B4-BE49-F238E27FC236}">
-                <a16:creationId xmlns:a16="http://schemas.microsoft.com/office/drawing/2014/main" id="{2CFE2CEE-2147-BA8A-7A7E-723B0A0B7C47}"/>
+                <a16:creationId xmlns:a16="http://schemas.microsoft.com/office/drawing/2014/main" id="{6501750C-1201-DEE4-6C30-4BAA5BFAF35B}"/>
               </a:ext>
             </a:extLst>
           </p:cNvPr>
@@ -6216,7 +6321,7 @@
                 </a:solidFill>
                 <a:latin typeface="Calibri" panose="020F0502020204030204" pitchFamily="34" charset="0"/>
               </a:rPr>
-              <a:t>Movilidad Limpia para la Red de Salud</a:t>
+              <a:t>Red Inteligente de Distribucion Farmaceutica</a:t>
             </a:r>
           </a:p>
           <a:p>
@@ -6227,7 +6332,7 @@
                 </a:solidFill>
                 <a:latin typeface="Calibri" panose="020F0502020204030204" pitchFamily="34" charset="0"/>
               </a:rPr>
-              <a:t>Conexion operativa entre Farmacias y Flota BYD</a:t>
+              <a:t>Conexion de inventarios locales para cero quiebres</a:t>
             </a:r>
             <a:endParaRPr lang="es-EC" sz="1200">
               <a:solidFill>
@@ -6241,7 +6346,7 @@
     </p:spTree>
     <p:extLst>
       <p:ext uri="{BB962C8B-B14F-4D97-AF65-F5344CB8AC3E}">
-        <p14:creationId xmlns:p14="http://schemas.microsoft.com/office/powerpoint/2010/main" val="458353967"/>
+        <p14:creationId xmlns:p14="http://schemas.microsoft.com/office/powerpoint/2010/main" val="483173894"/>
       </p:ext>
     </p:extLst>
   </p:cSld>
@@ -6273,7 +6378,7 @@
           <p:cNvPr id="2" name="Rectángulo 1">
             <a:extLst>
               <a:ext uri="{FF2B5EF4-FFF2-40B4-BE49-F238E27FC236}">
-                <a16:creationId xmlns:a16="http://schemas.microsoft.com/office/drawing/2014/main" id="{639DB0EB-7061-436D-2112-B7E78B47DA9F}"/>
+                <a16:creationId xmlns:a16="http://schemas.microsoft.com/office/drawing/2014/main" id="{9D0B6163-AC2E-0CEA-DB22-0B5495D94FAC}"/>
               </a:ext>
             </a:extLst>
           </p:cNvPr>
@@ -6328,7 +6433,7 @@
           <p:cNvPr id="3" name="CuadroTexto 2">
             <a:extLst>
               <a:ext uri="{FF2B5EF4-FFF2-40B4-BE49-F238E27FC236}">
-                <a16:creationId xmlns:a16="http://schemas.microsoft.com/office/drawing/2014/main" id="{07682D6A-122A-38D6-9B31-6B861F18046C}"/>
+                <a16:creationId xmlns:a16="http://schemas.microsoft.com/office/drawing/2014/main" id="{071A7CE7-9582-537E-34F4-A9BCAF52C602}"/>
               </a:ext>
             </a:extLst>
           </p:cNvPr>
@@ -6374,7 +6479,7 @@
           <p:cNvPr id="4" name="CuadroTexto 3">
             <a:extLst>
               <a:ext uri="{FF2B5EF4-FFF2-40B4-BE49-F238E27FC236}">
-                <a16:creationId xmlns:a16="http://schemas.microsoft.com/office/drawing/2014/main" id="{EE63CDAC-55DE-21C1-92B8-C2666AA80A98}"/>
+                <a16:creationId xmlns:a16="http://schemas.microsoft.com/office/drawing/2014/main" id="{C64B6102-E6B5-B4CF-51EA-08A89DA7F250}"/>
               </a:ext>
             </a:extLst>
           </p:cNvPr>
@@ -6404,7 +6509,7 @@
                 </a:solidFill>
                 <a:latin typeface="Calibri" panose="020F0502020204030204" pitchFamily="34" charset="0"/>
               </a:rPr>
-              <a:t>FarmaSenal: Inteligencia Geoespacial para Farmaenlace y BYD</a:t>
+              <a:t>FarmaSenal: Mejora Operativa para Farmaenlace</a:t>
             </a:r>
           </a:p>
           <a:p>
@@ -6437,7 +6542,7 @@
     </p:spTree>
     <p:extLst>
       <p:ext uri="{BB962C8B-B14F-4D97-AF65-F5344CB8AC3E}">
-        <p14:creationId xmlns:p14="http://schemas.microsoft.com/office/powerpoint/2010/main" val="558561524"/>
+        <p14:creationId xmlns:p14="http://schemas.microsoft.com/office/powerpoint/2010/main" val="3905929582"/>
       </p:ext>
     </p:extLst>
   </p:cSld>

</xml_diff>

<commit_message>
Actualización de la presentacion
</commit_message>
<xml_diff>
--- a/docs/FarmaSenal_Pitch_Presentacion.pptx
+++ b/docs/FarmaSenal_Pitch_Presentacion.pptx
@@ -5,8 +5,8 @@
     <p:sldMasterId id="2147483648" r:id="rId1"/>
   </p:sldMasterIdLst>
   <p:sldIdLst>
-    <p:sldId id="256" r:id="rId2"/>
-    <p:sldId id="257" r:id="rId3"/>
+    <p:sldId id="257" r:id="rId2"/>
+    <p:sldId id="256" r:id="rId3"/>
     <p:sldId id="258" r:id="rId4"/>
     <p:sldId id="259" r:id="rId5"/>
     <p:sldId id="260" r:id="rId6"/>
@@ -109,6 +109,11 @@
       </a:defRPr>
     </a:lvl9pPr>
   </p:defaultTextStyle>
+  <p:extLst>
+    <p:ext uri="{EFAFB233-063F-42B5-8137-9DF3F51BA10A}">
+      <p15:sldGuideLst xmlns:p15="http://schemas.microsoft.com/office/powerpoint/2012/main"/>
+    </p:ext>
+  </p:extLst>
 </p:presentation>
 </file>
 
@@ -3352,7 +3357,7 @@
           <p:cNvPr id="2" name="Rectángulo 1">
             <a:extLst>
               <a:ext uri="{FF2B5EF4-FFF2-40B4-BE49-F238E27FC236}">
-                <a16:creationId xmlns:a16="http://schemas.microsoft.com/office/drawing/2014/main" id="{7526D181-044A-E827-11B2-F57F517DEFA1}"/>
+                <a16:creationId xmlns:a16="http://schemas.microsoft.com/office/drawing/2014/main" id="{23EBCB0A-4263-4D7C-3618-EDF03FD389A8}"/>
               </a:ext>
             </a:extLst>
           </p:cNvPr>
@@ -3368,7 +3373,7 @@
             <a:avLst/>
           </a:prstGeom>
           <a:solidFill>
-            <a:srgbClr val="0F2042"/>
+            <a:srgbClr val="F8FAFC"/>
           </a:solidFill>
           <a:ln w="19050" cap="flat" cmpd="sng" algn="ctr">
             <a:noFill/>
@@ -3398,7 +3403,7 @@
           <a:lstStyle/>
           <a:p>
             <a:pPr algn="ctr"/>
-            <a:endParaRPr lang="es-EC"/>
+            <a:endParaRPr lang="es-EC" dirty="0"/>
           </a:p>
         </p:txBody>
       </p:sp>
@@ -3407,7 +3412,7 @@
           <p:cNvPr id="3" name="Rectángulo 2">
             <a:extLst>
               <a:ext uri="{FF2B5EF4-FFF2-40B4-BE49-F238E27FC236}">
-                <a16:creationId xmlns:a16="http://schemas.microsoft.com/office/drawing/2014/main" id="{28A94069-985B-7E40-C080-6267D007012C}"/>
+                <a16:creationId xmlns:a16="http://schemas.microsoft.com/office/drawing/2014/main" id="{B1674EDB-AAFC-2E93-1C7B-DF8BF99DAEE4}"/>
               </a:ext>
             </a:extLst>
           </p:cNvPr>
@@ -3416,8 +3421,8 @@
         </p:nvSpPr>
         <p:spPr>
           <a:xfrm>
-            <a:off x="889000" y="1778000"/>
-            <a:ext cx="76200" cy="2159000"/>
+            <a:off x="0" y="0"/>
+            <a:ext cx="12192000" cy="101600"/>
           </a:xfrm>
           <a:prstGeom prst="rect">
             <a:avLst/>
@@ -3453,7 +3458,7 @@
           <a:lstStyle/>
           <a:p>
             <a:pPr algn="ctr"/>
-            <a:endParaRPr lang="es-EC"/>
+            <a:endParaRPr lang="es-EC" dirty="0"/>
           </a:p>
         </p:txBody>
       </p:sp>
@@ -3462,7 +3467,7 @@
           <p:cNvPr id="4" name="CuadroTexto 3">
             <a:extLst>
               <a:ext uri="{FF2B5EF4-FFF2-40B4-BE49-F238E27FC236}">
-                <a16:creationId xmlns:a16="http://schemas.microsoft.com/office/drawing/2014/main" id="{31F771DA-7567-8488-BC04-8E8A7F3FB59E}"/>
+                <a16:creationId xmlns:a16="http://schemas.microsoft.com/office/drawing/2014/main" id="{268DF4EA-3B42-FECE-366E-130B97CDA67D}"/>
               </a:ext>
             </a:extLst>
           </p:cNvPr>
@@ -3471,8 +3476,8 @@
         </p:nvSpPr>
         <p:spPr>
           <a:xfrm>
-            <a:off x="1143000" y="1651000"/>
-            <a:ext cx="10160000" cy="892552"/>
+            <a:off x="762000" y="381000"/>
+            <a:ext cx="10668000" cy="646331"/>
           </a:xfrm>
           <a:prstGeom prst="rect">
             <a:avLst/>
@@ -3480,19 +3485,37 @@
           <a:noFill/>
         </p:spPr>
         <p:txBody>
-          <a:bodyPr vert="horz" rtlCol="0">
+          <a:bodyPr vert="horz" wrap="square" rtlCol="0">
             <a:spAutoFit/>
           </a:bodyPr>
           <a:lstStyle/>
           <a:p>
             <a:r>
-              <a:rPr lang="es-EC" sz="5200" b="1">
-                <a:solidFill>
-                  <a:srgbClr val="FFFFFF"/>
-                </a:solidFill>
-                <a:latin typeface="Calibri" panose="020F0502020204030204" pitchFamily="34" charset="0"/>
-              </a:rPr>
-              <a:t>FarmaSenal</a:t>
+              <a:rPr lang="es-EC" sz="3600" b="1" dirty="0">
+                <a:solidFill>
+                  <a:srgbClr val="0F2042"/>
+                </a:solidFill>
+                <a:latin typeface="Calibri" panose="020F0502020204030204" pitchFamily="34" charset="0"/>
+              </a:rPr>
+              <a:t>Imaginemos a Don </a:t>
+            </a:r>
+            <a:r>
+              <a:rPr lang="es-EC" sz="3600" b="1" dirty="0" err="1">
+                <a:solidFill>
+                  <a:srgbClr val="0F2042"/>
+                </a:solidFill>
+                <a:latin typeface="Calibri" panose="020F0502020204030204" pitchFamily="34" charset="0"/>
+              </a:rPr>
+              <a:t>Jose</a:t>
+            </a:r>
+            <a:r>
+              <a:rPr lang="es-EC" sz="3600" b="1" dirty="0">
+                <a:solidFill>
+                  <a:srgbClr val="0F2042"/>
+                </a:solidFill>
+                <a:latin typeface="Calibri" panose="020F0502020204030204" pitchFamily="34" charset="0"/>
+              </a:rPr>
+              <a:t>...</a:t>
             </a:r>
           </a:p>
         </p:txBody>
@@ -3502,7 +3525,7 @@
           <p:cNvPr id="5" name="CuadroTexto 4">
             <a:extLst>
               <a:ext uri="{FF2B5EF4-FFF2-40B4-BE49-F238E27FC236}">
-                <a16:creationId xmlns:a16="http://schemas.microsoft.com/office/drawing/2014/main" id="{E0B21D2D-51CB-AA41-B949-61DA83EC6A39}"/>
+                <a16:creationId xmlns:a16="http://schemas.microsoft.com/office/drawing/2014/main" id="{453F91AB-8B84-3188-056D-8B09C0FAC0B7}"/>
               </a:ext>
             </a:extLst>
           </p:cNvPr>
@@ -3511,8 +3534,8 @@
         </p:nvSpPr>
         <p:spPr>
           <a:xfrm>
-            <a:off x="1206500" y="2794000"/>
-            <a:ext cx="10160000" cy="400110"/>
+            <a:off x="762000" y="952500"/>
+            <a:ext cx="10668000" cy="338554"/>
           </a:xfrm>
           <a:prstGeom prst="rect">
             <a:avLst/>
@@ -3526,17 +3549,17 @@
           <a:lstStyle/>
           <a:p>
             <a:r>
-              <a:rPr lang="es-MX" sz="2000">
-                <a:solidFill>
-                  <a:srgbClr val="0070BA"/>
-                </a:solidFill>
-                <a:latin typeface="Calibri" panose="020F0502020204030204" pitchFamily="34" charset="0"/>
-              </a:rPr>
-              <a:t>Inteligencia Geoespacial para la Cadena de Salud y Abastecimiento</a:t>
-            </a:r>
-            <a:endParaRPr lang="es-EC" sz="2000">
+              <a:rPr lang="es-MX" sz="1600">
+                <a:solidFill>
+                  <a:srgbClr val="64748B"/>
+                </a:solidFill>
+                <a:latin typeface="Calibri" panose="020F0502020204030204" pitchFamily="34" charset="0"/>
+              </a:rPr>
+              <a:t>La realidad humana detras de la percha vacia y el costo de la fuga de clientes</a:t>
+            </a:r>
+            <a:endParaRPr lang="es-EC" sz="1600">
               <a:solidFill>
-                <a:srgbClr val="0070BA"/>
+                <a:srgbClr val="64748B"/>
               </a:solidFill>
               <a:latin typeface="Calibri" panose="020F0502020204030204" pitchFamily="34" charset="0"/>
             </a:endParaRPr>
@@ -3548,7 +3571,7 @@
           <p:cNvPr id="6" name="CuadroTexto 5">
             <a:extLst>
               <a:ext uri="{FF2B5EF4-FFF2-40B4-BE49-F238E27FC236}">
-                <a16:creationId xmlns:a16="http://schemas.microsoft.com/office/drawing/2014/main" id="{708B3534-C43D-4E3E-9AC4-620633D0E3CF}"/>
+                <a16:creationId xmlns:a16="http://schemas.microsoft.com/office/drawing/2014/main" id="{79BA7106-EC60-8F7E-1B97-AF034796A9C5}"/>
               </a:ext>
             </a:extLst>
           </p:cNvPr>
@@ -3557,8 +3580,8 @@
         </p:nvSpPr>
         <p:spPr>
           <a:xfrm>
-            <a:off x="1206500" y="4064000"/>
-            <a:ext cx="10160000" cy="523220"/>
+            <a:off x="762000" y="6413500"/>
+            <a:ext cx="10668000" cy="246221"/>
           </a:xfrm>
           <a:prstGeom prst="rect">
             <a:avLst/>
@@ -3572,38 +3595,454 @@
           <a:lstStyle/>
           <a:p>
             <a:r>
-              <a:rPr lang="es-MX" sz="1400">
-                <a:solidFill>
-                  <a:srgbClr val="FFFFFF"/>
-                </a:solidFill>
-                <a:latin typeface="Calibri" panose="020F0502020204030204" pitchFamily="34" charset="0"/>
-              </a:rPr>
-              <a:t>Hackathon ConnectatVentures 2026</a:t>
-            </a:r>
-          </a:p>
-          <a:p>
-            <a:r>
-              <a:rPr lang="es-MX" sz="1400">
-                <a:solidFill>
-                  <a:srgbClr val="FFFFFF"/>
-                </a:solidFill>
-                <a:latin typeface="Calibri" panose="020F0502020204030204" pitchFamily="34" charset="0"/>
-              </a:rPr>
-              <a:t>Reto: Farmaenlace - Linea: Mejora Operativa  |  Equipo: Los 21 Pilotos</a:t>
-            </a:r>
-            <a:endParaRPr lang="es-EC" sz="1400">
+              <a:rPr lang="es-MX" sz="1000">
+                <a:solidFill>
+                  <a:srgbClr val="64748B"/>
+                </a:solidFill>
+                <a:latin typeface="Calibri" panose="020F0502020204030204" pitchFamily="34" charset="0"/>
+              </a:rPr>
+              <a:t>FarmaSenal | Reto Farmaenlace: Linea Mejora Operativa - Equipo Los 21 Pilotos</a:t>
+            </a:r>
+            <a:endParaRPr lang="es-EC" sz="1000">
               <a:solidFill>
-                <a:srgbClr val="FFFFFF"/>
+                <a:srgbClr val="64748B"/>
               </a:solidFill>
               <a:latin typeface="Calibri" panose="020F0502020204030204" pitchFamily="34" charset="0"/>
             </a:endParaRPr>
           </a:p>
         </p:txBody>
       </p:sp>
+      <p:pic>
+        <p:nvPicPr>
+          <p:cNvPr id="8" name="Imagen 7">
+            <a:extLst>
+              <a:ext uri="{FF2B5EF4-FFF2-40B4-BE49-F238E27FC236}">
+                <a16:creationId xmlns:a16="http://schemas.microsoft.com/office/drawing/2014/main" id="{070E6857-3344-9A04-9AAA-128DBD6B1767}"/>
+              </a:ext>
+            </a:extLst>
+          </p:cNvPr>
+          <p:cNvPicPr>
+            <a:picLocks/>
+          </p:cNvPicPr>
+          <p:nvPr/>
+        </p:nvPicPr>
+        <p:blipFill>
+          <a:blip r:embed="rId2">
+            <a:extLst>
+              <a:ext uri="{28A0092B-C50C-407E-A947-70E740481C1C}">
+                <a14:useLocalDpi xmlns:a14="http://schemas.microsoft.com/office/drawing/2010/main" val="0"/>
+              </a:ext>
+            </a:extLst>
+          </a:blip>
+          <a:stretch>
+            <a:fillRect/>
+          </a:stretch>
+        </p:blipFill>
+        <p:spPr>
+          <a:xfrm>
+            <a:off x="762000" y="1524000"/>
+            <a:ext cx="4572000" cy="3429000"/>
+          </a:xfrm>
+          <a:prstGeom prst="rect">
+            <a:avLst/>
+          </a:prstGeom>
+        </p:spPr>
+      </p:pic>
+      <p:sp>
+        <p:nvSpPr>
+          <p:cNvPr id="9" name="Rectángulo 8">
+            <a:extLst>
+              <a:ext uri="{FF2B5EF4-FFF2-40B4-BE49-F238E27FC236}">
+                <a16:creationId xmlns:a16="http://schemas.microsoft.com/office/drawing/2014/main" id="{A46AF4BF-5F76-3664-3E4A-EC65CE7E68F6}"/>
+              </a:ext>
+            </a:extLst>
+          </p:cNvPr>
+          <p:cNvSpPr/>
+          <p:nvPr/>
+        </p:nvSpPr>
+        <p:spPr>
+          <a:xfrm>
+            <a:off x="762000" y="1524000"/>
+            <a:ext cx="4572000" cy="3429000"/>
+          </a:xfrm>
+          <a:prstGeom prst="rect">
+            <a:avLst/>
+          </a:prstGeom>
+          <a:noFill/>
+          <a:ln w="25400" cap="flat" cmpd="sng" algn="ctr">
+            <a:solidFill>
+              <a:srgbClr val="0070BA"/>
+            </a:solidFill>
+            <a:prstDash val="solid"/>
+            <a:miter lim="800000"/>
+          </a:ln>
+          <a:effectLst/>
+          <a:extLst>
+            <a:ext uri="{909E8E84-426E-40DD-AFC4-6F175D3DCCD1}">
+              <a14:hiddenFill xmlns:a14="http://schemas.microsoft.com/office/drawing/2010/main">
+                <a:solidFill>
+                  <a:schemeClr val="accent1"/>
+                </a:solidFill>
+              </a14:hiddenFill>
+            </a:ext>
+          </a:extLst>
+        </p:spPr>
+        <p:style>
+          <a:lnRef idx="2">
+            <a:schemeClr val="accent1">
+              <a:shade val="15000"/>
+            </a:schemeClr>
+          </a:lnRef>
+          <a:fillRef idx="1">
+            <a:schemeClr val="accent1"/>
+          </a:fillRef>
+          <a:effectRef idx="0">
+            <a:schemeClr val="accent1"/>
+          </a:effectRef>
+          <a:fontRef idx="minor">
+            <a:schemeClr val="lt1"/>
+          </a:fontRef>
+        </p:style>
+        <p:txBody>
+          <a:bodyPr rtlCol="0" anchor="ctr"/>
+          <a:lstStyle/>
+          <a:p>
+            <a:pPr algn="ctr"/>
+            <a:endParaRPr lang="es-EC"/>
+          </a:p>
+        </p:txBody>
+      </p:sp>
+      <p:sp>
+        <p:nvSpPr>
+          <p:cNvPr id="10" name="Rectángulo 9">
+            <a:extLst>
+              <a:ext uri="{FF2B5EF4-FFF2-40B4-BE49-F238E27FC236}">
+                <a16:creationId xmlns:a16="http://schemas.microsoft.com/office/drawing/2014/main" id="{0949E502-80B3-DE4E-A4EA-E80555DB87EA}"/>
+              </a:ext>
+            </a:extLst>
+          </p:cNvPr>
+          <p:cNvSpPr/>
+          <p:nvPr/>
+        </p:nvSpPr>
+        <p:spPr>
+          <a:xfrm>
+            <a:off x="5715000" y="1524000"/>
+            <a:ext cx="5715000" cy="4445000"/>
+          </a:xfrm>
+          <a:prstGeom prst="rect">
+            <a:avLst/>
+          </a:prstGeom>
+          <a:solidFill>
+            <a:srgbClr val="FFFFFF"/>
+          </a:solidFill>
+          <a:ln w="19050">
+            <a:solidFill>
+              <a:srgbClr val="E2E8F0"/>
+            </a:solidFill>
+          </a:ln>
+        </p:spPr>
+        <p:style>
+          <a:lnRef idx="2">
+            <a:schemeClr val="accent1">
+              <a:shade val="15000"/>
+            </a:schemeClr>
+          </a:lnRef>
+          <a:fillRef idx="1">
+            <a:schemeClr val="accent1"/>
+          </a:fillRef>
+          <a:effectRef idx="0">
+            <a:schemeClr val="accent1"/>
+          </a:effectRef>
+          <a:fontRef idx="minor">
+            <a:schemeClr val="lt1"/>
+          </a:fontRef>
+        </p:style>
+        <p:txBody>
+          <a:bodyPr rtlCol="0" anchor="ctr"/>
+          <a:lstStyle/>
+          <a:p>
+            <a:pPr algn="ctr"/>
+            <a:endParaRPr lang="es-EC"/>
+          </a:p>
+        </p:txBody>
+      </p:sp>
+      <p:sp>
+        <p:nvSpPr>
+          <p:cNvPr id="11" name="CuadroTexto 10">
+            <a:extLst>
+              <a:ext uri="{FF2B5EF4-FFF2-40B4-BE49-F238E27FC236}">
+                <a16:creationId xmlns:a16="http://schemas.microsoft.com/office/drawing/2014/main" id="{32AFA6B6-7475-D463-4ABC-9349C0ACE130}"/>
+              </a:ext>
+            </a:extLst>
+          </p:cNvPr>
+          <p:cNvSpPr txBox="1"/>
+          <p:nvPr/>
+        </p:nvSpPr>
+        <p:spPr>
+          <a:xfrm>
+            <a:off x="5969000" y="1714500"/>
+            <a:ext cx="5207000" cy="3785652"/>
+          </a:xfrm>
+          <a:prstGeom prst="rect">
+            <a:avLst/>
+          </a:prstGeom>
+          <a:noFill/>
+        </p:spPr>
+        <p:txBody>
+          <a:bodyPr vert="horz" wrap="square" rtlCol="0">
+            <a:spAutoFit/>
+          </a:bodyPr>
+          <a:lstStyle/>
+          <a:p>
+            <a:r>
+              <a:rPr lang="es-MX" sz="1600" dirty="0">
+                <a:solidFill>
+                  <a:srgbClr val="1E293B"/>
+                </a:solidFill>
+                <a:latin typeface="Calibri" panose="020F0502020204030204" pitchFamily="34" charset="0"/>
+              </a:rPr>
+              <a:t>Pensemos en alguien querido:</a:t>
+            </a:r>
+          </a:p>
+          <a:p>
+            <a:endParaRPr lang="es-MX" sz="1600" dirty="0">
+              <a:solidFill>
+                <a:srgbClr val="1E293B"/>
+              </a:solidFill>
+              <a:latin typeface="Calibri" panose="020F0502020204030204" pitchFamily="34" charset="0"/>
+            </a:endParaRPr>
+          </a:p>
+          <a:p>
+            <a:r>
+              <a:rPr lang="es-MX" sz="1600" dirty="0">
+                <a:solidFill>
+                  <a:srgbClr val="1E293B"/>
+                </a:solidFill>
+                <a:latin typeface="Calibri" panose="020F0502020204030204" pitchFamily="34" charset="0"/>
+              </a:rPr>
+              <a:t>- Camina a su farmacia de confianza por sus medicinas diarias de la </a:t>
+            </a:r>
+            <a:r>
+              <a:rPr lang="es-MX" sz="1600" dirty="0" err="1">
+                <a:solidFill>
+                  <a:srgbClr val="1E293B"/>
+                </a:solidFill>
+                <a:latin typeface="Calibri" panose="020F0502020204030204" pitchFamily="34" charset="0"/>
+              </a:rPr>
+              <a:t>presion</a:t>
+            </a:r>
+            <a:r>
+              <a:rPr lang="es-MX" sz="1600" dirty="0">
+                <a:solidFill>
+                  <a:srgbClr val="1E293B"/>
+                </a:solidFill>
+                <a:latin typeface="Calibri" panose="020F0502020204030204" pitchFamily="34" charset="0"/>
+              </a:rPr>
+              <a:t> o dolor (</a:t>
+            </a:r>
+            <a:r>
+              <a:rPr lang="es-MX" sz="1600" dirty="0" err="1">
+                <a:solidFill>
+                  <a:srgbClr val="1E293B"/>
+                </a:solidFill>
+                <a:latin typeface="Calibri" panose="020F0502020204030204" pitchFamily="34" charset="0"/>
+              </a:rPr>
+              <a:t>Losartan</a:t>
+            </a:r>
+            <a:r>
+              <a:rPr lang="es-MX" sz="1600" dirty="0">
+                <a:solidFill>
+                  <a:srgbClr val="1E293B"/>
+                </a:solidFill>
+                <a:latin typeface="Calibri" panose="020F0502020204030204" pitchFamily="34" charset="0"/>
+              </a:rPr>
+              <a:t>, Paracetamol).</a:t>
+            </a:r>
+          </a:p>
+          <a:p>
+            <a:r>
+              <a:rPr lang="es-MX" sz="1600" dirty="0">
+                <a:solidFill>
+                  <a:srgbClr val="1E293B"/>
+                </a:solidFill>
+                <a:latin typeface="Calibri" panose="020F0502020204030204" pitchFamily="34" charset="0"/>
+              </a:rPr>
+              <a:t>- La respuesta en mostrador: 'Se termino, nos llega la </a:t>
+            </a:r>
+            <a:r>
+              <a:rPr lang="es-MX" sz="1600" dirty="0" err="1">
+                <a:solidFill>
+                  <a:srgbClr val="1E293B"/>
+                </a:solidFill>
+                <a:latin typeface="Calibri" panose="020F0502020204030204" pitchFamily="34" charset="0"/>
+              </a:rPr>
+              <a:t>proxima</a:t>
+            </a:r>
+            <a:r>
+              <a:rPr lang="es-MX" sz="1600" dirty="0">
+                <a:solidFill>
+                  <a:srgbClr val="1E293B"/>
+                </a:solidFill>
+                <a:latin typeface="Calibri" panose="020F0502020204030204" pitchFamily="34" charset="0"/>
+              </a:rPr>
+              <a:t> semana'.</a:t>
+            </a:r>
+          </a:p>
+          <a:p>
+            <a:endParaRPr lang="es-MX" sz="1600" dirty="0">
+              <a:solidFill>
+                <a:srgbClr val="1E293B"/>
+              </a:solidFill>
+              <a:latin typeface="Calibri" panose="020F0502020204030204" pitchFamily="34" charset="0"/>
+            </a:endParaRPr>
+          </a:p>
+          <a:p>
+            <a:r>
+              <a:rPr lang="es-MX" sz="1600" dirty="0">
+                <a:solidFill>
+                  <a:srgbClr val="1E293B"/>
+                </a:solidFill>
+                <a:latin typeface="Calibri" panose="020F0502020204030204" pitchFamily="34" charset="0"/>
+              </a:rPr>
+              <a:t>La Brecha Digital Real:</a:t>
+            </a:r>
+          </a:p>
+          <a:p>
+            <a:r>
+              <a:rPr lang="es-MX" sz="1600" dirty="0">
+                <a:solidFill>
+                  <a:srgbClr val="1E293B"/>
+                </a:solidFill>
+                <a:latin typeface="Calibri" panose="020F0502020204030204" pitchFamily="34" charset="0"/>
+              </a:rPr>
+              <a:t>- El adulto mayor no usa apps ni e-</a:t>
+            </a:r>
+            <a:r>
+              <a:rPr lang="es-MX" sz="1600" dirty="0" err="1">
+                <a:solidFill>
+                  <a:srgbClr val="1E293B"/>
+                </a:solidFill>
+                <a:latin typeface="Calibri" panose="020F0502020204030204" pitchFamily="34" charset="0"/>
+              </a:rPr>
+              <a:t>commerce</a:t>
+            </a:r>
+            <a:r>
+              <a:rPr lang="es-MX" sz="1600" dirty="0">
+                <a:solidFill>
+                  <a:srgbClr val="1E293B"/>
+                </a:solidFill>
+                <a:latin typeface="Calibri" panose="020F0502020204030204" pitchFamily="34" charset="0"/>
+              </a:rPr>
+              <a:t>; el 98% compra en el canal </a:t>
+            </a:r>
+            <a:r>
+              <a:rPr lang="es-MX" sz="1600" dirty="0" err="1">
+                <a:solidFill>
+                  <a:srgbClr val="1E293B"/>
+                </a:solidFill>
+                <a:latin typeface="Calibri" panose="020F0502020204030204" pitchFamily="34" charset="0"/>
+              </a:rPr>
+              <a:t>fisico</a:t>
+            </a:r>
+            <a:r>
+              <a:rPr lang="es-MX" sz="1600" dirty="0">
+                <a:solidFill>
+                  <a:srgbClr val="1E293B"/>
+                </a:solidFill>
+                <a:latin typeface="Calibri" panose="020F0502020204030204" pitchFamily="34" charset="0"/>
+              </a:rPr>
+              <a:t> presencial.</a:t>
+            </a:r>
+          </a:p>
+          <a:p>
+            <a:endParaRPr lang="es-MX" sz="1600" dirty="0">
+              <a:solidFill>
+                <a:srgbClr val="1E293B"/>
+              </a:solidFill>
+              <a:latin typeface="Calibri" panose="020F0502020204030204" pitchFamily="34" charset="0"/>
+            </a:endParaRPr>
+          </a:p>
+          <a:p>
+            <a:r>
+              <a:rPr lang="es-MX" sz="1600" dirty="0">
+                <a:solidFill>
+                  <a:srgbClr val="1E293B"/>
+                </a:solidFill>
+                <a:latin typeface="Calibri" panose="020F0502020204030204" pitchFamily="34" charset="0"/>
+              </a:rPr>
+              <a:t>El Costo para </a:t>
+            </a:r>
+            <a:r>
+              <a:rPr lang="es-MX" sz="1600" dirty="0" err="1">
+                <a:solidFill>
+                  <a:srgbClr val="1E293B"/>
+                </a:solidFill>
+                <a:latin typeface="Calibri" panose="020F0502020204030204" pitchFamily="34" charset="0"/>
+              </a:rPr>
+              <a:t>Farmaenlace</a:t>
+            </a:r>
+            <a:r>
+              <a:rPr lang="es-MX" sz="1600" dirty="0">
+                <a:solidFill>
+                  <a:srgbClr val="1E293B"/>
+                </a:solidFill>
+                <a:latin typeface="Calibri" panose="020F0502020204030204" pitchFamily="34" charset="0"/>
+              </a:rPr>
+              <a:t>:</a:t>
+            </a:r>
+          </a:p>
+          <a:p>
+            <a:r>
+              <a:rPr lang="es-MX" sz="1600" dirty="0">
+                <a:solidFill>
+                  <a:srgbClr val="1E293B"/>
+                </a:solidFill>
+                <a:latin typeface="Calibri" panose="020F0502020204030204" pitchFamily="34" charset="0"/>
+              </a:rPr>
+              <a:t>- &gt; 50% de clientes compra una sola vez (fuga a la competencia).</a:t>
+            </a:r>
+          </a:p>
+          <a:p>
+            <a:r>
+              <a:rPr lang="es-MX" sz="1600" dirty="0">
+                <a:solidFill>
+                  <a:srgbClr val="1E293B"/>
+                </a:solidFill>
+                <a:latin typeface="Calibri" panose="020F0502020204030204" pitchFamily="34" charset="0"/>
+              </a:rPr>
+              <a:t>- Se destruye el Valor de Vida (LTV) del paciente </a:t>
+            </a:r>
+            <a:r>
+              <a:rPr lang="es-MX" sz="1600" dirty="0" err="1">
+                <a:solidFill>
+                  <a:srgbClr val="1E293B"/>
+                </a:solidFill>
+                <a:latin typeface="Calibri" panose="020F0502020204030204" pitchFamily="34" charset="0"/>
+              </a:rPr>
+              <a:t>cronico</a:t>
+            </a:r>
+            <a:r>
+              <a:rPr lang="es-MX" sz="1600" dirty="0">
+                <a:solidFill>
+                  <a:srgbClr val="1E293B"/>
+                </a:solidFill>
+                <a:latin typeface="Calibri" panose="020F0502020204030204" pitchFamily="34" charset="0"/>
+              </a:rPr>
+              <a:t>.</a:t>
+            </a:r>
+            <a:endParaRPr lang="es-EC" sz="1600" dirty="0">
+              <a:solidFill>
+                <a:srgbClr val="1E293B"/>
+              </a:solidFill>
+              <a:latin typeface="Calibri" panose="020F0502020204030204" pitchFamily="34" charset="0"/>
+            </a:endParaRPr>
+          </a:p>
+        </p:txBody>
+      </p:sp>
     </p:spTree>
     <p:extLst>
       <p:ext uri="{BB962C8B-B14F-4D97-AF65-F5344CB8AC3E}">
-        <p14:creationId xmlns:p14="http://schemas.microsoft.com/office/powerpoint/2010/main" val="438993333"/>
+        <p14:creationId xmlns:p14="http://schemas.microsoft.com/office/powerpoint/2010/main" val="211041013"/>
       </p:ext>
     </p:extLst>
   </p:cSld>
@@ -3635,7 +4074,7 @@
           <p:cNvPr id="2" name="Rectángulo 1">
             <a:extLst>
               <a:ext uri="{FF2B5EF4-FFF2-40B4-BE49-F238E27FC236}">
-                <a16:creationId xmlns:a16="http://schemas.microsoft.com/office/drawing/2014/main" id="{23EBCB0A-4263-4D7C-3618-EDF03FD389A8}"/>
+                <a16:creationId xmlns:a16="http://schemas.microsoft.com/office/drawing/2014/main" id="{7526D181-044A-E827-11B2-F57F517DEFA1}"/>
               </a:ext>
             </a:extLst>
           </p:cNvPr>
@@ -3651,7 +4090,7 @@
             <a:avLst/>
           </a:prstGeom>
           <a:solidFill>
-            <a:srgbClr val="F8FAFC"/>
+            <a:srgbClr val="0F2042"/>
           </a:solidFill>
           <a:ln w="19050" cap="flat" cmpd="sng" algn="ctr">
             <a:noFill/>
@@ -3690,7 +4129,7 @@
           <p:cNvPr id="3" name="Rectángulo 2">
             <a:extLst>
               <a:ext uri="{FF2B5EF4-FFF2-40B4-BE49-F238E27FC236}">
-                <a16:creationId xmlns:a16="http://schemas.microsoft.com/office/drawing/2014/main" id="{B1674EDB-AAFC-2E93-1C7B-DF8BF99DAEE4}"/>
+                <a16:creationId xmlns:a16="http://schemas.microsoft.com/office/drawing/2014/main" id="{28A94069-985B-7E40-C080-6267D007012C}"/>
               </a:ext>
             </a:extLst>
           </p:cNvPr>
@@ -3699,8 +4138,8 @@
         </p:nvSpPr>
         <p:spPr>
           <a:xfrm>
-            <a:off x="0" y="0"/>
-            <a:ext cx="12192000" cy="101600"/>
+            <a:off x="889000" y="1778000"/>
+            <a:ext cx="76200" cy="2159000"/>
           </a:xfrm>
           <a:prstGeom prst="rect">
             <a:avLst/>
@@ -3745,7 +4184,7 @@
           <p:cNvPr id="4" name="CuadroTexto 3">
             <a:extLst>
               <a:ext uri="{FF2B5EF4-FFF2-40B4-BE49-F238E27FC236}">
-                <a16:creationId xmlns:a16="http://schemas.microsoft.com/office/drawing/2014/main" id="{268DF4EA-3B42-FECE-366E-130B97CDA67D}"/>
+                <a16:creationId xmlns:a16="http://schemas.microsoft.com/office/drawing/2014/main" id="{31F771DA-7567-8488-BC04-8E8A7F3FB59E}"/>
               </a:ext>
             </a:extLst>
           </p:cNvPr>
@@ -3754,8 +4193,8 @@
         </p:nvSpPr>
         <p:spPr>
           <a:xfrm>
-            <a:off x="762000" y="381000"/>
-            <a:ext cx="10668000" cy="492443"/>
+            <a:off x="1143000" y="1651000"/>
+            <a:ext cx="10160000" cy="1107996"/>
           </a:xfrm>
           <a:prstGeom prst="rect">
             <a:avLst/>
@@ -3763,20 +4202,26 @@
           <a:noFill/>
         </p:spPr>
         <p:txBody>
-          <a:bodyPr vert="horz" wrap="square" rtlCol="0">
+          <a:bodyPr vert="horz" rtlCol="0">
             <a:spAutoFit/>
           </a:bodyPr>
           <a:lstStyle/>
           <a:p>
             <a:r>
-              <a:rPr lang="es-EC" sz="2600" b="1">
-                <a:solidFill>
-                  <a:srgbClr val="0F2042"/>
-                </a:solidFill>
-                <a:latin typeface="Calibri" panose="020F0502020204030204" pitchFamily="34" charset="0"/>
-              </a:rPr>
-              <a:t>Imaginemos a Don Jose...</a:t>
-            </a:r>
+              <a:rPr lang="es-EC" sz="6600" b="1" dirty="0" err="1">
+                <a:solidFill>
+                  <a:srgbClr val="FFFFFF"/>
+                </a:solidFill>
+                <a:latin typeface="Calibri" panose="020F0502020204030204" pitchFamily="34" charset="0"/>
+              </a:rPr>
+              <a:t>FarmaSeñal</a:t>
+            </a:r>
+            <a:endParaRPr lang="es-EC" sz="6600" b="1" dirty="0">
+              <a:solidFill>
+                <a:srgbClr val="FFFFFF"/>
+              </a:solidFill>
+              <a:latin typeface="Calibri" panose="020F0502020204030204" pitchFamily="34" charset="0"/>
+            </a:endParaRPr>
           </a:p>
         </p:txBody>
       </p:sp>
@@ -3785,7 +4230,7 @@
           <p:cNvPr id="5" name="CuadroTexto 4">
             <a:extLst>
               <a:ext uri="{FF2B5EF4-FFF2-40B4-BE49-F238E27FC236}">
-                <a16:creationId xmlns:a16="http://schemas.microsoft.com/office/drawing/2014/main" id="{453F91AB-8B84-3188-056D-8B09C0FAC0B7}"/>
+                <a16:creationId xmlns:a16="http://schemas.microsoft.com/office/drawing/2014/main" id="{E0B21D2D-51CB-AA41-B949-61DA83EC6A39}"/>
               </a:ext>
             </a:extLst>
           </p:cNvPr>
@@ -3794,8 +4239,8 @@
         </p:nvSpPr>
         <p:spPr>
           <a:xfrm>
-            <a:off x="762000" y="952500"/>
-            <a:ext cx="10668000" cy="292388"/>
+            <a:off x="1206500" y="2794000"/>
+            <a:ext cx="10160000" cy="1077218"/>
           </a:xfrm>
           <a:prstGeom prst="rect">
             <a:avLst/>
@@ -3809,17 +4254,17 @@
           <a:lstStyle/>
           <a:p>
             <a:r>
-              <a:rPr lang="es-MX" sz="1300">
-                <a:solidFill>
-                  <a:srgbClr val="64748B"/>
-                </a:solidFill>
-                <a:latin typeface="Calibri" panose="020F0502020204030204" pitchFamily="34" charset="0"/>
-              </a:rPr>
-              <a:t>La realidad humana detras de la percha vacia y el costo de la fuga de clientes</a:t>
-            </a:r>
-            <a:endParaRPr lang="es-EC" sz="1300">
+              <a:rPr lang="es-MX" sz="3200" dirty="0">
+                <a:solidFill>
+                  <a:srgbClr val="0070BA"/>
+                </a:solidFill>
+                <a:latin typeface="Calibri" panose="020F0502020204030204" pitchFamily="34" charset="0"/>
+              </a:rPr>
+              <a:t>Inteligencia Geoespacial para la Cadena de Salud y Abastecimiento</a:t>
+            </a:r>
+            <a:endParaRPr lang="es-EC" sz="3200" dirty="0">
               <a:solidFill>
-                <a:srgbClr val="64748B"/>
+                <a:srgbClr val="0070BA"/>
               </a:solidFill>
               <a:latin typeface="Calibri" panose="020F0502020204030204" pitchFamily="34" charset="0"/>
             </a:endParaRPr>
@@ -3831,7 +4276,7 @@
           <p:cNvPr id="6" name="CuadroTexto 5">
             <a:extLst>
               <a:ext uri="{FF2B5EF4-FFF2-40B4-BE49-F238E27FC236}">
-                <a16:creationId xmlns:a16="http://schemas.microsoft.com/office/drawing/2014/main" id="{79BA7106-EC60-8F7E-1B97-AF034796A9C5}"/>
+                <a16:creationId xmlns:a16="http://schemas.microsoft.com/office/drawing/2014/main" id="{708B3534-C43D-4E3E-9AC4-620633D0E3CF}"/>
               </a:ext>
             </a:extLst>
           </p:cNvPr>
@@ -3840,8 +4285,8 @@
         </p:nvSpPr>
         <p:spPr>
           <a:xfrm>
-            <a:off x="762000" y="6413500"/>
-            <a:ext cx="10668000" cy="246221"/>
+            <a:off x="1206500" y="4064000"/>
+            <a:ext cx="10160000" cy="646331"/>
           </a:xfrm>
           <a:prstGeom prst="rect">
             <a:avLst/>
@@ -3855,328 +4300,74 @@
           <a:lstStyle/>
           <a:p>
             <a:r>
-              <a:rPr lang="es-MX" sz="1000">
-                <a:solidFill>
-                  <a:srgbClr val="64748B"/>
-                </a:solidFill>
-                <a:latin typeface="Calibri" panose="020F0502020204030204" pitchFamily="34" charset="0"/>
-              </a:rPr>
-              <a:t>FarmaSenal | Reto Farmaenlace: Linea Mejora Operativa - Equipo Los 21 Pilotos</a:t>
-            </a:r>
-            <a:endParaRPr lang="es-EC" sz="1000">
+              <a:rPr lang="es-MX" dirty="0">
+                <a:solidFill>
+                  <a:srgbClr val="FFFFFF"/>
+                </a:solidFill>
+                <a:latin typeface="Calibri" panose="020F0502020204030204" pitchFamily="34" charset="0"/>
+              </a:rPr>
+              <a:t>Hackathon </a:t>
+            </a:r>
+            <a:r>
+              <a:rPr lang="es-MX" dirty="0" err="1">
+                <a:solidFill>
+                  <a:srgbClr val="FFFFFF"/>
+                </a:solidFill>
+                <a:latin typeface="Calibri" panose="020F0502020204030204" pitchFamily="34" charset="0"/>
+              </a:rPr>
+              <a:t>ConnectatVentures</a:t>
+            </a:r>
+            <a:r>
+              <a:rPr lang="es-MX" dirty="0">
+                <a:solidFill>
+                  <a:srgbClr val="FFFFFF"/>
+                </a:solidFill>
+                <a:latin typeface="Calibri" panose="020F0502020204030204" pitchFamily="34" charset="0"/>
+              </a:rPr>
+              <a:t> 2026</a:t>
+            </a:r>
+          </a:p>
+          <a:p>
+            <a:r>
+              <a:rPr lang="es-MX" dirty="0">
+                <a:solidFill>
+                  <a:srgbClr val="FFFFFF"/>
+                </a:solidFill>
+                <a:latin typeface="Calibri" panose="020F0502020204030204" pitchFamily="34" charset="0"/>
+              </a:rPr>
+              <a:t>Reto: </a:t>
+            </a:r>
+            <a:r>
+              <a:rPr lang="es-MX" dirty="0" err="1">
+                <a:solidFill>
+                  <a:srgbClr val="FFFFFF"/>
+                </a:solidFill>
+                <a:latin typeface="Calibri" panose="020F0502020204030204" pitchFamily="34" charset="0"/>
+              </a:rPr>
+              <a:t>Farmaenlace</a:t>
+            </a:r>
+            <a:r>
+              <a:rPr lang="es-MX" dirty="0">
+                <a:solidFill>
+                  <a:srgbClr val="FFFFFF"/>
+                </a:solidFill>
+                <a:latin typeface="Calibri" panose="020F0502020204030204" pitchFamily="34" charset="0"/>
+              </a:rPr>
+              <a:t> - Línea: Mejora Operativa  |  Equipo: Los 21 Pilotos</a:t>
+            </a:r>
+            <a:endParaRPr lang="es-EC" dirty="0">
               <a:solidFill>
-                <a:srgbClr val="64748B"/>
+                <a:srgbClr val="FFFFFF"/>
               </a:solidFill>
               <a:latin typeface="Calibri" panose="020F0502020204030204" pitchFamily="34" charset="0"/>
             </a:endParaRPr>
           </a:p>
         </p:txBody>
       </p:sp>
-      <p:pic>
-        <p:nvPicPr>
-          <p:cNvPr id="8" name="Imagen 7">
-            <a:extLst>
-              <a:ext uri="{FF2B5EF4-FFF2-40B4-BE49-F238E27FC236}">
-                <a16:creationId xmlns:a16="http://schemas.microsoft.com/office/drawing/2014/main" id="{070E6857-3344-9A04-9AAA-128DBD6B1767}"/>
-              </a:ext>
-            </a:extLst>
-          </p:cNvPr>
-          <p:cNvPicPr>
-            <a:picLocks/>
-          </p:cNvPicPr>
-          <p:nvPr/>
-        </p:nvPicPr>
-        <p:blipFill>
-          <a:blip r:embed="rId2">
-            <a:extLst>
-              <a:ext uri="{28A0092B-C50C-407E-A947-70E740481C1C}">
-                <a14:useLocalDpi xmlns:a14="http://schemas.microsoft.com/office/drawing/2010/main" val="0"/>
-              </a:ext>
-            </a:extLst>
-          </a:blip>
-          <a:stretch>
-            <a:fillRect/>
-          </a:stretch>
-        </p:blipFill>
-        <p:spPr>
-          <a:xfrm>
-            <a:off x="762000" y="1524000"/>
-            <a:ext cx="4572000" cy="3429000"/>
-          </a:xfrm>
-          <a:prstGeom prst="rect">
-            <a:avLst/>
-          </a:prstGeom>
-        </p:spPr>
-      </p:pic>
-      <p:sp>
-        <p:nvSpPr>
-          <p:cNvPr id="9" name="Rectángulo 8">
-            <a:extLst>
-              <a:ext uri="{FF2B5EF4-FFF2-40B4-BE49-F238E27FC236}">
-                <a16:creationId xmlns:a16="http://schemas.microsoft.com/office/drawing/2014/main" id="{A46AF4BF-5F76-3664-3E4A-EC65CE7E68F6}"/>
-              </a:ext>
-            </a:extLst>
-          </p:cNvPr>
-          <p:cNvSpPr/>
-          <p:nvPr/>
-        </p:nvSpPr>
-        <p:spPr>
-          <a:xfrm>
-            <a:off x="762000" y="1524000"/>
-            <a:ext cx="4572000" cy="3429000"/>
-          </a:xfrm>
-          <a:prstGeom prst="rect">
-            <a:avLst/>
-          </a:prstGeom>
-          <a:noFill/>
-          <a:ln w="25400" cap="flat" cmpd="sng" algn="ctr">
-            <a:solidFill>
-              <a:srgbClr val="0070BA"/>
-            </a:solidFill>
-            <a:prstDash val="solid"/>
-            <a:miter lim="800000"/>
-          </a:ln>
-          <a:effectLst/>
-          <a:extLst>
-            <a:ext uri="{909E8E84-426E-40DD-AFC4-6F175D3DCCD1}">
-              <a14:hiddenFill xmlns:a14="http://schemas.microsoft.com/office/drawing/2010/main">
-                <a:solidFill>
-                  <a:schemeClr val="accent1"/>
-                </a:solidFill>
-              </a14:hiddenFill>
-            </a:ext>
-          </a:extLst>
-        </p:spPr>
-        <p:style>
-          <a:lnRef idx="2">
-            <a:schemeClr val="accent1">
-              <a:shade val="15000"/>
-            </a:schemeClr>
-          </a:lnRef>
-          <a:fillRef idx="1">
-            <a:schemeClr val="accent1"/>
-          </a:fillRef>
-          <a:effectRef idx="0">
-            <a:schemeClr val="accent1"/>
-          </a:effectRef>
-          <a:fontRef idx="minor">
-            <a:schemeClr val="lt1"/>
-          </a:fontRef>
-        </p:style>
-        <p:txBody>
-          <a:bodyPr rtlCol="0" anchor="ctr"/>
-          <a:lstStyle/>
-          <a:p>
-            <a:pPr algn="ctr"/>
-            <a:endParaRPr lang="es-EC"/>
-          </a:p>
-        </p:txBody>
-      </p:sp>
-      <p:sp>
-        <p:nvSpPr>
-          <p:cNvPr id="10" name="Rectángulo 9">
-            <a:extLst>
-              <a:ext uri="{FF2B5EF4-FFF2-40B4-BE49-F238E27FC236}">
-                <a16:creationId xmlns:a16="http://schemas.microsoft.com/office/drawing/2014/main" id="{0949E502-80B3-DE4E-A4EA-E80555DB87EA}"/>
-              </a:ext>
-            </a:extLst>
-          </p:cNvPr>
-          <p:cNvSpPr/>
-          <p:nvPr/>
-        </p:nvSpPr>
-        <p:spPr>
-          <a:xfrm>
-            <a:off x="5715000" y="1524000"/>
-            <a:ext cx="5715000" cy="4445000"/>
-          </a:xfrm>
-          <a:prstGeom prst="rect">
-            <a:avLst/>
-          </a:prstGeom>
-          <a:solidFill>
-            <a:srgbClr val="FFFFFF"/>
-          </a:solidFill>
-          <a:ln w="19050">
-            <a:solidFill>
-              <a:srgbClr val="E2E8F0"/>
-            </a:solidFill>
-          </a:ln>
-        </p:spPr>
-        <p:style>
-          <a:lnRef idx="2">
-            <a:schemeClr val="accent1">
-              <a:shade val="15000"/>
-            </a:schemeClr>
-          </a:lnRef>
-          <a:fillRef idx="1">
-            <a:schemeClr val="accent1"/>
-          </a:fillRef>
-          <a:effectRef idx="0">
-            <a:schemeClr val="accent1"/>
-          </a:effectRef>
-          <a:fontRef idx="minor">
-            <a:schemeClr val="lt1"/>
-          </a:fontRef>
-        </p:style>
-        <p:txBody>
-          <a:bodyPr rtlCol="0" anchor="ctr"/>
-          <a:lstStyle/>
-          <a:p>
-            <a:pPr algn="ctr"/>
-            <a:endParaRPr lang="es-EC"/>
-          </a:p>
-        </p:txBody>
-      </p:sp>
-      <p:sp>
-        <p:nvSpPr>
-          <p:cNvPr id="11" name="CuadroTexto 10">
-            <a:extLst>
-              <a:ext uri="{FF2B5EF4-FFF2-40B4-BE49-F238E27FC236}">
-                <a16:creationId xmlns:a16="http://schemas.microsoft.com/office/drawing/2014/main" id="{32AFA6B6-7475-D463-4ABC-9349C0ACE130}"/>
-              </a:ext>
-            </a:extLst>
-          </p:cNvPr>
-          <p:cNvSpPr txBox="1"/>
-          <p:nvPr/>
-        </p:nvSpPr>
-        <p:spPr>
-          <a:xfrm>
-            <a:off x="5969000" y="1714500"/>
-            <a:ext cx="5207000" cy="2793072"/>
-          </a:xfrm>
-          <a:prstGeom prst="rect">
-            <a:avLst/>
-          </a:prstGeom>
-          <a:noFill/>
-        </p:spPr>
-        <p:txBody>
-          <a:bodyPr vert="horz" wrap="square" rtlCol="0">
-            <a:spAutoFit/>
-          </a:bodyPr>
-          <a:lstStyle/>
-          <a:p>
-            <a:r>
-              <a:rPr lang="es-MX" sz="1350">
-                <a:solidFill>
-                  <a:srgbClr val="1E293B"/>
-                </a:solidFill>
-                <a:latin typeface="Calibri" panose="020F0502020204030204" pitchFamily="34" charset="0"/>
-              </a:rPr>
-              <a:t>Pensemos en alguien querido:</a:t>
-            </a:r>
-          </a:p>
-          <a:p>
-            <a:endParaRPr lang="es-MX" sz="1350">
-              <a:solidFill>
-                <a:srgbClr val="1E293B"/>
-              </a:solidFill>
-              <a:latin typeface="Calibri" panose="020F0502020204030204" pitchFamily="34" charset="0"/>
-            </a:endParaRPr>
-          </a:p>
-          <a:p>
-            <a:r>
-              <a:rPr lang="es-MX" sz="1350">
-                <a:solidFill>
-                  <a:srgbClr val="1E293B"/>
-                </a:solidFill>
-                <a:latin typeface="Calibri" panose="020F0502020204030204" pitchFamily="34" charset="0"/>
-              </a:rPr>
-              <a:t>- Camina a su farmacia de confianza por sus medicinas diarias de la presion o dolor (Losartan, Paracetamol).</a:t>
-            </a:r>
-          </a:p>
-          <a:p>
-            <a:r>
-              <a:rPr lang="es-MX" sz="1350">
-                <a:solidFill>
-                  <a:srgbClr val="1E293B"/>
-                </a:solidFill>
-                <a:latin typeface="Calibri" panose="020F0502020204030204" pitchFamily="34" charset="0"/>
-              </a:rPr>
-              <a:t>- La respuesta en mostrador: 'Se termino, nos llega la proxima semana'.</a:t>
-            </a:r>
-          </a:p>
-          <a:p>
-            <a:endParaRPr lang="es-MX" sz="1350">
-              <a:solidFill>
-                <a:srgbClr val="1E293B"/>
-              </a:solidFill>
-              <a:latin typeface="Calibri" panose="020F0502020204030204" pitchFamily="34" charset="0"/>
-            </a:endParaRPr>
-          </a:p>
-          <a:p>
-            <a:r>
-              <a:rPr lang="es-MX" sz="1350">
-                <a:solidFill>
-                  <a:srgbClr val="1E293B"/>
-                </a:solidFill>
-                <a:latin typeface="Calibri" panose="020F0502020204030204" pitchFamily="34" charset="0"/>
-              </a:rPr>
-              <a:t>La Brecha Digital Real:</a:t>
-            </a:r>
-          </a:p>
-          <a:p>
-            <a:r>
-              <a:rPr lang="es-MX" sz="1350">
-                <a:solidFill>
-                  <a:srgbClr val="1E293B"/>
-                </a:solidFill>
-                <a:latin typeface="Calibri" panose="020F0502020204030204" pitchFamily="34" charset="0"/>
-              </a:rPr>
-              <a:t>- El adulto mayor no usa apps ni e-commerce; el 98% compra en el canal fisico presencial.</a:t>
-            </a:r>
-          </a:p>
-          <a:p>
-            <a:endParaRPr lang="es-MX" sz="1350">
-              <a:solidFill>
-                <a:srgbClr val="1E293B"/>
-              </a:solidFill>
-              <a:latin typeface="Calibri" panose="020F0502020204030204" pitchFamily="34" charset="0"/>
-            </a:endParaRPr>
-          </a:p>
-          <a:p>
-            <a:r>
-              <a:rPr lang="es-MX" sz="1350">
-                <a:solidFill>
-                  <a:srgbClr val="1E293B"/>
-                </a:solidFill>
-                <a:latin typeface="Calibri" panose="020F0502020204030204" pitchFamily="34" charset="0"/>
-              </a:rPr>
-              <a:t>El Costo para Farmaenlace:</a:t>
-            </a:r>
-          </a:p>
-          <a:p>
-            <a:r>
-              <a:rPr lang="es-MX" sz="1350">
-                <a:solidFill>
-                  <a:srgbClr val="1E293B"/>
-                </a:solidFill>
-                <a:latin typeface="Calibri" panose="020F0502020204030204" pitchFamily="34" charset="0"/>
-              </a:rPr>
-              <a:t>- &gt; 50% de clientes compra una sola vez (fuga a la competencia).</a:t>
-            </a:r>
-          </a:p>
-          <a:p>
-            <a:r>
-              <a:rPr lang="es-MX" sz="1350">
-                <a:solidFill>
-                  <a:srgbClr val="1E293B"/>
-                </a:solidFill>
-                <a:latin typeface="Calibri" panose="020F0502020204030204" pitchFamily="34" charset="0"/>
-              </a:rPr>
-              <a:t>- Se destruye el Valor de Vida (LTV) del paciente cronico.</a:t>
-            </a:r>
-            <a:endParaRPr lang="es-EC" sz="1350">
-              <a:solidFill>
-                <a:srgbClr val="1E293B"/>
-              </a:solidFill>
-              <a:latin typeface="Calibri" panose="020F0502020204030204" pitchFamily="34" charset="0"/>
-            </a:endParaRPr>
-          </a:p>
-        </p:txBody>
-      </p:sp>
     </p:spTree>
     <p:extLst>
       <p:ext uri="{BB962C8B-B14F-4D97-AF65-F5344CB8AC3E}">
-        <p14:creationId xmlns:p14="http://schemas.microsoft.com/office/powerpoint/2010/main" val="211041013"/>
+        <p14:creationId xmlns:p14="http://schemas.microsoft.com/office/powerpoint/2010/main" val="438993333"/>
       </p:ext>
     </p:extLst>
   </p:cSld>
@@ -4254,7 +4445,7 @@
           <a:lstStyle/>
           <a:p>
             <a:pPr algn="ctr"/>
-            <a:endParaRPr lang="es-EC"/>
+            <a:endParaRPr lang="es-EC" dirty="0"/>
           </a:p>
         </p:txBody>
       </p:sp>
@@ -4309,7 +4500,7 @@
           <a:lstStyle/>
           <a:p>
             <a:pPr algn="ctr"/>
-            <a:endParaRPr lang="es-EC"/>
+            <a:endParaRPr lang="es-EC" dirty="0"/>
           </a:p>
         </p:txBody>
       </p:sp>
@@ -4328,7 +4519,7 @@
         <p:spPr>
           <a:xfrm>
             <a:off x="762000" y="381000"/>
-            <a:ext cx="10668000" cy="492443"/>
+            <a:ext cx="10668000" cy="584775"/>
           </a:xfrm>
           <a:prstGeom prst="rect">
             <a:avLst/>
@@ -4342,15 +4533,15 @@
           <a:lstStyle/>
           <a:p>
             <a:r>
-              <a:rPr lang="es-MX" sz="2600" b="1">
+              <a:rPr lang="es-MX" sz="3200" b="1" dirty="0">
                 <a:solidFill>
                   <a:srgbClr val="0F2042"/>
                 </a:solidFill>
                 <a:latin typeface="Calibri" panose="020F0502020204030204" pitchFamily="34" charset="0"/>
               </a:rPr>
-              <a:t>Por que ocurre? Fallas del Abastecimiento Tradicional</a:t>
-            </a:r>
-            <a:endParaRPr lang="es-EC" sz="2600" b="1">
+              <a:t>¿Por qué ocurre? Fallas del Abastecimiento Tradicional</a:t>
+            </a:r>
+            <a:endParaRPr lang="es-EC" sz="3200" b="1" dirty="0">
               <a:solidFill>
                 <a:srgbClr val="0F2042"/>
               </a:solidFill>
@@ -4374,7 +4565,7 @@
         <p:spPr>
           <a:xfrm>
             <a:off x="762000" y="952500"/>
-            <a:ext cx="10668000" cy="292388"/>
+            <a:ext cx="10668000" cy="338554"/>
           </a:xfrm>
           <a:prstGeom prst="rect">
             <a:avLst/>
@@ -4388,15 +4579,15 @@
           <a:lstStyle/>
           <a:p>
             <a:r>
-              <a:rPr lang="es-MX" sz="1300">
+              <a:rPr lang="es-MX" sz="1600" dirty="0">
                 <a:solidFill>
                   <a:srgbClr val="64748B"/>
                 </a:solidFill>
                 <a:latin typeface="Calibri" panose="020F0502020204030204" pitchFamily="34" charset="0"/>
               </a:rPr>
-              <a:t>El bache logistico de 24-48h y el aislamiento territorial entre farmacias</a:t>
-            </a:r>
-            <a:endParaRPr lang="es-EC" sz="1300">
+              <a:t>El bache logístico de 24-48h y el aislamiento territorial entre farmacias</a:t>
+            </a:r>
+            <a:endParaRPr lang="es-EC" sz="1600" dirty="0">
               <a:solidFill>
                 <a:srgbClr val="64748B"/>
               </a:solidFill>
@@ -4520,7 +4711,7 @@
         <p:spPr>
           <a:xfrm>
             <a:off x="952500" y="1841500"/>
-            <a:ext cx="2921000" cy="1661993"/>
+            <a:ext cx="2921000" cy="2677656"/>
           </a:xfrm>
           <a:prstGeom prst="rect">
             <a:avLst/>
@@ -4534,7 +4725,7 @@
           <a:lstStyle/>
           <a:p>
             <a:r>
-              <a:rPr lang="es-MX" b="1">
+              <a:rPr lang="es-MX" sz="2400" b="1" dirty="0">
                 <a:solidFill>
                   <a:srgbClr val="0F2042"/>
                 </a:solidFill>
@@ -4544,7 +4735,7 @@
             </a:r>
           </a:p>
           <a:p>
-            <a:endParaRPr lang="es-MX" sz="1400">
+            <a:endParaRPr lang="es-MX" dirty="0">
               <a:solidFill>
                 <a:srgbClr val="1E293B"/>
               </a:solidFill>
@@ -4553,17 +4744,17 @@
           </a:p>
           <a:p>
             <a:r>
-              <a:rPr lang="es-MX" sz="1400">
+              <a:rPr lang="es-MX" dirty="0">
                 <a:solidFill>
                   <a:srgbClr val="1E293B"/>
                 </a:solidFill>
                 <a:latin typeface="Calibri" panose="020F0502020204030204" pitchFamily="34" charset="0"/>
               </a:rPr>
-              <a:t>La reposicion se ordena tarde: solo cuando el estante ya esta vacio o cruzo minimos criticos.</a:t>
-            </a:r>
-          </a:p>
-          <a:p>
-            <a:endParaRPr lang="es-MX" sz="1400">
+              <a:t>La reposición se ordena tarde: solo cuando el estante ya esta vacío o cruzo mínimos críticos.</a:t>
+            </a:r>
+          </a:p>
+          <a:p>
+            <a:endParaRPr lang="es-MX" dirty="0">
               <a:solidFill>
                 <a:srgbClr val="1E293B"/>
               </a:solidFill>
@@ -4572,7 +4763,7 @@
           </a:p>
           <a:p>
             <a:r>
-              <a:rPr lang="es-MX" sz="1400">
+              <a:rPr lang="es-MX" dirty="0">
                 <a:solidFill>
                   <a:srgbClr val="1E293B"/>
                 </a:solidFill>
@@ -4580,7 +4771,7 @@
               </a:rPr>
               <a:t>No anticipa picos de consumo local.</a:t>
             </a:r>
-            <a:endParaRPr lang="es-EC" sz="1400">
+            <a:endParaRPr lang="es-EC" dirty="0">
               <a:solidFill>
                 <a:srgbClr val="1E293B"/>
               </a:solidFill>
@@ -4658,7 +4849,7 @@
         <p:spPr>
           <a:xfrm>
             <a:off x="4635500" y="1841500"/>
-            <a:ext cx="2921000" cy="1877437"/>
+            <a:ext cx="2921000" cy="2954655"/>
           </a:xfrm>
           <a:prstGeom prst="rect">
             <a:avLst/>
@@ -4672,17 +4863,17 @@
           <a:lstStyle/>
           <a:p>
             <a:r>
-              <a:rPr lang="es-MX" b="1">
+              <a:rPr lang="es-MX" sz="2400" b="1" dirty="0">
                 <a:solidFill>
                   <a:srgbClr val="E11D48"/>
                 </a:solidFill>
                 <a:latin typeface="Calibri" panose="020F0502020204030204" pitchFamily="34" charset="0"/>
               </a:rPr>
-              <a:t>2. Bache Logistico</a:t>
-            </a:r>
-          </a:p>
-          <a:p>
-            <a:endParaRPr lang="es-MX" sz="1400">
+              <a:t>2. Bache Logístico</a:t>
+            </a:r>
+          </a:p>
+          <a:p>
+            <a:endParaRPr lang="es-MX" dirty="0">
               <a:solidFill>
                 <a:srgbClr val="1E293B"/>
               </a:solidFill>
@@ -4691,7 +4882,7 @@
           </a:p>
           <a:p>
             <a:r>
-              <a:rPr lang="es-MX" sz="1400">
+              <a:rPr lang="es-MX" dirty="0">
                 <a:solidFill>
                   <a:srgbClr val="1E293B"/>
                 </a:solidFill>
@@ -4701,7 +4892,7 @@
             </a:r>
           </a:p>
           <a:p>
-            <a:endParaRPr lang="es-MX" sz="1400">
+            <a:endParaRPr lang="es-MX" dirty="0">
               <a:solidFill>
                 <a:srgbClr val="1E293B"/>
               </a:solidFill>
@@ -4710,15 +4901,15 @@
           </a:p>
           <a:p>
             <a:r>
-              <a:rPr lang="es-MX" sz="1400">
+              <a:rPr lang="es-MX" dirty="0">
                 <a:solidFill>
                   <a:srgbClr val="1E293B"/>
                 </a:solidFill>
                 <a:latin typeface="Calibri" panose="020F0502020204030204" pitchFamily="34" charset="0"/>
               </a:rPr>
-              <a:t>Ventana ciega con percha vacia.</a:t>
-            </a:r>
-            <a:endParaRPr lang="es-EC" sz="1400">
+              <a:t>Ventana ciega con percha vacía.</a:t>
+            </a:r>
+            <a:endParaRPr lang="es-EC" dirty="0">
               <a:solidFill>
                 <a:srgbClr val="1E293B"/>
               </a:solidFill>
@@ -4796,7 +4987,7 @@
         <p:spPr>
           <a:xfrm>
             <a:off x="8318500" y="1841500"/>
-            <a:ext cx="2921000" cy="1877437"/>
+            <a:ext cx="2921000" cy="2400657"/>
           </a:xfrm>
           <a:prstGeom prst="rect">
             <a:avLst/>
@@ -4810,7 +5001,7 @@
           <a:lstStyle/>
           <a:p>
             <a:r>
-              <a:rPr lang="es-MX" b="1">
+              <a:rPr lang="es-MX" sz="2400" b="1" dirty="0">
                 <a:solidFill>
                   <a:srgbClr val="0070BA"/>
                 </a:solidFill>
@@ -4820,7 +5011,7 @@
             </a:r>
           </a:p>
           <a:p>
-            <a:endParaRPr lang="es-MX" sz="1400">
+            <a:endParaRPr lang="es-MX" dirty="0">
               <a:solidFill>
                 <a:srgbClr val="1E293B"/>
               </a:solidFill>
@@ -4829,26 +5020,18 @@
           </a:p>
           <a:p>
             <a:r>
-              <a:rPr lang="es-MX" sz="1400">
+              <a:rPr lang="es-MX" dirty="0">
                 <a:solidFill>
                   <a:srgbClr val="1E293B"/>
                 </a:solidFill>
                 <a:latin typeface="Calibri" panose="020F0502020204030204" pitchFamily="34" charset="0"/>
               </a:rPr>
-              <a:t>Dos farmacias en el mismo sector (a 10 minutos de distancia) no se comunican operativamente.</a:t>
-            </a:r>
-          </a:p>
-          <a:p>
-            <a:endParaRPr lang="es-MX" sz="1400">
-              <a:solidFill>
-                <a:srgbClr val="1E293B"/>
-              </a:solidFill>
-              <a:latin typeface="Calibri" panose="020F0502020204030204" pitchFamily="34" charset="0"/>
-            </a:endParaRPr>
-          </a:p>
-          <a:p>
-            <a:r>
-              <a:rPr lang="es-MX" sz="1400">
+              <a:t>Dos farmacias en el mismo sector (a 10 minutos de distancia).</a:t>
+            </a:r>
+          </a:p>
+          <a:p>
+            <a:r>
+              <a:rPr lang="es-MX" dirty="0">
                 <a:solidFill>
                   <a:srgbClr val="1E293B"/>
                 </a:solidFill>
@@ -4856,7 +5039,7 @@
               </a:rPr>
               <a:t>Una sufre quiebre mientras la otra tiene excedentes en riesgo de vencer.</a:t>
             </a:r>
-            <a:endParaRPr lang="es-EC" sz="1400">
+            <a:endParaRPr lang="es-EC" dirty="0">
               <a:solidFill>
                 <a:srgbClr val="1E293B"/>
               </a:solidFill>
@@ -5020,7 +5203,7 @@
         <p:spPr>
           <a:xfrm>
             <a:off x="762000" y="381000"/>
-            <a:ext cx="10668000" cy="492443"/>
+            <a:ext cx="10668000" cy="584775"/>
           </a:xfrm>
           <a:prstGeom prst="rect">
             <a:avLst/>
@@ -5034,15 +5217,24 @@
           <a:lstStyle/>
           <a:p>
             <a:r>
-              <a:rPr lang="es-MX" sz="2600" b="1">
+              <a:rPr lang="es-MX" sz="3200" b="1" dirty="0" err="1">
                 <a:solidFill>
                   <a:srgbClr val="0F2042"/>
                 </a:solidFill>
                 <a:latin typeface="Calibri" panose="020F0502020204030204" pitchFamily="34" charset="0"/>
               </a:rPr>
-              <a:t>FarmaSenal: Inteligencia Geoespacial en Vivo</a:t>
-            </a:r>
-            <a:endParaRPr lang="es-EC" sz="2600" b="1">
+              <a:t>FarmaSeñal</a:t>
+            </a:r>
+            <a:r>
+              <a:rPr lang="es-MX" sz="3200" b="1" dirty="0">
+                <a:solidFill>
+                  <a:srgbClr val="0F2042"/>
+                </a:solidFill>
+                <a:latin typeface="Calibri" panose="020F0502020204030204" pitchFamily="34" charset="0"/>
+              </a:rPr>
+              <a:t>: Inteligencia Geoespacial en Vivo</a:t>
+            </a:r>
+            <a:endParaRPr lang="es-EC" sz="3200" b="1" dirty="0">
               <a:solidFill>
                 <a:srgbClr val="0F2042"/>
               </a:solidFill>
@@ -5066,7 +5258,7 @@
         <p:spPr>
           <a:xfrm>
             <a:off x="762000" y="952500"/>
-            <a:ext cx="10668000" cy="292388"/>
+            <a:ext cx="10668000" cy="338554"/>
           </a:xfrm>
           <a:prstGeom prst="rect">
             <a:avLst/>
@@ -5080,13 +5272,13 @@
           <a:lstStyle/>
           <a:p>
             <a:r>
-              <a:rPr lang="es-EC" sz="1300">
+              <a:rPr lang="es-EC" sz="1600" dirty="0">
                 <a:solidFill>
                   <a:srgbClr val="64748B"/>
                 </a:solidFill>
                 <a:latin typeface="Calibri" panose="020F0502020204030204" pitchFamily="34" charset="0"/>
               </a:rPr>
-              <a:t>Foco Estrategico: Linea 3 - Mejora Operativa de la Cadena de Suministro</a:t>
+              <a:t>Foco Estratégico: Línea 3 - Mejora Operativa de la Cadena de Suministro</a:t>
             </a:r>
           </a:p>
         </p:txBody>
@@ -5314,7 +5506,7 @@
         <p:spPr>
           <a:xfrm>
             <a:off x="1016000" y="2286000"/>
-            <a:ext cx="5842000" cy="2793072"/>
+            <a:ext cx="5842000" cy="3293209"/>
           </a:xfrm>
           <a:prstGeom prst="rect">
             <a:avLst/>
@@ -5328,17 +5520,17 @@
           <a:lstStyle/>
           <a:p>
             <a:r>
-              <a:rPr lang="es-EC" sz="1350">
+              <a:rPr lang="es-EC" sz="1600" dirty="0">
                 <a:solidFill>
                   <a:srgbClr val="1E293B"/>
                 </a:solidFill>
                 <a:latin typeface="Calibri" panose="020F0502020204030204" pitchFamily="34" charset="0"/>
               </a:rPr>
-              <a:t>Transformamos la reposicion de REACTIVA a PREDICTIVA:</a:t>
-            </a:r>
-          </a:p>
-          <a:p>
-            <a:endParaRPr lang="es-EC" sz="1350">
+              <a:t>Transformamos la reposición de REACTIVA a PREDICTIVA:</a:t>
+            </a:r>
+          </a:p>
+          <a:p>
+            <a:endParaRPr lang="es-EC" sz="1600" dirty="0">
               <a:solidFill>
                 <a:srgbClr val="1E293B"/>
               </a:solidFill>
@@ -5347,7 +5539,7 @@
           </a:p>
           <a:p>
             <a:r>
-              <a:rPr lang="es-EC" sz="1350">
+              <a:rPr lang="es-EC" sz="1600" dirty="0">
                 <a:solidFill>
                   <a:srgbClr val="1E293B"/>
                 </a:solidFill>
@@ -5358,17 +5550,17 @@
           </a:p>
           <a:p>
             <a:r>
-              <a:rPr lang="es-EC" sz="1350">
+              <a:rPr lang="es-EC" sz="1600" dirty="0">
                 <a:solidFill>
                   <a:srgbClr val="1E293B"/>
                 </a:solidFill>
                 <a:latin typeface="Calibri" panose="020F0502020204030204" pitchFamily="34" charset="0"/>
               </a:rPr>
-              <a:t>  Compara 30 dias recientes vs 90 dias base para detectar anomalias tempranas de consumo.</a:t>
-            </a:r>
-          </a:p>
-          <a:p>
-            <a:endParaRPr lang="es-EC" sz="1350">
+              <a:t>  Compara 30 días recientes vs 90 días base para detectar anomalías tempranas de consumo.</a:t>
+            </a:r>
+          </a:p>
+          <a:p>
+            <a:endParaRPr lang="es-EC" sz="1600" dirty="0">
               <a:solidFill>
                 <a:srgbClr val="1E293B"/>
               </a:solidFill>
@@ -5377,18 +5569,18 @@
           </a:p>
           <a:p>
             <a:r>
-              <a:rPr lang="es-EC" sz="1350">
+              <a:rPr lang="es-EC" sz="1600" dirty="0">
                 <a:solidFill>
                   <a:srgbClr val="1E293B"/>
                 </a:solidFill>
                 <a:latin typeface="Calibri" panose="020F0502020204030204" pitchFamily="34" charset="0"/>
               </a:rPr>
-              <a:t>- Semaforo Explicable por Sector:</a:t>
-            </a:r>
-          </a:p>
-          <a:p>
-            <a:r>
-              <a:rPr lang="es-EC" sz="1350">
+              <a:t>- Semáforo Explicable por Sector:</a:t>
+            </a:r>
+          </a:p>
+          <a:p>
+            <a:r>
+              <a:rPr lang="es-EC" sz="1600" dirty="0">
                 <a:solidFill>
                   <a:srgbClr val="1E293B"/>
                 </a:solidFill>
@@ -5399,7 +5591,7 @@
           </a:p>
           <a:p>
             <a:r>
-              <a:rPr lang="es-EC" sz="1350">
+              <a:rPr lang="es-EC" sz="1600" dirty="0">
                 <a:solidFill>
                   <a:srgbClr val="1E293B"/>
                 </a:solidFill>
@@ -5409,7 +5601,7 @@
             </a:r>
           </a:p>
           <a:p>
-            <a:endParaRPr lang="es-EC" sz="1350">
+            <a:endParaRPr lang="es-EC" sz="1600" dirty="0">
               <a:solidFill>
                 <a:srgbClr val="1E293B"/>
               </a:solidFill>
@@ -5418,7 +5610,7 @@
           </a:p>
           <a:p>
             <a:r>
-              <a:rPr lang="es-EC" sz="1350">
+              <a:rPr lang="es-EC" sz="1600" dirty="0">
                 <a:solidFill>
                   <a:srgbClr val="1E293B"/>
                 </a:solidFill>
@@ -5429,7 +5621,7 @@
           </a:p>
           <a:p>
             <a:r>
-              <a:rPr lang="es-EC" sz="1350">
+              <a:rPr lang="es-EC" sz="1600" dirty="0">
                 <a:solidFill>
                   <a:srgbClr val="1E293B"/>
                 </a:solidFill>
@@ -5523,7 +5715,7 @@
         <p:spPr>
           <a:xfrm>
             <a:off x="7620000" y="1905000"/>
-            <a:ext cx="3556000" cy="2585323"/>
+            <a:ext cx="3556000" cy="2739211"/>
           </a:xfrm>
           <a:prstGeom prst="rect">
             <a:avLst/>
@@ -5537,7 +5729,7 @@
           <a:lstStyle/>
           <a:p>
             <a:r>
-              <a:rPr lang="es-MX" sz="2200" b="1">
+              <a:rPr lang="es-MX" sz="2800" b="1" dirty="0">
                 <a:solidFill>
                   <a:srgbClr val="0070BA"/>
                 </a:solidFill>
@@ -5547,7 +5739,7 @@
             </a:r>
           </a:p>
           <a:p>
-            <a:endParaRPr lang="es-MX" sz="1400">
+            <a:endParaRPr lang="es-MX" dirty="0">
               <a:solidFill>
                 <a:srgbClr val="FFFFFF"/>
               </a:solidFill>
@@ -5556,78 +5748,95 @@
           </a:p>
           <a:p>
             <a:r>
-              <a:rPr lang="es-MX" sz="1400">
+              <a:rPr lang="es-MX" dirty="0">
                 <a:solidFill>
                   <a:srgbClr val="FFFFFF"/>
                 </a:solidFill>
                 <a:latin typeface="Calibri" panose="020F0502020204030204" pitchFamily="34" charset="0"/>
               </a:rPr>
-              <a:t>[Paso al Dashboard]</a:t>
-            </a:r>
-          </a:p>
-          <a:p>
-            <a:endParaRPr lang="es-MX" sz="1400">
-              <a:solidFill>
-                <a:srgbClr val="FFFFFF"/>
-              </a:solidFill>
-              <a:latin typeface="Calibri" panose="020F0502020204030204" pitchFamily="34" charset="0"/>
-            </a:endParaRPr>
-          </a:p>
-          <a:p>
-            <a:r>
-              <a:rPr lang="es-MX" sz="1400">
+              <a:t>- Mapa interactivo </a:t>
+            </a:r>
+            <a:r>
+              <a:rPr lang="es-MX" dirty="0" err="1">
                 <a:solidFill>
                   <a:srgbClr val="FFFFFF"/>
                 </a:solidFill>
                 <a:latin typeface="Calibri" panose="020F0502020204030204" pitchFamily="34" charset="0"/>
               </a:rPr>
-              <a:t>- Mapa interactivo Leaflet + CARTO</a:t>
-            </a:r>
-          </a:p>
-          <a:p>
-            <a:r>
-              <a:rPr lang="es-MX" sz="1400">
+              <a:t>Leaflet</a:t>
+            </a:r>
+            <a:r>
+              <a:rPr lang="es-MX" dirty="0">
                 <a:solidFill>
                   <a:srgbClr val="FFFFFF"/>
                 </a:solidFill>
                 <a:latin typeface="Calibri" panose="020F0502020204030204" pitchFamily="34" charset="0"/>
               </a:rPr>
+              <a:t> + CARTO</a:t>
+            </a:r>
+          </a:p>
+          <a:p>
+            <a:r>
+              <a:rPr lang="es-MX" dirty="0">
+                <a:solidFill>
+                  <a:srgbClr val="FFFFFF"/>
+                </a:solidFill>
+                <a:latin typeface="Calibri" panose="020F0502020204030204" pitchFamily="34" charset="0"/>
+              </a:rPr>
               <a:t>- 100 farmacias geolocalizadas</a:t>
             </a:r>
           </a:p>
           <a:p>
             <a:r>
-              <a:rPr lang="es-MX" sz="1400">
+              <a:rPr lang="es-MX" dirty="0">
                 <a:solidFill>
                   <a:srgbClr val="FFFFFF"/>
                 </a:solidFill>
                 <a:latin typeface="Calibri" panose="020F0502020204030204" pitchFamily="34" charset="0"/>
               </a:rPr>
-              <a:t>- Filtro en categorias sensibles (Cardio, Analgesicos, Respiratorios)</a:t>
-            </a:r>
-          </a:p>
-          <a:p>
-            <a:r>
-              <a:rPr lang="es-MX" sz="1400">
+              <a:t>- Filtro en categorías sensibles (Cardio, Analgésicos, Respiratorios)</a:t>
+            </a:r>
+          </a:p>
+          <a:p>
+            <a:r>
+              <a:rPr lang="es-MX" dirty="0">
                 <a:solidFill>
                   <a:srgbClr val="FFFFFF"/>
                 </a:solidFill>
                 <a:latin typeface="Calibri" panose="020F0502020204030204" pitchFamily="34" charset="0"/>
               </a:rPr>
-              <a:t>- Alertas dinamicas en tiempo real</a:t>
-            </a:r>
-          </a:p>
-          <a:p>
-            <a:r>
-              <a:rPr lang="es-MX" sz="1400">
+              <a:t>- Alertas dinámicas en tiempo real</a:t>
+            </a:r>
+          </a:p>
+          <a:p>
+            <a:r>
+              <a:rPr lang="es-MX" dirty="0">
                 <a:solidFill>
                   <a:srgbClr val="FFFFFF"/>
                 </a:solidFill>
                 <a:latin typeface="Calibri" panose="020F0502020204030204" pitchFamily="34" charset="0"/>
               </a:rPr>
-              <a:t>- API Python lista para AWS Lambda y Vendix POS</a:t>
-            </a:r>
-            <a:endParaRPr lang="es-EC" sz="1400">
+              <a:t>- API Python lista para AWS Lambda y </a:t>
+            </a:r>
+            <a:r>
+              <a:rPr lang="es-MX" dirty="0" err="1">
+                <a:solidFill>
+                  <a:srgbClr val="FFFFFF"/>
+                </a:solidFill>
+                <a:latin typeface="Calibri" panose="020F0502020204030204" pitchFamily="34" charset="0"/>
+              </a:rPr>
+              <a:t>Vendix</a:t>
+            </a:r>
+            <a:r>
+              <a:rPr lang="es-MX" dirty="0">
+                <a:solidFill>
+                  <a:srgbClr val="FFFFFF"/>
+                </a:solidFill>
+                <a:latin typeface="Calibri" panose="020F0502020204030204" pitchFamily="34" charset="0"/>
+              </a:rPr>
+              <a:t> POS</a:t>
+            </a:r>
+            <a:endParaRPr lang="es-EC" dirty="0">
               <a:solidFill>
                 <a:srgbClr val="FFFFFF"/>
               </a:solidFill>
@@ -5791,7 +6000,7 @@
         <p:spPr>
           <a:xfrm>
             <a:off x="762000" y="381000"/>
-            <a:ext cx="10668000" cy="492443"/>
+            <a:ext cx="10668000" cy="584775"/>
           </a:xfrm>
           <a:prstGeom prst="rect">
             <a:avLst/>
@@ -5805,15 +6014,15 @@
           <a:lstStyle/>
           <a:p>
             <a:r>
-              <a:rPr lang="es-MX" sz="2600" b="1">
+              <a:rPr lang="es-MX" sz="3200" b="1" dirty="0">
                 <a:solidFill>
                   <a:srgbClr val="0F2042"/>
                 </a:solidFill>
                 <a:latin typeface="Calibri" panose="020F0502020204030204" pitchFamily="34" charset="0"/>
               </a:rPr>
-              <a:t>Novedad, Diferenciacion e Impacto Operativo</a:t>
-            </a:r>
-            <a:endParaRPr lang="es-EC" sz="2600" b="1">
+              <a:t>Novedad, Diferenciación e Impacto Operativo</a:t>
+            </a:r>
+            <a:endParaRPr lang="es-EC" sz="3200" b="1" dirty="0">
               <a:solidFill>
                 <a:srgbClr val="0F2042"/>
               </a:solidFill>
@@ -5837,7 +6046,7 @@
         <p:spPr>
           <a:xfrm>
             <a:off x="762000" y="952500"/>
-            <a:ext cx="10668000" cy="292388"/>
+            <a:ext cx="10668000" cy="338554"/>
           </a:xfrm>
           <a:prstGeom prst="rect">
             <a:avLst/>
@@ -5851,7 +6060,7 @@
           <a:lstStyle/>
           <a:p>
             <a:r>
-              <a:rPr lang="es-MX" sz="1300">
+              <a:rPr lang="es-MX" sz="1600">
                 <a:solidFill>
                   <a:srgbClr val="64748B"/>
                 </a:solidFill>
@@ -5859,7 +6068,7 @@
               </a:rPr>
               <a:t>Eficiencia logistica de proximidad y retorno de inversion medible</a:t>
             </a:r>
-            <a:endParaRPr lang="es-EC" sz="1300">
+            <a:endParaRPr lang="es-EC" sz="1600">
               <a:solidFill>
                 <a:srgbClr val="64748B"/>
               </a:solidFill>
@@ -5928,7 +6137,7 @@
         </p:nvSpPr>
         <p:spPr>
           <a:xfrm>
-            <a:off x="762000" y="1524000"/>
+            <a:off x="762000" y="1563328"/>
             <a:ext cx="5715000" cy="4445000"/>
           </a:xfrm>
           <a:prstGeom prst="rect">
@@ -5983,7 +6192,7 @@
         <p:spPr>
           <a:xfrm>
             <a:off x="1016000" y="1714500"/>
-            <a:ext cx="5207000" cy="3000821"/>
+            <a:ext cx="5207000" cy="3293209"/>
           </a:xfrm>
           <a:prstGeom prst="rect">
             <a:avLst/>
@@ -5997,39 +6206,57 @@
           <a:lstStyle/>
           <a:p>
             <a:r>
-              <a:rPr lang="es-MX" sz="1350">
+              <a:rPr lang="es-MX" sz="1600" dirty="0">
                 <a:solidFill>
                   <a:srgbClr val="1E293B"/>
                 </a:solidFill>
                 <a:latin typeface="Calibri" panose="020F0502020204030204" pitchFamily="34" charset="0"/>
               </a:rPr>
-              <a:t>Diferenciacion vs BI Tradicional (Power BI / Qlik):</a:t>
-            </a:r>
-          </a:p>
-          <a:p>
-            <a:r>
-              <a:rPr lang="es-MX" sz="1350">
+              <a:t>Diferenciación vs BI Tradicional (Power BI / </a:t>
+            </a:r>
+            <a:r>
+              <a:rPr lang="es-MX" sz="1600" dirty="0" err="1">
                 <a:solidFill>
                   <a:srgbClr val="1E293B"/>
                 </a:solidFill>
                 <a:latin typeface="Calibri" panose="020F0502020204030204" pitchFamily="34" charset="0"/>
               </a:rPr>
+              <a:t>Qlik</a:t>
+            </a:r>
+            <a:r>
+              <a:rPr lang="es-MX" sz="1600" dirty="0">
+                <a:solidFill>
+                  <a:srgbClr val="1E293B"/>
+                </a:solidFill>
+                <a:latin typeface="Calibri" panose="020F0502020204030204" pitchFamily="34" charset="0"/>
+              </a:rPr>
+              <a:t>):</a:t>
+            </a:r>
+          </a:p>
+          <a:p>
+            <a:r>
+              <a:rPr lang="es-MX" sz="1600" dirty="0">
+                <a:solidFill>
+                  <a:srgbClr val="1E293B"/>
+                </a:solidFill>
+                <a:latin typeface="Calibri" panose="020F0502020204030204" pitchFamily="34" charset="0"/>
+              </a:rPr>
               <a:t>- No es un reporte forense mensual o semanal del pasado.</a:t>
             </a:r>
           </a:p>
           <a:p>
             <a:r>
-              <a:rPr lang="es-MX" sz="1350">
+              <a:rPr lang="es-MX" sz="1600" dirty="0">
                 <a:solidFill>
                   <a:srgbClr val="1E293B"/>
                 </a:solidFill>
                 <a:latin typeface="Calibri" panose="020F0502020204030204" pitchFamily="34" charset="0"/>
               </a:rPr>
-              <a:t>- Es un motor OPERATIVO en tiempo real que previene quiebres hoy y activa decisiones en primera linea.</a:t>
-            </a:r>
-          </a:p>
-          <a:p>
-            <a:endParaRPr lang="es-MX" sz="1350">
+              <a:t>- Es un motor OPERATIVO en tiempo real que previene quiebres hoy y activa decisiones en primera línea.</a:t>
+            </a:r>
+          </a:p>
+          <a:p>
+            <a:endParaRPr lang="es-MX" sz="1600" dirty="0">
               <a:solidFill>
                 <a:srgbClr val="1E293B"/>
               </a:solidFill>
@@ -6038,18 +6265,18 @@
           </a:p>
           <a:p>
             <a:r>
-              <a:rPr lang="es-MX" sz="1350">
+              <a:rPr lang="es-MX" sz="1600" dirty="0">
                 <a:solidFill>
                   <a:srgbClr val="1E293B"/>
                 </a:solidFill>
                 <a:latin typeface="Calibri" panose="020F0502020204030204" pitchFamily="34" charset="0"/>
               </a:rPr>
-              <a:t>Interconexion de Sucursales en Red:</a:t>
-            </a:r>
-          </a:p>
-          <a:p>
-            <a:r>
-              <a:rPr lang="es-MX" sz="1350">
+              <a:t>Interconexión de Sucursales en Red:</a:t>
+            </a:r>
+          </a:p>
+          <a:p>
+            <a:r>
+              <a:rPr lang="es-MX" sz="1600" dirty="0">
                 <a:solidFill>
                   <a:srgbClr val="1E293B"/>
                 </a:solidFill>
@@ -6059,7 +6286,7 @@
             </a:r>
           </a:p>
           <a:p>
-            <a:endParaRPr lang="es-MX" sz="1350">
+            <a:endParaRPr lang="es-MX" sz="1600" dirty="0">
               <a:solidFill>
                 <a:srgbClr val="1E293B"/>
               </a:solidFill>
@@ -6068,7 +6295,7 @@
           </a:p>
           <a:p>
             <a:r>
-              <a:rPr lang="es-MX" sz="1350">
+              <a:rPr lang="es-MX" sz="1600" dirty="0">
                 <a:solidFill>
                   <a:srgbClr val="1E293B"/>
                 </a:solidFill>
@@ -6079,18 +6306,18 @@
           </a:p>
           <a:p>
             <a:r>
-              <a:rPr lang="es-MX" sz="1350">
+              <a:rPr lang="es-MX" sz="1600" dirty="0">
                 <a:solidFill>
                   <a:srgbClr val="1E293B"/>
                 </a:solidFill>
                 <a:latin typeface="Calibri" panose="020F0502020204030204" pitchFamily="34" charset="0"/>
               </a:rPr>
-              <a:t>- Ecuacion de Ahorro: </a:t>
-            </a:r>
-          </a:p>
-          <a:p>
-            <a:r>
-              <a:rPr lang="es-MX" sz="1350">
+              <a:t>- Ecuación de Ahorro: </a:t>
+            </a:r>
+          </a:p>
+          <a:p>
+            <a:r>
+              <a:rPr lang="es-MX" sz="1600" dirty="0">
                 <a:solidFill>
                   <a:srgbClr val="1E293B"/>
                 </a:solidFill>
@@ -6098,23 +6325,6 @@
               </a:rPr>
               <a:t>  (Ventas Perdidas x Margen) + (Mermas por Caducidad x Costo) + Fletes Urgentes</a:t>
             </a:r>
-          </a:p>
-          <a:p>
-            <a:r>
-              <a:rPr lang="es-MX" sz="1350">
-                <a:solidFill>
-                  <a:srgbClr val="1E293B"/>
-                </a:solidFill>
-                <a:latin typeface="Calibri" panose="020F0502020204030204" pitchFamily="34" charset="0"/>
-              </a:rPr>
-              <a:t>- Proteccion directa del LTV del paciente cronico.</a:t>
-            </a:r>
-            <a:endParaRPr lang="es-EC" sz="1350">
-              <a:solidFill>
-                <a:srgbClr val="1E293B"/>
-              </a:solidFill>
-              <a:latin typeface="Calibri" panose="020F0502020204030204" pitchFamily="34" charset="0"/>
-            </a:endParaRPr>
           </a:p>
         </p:txBody>
       </p:sp>
@@ -6232,8 +6442,8 @@
         </p:nvSpPr>
         <p:spPr>
           <a:xfrm>
-            <a:off x="6858000" y="5143500"/>
-            <a:ext cx="4572000" cy="825500"/>
+            <a:off x="6858000" y="5143499"/>
+            <a:ext cx="4572000" cy="919897"/>
           </a:xfrm>
           <a:prstGeom prst="rect">
             <a:avLst/>
@@ -6301,7 +6511,7 @@
         <p:spPr>
           <a:xfrm>
             <a:off x="6985000" y="5232400"/>
-            <a:ext cx="4318000" cy="461665"/>
+            <a:ext cx="4318000" cy="830997"/>
           </a:xfrm>
           <a:prstGeom prst="rect">
             <a:avLst/>
@@ -6315,26 +6525,26 @@
           <a:lstStyle/>
           <a:p>
             <a:r>
-              <a:rPr lang="es-MX" sz="1200">
+              <a:rPr lang="es-MX" sz="1600" dirty="0">
                 <a:solidFill>
                   <a:srgbClr val="FFFFFF"/>
                 </a:solidFill>
                 <a:latin typeface="Calibri" panose="020F0502020204030204" pitchFamily="34" charset="0"/>
               </a:rPr>
-              <a:t>Red Inteligente de Distribucion Farmaceutica</a:t>
-            </a:r>
-          </a:p>
-          <a:p>
-            <a:r>
-              <a:rPr lang="es-MX" sz="1200">
+              <a:t>Red Inteligente de Distribución Farmacéutica</a:t>
+            </a:r>
+          </a:p>
+          <a:p>
+            <a:r>
+              <a:rPr lang="es-MX" sz="1600" dirty="0">
                 <a:solidFill>
                   <a:srgbClr val="FFFFFF"/>
                 </a:solidFill>
                 <a:latin typeface="Calibri" panose="020F0502020204030204" pitchFamily="34" charset="0"/>
               </a:rPr>
-              <a:t>Conexion de inventarios locales para cero quiebres</a:t>
-            </a:r>
-            <a:endParaRPr lang="es-EC" sz="1200">
+              <a:t>Conexión de inventarios locales para cero quiebres</a:t>
+            </a:r>
+            <a:endParaRPr lang="es-EC" sz="1600" dirty="0">
               <a:solidFill>
                 <a:srgbClr val="FFFFFF"/>
               </a:solidFill>
@@ -6443,7 +6653,7 @@
         <p:spPr>
           <a:xfrm>
             <a:off x="1016000" y="2032000"/>
-            <a:ext cx="10160000" cy="1077218"/>
+            <a:ext cx="10160000" cy="1200329"/>
           </a:xfrm>
           <a:prstGeom prst="rect">
             <a:avLst/>
@@ -6457,15 +6667,15 @@
           <a:lstStyle/>
           <a:p>
             <a:r>
-              <a:rPr lang="es-MX" sz="3200" b="1">
+              <a:rPr lang="es-MX" sz="3600" b="1" dirty="0">
                 <a:solidFill>
                   <a:srgbClr val="FFFFFF"/>
                 </a:solidFill>
                 <a:latin typeface="Calibri" panose="020F0502020204030204" pitchFamily="34" charset="0"/>
               </a:rPr>
-              <a:t>"Que ningun ser querido se quede sin su medicina, y que ninguna farmacia pierda una venta."</a:t>
-            </a:r>
-            <a:endParaRPr lang="es-EC" sz="3200" b="1">
+              <a:t>"Que ningún ser querido se quede sin su medicina, y que ninguna farmacia pierda una venta."</a:t>
+            </a:r>
+            <a:endParaRPr lang="es-EC" sz="3600" b="1" dirty="0">
               <a:solidFill>
                 <a:srgbClr val="FFFFFF"/>
               </a:solidFill>
@@ -6488,8 +6698,8 @@
         </p:nvSpPr>
         <p:spPr>
           <a:xfrm>
-            <a:off x="1079500" y="3683000"/>
-            <a:ext cx="10160000" cy="1015663"/>
+            <a:off x="1016000" y="3748783"/>
+            <a:ext cx="10160000" cy="523220"/>
           </a:xfrm>
           <a:prstGeom prst="rect">
             <a:avLst/>
@@ -6503,36 +6713,35 @@
           <a:lstStyle/>
           <a:p>
             <a:r>
-              <a:rPr lang="es-MX" sz="2000">
-                <a:solidFill>
-                  <a:srgbClr val="0070BA"/>
-                </a:solidFill>
-                <a:latin typeface="Calibri" panose="020F0502020204030204" pitchFamily="34" charset="0"/>
-              </a:rPr>
-              <a:t>FarmaSenal: Mejora Operativa para Farmaenlace</a:t>
-            </a:r>
-          </a:p>
-          <a:p>
-            <a:endParaRPr lang="es-MX" sz="2000">
+              <a:rPr lang="es-MX" sz="2800" dirty="0" err="1">
+                <a:solidFill>
+                  <a:schemeClr val="bg1"/>
+                </a:solidFill>
+                <a:latin typeface="Calibri" panose="020F0502020204030204" pitchFamily="34" charset="0"/>
+              </a:rPr>
+              <a:t>FarmaSeñal</a:t>
+            </a:r>
+            <a:r>
+              <a:rPr lang="es-MX" sz="2800" dirty="0">
+                <a:solidFill>
+                  <a:schemeClr val="bg1"/>
+                </a:solidFill>
+                <a:latin typeface="Calibri" panose="020F0502020204030204" pitchFamily="34" charset="0"/>
+              </a:rPr>
+              <a:t>: Mejora Operativa para </a:t>
+            </a:r>
+            <a:r>
+              <a:rPr lang="es-MX" sz="2800" dirty="0" err="1">
+                <a:solidFill>
+                  <a:schemeClr val="bg1"/>
+                </a:solidFill>
+                <a:latin typeface="Calibri" panose="020F0502020204030204" pitchFamily="34" charset="0"/>
+              </a:rPr>
+              <a:t>Farmaenlace</a:t>
+            </a:r>
+            <a:endParaRPr lang="es-MX" sz="2800" dirty="0">
               <a:solidFill>
-                <a:srgbClr val="0070BA"/>
-              </a:solidFill>
-              <a:latin typeface="Calibri" panose="020F0502020204030204" pitchFamily="34" charset="0"/>
-            </a:endParaRPr>
-          </a:p>
-          <a:p>
-            <a:r>
-              <a:rPr lang="es-MX" sz="2000">
-                <a:solidFill>
-                  <a:srgbClr val="0070BA"/>
-                </a:solidFill>
-                <a:latin typeface="Calibri" panose="020F0502020204030204" pitchFamily="34" charset="0"/>
-              </a:rPr>
-              <a:t>Muchas gracias. Pasamos a la sesion de preguntas.</a:t>
-            </a:r>
-            <a:endParaRPr lang="es-EC" sz="2000">
-              <a:solidFill>
-                <a:srgbClr val="0070BA"/>
+                <a:schemeClr val="bg1"/>
               </a:solidFill>
               <a:latin typeface="Calibri" panose="020F0502020204030204" pitchFamily="34" charset="0"/>
             </a:endParaRPr>

</xml_diff>